<commit_message>
docs: align midterm deck with actual progress and add project-management section
- midterm deck: slide 3 reflects the 8 scenarios already run, slide 7
  explains the 20/20 figure (separate N=2 experiment), slide 8 plan updated
- BAO_CAO.md / .docx: add "Quản trị dự án" (roles, board link placeholder, Git)

Co-Authored-By: Claude Sonnet 5.5 <noreply@anthropic.com>
</commit_message>
<xml_diff>
--- a/docs/BAO_CAO_GIUA_KY_R05-K15.pptx
+++ b/docs/BAO_CAO_GIUA_KY_R05-K15.pptx
@@ -114,34 +114,34 @@
   <p:extLst>
     <p:ext uri="{521415D9-36F7-43E2-AB2F-B90AF26B5E84}">
       <p14:sectionLst xmlns:p14="http://schemas.microsoft.com/office/powerpoint/2010/main">
-        <p14:section name="Mở đầu" id="{95269f01-fd09-4415-6ea2-93c2f377f9f8}">
+        <p14:section name="Mở đầu" id="{25913233-4e41-bdf6-0380-40651ac9a813}">
           <p14:sldIdLst>
             <p14:sldId id="256"/>
             <p14:sldId id="257"/>
           </p14:sldIdLst>
         </p14:section>
-        <p14:section name="Tiến độ" id="{314e9c1d-18e3-b994-c348-b1751faf405d}">
+        <p14:section name="Tiến độ" id="{099a27df-3b7a-1502-9a22-27b745971eb9}">
           <p14:sldIdLst>
             <p14:sldId id="258"/>
           </p14:sldIdLst>
         </p14:section>
-        <p14:section name="Hệ thống và kiểm thử" id="{3bb62c01-94bd-f437-f081-1a83a2cf7ff2}">
+        <p14:section name="Hệ thống và kiểm thử" id="{b5e90492-87eb-120c-3dc4-6a1d4fa5bb0c}">
           <p14:sldIdLst>
             <p14:sldId id="259"/>
             <p14:sldId id="260"/>
           </p14:sldIdLst>
         </p14:section>
-        <p14:section name="Kế hoạch kiểm thử" id="{b4b83cd5-e287-cbe5-f5b4-65036a5f64be}">
+        <p14:section name="Kế hoạch kiểm thử" id="{5760c3a2-78e9-0f69-6596-eb65fb09327b}">
           <p14:sldIdLst>
             <p14:sldId id="261"/>
           </p14:sldIdLst>
         </p14:section>
-        <p14:section name="Kết quả sơ bộ" id="{b2452dd7-9a76-ae7a-a274-47f5cc9c4193}">
+        <p14:section name="Kết quả sơ bộ" id="{71074cac-7e51-fa6d-4e32-8b511cb9081a}">
           <p14:sldIdLst>
             <p14:sldId id="262"/>
           </p14:sldIdLst>
         </p14:section>
-        <p14:section name="Tiếp theo" id="{e830b022-244b-631d-f5ca-ee494a50ecc4}">
+        <p14:section name="Tiếp theo" id="{ac26d88b-fa99-f9c9-e3a0-418126b44286}">
           <p14:sldIdLst>
             <p14:sldId id="263"/>
           </p14:sldIdLst>
@@ -726,7 +726,7 @@
           <a:p>
             <a:r>
               <a:rPr lang="en-US" dirty="0"/>
-              <a:t>Mọi mục của Sprint 1 đã xong. Nhóm đã bắt đầu sang Sprint 2: harness cho nhiều scenario đã có bản nháp, đang chạy thử nhiều vòng. Phần phân tích nguyên nhân gốc và báo cáo cuối còn lại.</a:t>
+              <a:t>Mọi mục của Sprint 1 đã xong, và nhóm đã làm trước: harness 8 scenario đã chạy 10 vòng mỗi scenario kèm nhóm đối chứng tuần tự, đã phân tích nguyên nhân gốc. Giữa kỳ nhóm chỉ trình bày kết quả sơ bộ S1 và S2; kết quả đầy đủ dành cho buổi bảo vệ cuối kỳ. Còn lại: Playwright qua giao diện, hoàn thiện báo cáo, và chuẩn bị bảo vệ. Nói rõ phân vai và board Trello/Jira của nhóm.</a:t>
             </a:r>
             <a:endParaRPr lang="en-US" dirty="0"/>
           </a:p>
@@ -1078,7 +1078,7 @@
           <a:p>
             <a:r>
               <a:rPr lang="en-US" dirty="0"/>
-              <a:t>Kết quả sơ bộ: S1 đặt cùng slot PASS nhờ khóa idempotency. S2 đặt hai slot chồng lấn thì FAIL ở mọi vòng: host bị đặt chồng. Đây là lý do nhóm chọn kỹ thuật này. Kết quả đầy đủ 8 scenario, nguyên nhân gốc và thí nghiệm khắc phục sẽ trình bày ở cuối kỳ.</a:t>
+              <a:t>Kết quả sơ bộ: S1 đặt cùng slot PASS nhờ khóa idempotency. S2 đặt hai slot chồng lấn thì FAIL ở mọi vòng: host bị đặt chồng. Đây là lý do nhóm chọn kỹ thuật này. Nhóm đã chạy đủ 8 scenario; kết quả đầy đủ, nguyên nhân gốc và thí nghiệm khắc phục xin để dành cho buổi bảo vệ cuối kỳ. Con số 20/20 đến từ thí nghiệm riêng với 2 request, 20 vòng.</a:t>
             </a:r>
             <a:endParaRPr lang="en-US" dirty="0"/>
           </a:p>
@@ -1166,7 +1166,7 @@
           <a:p>
             <a:r>
               <a:rPr lang="en-US" dirty="0"/>
-              <a:t>Kế hoạch bốn giai đoạn đến bảo vệ. Rủi ro chính là race không tái hiện ổn định nên nhóm chạy nhiều vòng và báo tỉ lệ. Kết thúc phần báo cáo, mời thầy đặt câu hỏi.</a:t>
+              <a:t>Kế hoạch bốn giai đoạn đến bảo vệ; phần kiểm thử chính đã chạy xong nên thời gian còn lại dành cho kiểm chứng lại, hoàn thiện báo cáo và chuẩn bị bảo vệ. Rủi ro chính là race không tái hiện ổn định nên nhóm chạy nhiều vòng và báo tỉ lệ. Kết thúc phần báo cáo, mời thầy đặt câu hỏi.</a:t>
             </a:r>
             <a:endParaRPr lang="en-US" dirty="0"/>
           </a:p>
@@ -2811,7 +2811,7 @@
                 <a:ea typeface="Calibri" pitchFamily="34" charset="-122"/>
                 <a:cs typeface="Calibri" pitchFamily="34" charset="-120"/>
               </a:rPr>
-              <a:t>Sprint 1 hoàn thành, đã làm trước một phần Sprint 2</a:t>
+              <a:t>Sprint 1 hoàn thành, harness 8 scenario đã chạy xong</a:t>
             </a:r>
             <a:endParaRPr lang="en-US" sz="3400" dirty="0"/>
           </a:p>
@@ -2840,12 +2840,12 @@
             <a:tbl>
               <a:tblPr/>
               <a:tblGrid>
-                <a:gridCol w="5120640"/>
-                <a:gridCol w="1280160"/>
-                <a:gridCol w="1463040"/>
+                <a:gridCol w="5394960"/>
+                <a:gridCol w="1097280"/>
+                <a:gridCol w="1371600"/>
                 <a:gridCol w="3044952"/>
               </a:tblGrid>
-              <a:tr h="457200">
+              <a:tr h="420624">
                 <a:tc>
                   <a:txBody>
                     <a:bodyPr/>
@@ -2855,7 +2855,7 @@
                         <a:buNone/>
                       </a:pPr>
                       <a:r>
-                        <a:rPr lang="en-US" sz="1400" b="1" dirty="0">
+                        <a:rPr lang="en-US" sz="1300" b="1" dirty="0">
                           <a:solidFill>
                             <a:srgbClr val="12202B"/>
                           </a:solidFill>
@@ -2865,7 +2865,7 @@
                         </a:rPr>
                         <a:t>Hạng mục</a:t>
                       </a:r>
-                      <a:endParaRPr lang="en-US" sz="1400" dirty="0">
+                      <a:endParaRPr lang="en-US" sz="1300" dirty="0">
                         <a:latin typeface="Calibri" charset="0"/>
                         <a:ea typeface="Calibri" charset="0"/>
                         <a:cs typeface="Calibri" charset="0"/>
@@ -2923,7 +2923,7 @@
                         <a:buNone/>
                       </a:pPr>
                       <a:r>
-                        <a:rPr lang="en-US" sz="1400" b="1" dirty="0">
+                        <a:rPr lang="en-US" sz="1300" b="1" dirty="0">
                           <a:solidFill>
                             <a:srgbClr val="12202B"/>
                           </a:solidFill>
@@ -2933,7 +2933,7 @@
                         </a:rPr>
                         <a:t>Sprint</a:t>
                       </a:r>
-                      <a:endParaRPr lang="en-US" sz="1400" dirty="0">
+                      <a:endParaRPr lang="en-US" sz="1300" dirty="0">
                         <a:latin typeface="Calibri" charset="0"/>
                         <a:ea typeface="Calibri" charset="0"/>
                         <a:cs typeface="Calibri" charset="0"/>
@@ -2991,7 +2991,7 @@
                         <a:buNone/>
                       </a:pPr>
                       <a:r>
-                        <a:rPr lang="en-US" sz="1400" b="1" dirty="0">
+                        <a:rPr lang="en-US" sz="1300" b="1" dirty="0">
                           <a:solidFill>
                             <a:srgbClr val="12202B"/>
                           </a:solidFill>
@@ -3001,7 +3001,7 @@
                         </a:rPr>
                         <a:t>Trạng thái</a:t>
                       </a:r>
-                      <a:endParaRPr lang="en-US" sz="1400" dirty="0">
+                      <a:endParaRPr lang="en-US" sz="1300" dirty="0">
                         <a:latin typeface="Calibri" charset="0"/>
                         <a:ea typeface="Calibri" charset="0"/>
                         <a:cs typeface="Calibri" charset="0"/>
@@ -3059,7 +3059,7 @@
                         <a:buNone/>
                       </a:pPr>
                       <a:r>
-                        <a:rPr lang="en-US" sz="1400" b="1" dirty="0">
+                        <a:rPr lang="en-US" sz="1300" b="1" dirty="0">
                           <a:solidFill>
                             <a:srgbClr val="12202B"/>
                           </a:solidFill>
@@ -3069,7 +3069,7 @@
                         </a:rPr>
                         <a:t>Bằng chứng</a:t>
                       </a:r>
-                      <a:endParaRPr lang="en-US" sz="1400" dirty="0">
+                      <a:endParaRPr lang="en-US" sz="1300" dirty="0">
                         <a:latin typeface="Calibri" charset="0"/>
                         <a:ea typeface="Calibri" charset="0"/>
                         <a:cs typeface="Calibri" charset="0"/>
@@ -3119,7 +3119,7 @@
                   </a:tcPr>
                 </a:tc>
               </a:tr>
-              <a:tr h="457200">
+              <a:tr h="420624">
                 <a:tc>
                   <a:txBody>
                     <a:bodyPr/>
@@ -3129,7 +3129,7 @@
                         <a:buNone/>
                       </a:pPr>
                       <a:r>
-                        <a:rPr lang="en-US" sz="1400" dirty="0">
+                        <a:rPr lang="en-US" sz="1300" dirty="0">
                           <a:solidFill>
                             <a:srgbClr val="12202B"/>
                           </a:solidFill>
@@ -3139,7 +3139,7 @@
                         </a:rPr>
                         <a:t>Chốt repo, kỹ thuật, pin tag và commit SHA</a:t>
                       </a:r>
-                      <a:endParaRPr lang="en-US" sz="1400" dirty="0">
+                      <a:endParaRPr lang="en-US" sz="1300" dirty="0">
                         <a:latin typeface="Calibri" charset="0"/>
                         <a:ea typeface="Calibri" charset="0"/>
                         <a:cs typeface="Calibri" charset="0"/>
@@ -3197,7 +3197,7 @@
                         <a:buNone/>
                       </a:pPr>
                       <a:r>
-                        <a:rPr lang="en-US" sz="1400" dirty="0">
+                        <a:rPr lang="en-US" sz="1300" dirty="0">
                           <a:solidFill>
                             <a:srgbClr val="12202B"/>
                           </a:solidFill>
@@ -3207,7 +3207,7 @@
                         </a:rPr>
                         <a:t>Đăng ký</a:t>
                       </a:r>
-                      <a:endParaRPr lang="en-US" sz="1400" dirty="0">
+                      <a:endParaRPr lang="en-US" sz="1300" dirty="0">
                         <a:latin typeface="Calibri" charset="0"/>
                         <a:ea typeface="Calibri" charset="0"/>
                         <a:cs typeface="Calibri" charset="0"/>
@@ -3265,7 +3265,7 @@
                         <a:buNone/>
                       </a:pPr>
                       <a:r>
-                        <a:rPr lang="en-US" sz="1400" b="1" dirty="0">
+                        <a:rPr lang="en-US" sz="1300" b="1" dirty="0">
                           <a:solidFill>
                             <a:srgbClr val="2E7D4F"/>
                           </a:solidFill>
@@ -3275,7 +3275,7 @@
                         </a:rPr>
                         <a:t>Xong</a:t>
                       </a:r>
-                      <a:endParaRPr lang="en-US" sz="1400" dirty="0">
+                      <a:endParaRPr lang="en-US" sz="1300" dirty="0">
                         <a:latin typeface="Calibri" charset="0"/>
                         <a:ea typeface="Calibri" charset="0"/>
                         <a:cs typeface="Calibri" charset="0"/>
@@ -3333,7 +3333,7 @@
                         <a:buNone/>
                       </a:pPr>
                       <a:r>
-                        <a:rPr lang="en-US" sz="1400" dirty="0">
+                        <a:rPr lang="en-US" sz="1300" dirty="0">
                           <a:solidFill>
                             <a:srgbClr val="12202B"/>
                           </a:solidFill>
@@ -3343,7 +3343,7 @@
                         </a:rPr>
                         <a:t>README.md mục 1</a:t>
                       </a:r>
-                      <a:endParaRPr lang="en-US" sz="1400" dirty="0">
+                      <a:endParaRPr lang="en-US" sz="1300" dirty="0">
                         <a:latin typeface="Calibri" charset="0"/>
                         <a:ea typeface="Calibri" charset="0"/>
                         <a:cs typeface="Calibri" charset="0"/>
@@ -3393,7 +3393,7 @@
                   </a:tcPr>
                 </a:tc>
               </a:tr>
-              <a:tr h="457200">
+              <a:tr h="420624">
                 <a:tc>
                   <a:txBody>
                     <a:bodyPr/>
@@ -3403,7 +3403,7 @@
                         <a:buNone/>
                       </a:pPr>
                       <a:r>
-                        <a:rPr lang="en-US" sz="1400" dirty="0">
+                        <a:rPr lang="en-US" sz="1300" dirty="0">
                           <a:solidFill>
                             <a:srgbClr val="12202B"/>
                           </a:solidFill>
@@ -3413,7 +3413,7 @@
                         </a:rPr>
                         <a:t>Dựng Cal.com local, seed data, chạy 3 luồng nghiệp vụ</a:t>
                       </a:r>
-                      <a:endParaRPr lang="en-US" sz="1400" dirty="0">
+                      <a:endParaRPr lang="en-US" sz="1300" dirty="0">
                         <a:latin typeface="Calibri" charset="0"/>
                         <a:ea typeface="Calibri" charset="0"/>
                         <a:cs typeface="Calibri" charset="0"/>
@@ -3471,7 +3471,7 @@
                         <a:buNone/>
                       </a:pPr>
                       <a:r>
-                        <a:rPr lang="en-US" sz="1400" dirty="0">
+                        <a:rPr lang="en-US" sz="1300" dirty="0">
                           <a:solidFill>
                             <a:srgbClr val="12202B"/>
                           </a:solidFill>
@@ -3481,7 +3481,7 @@
                         </a:rPr>
                         <a:t>1</a:t>
                       </a:r>
-                      <a:endParaRPr lang="en-US" sz="1400" dirty="0">
+                      <a:endParaRPr lang="en-US" sz="1300" dirty="0">
                         <a:latin typeface="Calibri" charset="0"/>
                         <a:ea typeface="Calibri" charset="0"/>
                         <a:cs typeface="Calibri" charset="0"/>
@@ -3539,7 +3539,7 @@
                         <a:buNone/>
                       </a:pPr>
                       <a:r>
-                        <a:rPr lang="en-US" sz="1400" b="1" dirty="0">
+                        <a:rPr lang="en-US" sz="1300" b="1" dirty="0">
                           <a:solidFill>
                             <a:srgbClr val="2E7D4F"/>
                           </a:solidFill>
@@ -3549,7 +3549,7 @@
                         </a:rPr>
                         <a:t>Xong</a:t>
                       </a:r>
-                      <a:endParaRPr lang="en-US" sz="1400" dirty="0">
+                      <a:endParaRPr lang="en-US" sz="1300" dirty="0">
                         <a:latin typeface="Calibri" charset="0"/>
                         <a:ea typeface="Calibri" charset="0"/>
                         <a:cs typeface="Calibri" charset="0"/>
@@ -3607,7 +3607,7 @@
                         <a:buNone/>
                       </a:pPr>
                       <a:r>
-                        <a:rPr lang="en-US" sz="1400" dirty="0">
+                        <a:rPr lang="en-US" sz="1300" dirty="0">
                           <a:solidFill>
                             <a:srgbClr val="12202B"/>
                           </a:solidFill>
@@ -3617,7 +3617,7 @@
                         </a:rPr>
                         <a:t>docs/evidence/smoke-test.txt</a:t>
                       </a:r>
-                      <a:endParaRPr lang="en-US" sz="1400" dirty="0">
+                      <a:endParaRPr lang="en-US" sz="1300" dirty="0">
                         <a:latin typeface="Calibri" charset="0"/>
                         <a:ea typeface="Calibri" charset="0"/>
                         <a:cs typeface="Calibri" charset="0"/>
@@ -3667,7 +3667,7 @@
                   </a:tcPr>
                 </a:tc>
               </a:tr>
-              <a:tr h="457200">
+              <a:tr h="420624">
                 <a:tc>
                   <a:txBody>
                     <a:bodyPr/>
@@ -3677,7 +3677,7 @@
                         <a:buNone/>
                       </a:pPr>
                       <a:r>
-                        <a:rPr lang="en-US" sz="1400" dirty="0">
+                        <a:rPr lang="en-US" sz="1300" dirty="0">
                           <a:solidFill>
                             <a:srgbClr val="12202B"/>
                           </a:solidFill>
@@ -3687,7 +3687,7 @@
                         </a:rPr>
                         <a:t>Đọc code, vẽ kiến trúc và luồng dữ liệu</a:t>
                       </a:r>
-                      <a:endParaRPr lang="en-US" sz="1400" dirty="0">
+                      <a:endParaRPr lang="en-US" sz="1300" dirty="0">
                         <a:latin typeface="Calibri" charset="0"/>
                         <a:ea typeface="Calibri" charset="0"/>
                         <a:cs typeface="Calibri" charset="0"/>
@@ -3745,7 +3745,7 @@
                         <a:buNone/>
                       </a:pPr>
                       <a:r>
-                        <a:rPr lang="en-US" sz="1400" dirty="0">
+                        <a:rPr lang="en-US" sz="1300" dirty="0">
                           <a:solidFill>
                             <a:srgbClr val="12202B"/>
                           </a:solidFill>
@@ -3755,7 +3755,7 @@
                         </a:rPr>
                         <a:t>1</a:t>
                       </a:r>
-                      <a:endParaRPr lang="en-US" sz="1400" dirty="0">
+                      <a:endParaRPr lang="en-US" sz="1300" dirty="0">
                         <a:latin typeface="Calibri" charset="0"/>
                         <a:ea typeface="Calibri" charset="0"/>
                         <a:cs typeface="Calibri" charset="0"/>
@@ -3813,7 +3813,7 @@
                         <a:buNone/>
                       </a:pPr>
                       <a:r>
-                        <a:rPr lang="en-US" sz="1400" b="1" dirty="0">
+                        <a:rPr lang="en-US" sz="1300" b="1" dirty="0">
                           <a:solidFill>
                             <a:srgbClr val="2E7D4F"/>
                           </a:solidFill>
@@ -3823,7 +3823,7 @@
                         </a:rPr>
                         <a:t>Xong</a:t>
                       </a:r>
-                      <a:endParaRPr lang="en-US" sz="1400" dirty="0">
+                      <a:endParaRPr lang="en-US" sz="1300" dirty="0">
                         <a:latin typeface="Calibri" charset="0"/>
                         <a:ea typeface="Calibri" charset="0"/>
                         <a:cs typeface="Calibri" charset="0"/>
@@ -3881,7 +3881,7 @@
                         <a:buNone/>
                       </a:pPr>
                       <a:r>
-                        <a:rPr lang="en-US" sz="1400" dirty="0">
+                        <a:rPr lang="en-US" sz="1300" dirty="0">
                           <a:solidFill>
                             <a:srgbClr val="12202B"/>
                           </a:solidFill>
@@ -3891,7 +3891,7 @@
                         </a:rPr>
                         <a:t>docs/diagrams/kien-truc.md</a:t>
                       </a:r>
-                      <a:endParaRPr lang="en-US" sz="1400" dirty="0">
+                      <a:endParaRPr lang="en-US" sz="1300" dirty="0">
                         <a:latin typeface="Calibri" charset="0"/>
                         <a:ea typeface="Calibri" charset="0"/>
                         <a:cs typeface="Calibri" charset="0"/>
@@ -3941,7 +3941,7 @@
                   </a:tcPr>
                 </a:tc>
               </a:tr>
-              <a:tr h="457200">
+              <a:tr h="420624">
                 <a:tc>
                   <a:txBody>
                     <a:bodyPr/>
@@ -3951,7 +3951,7 @@
                         <a:buNone/>
                       </a:pPr>
                       <a:r>
-                        <a:rPr lang="en-US" sz="1400" dirty="0">
+                        <a:rPr lang="en-US" sz="1300" dirty="0">
                           <a:solidFill>
                             <a:srgbClr val="12202B"/>
                           </a:solidFill>
@@ -3959,9 +3959,9 @@
                           <a:ea typeface="Calibri" pitchFamily="34" charset="-122"/>
                           <a:cs typeface="Calibri" pitchFamily="34" charset="-120"/>
                         </a:rPr>
-                        <a:t>Tài liệu on-boarding, cài đặt từ máy sạch</a:t>
+                        <a:t>Tài liệu on-boarding, kế hoạch kiểm thử</a:t>
                       </a:r>
-                      <a:endParaRPr lang="en-US" sz="1400" dirty="0">
+                      <a:endParaRPr lang="en-US" sz="1300" dirty="0">
                         <a:latin typeface="Calibri" charset="0"/>
                         <a:ea typeface="Calibri" charset="0"/>
                         <a:cs typeface="Calibri" charset="0"/>
@@ -4019,7 +4019,7 @@
                         <a:buNone/>
                       </a:pPr>
                       <a:r>
-                        <a:rPr lang="en-US" sz="1400" dirty="0">
+                        <a:rPr lang="en-US" sz="1300" dirty="0">
                           <a:solidFill>
                             <a:srgbClr val="12202B"/>
                           </a:solidFill>
@@ -4029,7 +4029,7 @@
                         </a:rPr>
                         <a:t>1</a:t>
                       </a:r>
-                      <a:endParaRPr lang="en-US" sz="1400" dirty="0">
+                      <a:endParaRPr lang="en-US" sz="1300" dirty="0">
                         <a:latin typeface="Calibri" charset="0"/>
                         <a:ea typeface="Calibri" charset="0"/>
                         <a:cs typeface="Calibri" charset="0"/>
@@ -4087,7 +4087,7 @@
                         <a:buNone/>
                       </a:pPr>
                       <a:r>
-                        <a:rPr lang="en-US" sz="1400" b="1" dirty="0">
+                        <a:rPr lang="en-US" sz="1300" b="1" dirty="0">
                           <a:solidFill>
                             <a:srgbClr val="2E7D4F"/>
                           </a:solidFill>
@@ -4097,7 +4097,7 @@
                         </a:rPr>
                         <a:t>Xong</a:t>
                       </a:r>
-                      <a:endParaRPr lang="en-US" sz="1400" dirty="0">
+                      <a:endParaRPr lang="en-US" sz="1300" dirty="0">
                         <a:latin typeface="Calibri" charset="0"/>
                         <a:ea typeface="Calibri" charset="0"/>
                         <a:cs typeface="Calibri" charset="0"/>
@@ -4155,7 +4155,7 @@
                         <a:buNone/>
                       </a:pPr>
                       <a:r>
-                        <a:rPr lang="en-US" sz="1400" dirty="0">
+                        <a:rPr lang="en-US" sz="1300" dirty="0">
                           <a:solidFill>
                             <a:srgbClr val="12202B"/>
                           </a:solidFill>
@@ -4163,9 +4163,9 @@
                           <a:ea typeface="Calibri" pitchFamily="34" charset="-122"/>
                           <a:cs typeface="Calibri" pitchFamily="34" charset="-120"/>
                         </a:rPr>
-                        <a:t>README.md mục 2–3</a:t>
+                        <a:t>README.md, slide 6</a:t>
                       </a:r>
-                      <a:endParaRPr lang="en-US" sz="1400" dirty="0">
+                      <a:endParaRPr lang="en-US" sz="1300" dirty="0">
                         <a:latin typeface="Calibri" charset="0"/>
                         <a:ea typeface="Calibri" charset="0"/>
                         <a:cs typeface="Calibri" charset="0"/>
@@ -4215,7 +4215,7 @@
                   </a:tcPr>
                 </a:tc>
               </a:tr>
-              <a:tr h="457200">
+              <a:tr h="420624">
                 <a:tc>
                   <a:txBody>
                     <a:bodyPr/>
@@ -4225,7 +4225,7 @@
                         <a:buNone/>
                       </a:pPr>
                       <a:r>
-                        <a:rPr lang="en-US" sz="1400" dirty="0">
+                        <a:rPr lang="en-US" sz="1300" dirty="0">
                           <a:solidFill>
                             <a:srgbClr val="12202B"/>
                           </a:solidFill>
@@ -4233,9 +4233,9 @@
                           <a:ea typeface="Calibri" pitchFamily="34" charset="-122"/>
                           <a:cs typeface="Calibri" pitchFamily="34" charset="-120"/>
                         </a:rPr>
-                        <a:t>Kế hoạch kiểm thử: phạm vi, giả định, tiêu chí</a:t>
+                        <a:t>Harness k6 + SQL, 8 scenario, mỗi scenario 10 vòng, có đối chứng tuần tự</a:t>
                       </a:r>
-                      <a:endParaRPr lang="en-US" sz="1400" dirty="0">
+                      <a:endParaRPr lang="en-US" sz="1300" dirty="0">
                         <a:latin typeface="Calibri" charset="0"/>
                         <a:ea typeface="Calibri" charset="0"/>
                         <a:cs typeface="Calibri" charset="0"/>
@@ -4293,7 +4293,7 @@
                         <a:buNone/>
                       </a:pPr>
                       <a:r>
-                        <a:rPr lang="en-US" sz="1400" dirty="0">
+                        <a:rPr lang="en-US" sz="1300" dirty="0">
                           <a:solidFill>
                             <a:srgbClr val="12202B"/>
                           </a:solidFill>
@@ -4301,9 +4301,9 @@
                           <a:ea typeface="Calibri" pitchFamily="34" charset="-122"/>
                           <a:cs typeface="Calibri" pitchFamily="34" charset="-120"/>
                         </a:rPr>
-                        <a:t>1</a:t>
+                        <a:t>2–3</a:t>
                       </a:r>
-                      <a:endParaRPr lang="en-US" sz="1400" dirty="0">
+                      <a:endParaRPr lang="en-US" sz="1300" dirty="0">
                         <a:latin typeface="Calibri" charset="0"/>
                         <a:ea typeface="Calibri" charset="0"/>
                         <a:cs typeface="Calibri" charset="0"/>
@@ -4361,7 +4361,7 @@
                         <a:buNone/>
                       </a:pPr>
                       <a:r>
-                        <a:rPr lang="en-US" sz="1400" b="1" dirty="0">
+                        <a:rPr lang="en-US" sz="1300" b="1" dirty="0">
                           <a:solidFill>
                             <a:srgbClr val="2E7D4F"/>
                           </a:solidFill>
@@ -4371,7 +4371,7 @@
                         </a:rPr>
                         <a:t>Xong</a:t>
                       </a:r>
-                      <a:endParaRPr lang="en-US" sz="1400" dirty="0">
+                      <a:endParaRPr lang="en-US" sz="1300" dirty="0">
                         <a:latin typeface="Calibri" charset="0"/>
                         <a:ea typeface="Calibri" charset="0"/>
                         <a:cs typeface="Calibri" charset="0"/>
@@ -4429,7 +4429,7 @@
                         <a:buNone/>
                       </a:pPr>
                       <a:r>
-                        <a:rPr lang="en-US" sz="1400" dirty="0">
+                        <a:rPr lang="en-US" sz="1300" dirty="0">
                           <a:solidFill>
                             <a:srgbClr val="12202B"/>
                           </a:solidFill>
@@ -4437,9 +4437,9 @@
                           <a:ea typeface="Calibri" pitchFamily="34" charset="-122"/>
                           <a:cs typeface="Calibri" pitchFamily="34" charset="-120"/>
                         </a:rPr>
-                        <a:t>Slide 6</a:t>
+                        <a:t>race-tests/results/</a:t>
                       </a:r>
-                      <a:endParaRPr lang="en-US" sz="1400" dirty="0">
+                      <a:endParaRPr lang="en-US" sz="1300" dirty="0">
                         <a:latin typeface="Calibri" charset="0"/>
                         <a:ea typeface="Calibri" charset="0"/>
                         <a:cs typeface="Calibri" charset="0"/>
@@ -4489,7 +4489,7 @@
                   </a:tcPr>
                 </a:tc>
               </a:tr>
-              <a:tr h="457200">
+              <a:tr h="420624">
                 <a:tc>
                   <a:txBody>
                     <a:bodyPr/>
@@ -4499,7 +4499,7 @@
                         <a:buNone/>
                       </a:pPr>
                       <a:r>
-                        <a:rPr lang="en-US" sz="1400" dirty="0">
+                        <a:rPr lang="en-US" sz="1300" dirty="0">
                           <a:solidFill>
                             <a:srgbClr val="12202B"/>
                           </a:solidFill>
@@ -4507,9 +4507,9 @@
                           <a:ea typeface="Calibri" pitchFamily="34" charset="-122"/>
                           <a:cs typeface="Calibri" pitchFamily="34" charset="-120"/>
                         </a:rPr>
-                        <a:t>PoC race đầu tiên (đặt trùng slot)</a:t>
+                        <a:t>Phân tích nguyên nhân gốc, thí nghiệm khắc phục</a:t>
                       </a:r>
-                      <a:endParaRPr lang="en-US" sz="1400" dirty="0">
+                      <a:endParaRPr lang="en-US" sz="1300" dirty="0">
                         <a:latin typeface="Calibri" charset="0"/>
                         <a:ea typeface="Calibri" charset="0"/>
                         <a:cs typeface="Calibri" charset="0"/>
@@ -4567,7 +4567,7 @@
                         <a:buNone/>
                       </a:pPr>
                       <a:r>
-                        <a:rPr lang="en-US" sz="1400" dirty="0">
+                        <a:rPr lang="en-US" sz="1300" dirty="0">
                           <a:solidFill>
                             <a:srgbClr val="12202B"/>
                           </a:solidFill>
@@ -4575,9 +4575,9 @@
                           <a:ea typeface="Calibri" pitchFamily="34" charset="-122"/>
                           <a:cs typeface="Calibri" pitchFamily="34" charset="-120"/>
                         </a:rPr>
-                        <a:t>1</a:t>
+                        <a:t>4</a:t>
                       </a:r>
-                      <a:endParaRPr lang="en-US" sz="1400" dirty="0">
+                      <a:endParaRPr lang="en-US" sz="1300" dirty="0">
                         <a:latin typeface="Calibri" charset="0"/>
                         <a:ea typeface="Calibri" charset="0"/>
                         <a:cs typeface="Calibri" charset="0"/>
@@ -4635,7 +4635,7 @@
                         <a:buNone/>
                       </a:pPr>
                       <a:r>
-                        <a:rPr lang="en-US" sz="1400" b="1" dirty="0">
+                        <a:rPr lang="en-US" sz="1300" b="1" dirty="0">
                           <a:solidFill>
                             <a:srgbClr val="2E7D4F"/>
                           </a:solidFill>
@@ -4645,7 +4645,7 @@
                         </a:rPr>
                         <a:t>Xong</a:t>
                       </a:r>
-                      <a:endParaRPr lang="en-US" sz="1400" dirty="0">
+                      <a:endParaRPr lang="en-US" sz="1300" dirty="0">
                         <a:latin typeface="Calibri" charset="0"/>
                         <a:ea typeface="Calibri" charset="0"/>
                         <a:cs typeface="Calibri" charset="0"/>
@@ -4703,7 +4703,7 @@
                         <a:buNone/>
                       </a:pPr>
                       <a:r>
-                        <a:rPr lang="en-US" sz="1400" dirty="0">
+                        <a:rPr lang="en-US" sz="1300" dirty="0">
                           <a:solidFill>
                             <a:srgbClr val="12202B"/>
                           </a:solidFill>
@@ -4711,9 +4711,9 @@
                           <a:ea typeface="Calibri" pitchFamily="34" charset="-122"/>
                           <a:cs typeface="Calibri" pitchFamily="34" charset="-120"/>
                         </a:rPr>
-                        <a:t>Slide 7</a:t>
+                        <a:t>docs/DEFECTS.md</a:t>
                       </a:r>
-                      <a:endParaRPr lang="en-US" sz="1400" dirty="0">
+                      <a:endParaRPr lang="en-US" sz="1300" dirty="0">
                         <a:latin typeface="Calibri" charset="0"/>
                         <a:ea typeface="Calibri" charset="0"/>
                         <a:cs typeface="Calibri" charset="0"/>
@@ -4763,7 +4763,7 @@
                   </a:tcPr>
                 </a:tc>
               </a:tr>
-              <a:tr h="457200">
+              <a:tr h="420624">
                 <a:tc>
                   <a:txBody>
                     <a:bodyPr/>
@@ -4773,7 +4773,7 @@
                         <a:buNone/>
                       </a:pPr>
                       <a:r>
-                        <a:rPr lang="en-US" sz="1400" dirty="0">
+                        <a:rPr lang="en-US" sz="1300" dirty="0">
                           <a:solidFill>
                             <a:srgbClr val="12202B"/>
                           </a:solidFill>
@@ -4781,9 +4781,9 @@
                           <a:ea typeface="Calibri" pitchFamily="34" charset="-122"/>
                           <a:cs typeface="Calibri" pitchFamily="34" charset="-120"/>
                         </a:rPr>
-                        <a:t>Mở rộng scenario S3–S8, chạy nhiều vòng</a:t>
+                        <a:t>Báo cáo cuối (bản nháp A–H) và slide bảo vệ</a:t>
                       </a:r>
-                      <a:endParaRPr lang="en-US" sz="1400" dirty="0">
+                      <a:endParaRPr lang="en-US" sz="1300" dirty="0">
                         <a:latin typeface="Calibri" charset="0"/>
                         <a:ea typeface="Calibri" charset="0"/>
                         <a:cs typeface="Calibri" charset="0"/>
@@ -4841,7 +4841,7 @@
                         <a:buNone/>
                       </a:pPr>
                       <a:r>
-                        <a:rPr lang="en-US" sz="1400" dirty="0">
+                        <a:rPr lang="en-US" sz="1300" dirty="0">
                           <a:solidFill>
                             <a:srgbClr val="12202B"/>
                           </a:solidFill>
@@ -4849,9 +4849,9 @@
                           <a:ea typeface="Calibri" pitchFamily="34" charset="-122"/>
                           <a:cs typeface="Calibri" pitchFamily="34" charset="-120"/>
                         </a:rPr>
-                        <a:t>2–3</a:t>
+                        <a:t>4–5</a:t>
                       </a:r>
-                      <a:endParaRPr lang="en-US" sz="1400" dirty="0">
+                      <a:endParaRPr lang="en-US" sz="1300" dirty="0">
                         <a:latin typeface="Calibri" charset="0"/>
                         <a:ea typeface="Calibri" charset="0"/>
                         <a:cs typeface="Calibri" charset="0"/>
@@ -4909,7 +4909,7 @@
                         <a:buNone/>
                       </a:pPr>
                       <a:r>
-                        <a:rPr lang="en-US" sz="1400" b="1" dirty="0">
+                        <a:rPr lang="en-US" sz="1300" b="1" dirty="0">
                           <a:solidFill>
                             <a:srgbClr val="B4531A"/>
                           </a:solidFill>
@@ -4917,9 +4917,9 @@
                           <a:ea typeface="Calibri" pitchFamily="34" charset="-122"/>
                           <a:cs typeface="Calibri" pitchFamily="34" charset="-120"/>
                         </a:rPr>
-                        <a:t>Đang làm</a:t>
+                        <a:t>Một phần</a:t>
                       </a:r>
-                      <a:endParaRPr lang="en-US" sz="1400" dirty="0">
+                      <a:endParaRPr lang="en-US" sz="1300" dirty="0">
                         <a:latin typeface="Calibri" charset="0"/>
                         <a:ea typeface="Calibri" charset="0"/>
                         <a:cs typeface="Calibri" charset="0"/>
@@ -4977,7 +4977,7 @@
                         <a:buNone/>
                       </a:pPr>
                       <a:r>
-                        <a:rPr lang="en-US" sz="1400" dirty="0">
+                        <a:rPr lang="en-US" sz="1300" dirty="0">
                           <a:solidFill>
                             <a:srgbClr val="12202B"/>
                           </a:solidFill>
@@ -4985,9 +4985,9 @@
                           <a:ea typeface="Calibri" pitchFamily="34" charset="-122"/>
                           <a:cs typeface="Calibri" pitchFamily="34" charset="-120"/>
                         </a:rPr>
-                        <a:t>Đã có bản nháp harness</a:t>
+                        <a:t>docs/BAO_CAO.md</a:t>
                       </a:r>
-                      <a:endParaRPr lang="en-US" sz="1400" dirty="0">
+                      <a:endParaRPr lang="en-US" sz="1300" dirty="0">
                         <a:latin typeface="Calibri" charset="0"/>
                         <a:ea typeface="Calibri" charset="0"/>
                         <a:cs typeface="Calibri" charset="0"/>
@@ -5037,7 +5037,7 @@
                   </a:tcPr>
                 </a:tc>
               </a:tr>
-              <a:tr h="457200">
+              <a:tr h="420624">
                 <a:tc>
                   <a:txBody>
                     <a:bodyPr/>
@@ -5047,7 +5047,7 @@
                         <a:buNone/>
                       </a:pPr>
                       <a:r>
-                        <a:rPr lang="en-US" sz="1400" dirty="0">
+                        <a:rPr lang="en-US" sz="1300" dirty="0">
                           <a:solidFill>
                             <a:srgbClr val="12202B"/>
                           </a:solidFill>
@@ -5055,9 +5055,9 @@
                           <a:ea typeface="Calibri" pitchFamily="34" charset="-122"/>
                           <a:cs typeface="Calibri" pitchFamily="34" charset="-120"/>
                         </a:rPr>
-                        <a:t>Phân tích nguyên nhân gốc, viết báo cáo cuối</a:t>
+                        <a:t>Scenario Playwright qua giao diện, chạy lại trên máy khác</a:t>
                       </a:r>
-                      <a:endParaRPr lang="en-US" sz="1400" dirty="0">
+                      <a:endParaRPr lang="en-US" sz="1300" dirty="0">
                         <a:latin typeface="Calibri" charset="0"/>
                         <a:ea typeface="Calibri" charset="0"/>
                         <a:cs typeface="Calibri" charset="0"/>
@@ -5115,7 +5115,7 @@
                         <a:buNone/>
                       </a:pPr>
                       <a:r>
-                        <a:rPr lang="en-US" sz="1400" dirty="0">
+                        <a:rPr lang="en-US" sz="1300" dirty="0">
                           <a:solidFill>
                             <a:srgbClr val="12202B"/>
                           </a:solidFill>
@@ -5123,9 +5123,9 @@
                           <a:ea typeface="Calibri" pitchFamily="34" charset="-122"/>
                           <a:cs typeface="Calibri" pitchFamily="34" charset="-120"/>
                         </a:rPr>
-                        <a:t>4</a:t>
+                        <a:t>3</a:t>
                       </a:r>
-                      <a:endParaRPr lang="en-US" sz="1400" dirty="0">
+                      <a:endParaRPr lang="en-US" sz="1300" dirty="0">
                         <a:latin typeface="Calibri" charset="0"/>
                         <a:ea typeface="Calibri" charset="0"/>
                         <a:cs typeface="Calibri" charset="0"/>
@@ -5183,7 +5183,7 @@
                         <a:buNone/>
                       </a:pPr>
                       <a:r>
-                        <a:rPr lang="en-US" sz="1400" b="1" dirty="0">
+                        <a:rPr lang="en-US" sz="1300" b="1" dirty="0">
                           <a:solidFill>
                             <a:srgbClr val="4A5866"/>
                           </a:solidFill>
@@ -5193,7 +5193,7 @@
                         </a:rPr>
                         <a:t>Chưa làm</a:t>
                       </a:r>
-                      <a:endParaRPr lang="en-US" sz="1400" dirty="0">
+                      <a:endParaRPr lang="en-US" sz="1300" dirty="0">
                         <a:latin typeface="Calibri" charset="0"/>
                         <a:ea typeface="Calibri" charset="0"/>
                         <a:cs typeface="Calibri" charset="0"/>
@@ -5251,7 +5251,7 @@
                         <a:buNone/>
                       </a:pPr>
                       <a:r>
-                        <a:rPr lang="en-US" sz="1400" dirty="0">
+                        <a:rPr lang="en-US" sz="1300" dirty="0">
                           <a:solidFill>
                             <a:srgbClr val="12202B"/>
                           </a:solidFill>
@@ -5261,7 +5261,281 @@
                         </a:rPr>
                         <a:t>–</a:t>
                       </a:r>
-                      <a:endParaRPr lang="en-US" sz="1400" dirty="0">
+                      <a:endParaRPr lang="en-US" sz="1300" dirty="0">
+                        <a:latin typeface="Calibri" charset="0"/>
+                        <a:ea typeface="Calibri" charset="0"/>
+                        <a:cs typeface="Calibri" charset="0"/>
+                      </a:endParaRPr>
+                    </a:p>
+                  </a:txBody>
+                  <a:tcPr marL="91440" marR="91440" marT="36576" marB="36576" anchor="ctr">
+                    <a:lnL w="9525" cap="flat" cmpd="sng" algn="ctr">
+                      <a:solidFill>
+                        <a:srgbClr val="DAD6CC"/>
+                      </a:solidFill>
+                      <a:prstDash val="solid"/>
+                      <a:round/>
+                      <a:headEnd type="none" w="med" len="med"/>
+                      <a:tailEnd type="none" w="med" len="med"/>
+                    </a:lnL>
+                    <a:lnR w="9525" cap="flat" cmpd="sng" algn="ctr">
+                      <a:solidFill>
+                        <a:srgbClr val="DAD6CC"/>
+                      </a:solidFill>
+                      <a:prstDash val="solid"/>
+                      <a:round/>
+                      <a:headEnd type="none" w="med" len="med"/>
+                      <a:tailEnd type="none" w="med" len="med"/>
+                    </a:lnR>
+                    <a:lnT w="9525" cap="flat" cmpd="sng" algn="ctr">
+                      <a:solidFill>
+                        <a:srgbClr val="DAD6CC"/>
+                      </a:solidFill>
+                      <a:prstDash val="solid"/>
+                      <a:round/>
+                      <a:headEnd type="none" w="med" len="med"/>
+                      <a:tailEnd type="none" w="med" len="med"/>
+                    </a:lnT>
+                    <a:lnB w="9525" cap="flat" cmpd="sng" algn="ctr">
+                      <a:solidFill>
+                        <a:srgbClr val="DAD6CC"/>
+                      </a:solidFill>
+                      <a:prstDash val="solid"/>
+                      <a:round/>
+                      <a:headEnd type="none" w="med" len="med"/>
+                      <a:tailEnd type="none" w="med" len="med"/>
+                    </a:lnB>
+                    <a:solidFill>
+                      <a:srgbClr val="FFFFFF"/>
+                    </a:solidFill>
+                  </a:tcPr>
+                </a:tc>
+              </a:tr>
+              <a:tr h="420624">
+                <a:tc>
+                  <a:txBody>
+                    <a:bodyPr/>
+                    <a:lstStyle/>
+                    <a:p>
+                      <a:pPr indent="0" marL="0">
+                        <a:buNone/>
+                      </a:pPr>
+                      <a:r>
+                        <a:rPr lang="en-US" sz="1300" dirty="0">
+                          <a:solidFill>
+                            <a:srgbClr val="12202B"/>
+                          </a:solidFill>
+                          <a:latin typeface="Calibri" pitchFamily="34" charset="0"/>
+                          <a:ea typeface="Calibri" pitchFamily="34" charset="-122"/>
+                          <a:cs typeface="Calibri" pitchFamily="34" charset="-120"/>
+                        </a:rPr>
+                        <a:t>Phân vai 4 người, board Trello/Jira, lịch sử Git đều các thành viên</a:t>
+                      </a:r>
+                      <a:endParaRPr lang="en-US" sz="1300" dirty="0">
+                        <a:latin typeface="Calibri" charset="0"/>
+                        <a:ea typeface="Calibri" charset="0"/>
+                        <a:cs typeface="Calibri" charset="0"/>
+                      </a:endParaRPr>
+                    </a:p>
+                  </a:txBody>
+                  <a:tcPr marL="91440" marR="91440" marT="36576" marB="36576" anchor="ctr">
+                    <a:lnL w="9525" cap="flat" cmpd="sng" algn="ctr">
+                      <a:solidFill>
+                        <a:srgbClr val="DAD6CC"/>
+                      </a:solidFill>
+                      <a:prstDash val="solid"/>
+                      <a:round/>
+                      <a:headEnd type="none" w="med" len="med"/>
+                      <a:tailEnd type="none" w="med" len="med"/>
+                    </a:lnL>
+                    <a:lnR w="9525" cap="flat" cmpd="sng" algn="ctr">
+                      <a:solidFill>
+                        <a:srgbClr val="DAD6CC"/>
+                      </a:solidFill>
+                      <a:prstDash val="solid"/>
+                      <a:round/>
+                      <a:headEnd type="none" w="med" len="med"/>
+                      <a:tailEnd type="none" w="med" len="med"/>
+                    </a:lnR>
+                    <a:lnT w="9525" cap="flat" cmpd="sng" algn="ctr">
+                      <a:solidFill>
+                        <a:srgbClr val="DAD6CC"/>
+                      </a:solidFill>
+                      <a:prstDash val="solid"/>
+                      <a:round/>
+                      <a:headEnd type="none" w="med" len="med"/>
+                      <a:tailEnd type="none" w="med" len="med"/>
+                    </a:lnT>
+                    <a:lnB w="9525" cap="flat" cmpd="sng" algn="ctr">
+                      <a:solidFill>
+                        <a:srgbClr val="DAD6CC"/>
+                      </a:solidFill>
+                      <a:prstDash val="solid"/>
+                      <a:round/>
+                      <a:headEnd type="none" w="med" len="med"/>
+                      <a:tailEnd type="none" w="med" len="med"/>
+                    </a:lnB>
+                    <a:solidFill>
+                      <a:srgbClr val="FFFFFF"/>
+                    </a:solidFill>
+                  </a:tcPr>
+                </a:tc>
+                <a:tc>
+                  <a:txBody>
+                    <a:bodyPr/>
+                    <a:lstStyle/>
+                    <a:p>
+                      <a:pPr indent="0" marL="0">
+                        <a:buNone/>
+                      </a:pPr>
+                      <a:r>
+                        <a:rPr lang="en-US" sz="1300" dirty="0">
+                          <a:solidFill>
+                            <a:srgbClr val="12202B"/>
+                          </a:solidFill>
+                          <a:latin typeface="Calibri" pitchFamily="34" charset="0"/>
+                          <a:ea typeface="Calibri" pitchFamily="34" charset="-122"/>
+                          <a:cs typeface="Calibri" pitchFamily="34" charset="-120"/>
+                        </a:rPr>
+                        <a:t>Đăng ký</a:t>
+                      </a:r>
+                      <a:endParaRPr lang="en-US" sz="1300" dirty="0">
+                        <a:latin typeface="Calibri" charset="0"/>
+                        <a:ea typeface="Calibri" charset="0"/>
+                        <a:cs typeface="Calibri" charset="0"/>
+                      </a:endParaRPr>
+                    </a:p>
+                  </a:txBody>
+                  <a:tcPr marL="91440" marR="91440" marT="36576" marB="36576" anchor="ctr">
+                    <a:lnL w="9525" cap="flat" cmpd="sng" algn="ctr">
+                      <a:solidFill>
+                        <a:srgbClr val="DAD6CC"/>
+                      </a:solidFill>
+                      <a:prstDash val="solid"/>
+                      <a:round/>
+                      <a:headEnd type="none" w="med" len="med"/>
+                      <a:tailEnd type="none" w="med" len="med"/>
+                    </a:lnL>
+                    <a:lnR w="9525" cap="flat" cmpd="sng" algn="ctr">
+                      <a:solidFill>
+                        <a:srgbClr val="DAD6CC"/>
+                      </a:solidFill>
+                      <a:prstDash val="solid"/>
+                      <a:round/>
+                      <a:headEnd type="none" w="med" len="med"/>
+                      <a:tailEnd type="none" w="med" len="med"/>
+                    </a:lnR>
+                    <a:lnT w="9525" cap="flat" cmpd="sng" algn="ctr">
+                      <a:solidFill>
+                        <a:srgbClr val="DAD6CC"/>
+                      </a:solidFill>
+                      <a:prstDash val="solid"/>
+                      <a:round/>
+                      <a:headEnd type="none" w="med" len="med"/>
+                      <a:tailEnd type="none" w="med" len="med"/>
+                    </a:lnT>
+                    <a:lnB w="9525" cap="flat" cmpd="sng" algn="ctr">
+                      <a:solidFill>
+                        <a:srgbClr val="DAD6CC"/>
+                      </a:solidFill>
+                      <a:prstDash val="solid"/>
+                      <a:round/>
+                      <a:headEnd type="none" w="med" len="med"/>
+                      <a:tailEnd type="none" w="med" len="med"/>
+                    </a:lnB>
+                    <a:solidFill>
+                      <a:srgbClr val="FFFFFF"/>
+                    </a:solidFill>
+                  </a:tcPr>
+                </a:tc>
+                <a:tc>
+                  <a:txBody>
+                    <a:bodyPr/>
+                    <a:lstStyle/>
+                    <a:p>
+                      <a:pPr indent="0" marL="0">
+                        <a:buNone/>
+                      </a:pPr>
+                      <a:r>
+                        <a:rPr lang="en-US" sz="1300" b="1" dirty="0">
+                          <a:solidFill>
+                            <a:srgbClr val="B4531A"/>
+                          </a:solidFill>
+                          <a:latin typeface="Calibri" pitchFamily="34" charset="0"/>
+                          <a:ea typeface="Calibri" pitchFamily="34" charset="-122"/>
+                          <a:cs typeface="Calibri" pitchFamily="34" charset="-120"/>
+                        </a:rPr>
+                        <a:t>Cần điền</a:t>
+                      </a:r>
+                      <a:endParaRPr lang="en-US" sz="1300" dirty="0">
+                        <a:latin typeface="Calibri" charset="0"/>
+                        <a:ea typeface="Calibri" charset="0"/>
+                        <a:cs typeface="Calibri" charset="0"/>
+                      </a:endParaRPr>
+                    </a:p>
+                  </a:txBody>
+                  <a:tcPr marL="91440" marR="91440" marT="36576" marB="36576" anchor="ctr">
+                    <a:lnL w="9525" cap="flat" cmpd="sng" algn="ctr">
+                      <a:solidFill>
+                        <a:srgbClr val="DAD6CC"/>
+                      </a:solidFill>
+                      <a:prstDash val="solid"/>
+                      <a:round/>
+                      <a:headEnd type="none" w="med" len="med"/>
+                      <a:tailEnd type="none" w="med" len="med"/>
+                    </a:lnL>
+                    <a:lnR w="9525" cap="flat" cmpd="sng" algn="ctr">
+                      <a:solidFill>
+                        <a:srgbClr val="DAD6CC"/>
+                      </a:solidFill>
+                      <a:prstDash val="solid"/>
+                      <a:round/>
+                      <a:headEnd type="none" w="med" len="med"/>
+                      <a:tailEnd type="none" w="med" len="med"/>
+                    </a:lnR>
+                    <a:lnT w="9525" cap="flat" cmpd="sng" algn="ctr">
+                      <a:solidFill>
+                        <a:srgbClr val="DAD6CC"/>
+                      </a:solidFill>
+                      <a:prstDash val="solid"/>
+                      <a:round/>
+                      <a:headEnd type="none" w="med" len="med"/>
+                      <a:tailEnd type="none" w="med" len="med"/>
+                    </a:lnT>
+                    <a:lnB w="9525" cap="flat" cmpd="sng" algn="ctr">
+                      <a:solidFill>
+                        <a:srgbClr val="DAD6CC"/>
+                      </a:solidFill>
+                      <a:prstDash val="solid"/>
+                      <a:round/>
+                      <a:headEnd type="none" w="med" len="med"/>
+                      <a:tailEnd type="none" w="med" len="med"/>
+                    </a:lnB>
+                    <a:solidFill>
+                      <a:srgbClr val="FFFFFF"/>
+                    </a:solidFill>
+                  </a:tcPr>
+                </a:tc>
+                <a:tc>
+                  <a:txBody>
+                    <a:bodyPr/>
+                    <a:lstStyle/>
+                    <a:p>
+                      <a:pPr indent="0" marL="0">
+                        <a:buNone/>
+                      </a:pPr>
+                      <a:r>
+                        <a:rPr lang="en-US" sz="1300" dirty="0">
+                          <a:solidFill>
+                            <a:srgbClr val="12202B"/>
+                          </a:solidFill>
+                          <a:latin typeface="Calibri" pitchFamily="34" charset="0"/>
+                          <a:ea typeface="Calibri" pitchFamily="34" charset="-122"/>
+                          <a:cs typeface="Calibri" pitchFamily="34" charset="-120"/>
+                        </a:rPr>
+                        <a:t>Ảnh board, git log</a:t>
+                      </a:r>
+                      <a:endParaRPr lang="en-US" sz="1300" dirty="0">
                         <a:latin typeface="Calibri" charset="0"/>
                         <a:ea typeface="Calibri" charset="0"/>
                         <a:cs typeface="Calibri" charset="0"/>
@@ -10300,7 +10574,7 @@
                 <a:ea typeface="Calibri" pitchFamily="34" charset="-122"/>
                 <a:cs typeface="Calibri" pitchFamily="34" charset="-120"/>
               </a:rPr>
-              <a:t>Với 2 request đồng thời, S2 vi phạm ở 20/20 vòng.</a:t>
+              <a:t>Thí nghiệm riêng với 2 request đồng thời, 20 vòng: S2 vi phạm 20/20 (results/sensitivity-n2).</a:t>
             </a:r>
             <a:endParaRPr lang="en-US" sz="1500" dirty="0"/>
           </a:p>
@@ -10444,7 +10718,7 @@
                 <a:ea typeface="Calibri" pitchFamily="34" charset="-122"/>
                 <a:cs typeface="Calibri" pitchFamily="34" charset="-120"/>
               </a:rPr>
-              <a:t>Chạy lại: npm run demo:midterm · kết quả đầy đủ 8 scenario sẽ trình bày ở bảo vệ cuối kỳ</a:t>
+              <a:t>Bảng: 10 request/vòng; demo chạy 3 vòng, kết quả chuẩn 10 vòng · Nhóm đã chạy đủ 8 scenario, trình bày ở cuối kỳ</a:t>
             </a:r>
             <a:endParaRPr lang="en-US" sz="1200" dirty="0"/>
           </a:p>
@@ -10729,7 +11003,7 @@
                 <a:ea typeface="Calibri" pitchFamily="34" charset="-122"/>
                 <a:cs typeface="Calibri" pitchFamily="34" charset="-120"/>
               </a:rPr>
-              <a:t>Hoàn thiện test model, viết scenario seated, PENDING, đổi lịch, hủy lịch</a:t>
+              <a:t>Thêm scenario Playwright qua giao diện, chạy lại toàn bộ trên máy sạch của thành viên khác</a:t>
             </a:r>
             <a:endParaRPr lang="en-US" sz="1600" dirty="0"/>
           </a:p>
@@ -10861,7 +11135,7 @@
                 <a:ea typeface="Calibri" pitchFamily="34" charset="-122"/>
                 <a:cs typeface="Calibri" pitchFamily="34" charset="-120"/>
               </a:rPr>
-              <a:t>Chạy nhiều vòng, đo cửa sổ race, thêm một scenario Playwright qua giao diện</a:t>
+              <a:t>Rà soát nguyên nhân gốc và đề xuất sửa; chuẩn bị báo cáo lỗi D1, D4 cho Cal.com</a:t>
             </a:r>
             <a:endParaRPr lang="en-US" sz="1600" dirty="0"/>
           </a:p>
@@ -10993,7 +11267,7 @@
                 <a:ea typeface="Calibri" pitchFamily="34" charset="-122"/>
                 <a:cs typeface="Calibri" pitchFamily="34" charset="-120"/>
               </a:rPr>
-              <a:t>Phân tích nguyên nhân gốc, thí nghiệm khắc phục, viết báo cáo, nộp trước bảo vệ 1 tuần</a:t>
+              <a:t>Hoàn thiện báo cáo A–H, nộp trước bảo vệ 1 tuần</a:t>
             </a:r>
             <a:endParaRPr lang="en-US" sz="1600" dirty="0"/>
           </a:p>
@@ -11125,7 +11399,7 @@
                 <a:ea typeface="Calibri" pitchFamily="34" charset="-122"/>
                 <a:cs typeface="Calibri" pitchFamily="34" charset="-120"/>
               </a:rPr>
-              <a:t>Slide, tập dượt, chạy lại trên máy sạch, đánh giá chéo</a:t>
+              <a:t>Slide bảo vệ, tập dượt, đánh giá chéo giữa các thành viên</a:t>
             </a:r>
             <a:endParaRPr lang="en-US" sz="1600" dirty="0"/>
           </a:p>
@@ -11164,7 +11438,7 @@
                 <a:ea typeface="Calibri" pitchFamily="34" charset="-122"/>
                 <a:cs typeface="Calibri" pitchFamily="34" charset="-120"/>
               </a:rPr>
-              <a:t>Rủi ro: race không tái hiện ổn định (chạy nhiều vòng, báo tỉ lệ) · máy yếu khi chạy Cal.com + PostgreSQL + k6 (giảm số VU) · cần chứng minh coverage nếu không tìm được lỗi.</a:t>
+              <a:t>Rủi ro: kết quả race có thể khác trên máy khác (báo tỉ lệ, không báo một lần chạy) · máy yếu khi chạy Cal.com + PostgreSQL + k6 (giảm số VU) · thành viên đóng góp không đều (board có người phụ trách, đánh giá chéo hằng tuần).</a:t>
             </a:r>
             <a:endParaRPr lang="en-US" sz="1500" dirty="0"/>
           </a:p>

</xml_diff>

<commit_message>
docs: add team members, board link and card list
- cover slides (midterm and final decks), BAO_CAO.md and .docx now list
  group 13 members and student IDs; generators updated so rebuilds keep them
- add docs/board-cards.md for the GitHub Projects board
- ignore Office lock files

Co-Authored-By: Claude Sonnet 5.5 <noreply@anthropic.com>
</commit_message>
<xml_diff>
--- a/docs/BAO_CAO_GIUA_KY_R05-K15.pptx
+++ b/docs/BAO_CAO_GIUA_KY_R05-K15.pptx
@@ -114,34 +114,34 @@
   <p:extLst>
     <p:ext uri="{521415D9-36F7-43E2-AB2F-B90AF26B5E84}">
       <p14:sectionLst xmlns:p14="http://schemas.microsoft.com/office/powerpoint/2010/main">
-        <p14:section name="Mở đầu" id="{25913233-4e41-bdf6-0380-40651ac9a813}">
+        <p14:section name="Mở đầu" id="{fa5adf8b-2168-91ef-f2d4-654d810cc253}">
           <p14:sldIdLst>
             <p14:sldId id="256"/>
             <p14:sldId id="257"/>
           </p14:sldIdLst>
         </p14:section>
-        <p14:section name="Tiến độ" id="{099a27df-3b7a-1502-9a22-27b745971eb9}">
+        <p14:section name="Tiến độ" id="{1968de12-6516-c9f1-b632-149ddf5ac809}">
           <p14:sldIdLst>
             <p14:sldId id="258"/>
           </p14:sldIdLst>
         </p14:section>
-        <p14:section name="Hệ thống và kiểm thử" id="{b5e90492-87eb-120c-3dc4-6a1d4fa5bb0c}">
+        <p14:section name="Hệ thống và kiểm thử" id="{0e9995a9-b09b-ef82-f91e-32b1be630b8a}">
           <p14:sldIdLst>
             <p14:sldId id="259"/>
             <p14:sldId id="260"/>
           </p14:sldIdLst>
         </p14:section>
-        <p14:section name="Kế hoạch kiểm thử" id="{5760c3a2-78e9-0f69-6596-eb65fb09327b}">
+        <p14:section name="Kế hoạch kiểm thử" id="{8b394beb-0ad1-3d07-ef44-ce961fe4d586}">
           <p14:sldIdLst>
             <p14:sldId id="261"/>
           </p14:sldIdLst>
         </p14:section>
-        <p14:section name="Kết quả sơ bộ" id="{71074cac-7e51-fa6d-4e32-8b511cb9081a}">
+        <p14:section name="Kết quả sơ bộ" id="{5be1e883-1555-7105-3d63-6499d3d4b382}">
           <p14:sldIdLst>
             <p14:sldId id="262"/>
           </p14:sldIdLst>
         </p14:section>
-        <p14:section name="Tiếp theo" id="{ac26d88b-fa99-f9c9-e3a0-418126b44286}">
+        <p14:section name="Tiếp theo" id="{a6b0e9cc-b5a9-dd9f-bee4-5f8eb4cbe1ef}">
           <p14:sldIdLst>
             <p14:sldId id="263"/>
           </p14:sldIdLst>
@@ -2057,8 +2057,8 @@
         </p:nvSpPr>
         <p:spPr>
           <a:xfrm>
-            <a:off x="7498080" y="5577840"/>
-            <a:ext cx="4023360" cy="731520"/>
+            <a:off x="6949440" y="5029200"/>
+            <a:ext cx="4599432" cy="1325880"/>
           </a:xfrm>
           <a:prstGeom prst="rect">
             <a:avLst/>
@@ -2067,7 +2067,7 @@
           <a:ln/>
         </p:spPr>
         <p:txBody>
-          <a:bodyPr wrap="square" lIns="0" tIns="0" rIns="0" bIns="0" rtlCol="0" anchor="ctr"/>
+          <a:bodyPr wrap="square" lIns="0" tIns="0" rIns="0" bIns="0" rtlCol="0" anchor="b"/>
           <a:lstStyle/>
           <a:p>
             <a:pPr algn="r" indent="0" marL="0">
@@ -2082,7 +2082,75 @@
                 <a:ea typeface="Calibri" pitchFamily="34" charset="-122"/>
                 <a:cs typeface="Calibri" pitchFamily="34" charset="-120"/>
               </a:rPr>
-              <a:t>Nhóm: [Tên thành viên 1 – 4]</a:t>
+              <a:t>Nhóm 13</a:t>
+            </a:r>
+            <a:endParaRPr lang="en-US" sz="1600" dirty="0"/>
+          </a:p>
+          <a:p>
+            <a:pPr algn="r" indent="0" marL="0">
+              <a:buNone/>
+            </a:pPr>
+            <a:r>
+              <a:rPr lang="en-US" sz="1600" dirty="0">
+                <a:solidFill>
+                  <a:srgbClr val="B8C6D2"/>
+                </a:solidFill>
+                <a:latin typeface="Calibri" pitchFamily="34" charset="0"/>
+                <a:ea typeface="Calibri" pitchFamily="34" charset="-122"/>
+                <a:cs typeface="Calibri" pitchFamily="34" charset="-120"/>
+              </a:rPr>
+              <a:t>2312741 - Nguyễn Thanh Tâm</a:t>
+            </a:r>
+            <a:endParaRPr lang="en-US" sz="1600" dirty="0"/>
+          </a:p>
+          <a:p>
+            <a:pPr algn="r" indent="0" marL="0">
+              <a:buNone/>
+            </a:pPr>
+            <a:r>
+              <a:rPr lang="en-US" sz="1600" dirty="0">
+                <a:solidFill>
+                  <a:srgbClr val="B8C6D2"/>
+                </a:solidFill>
+                <a:latin typeface="Calibri" pitchFamily="34" charset="0"/>
+                <a:ea typeface="Calibri" pitchFamily="34" charset="-122"/>
+                <a:cs typeface="Calibri" pitchFamily="34" charset="-120"/>
+              </a:rPr>
+              <a:t>2312800 - Võ Công Vinh</a:t>
+            </a:r>
+            <a:endParaRPr lang="en-US" sz="1600" dirty="0"/>
+          </a:p>
+          <a:p>
+            <a:pPr algn="r" indent="0" marL="0">
+              <a:buNone/>
+            </a:pPr>
+            <a:r>
+              <a:rPr lang="en-US" sz="1600" dirty="0">
+                <a:solidFill>
+                  <a:srgbClr val="B8C6D2"/>
+                </a:solidFill>
+                <a:latin typeface="Calibri" pitchFamily="34" charset="0"/>
+                <a:ea typeface="Calibri" pitchFamily="34" charset="-122"/>
+                <a:cs typeface="Calibri" pitchFamily="34" charset="-120"/>
+              </a:rPr>
+              <a:t>2312774 - Nguyễn Đức Tín</a:t>
+            </a:r>
+            <a:endParaRPr lang="en-US" sz="1600" dirty="0"/>
+          </a:p>
+          <a:p>
+            <a:pPr algn="r" indent="0" marL="0">
+              <a:buNone/>
+            </a:pPr>
+            <a:r>
+              <a:rPr lang="en-US" sz="1600" dirty="0">
+                <a:solidFill>
+                  <a:srgbClr val="B8C6D2"/>
+                </a:solidFill>
+                <a:latin typeface="Calibri" pitchFamily="34" charset="0"/>
+                <a:ea typeface="Calibri" pitchFamily="34" charset="-122"/>
+                <a:cs typeface="Calibri" pitchFamily="34" charset="-120"/>
+              </a:rPr>
+              <a:t>2312796 - Ngô Quốc Trường Vĩ</a:t>
             </a:r>
             <a:endParaRPr lang="en-US" sz="1600" dirty="0"/>
           </a:p>
@@ -5329,7 +5397,7 @@
                           <a:ea typeface="Calibri" pitchFamily="34" charset="-122"/>
                           <a:cs typeface="Calibri" pitchFamily="34" charset="-120"/>
                         </a:rPr>
-                        <a:t>Phân vai 4 người, board Trello/Jira, lịch sử Git đều các thành viên</a:t>
+                        <a:t>Board GitHub Projects đã tạo; đang thêm thẻ và gán người, commit đều các thành viên</a:t>
                       </a:r>
                       <a:endParaRPr lang="en-US" sz="1300" dirty="0">
                         <a:latin typeface="Calibri" charset="0"/>
@@ -5465,7 +5533,7 @@
                           <a:ea typeface="Calibri" pitchFamily="34" charset="-122"/>
                           <a:cs typeface="Calibri" pitchFamily="34" charset="-120"/>
                         </a:rPr>
-                        <a:t>Cần điền</a:t>
+                        <a:t>Một phần</a:t>
                       </a:r>
                       <a:endParaRPr lang="en-US" sz="1300" dirty="0">
                         <a:latin typeface="Calibri" charset="0"/>
@@ -5533,7 +5601,7 @@
                           <a:ea typeface="Calibri" pitchFamily="34" charset="-122"/>
                           <a:cs typeface="Calibri" pitchFamily="34" charset="-120"/>
                         </a:rPr>
-                        <a:t>Ảnh board, git log</a:t>
+                        <a:t>github.com/users/2312741-sudo/projects/1</a:t>
                       </a:r>
                       <a:endParaRPr lang="en-US" sz="1300" dirty="0">
                         <a:latin typeface="Calibri" charset="0"/>

</xml_diff>

<commit_message>
docs: add GitHub Projects board evidence to report and midterm deck
- docs/evidence/board.png: screenshot of the board (7 Todo, 1 In Progress, 10 Done)
- BAO_CAO.md / .docx: embed the board screenshot in the project-management section
- build-docx.cjs: support image lines in markdown
- midterm deck slide 3: board row now points to the screenshot

Co-Authored-By: Claude Sonnet 5.5 <noreply@anthropic.com>
</commit_message>
<xml_diff>
--- a/docs/BAO_CAO_GIUA_KY_R05-K15.pptx
+++ b/docs/BAO_CAO_GIUA_KY_R05-K15.pptx
@@ -114,34 +114,34 @@
   <p:extLst>
     <p:ext uri="{521415D9-36F7-43E2-AB2F-B90AF26B5E84}">
       <p14:sectionLst xmlns:p14="http://schemas.microsoft.com/office/powerpoint/2010/main">
-        <p14:section name="Mở đầu" id="{fa5adf8b-2168-91ef-f2d4-654d810cc253}">
+        <p14:section name="Mở đầu" id="{cd8f40c2-ac26-2047-d8d3-ad9bce72e0c3}">
           <p14:sldIdLst>
             <p14:sldId id="256"/>
             <p14:sldId id="257"/>
           </p14:sldIdLst>
         </p14:section>
-        <p14:section name="Tiến độ" id="{1968de12-6516-c9f1-b632-149ddf5ac809}">
+        <p14:section name="Tiến độ" id="{e5b731e4-7478-d7f3-d33c-eecfcc6f640c}">
           <p14:sldIdLst>
             <p14:sldId id="258"/>
           </p14:sldIdLst>
         </p14:section>
-        <p14:section name="Hệ thống và kiểm thử" id="{0e9995a9-b09b-ef82-f91e-32b1be630b8a}">
+        <p14:section name="Hệ thống và kiểm thử" id="{2191bc9a-79cd-0a37-4b29-9d8305ea8d1a}">
           <p14:sldIdLst>
             <p14:sldId id="259"/>
             <p14:sldId id="260"/>
           </p14:sldIdLst>
         </p14:section>
-        <p14:section name="Kế hoạch kiểm thử" id="{8b394beb-0ad1-3d07-ef44-ce961fe4d586}">
+        <p14:section name="Kế hoạch kiểm thử" id="{277f953f-c330-8d22-53ea-bcbecd9414dd}">
           <p14:sldIdLst>
             <p14:sldId id="261"/>
           </p14:sldIdLst>
         </p14:section>
-        <p14:section name="Kết quả sơ bộ" id="{5be1e883-1555-7105-3d63-6499d3d4b382}">
+        <p14:section name="Kết quả sơ bộ" id="{81ea8cc3-5232-1997-0356-52dca9ae153f}">
           <p14:sldIdLst>
             <p14:sldId id="262"/>
           </p14:sldIdLst>
         </p14:section>
-        <p14:section name="Tiếp theo" id="{a6b0e9cc-b5a9-dd9f-bee4-5f8eb4cbe1ef}">
+        <p14:section name="Tiếp theo" id="{44ffd690-acca-92ca-a8ca-6b68fd45aa19}">
           <p14:sldIdLst>
             <p14:sldId id="263"/>
           </p14:sldIdLst>
@@ -5397,7 +5397,7 @@
                           <a:ea typeface="Calibri" pitchFamily="34" charset="-122"/>
                           <a:cs typeface="Calibri" pitchFamily="34" charset="-120"/>
                         </a:rPr>
-                        <a:t>Board GitHub Projects đã tạo; đang thêm thẻ và gán người, commit đều các thành viên</a:t>
+                        <a:t>Board GitHub Projects: 18 thẻ ở 3 cột; còn gán người và commit đều các thành viên</a:t>
                       </a:r>
                       <a:endParaRPr lang="en-US" sz="1300" dirty="0">
                         <a:latin typeface="Calibri" charset="0"/>
@@ -5601,7 +5601,7 @@
                           <a:ea typeface="Calibri" pitchFamily="34" charset="-122"/>
                           <a:cs typeface="Calibri" pitchFamily="34" charset="-120"/>
                         </a:rPr>
-                        <a:t>github.com/users/2312741-sudo/projects/1</a:t>
+                        <a:t>docs/evidence/board.png</a:t>
                       </a:r>
                       <a:endParaRPr lang="en-US" sz="1300" dirty="0">
                         <a:latin typeface="Calibri" charset="0"/>

</xml_diff>

<commit_message>
docs: add test process, supplementary midterm slides and independent curl repros
- docs/QUY_TRINH_TEST.md: test process, test-case list, measured cost,
  midterm plan, technique and proof the defects are real
- race-tests/repro/repro-curl.sh + docs/evidence/repro-curl.txt: D2, D3, D5, D6
  reproduced with plain curl (no k6 / harness)
- docs/BAO_CAO_GIUA_KY_BO_SUNG.pptx: 4 supplementary slides (process, test cases,
  cost, real defects) generated by tools/build-pptx-midterm-extra.cjs
- demo script retries and prints the real connection error
- midterm deck: include the team's manual cover edit

Co-Authored-By: Claude Sonnet 5.5 <noreply@anthropic.com>
</commit_message>
<xml_diff>
--- a/docs/BAO_CAO_GIUA_KY_R05-K15.pptx
+++ b/docs/BAO_CAO_GIUA_KY_R05-K15.pptx
@@ -4,6 +4,9 @@
   <p:sldMasterIdLst>
     <p:sldMasterId id="2147483648" r:id="rId1"/>
   </p:sldMasterIdLst>
+  <p:notesMasterIdLst>
+    <p:notesMasterId r:id="rId10"/>
+  </p:notesMasterIdLst>
   <p:sldIdLst>
     <p:sldId id="256" r:id="rId2"/>
     <p:sldId id="257" r:id="rId3"/>
@@ -14,9 +17,6 @@
     <p:sldId id="262" r:id="rId8"/>
     <p:sldId id="263" r:id="rId9"/>
   </p:sldIdLst>
-  <p:notesMasterIdLst>
-    <p:notesMasterId r:id="rId10"/>
-  </p:notesMasterIdLst>
   <p:sldSz cx="12192000" cy="6858000"/>
   <p:notesSz cx="6858000" cy="12192000"/>
   <p:defaultTextStyle>
@@ -114,34 +114,34 @@
   <p:extLst>
     <p:ext uri="{521415D9-36F7-43E2-AB2F-B90AF26B5E84}">
       <p14:sectionLst xmlns:p14="http://schemas.microsoft.com/office/powerpoint/2010/main">
-        <p14:section name="Mở đầu" id="{cd8f40c2-ac26-2047-d8d3-ad9bce72e0c3}">
+        <p14:section name="Mở đầu" id="{CD8F40C2-AC26-2047-D8D3-AD9BCE72E0C3}">
           <p14:sldIdLst>
             <p14:sldId id="256"/>
             <p14:sldId id="257"/>
           </p14:sldIdLst>
         </p14:section>
-        <p14:section name="Tiến độ" id="{e5b731e4-7478-d7f3-d33c-eecfcc6f640c}">
+        <p14:section name="Tiến độ" id="{E5B731E4-7478-D7F3-D33C-EECFCC6F640C}">
           <p14:sldIdLst>
             <p14:sldId id="258"/>
           </p14:sldIdLst>
         </p14:section>
-        <p14:section name="Hệ thống và kiểm thử" id="{2191bc9a-79cd-0a37-4b29-9d8305ea8d1a}">
+        <p14:section name="Hệ thống và kiểm thử" id="{2191BC9A-79CD-0A37-4B29-9D8305EA8D1A}">
           <p14:sldIdLst>
             <p14:sldId id="259"/>
             <p14:sldId id="260"/>
           </p14:sldIdLst>
         </p14:section>
-        <p14:section name="Kế hoạch kiểm thử" id="{277f953f-c330-8d22-53ea-bcbecd9414dd}">
+        <p14:section name="Kế hoạch kiểm thử" id="{277F953F-C330-8D22-53EA-BCBECD9414DD}">
           <p14:sldIdLst>
             <p14:sldId id="261"/>
           </p14:sldIdLst>
         </p14:section>
-        <p14:section name="Kết quả sơ bộ" id="{81ea8cc3-5232-1997-0356-52dca9ae153f}">
+        <p14:section name="Kết quả sơ bộ" id="{81EA8CC3-5232-1997-0356-52DCA9AE153F}">
           <p14:sldIdLst>
             <p14:sldId id="262"/>
           </p14:sldIdLst>
         </p14:section>
-        <p14:section name="Tiếp theo" id="{44ffd690-acca-92ca-a8ca-6b68fd45aa19}">
+        <p14:section name="Tiếp theo" id="{44FFD690-ACCA-92CA-A8CA-6B68FD45AA19}">
           <p14:sldIdLst>
             <p14:sldId id="263"/>
           </p14:sldIdLst>
@@ -177,234 +177,10 @@
           <a:chExt cx="0" cy="0"/>
         </a:xfrm>
       </p:grpSpPr>
-      <p:sp>
-        <p:nvSpPr>
-          <p:cNvPr id="2" name="Header Placeholder 1"/>
-          <p:cNvSpPr>
-            <a:spLocks noGrp="1"/>
-          </p:cNvSpPr>
-          <p:nvPr>
-            <p:ph type="hdr" sz="quarter"/>
-          </p:nvPr>
-        </p:nvSpPr>
-        <p:spPr>
-          <a:xfrm>
-            <a:off x="0" y="0"/>
-            <a:ext cx="2971800" cy="458788"/>
-          </a:xfrm>
-          <a:prstGeom prst="rect">
-            <a:avLst/>
-          </a:prstGeom>
-        </p:spPr>
-        <p:txBody>
-          <a:bodyPr vert="horz" lIns="91440" tIns="45720" rIns="91440" bIns="45720" rtlCol="0"/>
-          <a:lstStyle>
-            <a:lvl1pPr algn="l">
-              <a:defRPr sz="1200"/>
-            </a:lvl1pPr>
-          </a:lstStyle>
-          <a:p>
-            <a:endParaRPr lang="en-US"/>
-          </a:p>
-        </p:txBody>
-      </p:sp>
-      <p:sp>
-        <p:nvSpPr>
-          <p:cNvPr id="3" name="Date Placeholder 2"/>
-          <p:cNvSpPr>
-            <a:spLocks noGrp="1"/>
-          </p:cNvSpPr>
-          <p:nvPr>
-            <p:ph type="dt" idx="1"/>
-          </p:nvPr>
-        </p:nvSpPr>
-        <p:spPr>
-          <a:xfrm>
-            <a:off x="3884613" y="0"/>
-            <a:ext cx="2971800" cy="458788"/>
-          </a:xfrm>
-          <a:prstGeom prst="rect">
-            <a:avLst/>
-          </a:prstGeom>
-        </p:spPr>
-        <p:txBody>
-          <a:bodyPr vert="horz" lIns="91440" tIns="45720" rIns="91440" bIns="45720" rtlCol="0"/>
-          <a:lstStyle>
-            <a:lvl1pPr algn="r">
-              <a:defRPr sz="1200"/>
-            </a:lvl1pPr>
-          </a:lstStyle>
-          <a:p>
-            <a:fld id="{5282F153-3F37-0F45-9E97-73ACFA13230C}" type="datetimeFigureOut">
-              <a:rPr lang="en-US"/>
-              <a:t>7/23/19</a:t>
-            </a:fld>
-            <a:endParaRPr lang="en-US"/>
-          </a:p>
-        </p:txBody>
-      </p:sp>
-      <p:sp>
-        <p:nvSpPr>
-          <p:cNvPr id="4" name="Slide Image Placeholder 3"/>
-          <p:cNvSpPr>
-            <a:spLocks noGrp="1" noRot="1" noChangeAspect="1"/>
-          </p:cNvSpPr>
-          <p:nvPr>
-            <p:ph type="sldImg" idx="2"/>
-          </p:nvPr>
-        </p:nvSpPr>
-        <p:spPr>
-          <a:xfrm>
-            <a:off x="685800" y="1143000"/>
-            <a:ext cx="5486400" cy="3086100"/>
-          </a:xfrm>
-          <a:prstGeom prst="rect">
-            <a:avLst/>
-          </a:prstGeom>
-          <a:noFill/>
-          <a:ln w="12700">
-            <a:solidFill>
-              <a:prstClr val="black"/>
-            </a:solidFill>
-          </a:ln>
-        </p:spPr>
-        <p:txBody>
-          <a:bodyPr vert="horz" lIns="91440" tIns="45720" rIns="91440" bIns="45720" rtlCol="0" anchor="ctr"/>
-          <a:lstStyle/>
-          <a:p>
-            <a:endParaRPr lang="en-US"/>
-          </a:p>
-        </p:txBody>
-      </p:sp>
-      <p:sp>
-        <p:nvSpPr>
-          <p:cNvPr id="5" name="Notes Placeholder 4"/>
-          <p:cNvSpPr>
-            <a:spLocks noGrp="1"/>
-          </p:cNvSpPr>
-          <p:nvPr>
-            <p:ph type="body" sz="quarter" idx="3"/>
-          </p:nvPr>
-        </p:nvSpPr>
-        <p:spPr>
-          <a:xfrm>
-            <a:off x="685800" y="4400550"/>
-            <a:ext cx="5486400" cy="3600450"/>
-          </a:xfrm>
-          <a:prstGeom prst="rect">
-            <a:avLst/>
-          </a:prstGeom>
-        </p:spPr>
-        <p:txBody>
-          <a:bodyPr vert="horz" lIns="91440" tIns="45720" rIns="91440" bIns="45720" rtlCol="0"/>
-          <a:lstStyle/>
-          <a:p>
-            <a:pPr lvl="0"/>
-            <a:r>
-              <a:rPr lang="en-US"/>
-              <a:t>Click to edit Master text styles</a:t>
-            </a:r>
-          </a:p>
-          <a:p>
-            <a:pPr lvl="1"/>
-            <a:r>
-              <a:rPr lang="en-US"/>
-              <a:t>Second level</a:t>
-            </a:r>
-          </a:p>
-          <a:p>
-            <a:pPr lvl="2"/>
-            <a:r>
-              <a:rPr lang="en-US"/>
-              <a:t>Third level</a:t>
-            </a:r>
-          </a:p>
-          <a:p>
-            <a:pPr lvl="3"/>
-            <a:r>
-              <a:rPr lang="en-US"/>
-              <a:t>Fourth level</a:t>
-            </a:r>
-          </a:p>
-          <a:p>
-            <a:pPr lvl="4"/>
-            <a:r>
-              <a:rPr lang="en-US"/>
-              <a:t>Fifth level</a:t>
-            </a:r>
-          </a:p>
-        </p:txBody>
-      </p:sp>
-      <p:sp>
-        <p:nvSpPr>
-          <p:cNvPr id="6" name="Footer Placeholder 5"/>
-          <p:cNvSpPr>
-            <a:spLocks noGrp="1"/>
-          </p:cNvSpPr>
-          <p:nvPr>
-            <p:ph type="ftr" sz="quarter" idx="4"/>
-          </p:nvPr>
-        </p:nvSpPr>
-        <p:spPr>
-          <a:xfrm>
-            <a:off x="0" y="8685213"/>
-            <a:ext cx="2971800" cy="458787"/>
-          </a:xfrm>
-          <a:prstGeom prst="rect">
-            <a:avLst/>
-          </a:prstGeom>
-        </p:spPr>
-        <p:txBody>
-          <a:bodyPr vert="horz" lIns="91440" tIns="45720" rIns="91440" bIns="45720" rtlCol="0" anchor="b"/>
-          <a:lstStyle>
-            <a:lvl1pPr algn="l">
-              <a:defRPr sz="1200"/>
-            </a:lvl1pPr>
-          </a:lstStyle>
-          <a:p>
-            <a:endParaRPr lang="en-US"/>
-          </a:p>
-        </p:txBody>
-      </p:sp>
-      <p:sp>
-        <p:nvSpPr>
-          <p:cNvPr id="7" name="Slide Number Placeholder 6"/>
-          <p:cNvSpPr>
-            <a:spLocks noGrp="1"/>
-          </p:cNvSpPr>
-          <p:nvPr>
-            <p:ph type="sldNum" sz="quarter" idx="5"/>
-          </p:nvPr>
-        </p:nvSpPr>
-        <p:spPr>
-          <a:xfrm>
-            <a:off x="3884613" y="8685213"/>
-            <a:ext cx="2971800" cy="458787"/>
-          </a:xfrm>
-          <a:prstGeom prst="rect">
-            <a:avLst/>
-          </a:prstGeom>
-        </p:spPr>
-        <p:txBody>
-          <a:bodyPr vert="horz" lIns="91440" tIns="45720" rIns="91440" bIns="45720" rtlCol="0" anchor="b"/>
-          <a:lstStyle>
-            <a:lvl1pPr algn="r">
-              <a:defRPr sz="1200"/>
-            </a:lvl1pPr>
-          </a:lstStyle>
-          <a:p>
-            <a:fld id="{CE5E9CC1-C706-0F49-92D6-E571CC5EEA8F}" type="slidenum">
-              <a:rPr lang="en-US"/>
-              <a:t>‹#›</a:t>
-            </a:fld>
-            <a:endParaRPr lang="en-US"/>
-          </a:p>
-        </p:txBody>
-      </p:sp>
     </p:spTree>
     <p:extLst>
       <p:ext uri="{BB962C8B-B14F-4D97-AF65-F5344CB8AC3E}">
-        <p14:creationId xmlns:p14="http://schemas.microsoft.com/office/powerpoint/2010/main" val="1024086991"/>
+        <p14:creationId xmlns:p14="http://schemas.microsoft.com/office/powerpoint/2010/main" val="358684048"/>
       </p:ext>
     </p:extLst>
   </p:cSld>
@@ -552,7 +328,6 @@
               <a:rPr lang="en-US" dirty="0"/>
               <a:t>Giữa kỳ cần trình bày bốn thứ: demo hệ thống chạy, sơ đồ kiến trúc và tài liệu on-boarding, kế hoạch áp dụng kỹ thuật kiểm thử. Nhóm có thêm một kết quả thử nghiệm đầu tiên.</a:t>
             </a:r>
-            <a:endParaRPr lang="en-US" dirty="0"/>
           </a:p>
         </p:txBody>
       </p:sp>
@@ -640,7 +415,6 @@
               <a:rPr lang="en-US" dirty="0"/>
               <a:t>Đề tài đã đăng ký là R05-K15. Nhóm khóa phiên bản ở tag v6.2.0 để test chạy lại được. Phạm vi hẹp vào luồng booking theo lưu ý của giảng viên.</a:t>
             </a:r>
-            <a:endParaRPr lang="en-US" dirty="0"/>
           </a:p>
         </p:txBody>
       </p:sp>
@@ -728,7 +502,6 @@
               <a:rPr lang="en-US" dirty="0"/>
               <a:t>Mọi mục của Sprint 1 đã xong, và nhóm đã làm trước: harness 8 scenario đã chạy 10 vòng mỗi scenario kèm nhóm đối chứng tuần tự, đã phân tích nguyên nhân gốc. Giữa kỳ nhóm chỉ trình bày kết quả sơ bộ S1 và S2; kết quả đầy đủ dành cho buổi bảo vệ cuối kỳ. Còn lại: Playwright qua giao diện, hoàn thiện báo cáo, và chuẩn bị bảo vệ. Nói rõ phân vai và board Trello/Jira của nhóm.</a:t>
             </a:r>
-            <a:endParaRPr lang="en-US" dirty="0"/>
           </a:p>
         </p:txBody>
       </p:sp>
@@ -816,7 +589,6 @@
               <a:rPr lang="en-US" dirty="0"/>
               <a:t>Đây là phần kiến trúc rút gọn. Sơ đồ đầy đủ ở docs/diagrams/kien-truc.md. Điểm mấu chốt rút ra khi đọc code: các bước kiểm tra chỉ đọc, giữa kiểm tra và ghi không có khóa, nên đây là nơi nhóm kỳ vọng tìm ra race.</a:t>
             </a:r>
-            <a:endParaRPr lang="en-US" dirty="0"/>
           </a:p>
         </p:txBody>
       </p:sp>
@@ -904,7 +676,6 @@
               <a:rPr lang="en-US" dirty="0"/>
               <a:t>Tài liệu on-boarding gồm phiên bản, lệnh cài đặt, biến môi trường, seed data. Smoke test chạy ba luồng: đặt, đổi, hủy lịch. Trong demo, nhóm chạy lệnh npm run demo:midterm để chứng minh.</a:t>
             </a:r>
-            <a:endParaRPr lang="en-US" dirty="0"/>
           </a:p>
         </p:txBody>
       </p:sp>
@@ -992,7 +763,6 @@
               <a:rPr lang="en-US" dirty="0"/>
               <a:t>Đây là phần đề bài yêu cầu cho giữa kỳ: kế hoạch áp dụng kỹ thuật với phạm vi test, giả định và tiêu chí đánh giá. Oracle là điểm khác biệt của kiểm thử race: không tin mã HTTP mà kiểm dữ liệu thật trong CSDL.</a:t>
             </a:r>
-            <a:endParaRPr lang="en-US" dirty="0"/>
           </a:p>
         </p:txBody>
       </p:sp>
@@ -1080,7 +850,6 @@
               <a:rPr lang="en-US" dirty="0"/>
               <a:t>Kết quả sơ bộ: S1 đặt cùng slot PASS nhờ khóa idempotency. S2 đặt hai slot chồng lấn thì FAIL ở mọi vòng: host bị đặt chồng. Đây là lý do nhóm chọn kỹ thuật này. Nhóm đã chạy đủ 8 scenario; kết quả đầy đủ, nguyên nhân gốc và thí nghiệm khắc phục xin để dành cho buổi bảo vệ cuối kỳ. Con số 20/20 đến từ thí nghiệm riêng với 2 request, 20 vòng.</a:t>
             </a:r>
-            <a:endParaRPr lang="en-US" dirty="0"/>
           </a:p>
         </p:txBody>
       </p:sp>
@@ -1168,7 +937,6 @@
               <a:rPr lang="en-US" dirty="0"/>
               <a:t>Kế hoạch bốn giai đoạn đến bảo vệ; phần kiểm thử chính đã chạy xong nên thời gian còn lại dành cho kiểm chứng lại, hoàn thiện báo cáo và chuẩn bị bảo vệ. Rủi ro chính là race không tái hiện ổn định nên nhóm chạy nhiều vòng và báo tỉ lệ. Kết thúc phần báo cáo, mời thầy đặt câu hỏi.</a:t>
             </a:r>
-            <a:endParaRPr lang="en-US" dirty="0"/>
           </a:p>
         </p:txBody>
       </p:sp>
@@ -1246,6 +1014,7 @@
         <a:solidFill>
           <a:srgbClr val="F4F2EC"/>
         </a:solidFill>
+        <a:effectLst/>
       </p:bgPr>
     </p:bg>
     <p:spTree>
@@ -1265,9 +1034,11 @@
       <p:sp>
         <p:nvSpPr>
           <p:cNvPr id="2" name="Text 0"/>
-          <p:cNvSpPr/>
+          <p:cNvSpPr>
+            <a:spLocks noGrp="1"/>
+          </p:cNvSpPr>
           <p:nvPr>
-            <p:ph idx="100" type="title" hasCustomPrompt="1"/>
+            <p:ph type="title" idx="100" hasCustomPrompt="1"/>
           </p:nvPr>
         </p:nvSpPr>
         <p:spPr>
@@ -1284,7 +1055,7 @@
         <p:txBody>
           <a:bodyPr wrap="square" rtlCol="0"/>
           <a:lstStyle>
-            <a:lvl1pPr indent="0" marL="0">
+            <a:lvl1pPr marL="0" indent="0">
               <a:buNone/>
               <a:defRPr lang="en-US" sz="3400" b="1" dirty="0">
                 <a:solidFill>
@@ -1297,7 +1068,7 @@
             </a:lvl1pPr>
           </a:lstStyle>
           <a:p>
-            <a:pPr indent="0" marL="0">
+            <a:pPr marL="0" indent="0">
               <a:buNone/>
             </a:pPr>
             <a:endParaRPr lang="en-US" sz="3400" dirty="0"/>
@@ -1324,7 +1095,7 @@
           </a:prstGeom>
           <a:extLst>
             <a:ext uri="{C572A759-6A51-4108-AA02-DFA0A04FC94B}">
-              <ma14:wrappingTextBoxFlag xmlns:ma14="http://schemas.microsoft.com/office/mac/drawingml/2011/main" val="0"/>
+              <ma14:wrappingTextBoxFlag xmlns:ma14="http://schemas.microsoft.com/office/mac/drawingml/2011/main" xmlns="" val="0"/>
             </a:ext>
           </a:extLst>
         </p:spPr>
@@ -1345,8 +1116,8 @@
           <a:p>
             <a:pPr algn="r"/>
             <a:fld id="{F7021451-1387-4CA6-816F-3879F97B5CBC}" type="slidenum">
-              <a:rPr b="0" lang="en-US"/>
-              <a:t>1002</a:t>
+              <a:rPr lang="en-US" b="0"/>
+              <a:t>‹#›</a:t>
             </a:fld>
             <a:endParaRPr lang="en-US"/>
           </a:p>
@@ -1368,6 +1139,7 @@
         <a:solidFill>
           <a:srgbClr val="12202B"/>
         </a:solidFill>
+        <a:effectLst/>
       </p:bgPr>
     </p:bg>
     <p:spTree>
@@ -1387,9 +1159,11 @@
       <p:sp>
         <p:nvSpPr>
           <p:cNvPr id="2" name="Text 0"/>
-          <p:cNvSpPr/>
+          <p:cNvSpPr>
+            <a:spLocks noGrp="1"/>
+          </p:cNvSpPr>
           <p:nvPr>
-            <p:ph idx="100" type="title" hasCustomPrompt="1"/>
+            <p:ph type="title" idx="100" hasCustomPrompt="1"/>
           </p:nvPr>
         </p:nvSpPr>
         <p:spPr>
@@ -1406,7 +1180,7 @@
         <p:txBody>
           <a:bodyPr wrap="square" rtlCol="0"/>
           <a:lstStyle>
-            <a:lvl1pPr indent="0" marL="0">
+            <a:lvl1pPr marL="0" indent="0">
               <a:buNone/>
               <a:defRPr lang="en-US" sz="3400" b="1" dirty="0">
                 <a:solidFill>
@@ -1419,7 +1193,7 @@
             </a:lvl1pPr>
           </a:lstStyle>
           <a:p>
-            <a:pPr indent="0" marL="0">
+            <a:pPr marL="0" indent="0">
               <a:buNone/>
             </a:pPr>
             <a:endParaRPr lang="en-US" sz="3400" dirty="0"/>
@@ -1446,7 +1220,7 @@
           </a:prstGeom>
           <a:extLst>
             <a:ext uri="{C572A759-6A51-4108-AA02-DFA0A04FC94B}">
-              <ma14:wrappingTextBoxFlag xmlns:ma14="http://schemas.microsoft.com/office/mac/drawingml/2011/main" val="0"/>
+              <ma14:wrappingTextBoxFlag xmlns:ma14="http://schemas.microsoft.com/office/mac/drawingml/2011/main" xmlns="" val="0"/>
             </a:ext>
           </a:extLst>
         </p:spPr>
@@ -1467,8 +1241,8 @@
           <a:p>
             <a:pPr algn="r"/>
             <a:fld id="{F7021451-1387-4CA6-816F-3879F97B5CBC}" type="slidenum">
-              <a:rPr b="0" lang="en-US"/>
-              <a:t>1003</a:t>
+              <a:rPr lang="en-US" b="0"/>
+              <a:t>‹#›</a:t>
             </a:fld>
             <a:endParaRPr lang="en-US"/>
           </a:p>
@@ -1490,6 +1264,7 @@
         <a:solidFill>
           <a:srgbClr val="12202B"/>
         </a:solidFill>
+        <a:effectLst/>
       </p:bgPr>
     </p:bg>
     <p:spTree>
@@ -1517,6 +1292,11 @@
 <file path=ppt/slideMasters/slideMaster1.xml><?xml version="1.0" encoding="utf-8"?>
 <p:sldMaster xmlns:a="http://schemas.openxmlformats.org/drawingml/2006/main" xmlns:r="http://schemas.openxmlformats.org/officeDocument/2006/relationships" xmlns:p="http://schemas.openxmlformats.org/presentationml/2006/main">
   <p:cSld>
+    <p:bg>
+      <p:bgRef idx="1001">
+        <a:schemeClr val="bg1"/>
+      </p:bgRef>
+    </p:bg>
     <p:spTree>
       <p:nvGrpSpPr>
         <p:cNvPr id="1" name=""/>
@@ -1551,7 +1331,7 @@
           </a:prstGeom>
           <a:extLst>
             <a:ext uri="{C572A759-6A51-4108-AA02-DFA0A04FC94B}">
-              <ma14:wrappingTextBoxFlag xmlns:ma14="http://schemas.microsoft.com/office/mac/drawingml/2011/main" val="0"/>
+              <ma14:wrappingTextBoxFlag xmlns:ma14="http://schemas.microsoft.com/office/mac/drawingml/2011/main" xmlns="" val="0"/>
             </a:ext>
           </a:extLst>
         </p:spPr>
@@ -1572,8 +1352,8 @@
           <a:p>
             <a:pPr algn="r"/>
             <a:fld id="{F7021451-1387-4CA6-816F-3879F97B5CBC}" type="slidenum">
-              <a:rPr b="0" lang="en-US"/>
-              <a:t>null</a:t>
+              <a:rPr lang="en-US" b="0"/>
+              <a:t>‹#›</a:t>
             </a:fld>
             <a:endParaRPr lang="en-US"/>
           </a:p>
@@ -1880,11 +1660,11 @@
           <a:bodyPr wrap="square" lIns="0" tIns="0" rIns="0" bIns="0" rtlCol="0" anchor="ctr"/>
           <a:lstStyle/>
           <a:p>
-            <a:pPr indent="0" marL="0">
+            <a:pPr marL="0" indent="0">
               <a:buNone/>
             </a:pPr>
             <a:r>
-              <a:rPr lang="en-US" sz="1600" b="1" spc="300" kern="0" dirty="0">
+              <a:rPr lang="en-US" sz="1600" b="1" kern="0" spc="300" dirty="0">
                 <a:solidFill>
                   <a:srgbClr val="E07B39"/>
                 </a:solidFill>
@@ -1919,7 +1699,7 @@
           <a:bodyPr wrap="square" lIns="0" tIns="0" rIns="0" bIns="0" rtlCol="0" anchor="t"/>
           <a:lstStyle/>
           <a:p>
-            <a:pPr indent="0" marL="0">
+            <a:pPr marL="0" indent="0">
               <a:buNone/>
             </a:pPr>
             <a:r>
@@ -1936,7 +1716,7 @@
             <a:endParaRPr lang="en-US" sz="5400" dirty="0"/>
           </a:p>
           <a:p>
-            <a:pPr indent="0" marL="0">
+            <a:pPr marL="0" indent="0">
               <a:buNone/>
             </a:pPr>
             <a:r>
@@ -1975,7 +1755,7 @@
           <a:bodyPr wrap="square" lIns="0" tIns="0" rIns="0" bIns="0" rtlCol="0" anchor="t"/>
           <a:lstStyle/>
           <a:p>
-            <a:pPr indent="0" marL="0">
+            <a:pPr marL="0" indent="0">
               <a:buNone/>
             </a:pPr>
             <a:r>
@@ -2014,7 +1794,7 @@
           <a:bodyPr wrap="square" lIns="0" tIns="0" rIns="0" bIns="0" rtlCol="0" anchor="ctr"/>
           <a:lstStyle/>
           <a:p>
-            <a:pPr indent="0" marL="0">
+            <a:pPr marL="0" indent="0">
               <a:buNone/>
             </a:pPr>
             <a:r>
@@ -2031,7 +1811,7 @@
             <a:endParaRPr lang="en-US" sz="1600" dirty="0"/>
           </a:p>
           <a:p>
-            <a:pPr indent="0" marL="0">
+            <a:pPr marL="0" indent="0">
               <a:buNone/>
             </a:pPr>
             <a:r>
@@ -2070,11 +1850,11 @@
           <a:bodyPr wrap="square" lIns="0" tIns="0" rIns="0" bIns="0" rtlCol="0" anchor="b"/>
           <a:lstStyle/>
           <a:p>
-            <a:pPr algn="r" indent="0" marL="0">
+            <a:pPr marL="0" indent="0" algn="r">
               <a:buNone/>
             </a:pPr>
             <a:r>
-              <a:rPr lang="en-US" sz="1600" dirty="0">
+              <a:rPr lang="en-US" sz="1600" dirty="0" err="1">
                 <a:solidFill>
                   <a:srgbClr val="B8C6D2"/>
                 </a:solidFill>
@@ -2082,12 +1862,23 @@
                 <a:ea typeface="Calibri" pitchFamily="34" charset="-122"/>
                 <a:cs typeface="Calibri" pitchFamily="34" charset="-120"/>
               </a:rPr>
-              <a:t>Nhóm 13</a:t>
+              <a:t>Nhóm</a:t>
+            </a:r>
+            <a:r>
+              <a:rPr lang="en-US" sz="1600">
+                <a:solidFill>
+                  <a:srgbClr val="B8C6D2"/>
+                </a:solidFill>
+                <a:latin typeface="Calibri" pitchFamily="34" charset="0"/>
+                <a:ea typeface="Calibri" pitchFamily="34" charset="-122"/>
+                <a:cs typeface="Calibri" pitchFamily="34" charset="-120"/>
+              </a:rPr>
+              <a:t> 14:</a:t>
             </a:r>
             <a:endParaRPr lang="en-US" sz="1600" dirty="0"/>
           </a:p>
           <a:p>
-            <a:pPr algn="r" indent="0" marL="0">
+            <a:pPr marL="0" indent="0" algn="r">
               <a:buNone/>
             </a:pPr>
             <a:r>
@@ -2104,7 +1895,7 @@
             <a:endParaRPr lang="en-US" sz="1600" dirty="0"/>
           </a:p>
           <a:p>
-            <a:pPr algn="r" indent="0" marL="0">
+            <a:pPr marL="0" indent="0" algn="r">
               <a:buNone/>
             </a:pPr>
             <a:r>
@@ -2121,7 +1912,7 @@
             <a:endParaRPr lang="en-US" sz="1600" dirty="0"/>
           </a:p>
           <a:p>
-            <a:pPr algn="r" indent="0" marL="0">
+            <a:pPr marL="0" indent="0" algn="r">
               <a:buNone/>
             </a:pPr>
             <a:r>
@@ -2138,7 +1929,7 @@
             <a:endParaRPr lang="en-US" sz="1600" dirty="0"/>
           </a:p>
           <a:p>
-            <a:pPr algn="r" indent="0" marL="0">
+            <a:pPr marL="0" indent="0" algn="r">
               <a:buNone/>
             </a:pPr>
             <a:r>
@@ -2202,11 +1993,11 @@
           <a:bodyPr wrap="square" lIns="0" tIns="0" rIns="0" bIns="0" rtlCol="0" anchor="ctr"/>
           <a:lstStyle/>
           <a:p>
-            <a:pPr indent="0" marL="0">
+            <a:pPr marL="0" indent="0">
               <a:buNone/>
             </a:pPr>
             <a:r>
-              <a:rPr lang="en-US" sz="1300" b="1" spc="200" kern="0" dirty="0">
+              <a:rPr lang="en-US" sz="1300" b="1" kern="0" spc="200" dirty="0">
                 <a:solidFill>
                   <a:srgbClr val="B4531A"/>
                 </a:solidFill>
@@ -2223,9 +2014,11 @@
       <p:sp>
         <p:nvSpPr>
           <p:cNvPr id="3" name="Text 0"/>
-          <p:cNvSpPr/>
+          <p:cNvSpPr>
+            <a:spLocks noGrp="1"/>
+          </p:cNvSpPr>
           <p:nvPr>
-            <p:ph idx="100" type="title" hasCustomPrompt="1"/>
+            <p:ph type="title" idx="100" hasCustomPrompt="1"/>
           </p:nvPr>
         </p:nvSpPr>
         <p:spPr>
@@ -2243,7 +2036,7 @@
           <a:bodyPr wrap="square" lIns="0" tIns="0" rIns="0" bIns="0" rtlCol="0" anchor="t"/>
           <a:lstStyle/>
           <a:p>
-            <a:pPr indent="0" marL="0">
+            <a:pPr marL="0" indent="0">
               <a:buNone/>
             </a:pPr>
             <a:r>
@@ -2287,6 +2080,13 @@
             <a:prstDash val="solid"/>
           </a:ln>
         </p:spPr>
+        <p:txBody>
+          <a:bodyPr/>
+          <a:lstStyle/>
+          <a:p>
+            <a:endParaRPr lang="en-VN"/>
+          </a:p>
+        </p:txBody>
       </p:sp>
       <p:sp>
         <p:nvSpPr>
@@ -2309,7 +2109,7 @@
           <a:bodyPr wrap="square" lIns="0" tIns="0" rIns="0" bIns="0" rtlCol="0" anchor="ctr"/>
           <a:lstStyle/>
           <a:p>
-            <a:pPr indent="0" marL="0">
+            <a:pPr marL="0" indent="0">
               <a:buNone/>
             </a:pPr>
             <a:r>
@@ -2348,7 +2148,7 @@
           <a:bodyPr wrap="square" lIns="0" tIns="0" rIns="0" bIns="0" rtlCol="0" anchor="ctr"/>
           <a:lstStyle/>
           <a:p>
-            <a:pPr indent="0" marL="0">
+            <a:pPr marL="0" indent="0">
               <a:buNone/>
             </a:pPr>
             <a:r>
@@ -2387,7 +2187,7 @@
           <a:bodyPr wrap="square" lIns="0" tIns="0" rIns="0" bIns="0" rtlCol="0" anchor="t"/>
           <a:lstStyle/>
           <a:p>
-            <a:pPr indent="0" marL="0">
+            <a:pPr marL="0" indent="0">
               <a:buNone/>
             </a:pPr>
             <a:r>
@@ -2431,6 +2231,13 @@
             <a:prstDash val="solid"/>
           </a:ln>
         </p:spPr>
+        <p:txBody>
+          <a:bodyPr/>
+          <a:lstStyle/>
+          <a:p>
+            <a:endParaRPr lang="en-VN"/>
+          </a:p>
+        </p:txBody>
       </p:sp>
       <p:sp>
         <p:nvSpPr>
@@ -2453,7 +2260,7 @@
           <a:bodyPr wrap="square" lIns="0" tIns="0" rIns="0" bIns="0" rtlCol="0" anchor="ctr"/>
           <a:lstStyle/>
           <a:p>
-            <a:pPr indent="0" marL="0">
+            <a:pPr marL="0" indent="0">
               <a:buNone/>
             </a:pPr>
             <a:r>
@@ -2492,7 +2299,7 @@
           <a:bodyPr wrap="square" lIns="0" tIns="0" rIns="0" bIns="0" rtlCol="0" anchor="ctr"/>
           <a:lstStyle/>
           <a:p>
-            <a:pPr indent="0" marL="0">
+            <a:pPr marL="0" indent="0">
               <a:buNone/>
             </a:pPr>
             <a:r>
@@ -2531,7 +2338,7 @@
           <a:bodyPr wrap="square" lIns="0" tIns="0" rIns="0" bIns="0" rtlCol="0" anchor="t"/>
           <a:lstStyle/>
           <a:p>
-            <a:pPr indent="0" marL="0">
+            <a:pPr marL="0" indent="0">
               <a:buNone/>
             </a:pPr>
             <a:r>
@@ -2575,6 +2382,13 @@
             <a:prstDash val="solid"/>
           </a:ln>
         </p:spPr>
+        <p:txBody>
+          <a:bodyPr/>
+          <a:lstStyle/>
+          <a:p>
+            <a:endParaRPr lang="en-VN"/>
+          </a:p>
+        </p:txBody>
       </p:sp>
       <p:sp>
         <p:nvSpPr>
@@ -2597,7 +2411,7 @@
           <a:bodyPr wrap="square" lIns="0" tIns="0" rIns="0" bIns="0" rtlCol="0" anchor="ctr"/>
           <a:lstStyle/>
           <a:p>
-            <a:pPr indent="0" marL="0">
+            <a:pPr marL="0" indent="0">
               <a:buNone/>
             </a:pPr>
             <a:r>
@@ -2636,7 +2450,7 @@
           <a:bodyPr wrap="square" lIns="0" tIns="0" rIns="0" bIns="0" rtlCol="0" anchor="ctr"/>
           <a:lstStyle/>
           <a:p>
-            <a:pPr indent="0" marL="0">
+            <a:pPr marL="0" indent="0">
               <a:buNone/>
             </a:pPr>
             <a:r>
@@ -2675,7 +2489,7 @@
           <a:bodyPr wrap="square" lIns="0" tIns="0" rIns="0" bIns="0" rtlCol="0" anchor="t"/>
           <a:lstStyle/>
           <a:p>
-            <a:pPr indent="0" marL="0">
+            <a:pPr marL="0" indent="0">
               <a:buNone/>
             </a:pPr>
             <a:r>
@@ -2714,7 +2528,7 @@
           <a:bodyPr wrap="square" lIns="0" tIns="0" rIns="0" bIns="0" rtlCol="0" anchor="ctr"/>
           <a:lstStyle/>
           <a:p>
-            <a:pPr indent="0" marL="0">
+            <a:pPr marL="0" indent="0">
               <a:buNone/>
             </a:pPr>
             <a:r>
@@ -2752,7 +2566,7 @@
           </a:prstGeom>
           <a:extLst>
             <a:ext uri="{C572A759-6A51-4108-AA02-DFA0A04FC94B}">
-              <ma14:wrappingTextBoxFlag xmlns:ma14="http://schemas.microsoft.com/office/mac/drawingml/2011/main" val="0"/>
+              <ma14:wrappingTextBoxFlag xmlns:ma14="http://schemas.microsoft.com/office/mac/drawingml/2011/main" xmlns="" val="0"/>
             </a:ext>
           </a:extLst>
         </p:spPr>
@@ -2773,7 +2587,7 @@
           <a:p>
             <a:pPr algn="r"/>
             <a:fld id="{F7021451-1387-4CA6-816F-3879F97B5CBC}" type="slidenum">
-              <a:rPr b="0" lang="en-US"/>
+              <a:rPr lang="en-US" b="0"/>
               <a:t>2</a:t>
             </a:fld>
             <a:endParaRPr lang="en-US"/>
@@ -2826,11 +2640,11 @@
           <a:bodyPr wrap="square" lIns="0" tIns="0" rIns="0" bIns="0" rtlCol="0" anchor="ctr"/>
           <a:lstStyle/>
           <a:p>
-            <a:pPr indent="0" marL="0">
+            <a:pPr marL="0" indent="0">
               <a:buNone/>
             </a:pPr>
             <a:r>
-              <a:rPr lang="en-US" sz="1300" b="1" spc="200" kern="0" dirty="0">
+              <a:rPr lang="en-US" sz="1300" b="1" kern="0" spc="200" dirty="0">
                 <a:solidFill>
                   <a:srgbClr val="B4531A"/>
                 </a:solidFill>
@@ -2847,9 +2661,11 @@
       <p:sp>
         <p:nvSpPr>
           <p:cNvPr id="3" name="Text 0"/>
-          <p:cNvSpPr/>
+          <p:cNvSpPr>
+            <a:spLocks noGrp="1"/>
+          </p:cNvSpPr>
           <p:nvPr>
-            <p:ph idx="100" type="title" hasCustomPrompt="1"/>
+            <p:ph type="title" idx="100" hasCustomPrompt="1"/>
           </p:nvPr>
         </p:nvSpPr>
         <p:spPr>
@@ -2867,7 +2683,7 @@
           <a:bodyPr wrap="square" lIns="0" tIns="0" rIns="0" bIns="0" rtlCol="0" anchor="t"/>
           <a:lstStyle/>
           <a:p>
-            <a:pPr indent="0" marL="0">
+            <a:pPr marL="0" indent="0">
               <a:buNone/>
             </a:pPr>
             <a:r>
@@ -2901,17 +2717,41 @@
         </p:nvGraphicFramePr>
         <p:xfrm>
           <a:off x="640080" y="1600200"/>
-          <a:ext cx="10908792" cy="914400"/>
+          <a:ext cx="10908792" cy="4255008"/>
         </p:xfrm>
         <a:graphic>
           <a:graphicData uri="http://schemas.openxmlformats.org/drawingml/2006/table">
             <a:tbl>
               <a:tblPr/>
               <a:tblGrid>
-                <a:gridCol w="5394960"/>
-                <a:gridCol w="1097280"/>
-                <a:gridCol w="1371600"/>
-                <a:gridCol w="3044952"/>
+                <a:gridCol w="5394960">
+                  <a:extLst>
+                    <a:ext uri="{9D8B030D-6E8A-4147-A177-3AD203B41FA5}">
+                      <a16:colId xmlns:a16="http://schemas.microsoft.com/office/drawing/2014/main" val="20000"/>
+                    </a:ext>
+                  </a:extLst>
+                </a:gridCol>
+                <a:gridCol w="1097280">
+                  <a:extLst>
+                    <a:ext uri="{9D8B030D-6E8A-4147-A177-3AD203B41FA5}">
+                      <a16:colId xmlns:a16="http://schemas.microsoft.com/office/drawing/2014/main" val="20001"/>
+                    </a:ext>
+                  </a:extLst>
+                </a:gridCol>
+                <a:gridCol w="1371600">
+                  <a:extLst>
+                    <a:ext uri="{9D8B030D-6E8A-4147-A177-3AD203B41FA5}">
+                      <a16:colId xmlns:a16="http://schemas.microsoft.com/office/drawing/2014/main" val="20002"/>
+                    </a:ext>
+                  </a:extLst>
+                </a:gridCol>
+                <a:gridCol w="3044952">
+                  <a:extLst>
+                    <a:ext uri="{9D8B030D-6E8A-4147-A177-3AD203B41FA5}">
+                      <a16:colId xmlns:a16="http://schemas.microsoft.com/office/drawing/2014/main" val="20003"/>
+                    </a:ext>
+                  </a:extLst>
+                </a:gridCol>
               </a:tblGrid>
               <a:tr h="420624">
                 <a:tc>
@@ -2919,7 +2759,7 @@
                     <a:bodyPr/>
                     <a:lstStyle/>
                     <a:p>
-                      <a:pPr indent="0" marL="0">
+                      <a:pPr marL="0" indent="0">
                         <a:buNone/>
                       </a:pPr>
                       <a:r>
@@ -2940,7 +2780,7 @@
                       </a:endParaRPr>
                     </a:p>
                   </a:txBody>
-                  <a:tcPr marL="91440" marR="91440" marT="36576" marB="36576" anchor="ctr">
+                  <a:tcPr marT="36576" marB="36576" anchor="ctr">
                     <a:lnL w="9525" cap="flat" cmpd="sng" algn="ctr">
                       <a:solidFill>
                         <a:srgbClr val="DAD6CC"/>
@@ -2987,7 +2827,7 @@
                     <a:bodyPr/>
                     <a:lstStyle/>
                     <a:p>
-                      <a:pPr indent="0" marL="0">
+                      <a:pPr marL="0" indent="0">
                         <a:buNone/>
                       </a:pPr>
                       <a:r>
@@ -3008,7 +2848,7 @@
                       </a:endParaRPr>
                     </a:p>
                   </a:txBody>
-                  <a:tcPr marL="91440" marR="91440" marT="36576" marB="36576" anchor="ctr">
+                  <a:tcPr marT="36576" marB="36576" anchor="ctr">
                     <a:lnL w="9525" cap="flat" cmpd="sng" algn="ctr">
                       <a:solidFill>
                         <a:srgbClr val="DAD6CC"/>
@@ -3055,7 +2895,7 @@
                     <a:bodyPr/>
                     <a:lstStyle/>
                     <a:p>
-                      <a:pPr indent="0" marL="0">
+                      <a:pPr marL="0" indent="0">
                         <a:buNone/>
                       </a:pPr>
                       <a:r>
@@ -3076,7 +2916,7 @@
                       </a:endParaRPr>
                     </a:p>
                   </a:txBody>
-                  <a:tcPr marL="91440" marR="91440" marT="36576" marB="36576" anchor="ctr">
+                  <a:tcPr marT="36576" marB="36576" anchor="ctr">
                     <a:lnL w="9525" cap="flat" cmpd="sng" algn="ctr">
                       <a:solidFill>
                         <a:srgbClr val="DAD6CC"/>
@@ -3123,7 +2963,7 @@
                     <a:bodyPr/>
                     <a:lstStyle/>
                     <a:p>
-                      <a:pPr indent="0" marL="0">
+                      <a:pPr marL="0" indent="0">
                         <a:buNone/>
                       </a:pPr>
                       <a:r>
@@ -3144,7 +2984,7 @@
                       </a:endParaRPr>
                     </a:p>
                   </a:txBody>
-                  <a:tcPr marL="91440" marR="91440" marT="36576" marB="36576" anchor="ctr">
+                  <a:tcPr marT="36576" marB="36576" anchor="ctr">
                     <a:lnL w="9525" cap="flat" cmpd="sng" algn="ctr">
                       <a:solidFill>
                         <a:srgbClr val="DAD6CC"/>
@@ -3186,6 +3026,11 @@
                     </a:solidFill>
                   </a:tcPr>
                 </a:tc>
+                <a:extLst>
+                  <a:ext uri="{0D108BD9-81ED-4DB2-BD59-A6C34878D82A}">
+                    <a16:rowId xmlns:a16="http://schemas.microsoft.com/office/drawing/2014/main" val="10000"/>
+                  </a:ext>
+                </a:extLst>
               </a:tr>
               <a:tr h="420624">
                 <a:tc>
@@ -3193,7 +3038,7 @@
                     <a:bodyPr/>
                     <a:lstStyle/>
                     <a:p>
-                      <a:pPr indent="0" marL="0">
+                      <a:pPr marL="0" indent="0">
                         <a:buNone/>
                       </a:pPr>
                       <a:r>
@@ -3214,7 +3059,7 @@
                       </a:endParaRPr>
                     </a:p>
                   </a:txBody>
-                  <a:tcPr marL="91440" marR="91440" marT="36576" marB="36576" anchor="ctr">
+                  <a:tcPr marT="36576" marB="36576" anchor="ctr">
                     <a:lnL w="9525" cap="flat" cmpd="sng" algn="ctr">
                       <a:solidFill>
                         <a:srgbClr val="DAD6CC"/>
@@ -3261,7 +3106,7 @@
                     <a:bodyPr/>
                     <a:lstStyle/>
                     <a:p>
-                      <a:pPr indent="0" marL="0">
+                      <a:pPr marL="0" indent="0">
                         <a:buNone/>
                       </a:pPr>
                       <a:r>
@@ -3282,7 +3127,7 @@
                       </a:endParaRPr>
                     </a:p>
                   </a:txBody>
-                  <a:tcPr marL="91440" marR="91440" marT="36576" marB="36576" anchor="ctr">
+                  <a:tcPr marT="36576" marB="36576" anchor="ctr">
                     <a:lnL w="9525" cap="flat" cmpd="sng" algn="ctr">
                       <a:solidFill>
                         <a:srgbClr val="DAD6CC"/>
@@ -3329,7 +3174,7 @@
                     <a:bodyPr/>
                     <a:lstStyle/>
                     <a:p>
-                      <a:pPr indent="0" marL="0">
+                      <a:pPr marL="0" indent="0">
                         <a:buNone/>
                       </a:pPr>
                       <a:r>
@@ -3350,7 +3195,7 @@
                       </a:endParaRPr>
                     </a:p>
                   </a:txBody>
-                  <a:tcPr marL="91440" marR="91440" marT="36576" marB="36576" anchor="ctr">
+                  <a:tcPr marT="36576" marB="36576" anchor="ctr">
                     <a:lnL w="9525" cap="flat" cmpd="sng" algn="ctr">
                       <a:solidFill>
                         <a:srgbClr val="DAD6CC"/>
@@ -3397,7 +3242,7 @@
                     <a:bodyPr/>
                     <a:lstStyle/>
                     <a:p>
-                      <a:pPr indent="0" marL="0">
+                      <a:pPr marL="0" indent="0">
                         <a:buNone/>
                       </a:pPr>
                       <a:r>
@@ -3418,7 +3263,7 @@
                       </a:endParaRPr>
                     </a:p>
                   </a:txBody>
-                  <a:tcPr marL="91440" marR="91440" marT="36576" marB="36576" anchor="ctr">
+                  <a:tcPr marT="36576" marB="36576" anchor="ctr">
                     <a:lnL w="9525" cap="flat" cmpd="sng" algn="ctr">
                       <a:solidFill>
                         <a:srgbClr val="DAD6CC"/>
@@ -3460,6 +3305,11 @@
                     </a:solidFill>
                   </a:tcPr>
                 </a:tc>
+                <a:extLst>
+                  <a:ext uri="{0D108BD9-81ED-4DB2-BD59-A6C34878D82A}">
+                    <a16:rowId xmlns:a16="http://schemas.microsoft.com/office/drawing/2014/main" val="10001"/>
+                  </a:ext>
+                </a:extLst>
               </a:tr>
               <a:tr h="420624">
                 <a:tc>
@@ -3467,7 +3317,7 @@
                     <a:bodyPr/>
                     <a:lstStyle/>
                     <a:p>
-                      <a:pPr indent="0" marL="0">
+                      <a:pPr marL="0" indent="0">
                         <a:buNone/>
                       </a:pPr>
                       <a:r>
@@ -3488,7 +3338,7 @@
                       </a:endParaRPr>
                     </a:p>
                   </a:txBody>
-                  <a:tcPr marL="91440" marR="91440" marT="36576" marB="36576" anchor="ctr">
+                  <a:tcPr marT="36576" marB="36576" anchor="ctr">
                     <a:lnL w="9525" cap="flat" cmpd="sng" algn="ctr">
                       <a:solidFill>
                         <a:srgbClr val="DAD6CC"/>
@@ -3535,7 +3385,7 @@
                     <a:bodyPr/>
                     <a:lstStyle/>
                     <a:p>
-                      <a:pPr indent="0" marL="0">
+                      <a:pPr marL="0" indent="0">
                         <a:buNone/>
                       </a:pPr>
                       <a:r>
@@ -3556,7 +3406,7 @@
                       </a:endParaRPr>
                     </a:p>
                   </a:txBody>
-                  <a:tcPr marL="91440" marR="91440" marT="36576" marB="36576" anchor="ctr">
+                  <a:tcPr marT="36576" marB="36576" anchor="ctr">
                     <a:lnL w="9525" cap="flat" cmpd="sng" algn="ctr">
                       <a:solidFill>
                         <a:srgbClr val="DAD6CC"/>
@@ -3603,7 +3453,7 @@
                     <a:bodyPr/>
                     <a:lstStyle/>
                     <a:p>
-                      <a:pPr indent="0" marL="0">
+                      <a:pPr marL="0" indent="0">
                         <a:buNone/>
                       </a:pPr>
                       <a:r>
@@ -3624,7 +3474,7 @@
                       </a:endParaRPr>
                     </a:p>
                   </a:txBody>
-                  <a:tcPr marL="91440" marR="91440" marT="36576" marB="36576" anchor="ctr">
+                  <a:tcPr marT="36576" marB="36576" anchor="ctr">
                     <a:lnL w="9525" cap="flat" cmpd="sng" algn="ctr">
                       <a:solidFill>
                         <a:srgbClr val="DAD6CC"/>
@@ -3671,7 +3521,7 @@
                     <a:bodyPr/>
                     <a:lstStyle/>
                     <a:p>
-                      <a:pPr indent="0" marL="0">
+                      <a:pPr marL="0" indent="0">
                         <a:buNone/>
                       </a:pPr>
                       <a:r>
@@ -3692,7 +3542,7 @@
                       </a:endParaRPr>
                     </a:p>
                   </a:txBody>
-                  <a:tcPr marL="91440" marR="91440" marT="36576" marB="36576" anchor="ctr">
+                  <a:tcPr marT="36576" marB="36576" anchor="ctr">
                     <a:lnL w="9525" cap="flat" cmpd="sng" algn="ctr">
                       <a:solidFill>
                         <a:srgbClr val="DAD6CC"/>
@@ -3734,6 +3584,11 @@
                     </a:solidFill>
                   </a:tcPr>
                 </a:tc>
+                <a:extLst>
+                  <a:ext uri="{0D108BD9-81ED-4DB2-BD59-A6C34878D82A}">
+                    <a16:rowId xmlns:a16="http://schemas.microsoft.com/office/drawing/2014/main" val="10002"/>
+                  </a:ext>
+                </a:extLst>
               </a:tr>
               <a:tr h="420624">
                 <a:tc>
@@ -3741,7 +3596,7 @@
                     <a:bodyPr/>
                     <a:lstStyle/>
                     <a:p>
-                      <a:pPr indent="0" marL="0">
+                      <a:pPr marL="0" indent="0">
                         <a:buNone/>
                       </a:pPr>
                       <a:r>
@@ -3762,7 +3617,7 @@
                       </a:endParaRPr>
                     </a:p>
                   </a:txBody>
-                  <a:tcPr marL="91440" marR="91440" marT="36576" marB="36576" anchor="ctr">
+                  <a:tcPr marT="36576" marB="36576" anchor="ctr">
                     <a:lnL w="9525" cap="flat" cmpd="sng" algn="ctr">
                       <a:solidFill>
                         <a:srgbClr val="DAD6CC"/>
@@ -3809,7 +3664,7 @@
                     <a:bodyPr/>
                     <a:lstStyle/>
                     <a:p>
-                      <a:pPr indent="0" marL="0">
+                      <a:pPr marL="0" indent="0">
                         <a:buNone/>
                       </a:pPr>
                       <a:r>
@@ -3830,7 +3685,7 @@
                       </a:endParaRPr>
                     </a:p>
                   </a:txBody>
-                  <a:tcPr marL="91440" marR="91440" marT="36576" marB="36576" anchor="ctr">
+                  <a:tcPr marT="36576" marB="36576" anchor="ctr">
                     <a:lnL w="9525" cap="flat" cmpd="sng" algn="ctr">
                       <a:solidFill>
                         <a:srgbClr val="DAD6CC"/>
@@ -3877,7 +3732,7 @@
                     <a:bodyPr/>
                     <a:lstStyle/>
                     <a:p>
-                      <a:pPr indent="0" marL="0">
+                      <a:pPr marL="0" indent="0">
                         <a:buNone/>
                       </a:pPr>
                       <a:r>
@@ -3898,7 +3753,7 @@
                       </a:endParaRPr>
                     </a:p>
                   </a:txBody>
-                  <a:tcPr marL="91440" marR="91440" marT="36576" marB="36576" anchor="ctr">
+                  <a:tcPr marT="36576" marB="36576" anchor="ctr">
                     <a:lnL w="9525" cap="flat" cmpd="sng" algn="ctr">
                       <a:solidFill>
                         <a:srgbClr val="DAD6CC"/>
@@ -3945,7 +3800,7 @@
                     <a:bodyPr/>
                     <a:lstStyle/>
                     <a:p>
-                      <a:pPr indent="0" marL="0">
+                      <a:pPr marL="0" indent="0">
                         <a:buNone/>
                       </a:pPr>
                       <a:r>
@@ -3966,7 +3821,7 @@
                       </a:endParaRPr>
                     </a:p>
                   </a:txBody>
-                  <a:tcPr marL="91440" marR="91440" marT="36576" marB="36576" anchor="ctr">
+                  <a:tcPr marT="36576" marB="36576" anchor="ctr">
                     <a:lnL w="9525" cap="flat" cmpd="sng" algn="ctr">
                       <a:solidFill>
                         <a:srgbClr val="DAD6CC"/>
@@ -4008,6 +3863,11 @@
                     </a:solidFill>
                   </a:tcPr>
                 </a:tc>
+                <a:extLst>
+                  <a:ext uri="{0D108BD9-81ED-4DB2-BD59-A6C34878D82A}">
+                    <a16:rowId xmlns:a16="http://schemas.microsoft.com/office/drawing/2014/main" val="10003"/>
+                  </a:ext>
+                </a:extLst>
               </a:tr>
               <a:tr h="420624">
                 <a:tc>
@@ -4015,7 +3875,7 @@
                     <a:bodyPr/>
                     <a:lstStyle/>
                     <a:p>
-                      <a:pPr indent="0" marL="0">
+                      <a:pPr marL="0" indent="0">
                         <a:buNone/>
                       </a:pPr>
                       <a:r>
@@ -4036,7 +3896,7 @@
                       </a:endParaRPr>
                     </a:p>
                   </a:txBody>
-                  <a:tcPr marL="91440" marR="91440" marT="36576" marB="36576" anchor="ctr">
+                  <a:tcPr marT="36576" marB="36576" anchor="ctr">
                     <a:lnL w="9525" cap="flat" cmpd="sng" algn="ctr">
                       <a:solidFill>
                         <a:srgbClr val="DAD6CC"/>
@@ -4083,7 +3943,7 @@
                     <a:bodyPr/>
                     <a:lstStyle/>
                     <a:p>
-                      <a:pPr indent="0" marL="0">
+                      <a:pPr marL="0" indent="0">
                         <a:buNone/>
                       </a:pPr>
                       <a:r>
@@ -4104,7 +3964,7 @@
                       </a:endParaRPr>
                     </a:p>
                   </a:txBody>
-                  <a:tcPr marL="91440" marR="91440" marT="36576" marB="36576" anchor="ctr">
+                  <a:tcPr marT="36576" marB="36576" anchor="ctr">
                     <a:lnL w="9525" cap="flat" cmpd="sng" algn="ctr">
                       <a:solidFill>
                         <a:srgbClr val="DAD6CC"/>
@@ -4151,7 +4011,7 @@
                     <a:bodyPr/>
                     <a:lstStyle/>
                     <a:p>
-                      <a:pPr indent="0" marL="0">
+                      <a:pPr marL="0" indent="0">
                         <a:buNone/>
                       </a:pPr>
                       <a:r>
@@ -4172,7 +4032,7 @@
                       </a:endParaRPr>
                     </a:p>
                   </a:txBody>
-                  <a:tcPr marL="91440" marR="91440" marT="36576" marB="36576" anchor="ctr">
+                  <a:tcPr marT="36576" marB="36576" anchor="ctr">
                     <a:lnL w="9525" cap="flat" cmpd="sng" algn="ctr">
                       <a:solidFill>
                         <a:srgbClr val="DAD6CC"/>
@@ -4219,7 +4079,7 @@
                     <a:bodyPr/>
                     <a:lstStyle/>
                     <a:p>
-                      <a:pPr indent="0" marL="0">
+                      <a:pPr marL="0" indent="0">
                         <a:buNone/>
                       </a:pPr>
                       <a:r>
@@ -4240,7 +4100,7 @@
                       </a:endParaRPr>
                     </a:p>
                   </a:txBody>
-                  <a:tcPr marL="91440" marR="91440" marT="36576" marB="36576" anchor="ctr">
+                  <a:tcPr marT="36576" marB="36576" anchor="ctr">
                     <a:lnL w="9525" cap="flat" cmpd="sng" algn="ctr">
                       <a:solidFill>
                         <a:srgbClr val="DAD6CC"/>
@@ -4282,6 +4142,11 @@
                     </a:solidFill>
                   </a:tcPr>
                 </a:tc>
+                <a:extLst>
+                  <a:ext uri="{0D108BD9-81ED-4DB2-BD59-A6C34878D82A}">
+                    <a16:rowId xmlns:a16="http://schemas.microsoft.com/office/drawing/2014/main" val="10004"/>
+                  </a:ext>
+                </a:extLst>
               </a:tr>
               <a:tr h="420624">
                 <a:tc>
@@ -4289,7 +4154,7 @@
                     <a:bodyPr/>
                     <a:lstStyle/>
                     <a:p>
-                      <a:pPr indent="0" marL="0">
+                      <a:pPr marL="0" indent="0">
                         <a:buNone/>
                       </a:pPr>
                       <a:r>
@@ -4310,7 +4175,7 @@
                       </a:endParaRPr>
                     </a:p>
                   </a:txBody>
-                  <a:tcPr marL="91440" marR="91440" marT="36576" marB="36576" anchor="ctr">
+                  <a:tcPr marT="36576" marB="36576" anchor="ctr">
                     <a:lnL w="9525" cap="flat" cmpd="sng" algn="ctr">
                       <a:solidFill>
                         <a:srgbClr val="DAD6CC"/>
@@ -4357,7 +4222,7 @@
                     <a:bodyPr/>
                     <a:lstStyle/>
                     <a:p>
-                      <a:pPr indent="0" marL="0">
+                      <a:pPr marL="0" indent="0">
                         <a:buNone/>
                       </a:pPr>
                       <a:r>
@@ -4378,7 +4243,7 @@
                       </a:endParaRPr>
                     </a:p>
                   </a:txBody>
-                  <a:tcPr marL="91440" marR="91440" marT="36576" marB="36576" anchor="ctr">
+                  <a:tcPr marT="36576" marB="36576" anchor="ctr">
                     <a:lnL w="9525" cap="flat" cmpd="sng" algn="ctr">
                       <a:solidFill>
                         <a:srgbClr val="DAD6CC"/>
@@ -4425,7 +4290,7 @@
                     <a:bodyPr/>
                     <a:lstStyle/>
                     <a:p>
-                      <a:pPr indent="0" marL="0">
+                      <a:pPr marL="0" indent="0">
                         <a:buNone/>
                       </a:pPr>
                       <a:r>
@@ -4446,7 +4311,7 @@
                       </a:endParaRPr>
                     </a:p>
                   </a:txBody>
-                  <a:tcPr marL="91440" marR="91440" marT="36576" marB="36576" anchor="ctr">
+                  <a:tcPr marT="36576" marB="36576" anchor="ctr">
                     <a:lnL w="9525" cap="flat" cmpd="sng" algn="ctr">
                       <a:solidFill>
                         <a:srgbClr val="DAD6CC"/>
@@ -4493,7 +4358,7 @@
                     <a:bodyPr/>
                     <a:lstStyle/>
                     <a:p>
-                      <a:pPr indent="0" marL="0">
+                      <a:pPr marL="0" indent="0">
                         <a:buNone/>
                       </a:pPr>
                       <a:r>
@@ -4514,7 +4379,7 @@
                       </a:endParaRPr>
                     </a:p>
                   </a:txBody>
-                  <a:tcPr marL="91440" marR="91440" marT="36576" marB="36576" anchor="ctr">
+                  <a:tcPr marT="36576" marB="36576" anchor="ctr">
                     <a:lnL w="9525" cap="flat" cmpd="sng" algn="ctr">
                       <a:solidFill>
                         <a:srgbClr val="DAD6CC"/>
@@ -4556,6 +4421,11 @@
                     </a:solidFill>
                   </a:tcPr>
                 </a:tc>
+                <a:extLst>
+                  <a:ext uri="{0D108BD9-81ED-4DB2-BD59-A6C34878D82A}">
+                    <a16:rowId xmlns:a16="http://schemas.microsoft.com/office/drawing/2014/main" val="10005"/>
+                  </a:ext>
+                </a:extLst>
               </a:tr>
               <a:tr h="420624">
                 <a:tc>
@@ -4563,7 +4433,7 @@
                     <a:bodyPr/>
                     <a:lstStyle/>
                     <a:p>
-                      <a:pPr indent="0" marL="0">
+                      <a:pPr marL="0" indent="0">
                         <a:buNone/>
                       </a:pPr>
                       <a:r>
@@ -4584,7 +4454,7 @@
                       </a:endParaRPr>
                     </a:p>
                   </a:txBody>
-                  <a:tcPr marL="91440" marR="91440" marT="36576" marB="36576" anchor="ctr">
+                  <a:tcPr marT="36576" marB="36576" anchor="ctr">
                     <a:lnL w="9525" cap="flat" cmpd="sng" algn="ctr">
                       <a:solidFill>
                         <a:srgbClr val="DAD6CC"/>
@@ -4631,7 +4501,7 @@
                     <a:bodyPr/>
                     <a:lstStyle/>
                     <a:p>
-                      <a:pPr indent="0" marL="0">
+                      <a:pPr marL="0" indent="0">
                         <a:buNone/>
                       </a:pPr>
                       <a:r>
@@ -4652,7 +4522,7 @@
                       </a:endParaRPr>
                     </a:p>
                   </a:txBody>
-                  <a:tcPr marL="91440" marR="91440" marT="36576" marB="36576" anchor="ctr">
+                  <a:tcPr marT="36576" marB="36576" anchor="ctr">
                     <a:lnL w="9525" cap="flat" cmpd="sng" algn="ctr">
                       <a:solidFill>
                         <a:srgbClr val="DAD6CC"/>
@@ -4699,7 +4569,7 @@
                     <a:bodyPr/>
                     <a:lstStyle/>
                     <a:p>
-                      <a:pPr indent="0" marL="0">
+                      <a:pPr marL="0" indent="0">
                         <a:buNone/>
                       </a:pPr>
                       <a:r>
@@ -4720,7 +4590,7 @@
                       </a:endParaRPr>
                     </a:p>
                   </a:txBody>
-                  <a:tcPr marL="91440" marR="91440" marT="36576" marB="36576" anchor="ctr">
+                  <a:tcPr marT="36576" marB="36576" anchor="ctr">
                     <a:lnL w="9525" cap="flat" cmpd="sng" algn="ctr">
                       <a:solidFill>
                         <a:srgbClr val="DAD6CC"/>
@@ -4767,7 +4637,7 @@
                     <a:bodyPr/>
                     <a:lstStyle/>
                     <a:p>
-                      <a:pPr indent="0" marL="0">
+                      <a:pPr marL="0" indent="0">
                         <a:buNone/>
                       </a:pPr>
                       <a:r>
@@ -4788,7 +4658,7 @@
                       </a:endParaRPr>
                     </a:p>
                   </a:txBody>
-                  <a:tcPr marL="91440" marR="91440" marT="36576" marB="36576" anchor="ctr">
+                  <a:tcPr marT="36576" marB="36576" anchor="ctr">
                     <a:lnL w="9525" cap="flat" cmpd="sng" algn="ctr">
                       <a:solidFill>
                         <a:srgbClr val="DAD6CC"/>
@@ -4830,6 +4700,11 @@
                     </a:solidFill>
                   </a:tcPr>
                 </a:tc>
+                <a:extLst>
+                  <a:ext uri="{0D108BD9-81ED-4DB2-BD59-A6C34878D82A}">
+                    <a16:rowId xmlns:a16="http://schemas.microsoft.com/office/drawing/2014/main" val="10006"/>
+                  </a:ext>
+                </a:extLst>
               </a:tr>
               <a:tr h="420624">
                 <a:tc>
@@ -4837,7 +4712,7 @@
                     <a:bodyPr/>
                     <a:lstStyle/>
                     <a:p>
-                      <a:pPr indent="0" marL="0">
+                      <a:pPr marL="0" indent="0">
                         <a:buNone/>
                       </a:pPr>
                       <a:r>
@@ -4858,7 +4733,7 @@
                       </a:endParaRPr>
                     </a:p>
                   </a:txBody>
-                  <a:tcPr marL="91440" marR="91440" marT="36576" marB="36576" anchor="ctr">
+                  <a:tcPr marT="36576" marB="36576" anchor="ctr">
                     <a:lnL w="9525" cap="flat" cmpd="sng" algn="ctr">
                       <a:solidFill>
                         <a:srgbClr val="DAD6CC"/>
@@ -4905,7 +4780,7 @@
                     <a:bodyPr/>
                     <a:lstStyle/>
                     <a:p>
-                      <a:pPr indent="0" marL="0">
+                      <a:pPr marL="0" indent="0">
                         <a:buNone/>
                       </a:pPr>
                       <a:r>
@@ -4926,7 +4801,7 @@
                       </a:endParaRPr>
                     </a:p>
                   </a:txBody>
-                  <a:tcPr marL="91440" marR="91440" marT="36576" marB="36576" anchor="ctr">
+                  <a:tcPr marT="36576" marB="36576" anchor="ctr">
                     <a:lnL w="9525" cap="flat" cmpd="sng" algn="ctr">
                       <a:solidFill>
                         <a:srgbClr val="DAD6CC"/>
@@ -4973,7 +4848,7 @@
                     <a:bodyPr/>
                     <a:lstStyle/>
                     <a:p>
-                      <a:pPr indent="0" marL="0">
+                      <a:pPr marL="0" indent="0">
                         <a:buNone/>
                       </a:pPr>
                       <a:r>
@@ -4994,7 +4869,7 @@
                       </a:endParaRPr>
                     </a:p>
                   </a:txBody>
-                  <a:tcPr marL="91440" marR="91440" marT="36576" marB="36576" anchor="ctr">
+                  <a:tcPr marT="36576" marB="36576" anchor="ctr">
                     <a:lnL w="9525" cap="flat" cmpd="sng" algn="ctr">
                       <a:solidFill>
                         <a:srgbClr val="DAD6CC"/>
@@ -5041,7 +4916,7 @@
                     <a:bodyPr/>
                     <a:lstStyle/>
                     <a:p>
-                      <a:pPr indent="0" marL="0">
+                      <a:pPr marL="0" indent="0">
                         <a:buNone/>
                       </a:pPr>
                       <a:r>
@@ -5062,7 +4937,7 @@
                       </a:endParaRPr>
                     </a:p>
                   </a:txBody>
-                  <a:tcPr marL="91440" marR="91440" marT="36576" marB="36576" anchor="ctr">
+                  <a:tcPr marT="36576" marB="36576" anchor="ctr">
                     <a:lnL w="9525" cap="flat" cmpd="sng" algn="ctr">
                       <a:solidFill>
                         <a:srgbClr val="DAD6CC"/>
@@ -5104,6 +4979,11 @@
                     </a:solidFill>
                   </a:tcPr>
                 </a:tc>
+                <a:extLst>
+                  <a:ext uri="{0D108BD9-81ED-4DB2-BD59-A6C34878D82A}">
+                    <a16:rowId xmlns:a16="http://schemas.microsoft.com/office/drawing/2014/main" val="10007"/>
+                  </a:ext>
+                </a:extLst>
               </a:tr>
               <a:tr h="420624">
                 <a:tc>
@@ -5111,7 +4991,7 @@
                     <a:bodyPr/>
                     <a:lstStyle/>
                     <a:p>
-                      <a:pPr indent="0" marL="0">
+                      <a:pPr marL="0" indent="0">
                         <a:buNone/>
                       </a:pPr>
                       <a:r>
@@ -5132,7 +5012,7 @@
                       </a:endParaRPr>
                     </a:p>
                   </a:txBody>
-                  <a:tcPr marL="91440" marR="91440" marT="36576" marB="36576" anchor="ctr">
+                  <a:tcPr marT="36576" marB="36576" anchor="ctr">
                     <a:lnL w="9525" cap="flat" cmpd="sng" algn="ctr">
                       <a:solidFill>
                         <a:srgbClr val="DAD6CC"/>
@@ -5179,7 +5059,7 @@
                     <a:bodyPr/>
                     <a:lstStyle/>
                     <a:p>
-                      <a:pPr indent="0" marL="0">
+                      <a:pPr marL="0" indent="0">
                         <a:buNone/>
                       </a:pPr>
                       <a:r>
@@ -5200,7 +5080,7 @@
                       </a:endParaRPr>
                     </a:p>
                   </a:txBody>
-                  <a:tcPr marL="91440" marR="91440" marT="36576" marB="36576" anchor="ctr">
+                  <a:tcPr marT="36576" marB="36576" anchor="ctr">
                     <a:lnL w="9525" cap="flat" cmpd="sng" algn="ctr">
                       <a:solidFill>
                         <a:srgbClr val="DAD6CC"/>
@@ -5247,7 +5127,7 @@
                     <a:bodyPr/>
                     <a:lstStyle/>
                     <a:p>
-                      <a:pPr indent="0" marL="0">
+                      <a:pPr marL="0" indent="0">
                         <a:buNone/>
                       </a:pPr>
                       <a:r>
@@ -5268,7 +5148,7 @@
                       </a:endParaRPr>
                     </a:p>
                   </a:txBody>
-                  <a:tcPr marL="91440" marR="91440" marT="36576" marB="36576" anchor="ctr">
+                  <a:tcPr marT="36576" marB="36576" anchor="ctr">
                     <a:lnL w="9525" cap="flat" cmpd="sng" algn="ctr">
                       <a:solidFill>
                         <a:srgbClr val="DAD6CC"/>
@@ -5315,7 +5195,7 @@
                     <a:bodyPr/>
                     <a:lstStyle/>
                     <a:p>
-                      <a:pPr indent="0" marL="0">
+                      <a:pPr marL="0" indent="0">
                         <a:buNone/>
                       </a:pPr>
                       <a:r>
@@ -5336,7 +5216,7 @@
                       </a:endParaRPr>
                     </a:p>
                   </a:txBody>
-                  <a:tcPr marL="91440" marR="91440" marT="36576" marB="36576" anchor="ctr">
+                  <a:tcPr marT="36576" marB="36576" anchor="ctr">
                     <a:lnL w="9525" cap="flat" cmpd="sng" algn="ctr">
                       <a:solidFill>
                         <a:srgbClr val="DAD6CC"/>
@@ -5378,6 +5258,11 @@
                     </a:solidFill>
                   </a:tcPr>
                 </a:tc>
+                <a:extLst>
+                  <a:ext uri="{0D108BD9-81ED-4DB2-BD59-A6C34878D82A}">
+                    <a16:rowId xmlns:a16="http://schemas.microsoft.com/office/drawing/2014/main" val="10008"/>
+                  </a:ext>
+                </a:extLst>
               </a:tr>
               <a:tr h="420624">
                 <a:tc>
@@ -5385,7 +5270,7 @@
                     <a:bodyPr/>
                     <a:lstStyle/>
                     <a:p>
-                      <a:pPr indent="0" marL="0">
+                      <a:pPr marL="0" indent="0">
                         <a:buNone/>
                       </a:pPr>
                       <a:r>
@@ -5406,7 +5291,7 @@
                       </a:endParaRPr>
                     </a:p>
                   </a:txBody>
-                  <a:tcPr marL="91440" marR="91440" marT="36576" marB="36576" anchor="ctr">
+                  <a:tcPr marT="36576" marB="36576" anchor="ctr">
                     <a:lnL w="9525" cap="flat" cmpd="sng" algn="ctr">
                       <a:solidFill>
                         <a:srgbClr val="DAD6CC"/>
@@ -5453,7 +5338,7 @@
                     <a:bodyPr/>
                     <a:lstStyle/>
                     <a:p>
-                      <a:pPr indent="0" marL="0">
+                      <a:pPr marL="0" indent="0">
                         <a:buNone/>
                       </a:pPr>
                       <a:r>
@@ -5474,7 +5359,7 @@
                       </a:endParaRPr>
                     </a:p>
                   </a:txBody>
-                  <a:tcPr marL="91440" marR="91440" marT="36576" marB="36576" anchor="ctr">
+                  <a:tcPr marT="36576" marB="36576" anchor="ctr">
                     <a:lnL w="9525" cap="flat" cmpd="sng" algn="ctr">
                       <a:solidFill>
                         <a:srgbClr val="DAD6CC"/>
@@ -5521,7 +5406,7 @@
                     <a:bodyPr/>
                     <a:lstStyle/>
                     <a:p>
-                      <a:pPr indent="0" marL="0">
+                      <a:pPr marL="0" indent="0">
                         <a:buNone/>
                       </a:pPr>
                       <a:r>
@@ -5542,7 +5427,7 @@
                       </a:endParaRPr>
                     </a:p>
                   </a:txBody>
-                  <a:tcPr marL="91440" marR="91440" marT="36576" marB="36576" anchor="ctr">
+                  <a:tcPr marT="36576" marB="36576" anchor="ctr">
                     <a:lnL w="9525" cap="flat" cmpd="sng" algn="ctr">
                       <a:solidFill>
                         <a:srgbClr val="DAD6CC"/>
@@ -5589,7 +5474,7 @@
                     <a:bodyPr/>
                     <a:lstStyle/>
                     <a:p>
-                      <a:pPr indent="0" marL="0">
+                      <a:pPr marL="0" indent="0">
                         <a:buNone/>
                       </a:pPr>
                       <a:r>
@@ -5610,7 +5495,7 @@
                       </a:endParaRPr>
                     </a:p>
                   </a:txBody>
-                  <a:tcPr marL="91440" marR="91440" marT="36576" marB="36576" anchor="ctr">
+                  <a:tcPr marT="36576" marB="36576" anchor="ctr">
                     <a:lnL w="9525" cap="flat" cmpd="sng" algn="ctr">
                       <a:solidFill>
                         <a:srgbClr val="DAD6CC"/>
@@ -5652,6 +5537,11 @@
                     </a:solidFill>
                   </a:tcPr>
                 </a:tc>
+                <a:extLst>
+                  <a:ext uri="{0D108BD9-81ED-4DB2-BD59-A6C34878D82A}">
+                    <a16:rowId xmlns:a16="http://schemas.microsoft.com/office/drawing/2014/main" val="10009"/>
+                  </a:ext>
+                </a:extLst>
               </a:tr>
             </a:tbl>
           </a:graphicData>
@@ -5677,7 +5567,7 @@
           </a:prstGeom>
           <a:extLst>
             <a:ext uri="{C572A759-6A51-4108-AA02-DFA0A04FC94B}">
-              <ma14:wrappingTextBoxFlag xmlns:ma14="http://schemas.microsoft.com/office/mac/drawingml/2011/main" val="0"/>
+              <ma14:wrappingTextBoxFlag xmlns:ma14="http://schemas.microsoft.com/office/mac/drawingml/2011/main" xmlns="" val="0"/>
             </a:ext>
           </a:extLst>
         </p:spPr>
@@ -5698,7 +5588,7 @@
           <a:p>
             <a:pPr algn="r"/>
             <a:fld id="{F7021451-1387-4CA6-816F-3879F97B5CBC}" type="slidenum">
-              <a:rPr b="0" lang="en-US"/>
+              <a:rPr lang="en-US" b="0"/>
               <a:t>3</a:t>
             </a:fld>
             <a:endParaRPr lang="en-US"/>
@@ -5751,11 +5641,11 @@
           <a:bodyPr wrap="square" lIns="0" tIns="0" rIns="0" bIns="0" rtlCol="0" anchor="ctr"/>
           <a:lstStyle/>
           <a:p>
-            <a:pPr indent="0" marL="0">
+            <a:pPr marL="0" indent="0">
               <a:buNone/>
             </a:pPr>
             <a:r>
-              <a:rPr lang="en-US" sz="1300" b="1" spc="200" kern="0" dirty="0">
+              <a:rPr lang="en-US" sz="1300" b="1" kern="0" spc="200" dirty="0">
                 <a:solidFill>
                   <a:srgbClr val="B4531A"/>
                 </a:solidFill>
@@ -5772,9 +5662,11 @@
       <p:sp>
         <p:nvSpPr>
           <p:cNvPr id="3" name="Text 0"/>
-          <p:cNvSpPr/>
+          <p:cNvSpPr>
+            <a:spLocks noGrp="1"/>
+          </p:cNvSpPr>
           <p:nvPr>
-            <p:ph idx="100" type="title" hasCustomPrompt="1"/>
+            <p:ph type="title" idx="100" hasCustomPrompt="1"/>
           </p:nvPr>
         </p:nvSpPr>
         <p:spPr>
@@ -5792,7 +5684,7 @@
           <a:bodyPr wrap="square" lIns="0" tIns="0" rIns="0" bIns="0" rtlCol="0" anchor="t"/>
           <a:lstStyle/>
           <a:p>
-            <a:pPr indent="0" marL="0">
+            <a:pPr marL="0" indent="0">
               <a:buNone/>
             </a:pPr>
             <a:r>
@@ -5836,6 +5728,13 @@
             <a:prstDash val="solid"/>
           </a:ln>
         </p:spPr>
+        <p:txBody>
+          <a:bodyPr/>
+          <a:lstStyle/>
+          <a:p>
+            <a:endParaRPr lang="en-VN"/>
+          </a:p>
+        </p:txBody>
       </p:sp>
       <p:sp>
         <p:nvSpPr>
@@ -5858,7 +5757,7 @@
           <a:bodyPr wrap="square" lIns="0" tIns="0" rIns="0" bIns="0" rtlCol="0" anchor="t"/>
           <a:lstStyle/>
           <a:p>
-            <a:pPr indent="0" marL="0">
+            <a:pPr marL="0" indent="0">
               <a:buNone/>
             </a:pPr>
             <a:r>
@@ -5897,7 +5796,7 @@
           <a:bodyPr wrap="square" lIns="0" tIns="0" rIns="0" bIns="0" rtlCol="0" anchor="t"/>
           <a:lstStyle/>
           <a:p>
-            <a:pPr indent="0" marL="0">
+            <a:pPr marL="0" indent="0">
               <a:buNone/>
             </a:pPr>
             <a:r>
@@ -5914,7 +5813,7 @@
             <a:endParaRPr lang="en-US" sz="1400" dirty="0"/>
           </a:p>
           <a:p>
-            <a:pPr indent="0" marL="0">
+            <a:pPr marL="0" indent="0">
               <a:buNone/>
             </a:pPr>
             <a:r>
@@ -5955,6 +5854,13 @@
             <a:tailEnd type="triangle"/>
           </a:ln>
         </p:spPr>
+        <p:txBody>
+          <a:bodyPr/>
+          <a:lstStyle/>
+          <a:p>
+            <a:endParaRPr lang="en-VN"/>
+          </a:p>
+        </p:txBody>
       </p:sp>
       <p:sp>
         <p:nvSpPr>
@@ -5982,6 +5888,13 @@
             <a:prstDash val="solid"/>
           </a:ln>
         </p:spPr>
+        <p:txBody>
+          <a:bodyPr/>
+          <a:lstStyle/>
+          <a:p>
+            <a:endParaRPr lang="en-VN"/>
+          </a:p>
+        </p:txBody>
       </p:sp>
       <p:sp>
         <p:nvSpPr>
@@ -6004,7 +5917,7 @@
           <a:bodyPr wrap="square" lIns="0" tIns="0" rIns="0" bIns="0" rtlCol="0" anchor="t"/>
           <a:lstStyle/>
           <a:p>
-            <a:pPr indent="0" marL="0">
+            <a:pPr marL="0" indent="0">
               <a:buNone/>
             </a:pPr>
             <a:r>
@@ -6043,7 +5956,7 @@
           <a:bodyPr wrap="square" lIns="0" tIns="0" rIns="0" bIns="0" rtlCol="0" anchor="t"/>
           <a:lstStyle/>
           <a:p>
-            <a:pPr indent="0" marL="0">
+            <a:pPr marL="0" indent="0">
               <a:buNone/>
             </a:pPr>
             <a:r>
@@ -6084,6 +5997,13 @@
             <a:tailEnd type="triangle"/>
           </a:ln>
         </p:spPr>
+        <p:txBody>
+          <a:bodyPr/>
+          <a:lstStyle/>
+          <a:p>
+            <a:endParaRPr lang="en-VN"/>
+          </a:p>
+        </p:txBody>
       </p:sp>
       <p:sp>
         <p:nvSpPr>
@@ -6111,6 +6031,13 @@
             <a:prstDash val="solid"/>
           </a:ln>
         </p:spPr>
+        <p:txBody>
+          <a:bodyPr/>
+          <a:lstStyle/>
+          <a:p>
+            <a:endParaRPr lang="en-VN"/>
+          </a:p>
+        </p:txBody>
       </p:sp>
       <p:sp>
         <p:nvSpPr>
@@ -6133,7 +6060,7 @@
           <a:bodyPr wrap="square" lIns="0" tIns="0" rIns="0" bIns="0" rtlCol="0" anchor="t"/>
           <a:lstStyle/>
           <a:p>
-            <a:pPr indent="0" marL="0">
+            <a:pPr marL="0" indent="0">
               <a:buNone/>
             </a:pPr>
             <a:r>
@@ -6172,7 +6099,7 @@
           <a:bodyPr wrap="square" lIns="0" tIns="0" rIns="0" bIns="0" rtlCol="0" anchor="t"/>
           <a:lstStyle/>
           <a:p>
-            <a:pPr indent="0" marL="0">
+            <a:pPr marL="0" indent="0">
               <a:buNone/>
             </a:pPr>
             <a:r>
@@ -6213,6 +6140,13 @@
             <a:tailEnd type="triangle"/>
           </a:ln>
         </p:spPr>
+        <p:txBody>
+          <a:bodyPr/>
+          <a:lstStyle/>
+          <a:p>
+            <a:endParaRPr lang="en-VN"/>
+          </a:p>
+        </p:txBody>
       </p:sp>
       <p:sp>
         <p:nvSpPr>
@@ -6240,6 +6174,13 @@
             <a:prstDash val="solid"/>
           </a:ln>
         </p:spPr>
+        <p:txBody>
+          <a:bodyPr/>
+          <a:lstStyle/>
+          <a:p>
+            <a:endParaRPr lang="en-VN"/>
+          </a:p>
+        </p:txBody>
       </p:sp>
       <p:sp>
         <p:nvSpPr>
@@ -6262,7 +6203,7 @@
           <a:bodyPr wrap="square" lIns="0" tIns="0" rIns="0" bIns="0" rtlCol="0" anchor="t"/>
           <a:lstStyle/>
           <a:p>
-            <a:pPr indent="0" marL="0">
+            <a:pPr marL="0" indent="0">
               <a:buNone/>
             </a:pPr>
             <a:r>
@@ -6301,7 +6242,7 @@
           <a:bodyPr wrap="square" lIns="0" tIns="0" rIns="0" bIns="0" rtlCol="0" anchor="t"/>
           <a:lstStyle/>
           <a:p>
-            <a:pPr indent="0" marL="0">
+            <a:pPr marL="0" indent="0">
               <a:buNone/>
             </a:pPr>
             <a:r>
@@ -6318,7 +6259,7 @@
             <a:endParaRPr lang="en-US" sz="1400" dirty="0"/>
           </a:p>
           <a:p>
-            <a:pPr indent="0" marL="0">
+            <a:pPr marL="0" indent="0">
               <a:buNone/>
             </a:pPr>
             <a:r>
@@ -6357,7 +6298,7 @@
           <a:bodyPr wrap="square" lIns="0" tIns="0" rIns="0" bIns="0" rtlCol="0" anchor="ctr"/>
           <a:lstStyle/>
           <a:p>
-            <a:pPr indent="0" marL="0">
+            <a:pPr marL="0" indent="0">
               <a:buNone/>
             </a:pPr>
             <a:r>
@@ -6478,7 +6419,7 @@
           <a:bodyPr wrap="square" lIns="0" tIns="0" rIns="0" bIns="0" rtlCol="0" anchor="ctr"/>
           <a:lstStyle/>
           <a:p>
-            <a:pPr indent="0" marL="0">
+            <a:pPr marL="0" indent="0">
               <a:buNone/>
             </a:pPr>
             <a:r>
@@ -6516,7 +6457,7 @@
           </a:prstGeom>
           <a:extLst>
             <a:ext uri="{C572A759-6A51-4108-AA02-DFA0A04FC94B}">
-              <ma14:wrappingTextBoxFlag xmlns:ma14="http://schemas.microsoft.com/office/mac/drawingml/2011/main" val="0"/>
+              <ma14:wrappingTextBoxFlag xmlns:ma14="http://schemas.microsoft.com/office/mac/drawingml/2011/main" xmlns="" val="0"/>
             </a:ext>
           </a:extLst>
         </p:spPr>
@@ -6537,7 +6478,7 @@
           <a:p>
             <a:pPr algn="r"/>
             <a:fld id="{F7021451-1387-4CA6-816F-3879F97B5CBC}" type="slidenum">
-              <a:rPr b="0" lang="en-US"/>
+              <a:rPr lang="en-US" b="0"/>
               <a:t>4</a:t>
             </a:fld>
             <a:endParaRPr lang="en-US"/>
@@ -6590,11 +6531,11 @@
           <a:bodyPr wrap="square" lIns="0" tIns="0" rIns="0" bIns="0" rtlCol="0" anchor="ctr"/>
           <a:lstStyle/>
           <a:p>
-            <a:pPr indent="0" marL="0">
+            <a:pPr marL="0" indent="0">
               <a:buNone/>
             </a:pPr>
             <a:r>
-              <a:rPr lang="en-US" sz="1300" b="1" spc="200" kern="0" dirty="0">
+              <a:rPr lang="en-US" sz="1300" b="1" kern="0" spc="200" dirty="0">
                 <a:solidFill>
                   <a:srgbClr val="B4531A"/>
                 </a:solidFill>
@@ -6611,9 +6552,11 @@
       <p:sp>
         <p:nvSpPr>
           <p:cNvPr id="3" name="Text 0"/>
-          <p:cNvSpPr/>
+          <p:cNvSpPr>
+            <a:spLocks noGrp="1"/>
+          </p:cNvSpPr>
           <p:nvPr>
-            <p:ph idx="100" type="title" hasCustomPrompt="1"/>
+            <p:ph type="title" idx="100" hasCustomPrompt="1"/>
           </p:nvPr>
         </p:nvSpPr>
         <p:spPr>
@@ -6631,7 +6574,7 @@
           <a:bodyPr wrap="square" lIns="0" tIns="0" rIns="0" bIns="0" rtlCol="0" anchor="t"/>
           <a:lstStyle/>
           <a:p>
-            <a:pPr indent="0" marL="0">
+            <a:pPr marL="0" indent="0">
               <a:buNone/>
             </a:pPr>
             <a:r>
@@ -6672,8 +6615,20 @@
             <a:tbl>
               <a:tblPr/>
               <a:tblGrid>
-                <a:gridCol w="2011680"/>
-                <a:gridCol w="3214116"/>
+                <a:gridCol w="2011680">
+                  <a:extLst>
+                    <a:ext uri="{9D8B030D-6E8A-4147-A177-3AD203B41FA5}">
+                      <a16:colId xmlns:a16="http://schemas.microsoft.com/office/drawing/2014/main" val="20000"/>
+                    </a:ext>
+                  </a:extLst>
+                </a:gridCol>
+                <a:gridCol w="3214116">
+                  <a:extLst>
+                    <a:ext uri="{9D8B030D-6E8A-4147-A177-3AD203B41FA5}">
+                      <a16:colId xmlns:a16="http://schemas.microsoft.com/office/drawing/2014/main" val="20001"/>
+                    </a:ext>
+                  </a:extLst>
+                </a:gridCol>
               </a:tblGrid>
               <a:tr h="457200">
                 <a:tc>
@@ -6681,7 +6636,7 @@
                     <a:bodyPr/>
                     <a:lstStyle/>
                     <a:p>
-                      <a:pPr indent="0" marL="0">
+                      <a:pPr marL="0" indent="0">
                         <a:buNone/>
                       </a:pPr>
                       <a:r>
@@ -6702,7 +6657,7 @@
                       </a:endParaRPr>
                     </a:p>
                   </a:txBody>
-                  <a:tcPr marL="91440" marR="91440" marT="36576" marB="36576" anchor="ctr">
+                  <a:tcPr marT="36576" marB="36576" anchor="ctr">
                     <a:lnL w="9525" cap="flat" cmpd="sng" algn="ctr">
                       <a:solidFill>
                         <a:srgbClr val="DAD6CC"/>
@@ -6749,7 +6704,7 @@
                     <a:bodyPr/>
                     <a:lstStyle/>
                     <a:p>
-                      <a:pPr indent="0" marL="0">
+                      <a:pPr marL="0" indent="0">
                         <a:buNone/>
                       </a:pPr>
                       <a:r>
@@ -6770,7 +6725,7 @@
                       </a:endParaRPr>
                     </a:p>
                   </a:txBody>
-                  <a:tcPr marL="91440" marR="91440" marT="36576" marB="36576" anchor="ctr">
+                  <a:tcPr marT="36576" marB="36576" anchor="ctr">
                     <a:lnL w="9525" cap="flat" cmpd="sng" algn="ctr">
                       <a:solidFill>
                         <a:srgbClr val="DAD6CC"/>
@@ -6812,6 +6767,11 @@
                     </a:solidFill>
                   </a:tcPr>
                 </a:tc>
+                <a:extLst>
+                  <a:ext uri="{0D108BD9-81ED-4DB2-BD59-A6C34878D82A}">
+                    <a16:rowId xmlns:a16="http://schemas.microsoft.com/office/drawing/2014/main" val="10000"/>
+                  </a:ext>
+                </a:extLst>
               </a:tr>
               <a:tr h="457200">
                 <a:tc>
@@ -6819,7 +6779,7 @@
                     <a:bodyPr/>
                     <a:lstStyle/>
                     <a:p>
-                      <a:pPr indent="0" marL="0">
+                      <a:pPr marL="0" indent="0">
                         <a:buNone/>
                       </a:pPr>
                       <a:r>
@@ -6840,7 +6800,7 @@
                       </a:endParaRPr>
                     </a:p>
                   </a:txBody>
-                  <a:tcPr marL="91440" marR="91440" marT="36576" marB="36576" anchor="ctr">
+                  <a:tcPr marT="36576" marB="36576" anchor="ctr">
                     <a:lnL w="9525" cap="flat" cmpd="sng" algn="ctr">
                       <a:solidFill>
                         <a:srgbClr val="DAD6CC"/>
@@ -6887,7 +6847,7 @@
                     <a:bodyPr/>
                     <a:lstStyle/>
                     <a:p>
-                      <a:pPr indent="0" marL="0">
+                      <a:pPr marL="0" indent="0">
                         <a:buNone/>
                       </a:pPr>
                       <a:r>
@@ -6908,7 +6868,7 @@
                       </a:endParaRPr>
                     </a:p>
                   </a:txBody>
-                  <a:tcPr marL="91440" marR="91440" marT="36576" marB="36576" anchor="ctr">
+                  <a:tcPr marT="36576" marB="36576" anchor="ctr">
                     <a:lnL w="9525" cap="flat" cmpd="sng" algn="ctr">
                       <a:solidFill>
                         <a:srgbClr val="DAD6CC"/>
@@ -6950,6 +6910,11 @@
                     </a:solidFill>
                   </a:tcPr>
                 </a:tc>
+                <a:extLst>
+                  <a:ext uri="{0D108BD9-81ED-4DB2-BD59-A6C34878D82A}">
+                    <a16:rowId xmlns:a16="http://schemas.microsoft.com/office/drawing/2014/main" val="10001"/>
+                  </a:ext>
+                </a:extLst>
               </a:tr>
               <a:tr h="457200">
                 <a:tc>
@@ -6957,7 +6922,7 @@
                     <a:bodyPr/>
                     <a:lstStyle/>
                     <a:p>
-                      <a:pPr indent="0" marL="0">
+                      <a:pPr marL="0" indent="0">
                         <a:buNone/>
                       </a:pPr>
                       <a:r>
@@ -6978,7 +6943,7 @@
                       </a:endParaRPr>
                     </a:p>
                   </a:txBody>
-                  <a:tcPr marL="91440" marR="91440" marT="36576" marB="36576" anchor="ctr">
+                  <a:tcPr marT="36576" marB="36576" anchor="ctr">
                     <a:lnL w="9525" cap="flat" cmpd="sng" algn="ctr">
                       <a:solidFill>
                         <a:srgbClr val="DAD6CC"/>
@@ -7025,7 +6990,7 @@
                     <a:bodyPr/>
                     <a:lstStyle/>
                     <a:p>
-                      <a:pPr indent="0" marL="0">
+                      <a:pPr marL="0" indent="0">
                         <a:buNone/>
                       </a:pPr>
                       <a:r>
@@ -7046,7 +7011,7 @@
                       </a:endParaRPr>
                     </a:p>
                   </a:txBody>
-                  <a:tcPr marL="91440" marR="91440" marT="36576" marB="36576" anchor="ctr">
+                  <a:tcPr marT="36576" marB="36576" anchor="ctr">
                     <a:lnL w="9525" cap="flat" cmpd="sng" algn="ctr">
                       <a:solidFill>
                         <a:srgbClr val="DAD6CC"/>
@@ -7088,6 +7053,11 @@
                     </a:solidFill>
                   </a:tcPr>
                 </a:tc>
+                <a:extLst>
+                  <a:ext uri="{0D108BD9-81ED-4DB2-BD59-A6C34878D82A}">
+                    <a16:rowId xmlns:a16="http://schemas.microsoft.com/office/drawing/2014/main" val="10002"/>
+                  </a:ext>
+                </a:extLst>
               </a:tr>
               <a:tr h="457200">
                 <a:tc>
@@ -7095,7 +7065,7 @@
                     <a:bodyPr/>
                     <a:lstStyle/>
                     <a:p>
-                      <a:pPr indent="0" marL="0">
+                      <a:pPr marL="0" indent="0">
                         <a:buNone/>
                       </a:pPr>
                       <a:r>
@@ -7116,7 +7086,7 @@
                       </a:endParaRPr>
                     </a:p>
                   </a:txBody>
-                  <a:tcPr marL="91440" marR="91440" marT="36576" marB="36576" anchor="ctr">
+                  <a:tcPr marT="36576" marB="36576" anchor="ctr">
                     <a:lnL w="9525" cap="flat" cmpd="sng" algn="ctr">
                       <a:solidFill>
                         <a:srgbClr val="DAD6CC"/>
@@ -7163,7 +7133,7 @@
                     <a:bodyPr/>
                     <a:lstStyle/>
                     <a:p>
-                      <a:pPr indent="0" marL="0">
+                      <a:pPr marL="0" indent="0">
                         <a:buNone/>
                       </a:pPr>
                       <a:r>
@@ -7184,7 +7154,7 @@
                       </a:endParaRPr>
                     </a:p>
                   </a:txBody>
-                  <a:tcPr marL="91440" marR="91440" marT="36576" marB="36576" anchor="ctr">
+                  <a:tcPr marT="36576" marB="36576" anchor="ctr">
                     <a:lnL w="9525" cap="flat" cmpd="sng" algn="ctr">
                       <a:solidFill>
                         <a:srgbClr val="DAD6CC"/>
@@ -7226,6 +7196,11 @@
                     </a:solidFill>
                   </a:tcPr>
                 </a:tc>
+                <a:extLst>
+                  <a:ext uri="{0D108BD9-81ED-4DB2-BD59-A6C34878D82A}">
+                    <a16:rowId xmlns:a16="http://schemas.microsoft.com/office/drawing/2014/main" val="10003"/>
+                  </a:ext>
+                </a:extLst>
               </a:tr>
               <a:tr h="457200">
                 <a:tc>
@@ -7233,7 +7208,7 @@
                     <a:bodyPr/>
                     <a:lstStyle/>
                     <a:p>
-                      <a:pPr indent="0" marL="0">
+                      <a:pPr marL="0" indent="0">
                         <a:buNone/>
                       </a:pPr>
                       <a:r>
@@ -7254,7 +7229,7 @@
                       </a:endParaRPr>
                     </a:p>
                   </a:txBody>
-                  <a:tcPr marL="91440" marR="91440" marT="36576" marB="36576" anchor="ctr">
+                  <a:tcPr marT="36576" marB="36576" anchor="ctr">
                     <a:lnL w="9525" cap="flat" cmpd="sng" algn="ctr">
                       <a:solidFill>
                         <a:srgbClr val="DAD6CC"/>
@@ -7301,7 +7276,7 @@
                     <a:bodyPr/>
                     <a:lstStyle/>
                     <a:p>
-                      <a:pPr indent="0" marL="0">
+                      <a:pPr marL="0" indent="0">
                         <a:buNone/>
                       </a:pPr>
                       <a:r>
@@ -7322,7 +7297,7 @@
                       </a:endParaRPr>
                     </a:p>
                   </a:txBody>
-                  <a:tcPr marL="91440" marR="91440" marT="36576" marB="36576" anchor="ctr">
+                  <a:tcPr marT="36576" marB="36576" anchor="ctr">
                     <a:lnL w="9525" cap="flat" cmpd="sng" algn="ctr">
                       <a:solidFill>
                         <a:srgbClr val="DAD6CC"/>
@@ -7364,6 +7339,11 @@
                     </a:solidFill>
                   </a:tcPr>
                 </a:tc>
+                <a:extLst>
+                  <a:ext uri="{0D108BD9-81ED-4DB2-BD59-A6C34878D82A}">
+                    <a16:rowId xmlns:a16="http://schemas.microsoft.com/office/drawing/2014/main" val="10004"/>
+                  </a:ext>
+                </a:extLst>
               </a:tr>
               <a:tr h="457200">
                 <a:tc>
@@ -7371,7 +7351,7 @@
                     <a:bodyPr/>
                     <a:lstStyle/>
                     <a:p>
-                      <a:pPr indent="0" marL="0">
+                      <a:pPr marL="0" indent="0">
                         <a:buNone/>
                       </a:pPr>
                       <a:r>
@@ -7392,7 +7372,7 @@
                       </a:endParaRPr>
                     </a:p>
                   </a:txBody>
-                  <a:tcPr marL="91440" marR="91440" marT="36576" marB="36576" anchor="ctr">
+                  <a:tcPr marT="36576" marB="36576" anchor="ctr">
                     <a:lnL w="9525" cap="flat" cmpd="sng" algn="ctr">
                       <a:solidFill>
                         <a:srgbClr val="DAD6CC"/>
@@ -7439,7 +7419,7 @@
                     <a:bodyPr/>
                     <a:lstStyle/>
                     <a:p>
-                      <a:pPr indent="0" marL="0">
+                      <a:pPr marL="0" indent="0">
                         <a:buNone/>
                       </a:pPr>
                       <a:r>
@@ -7460,7 +7440,7 @@
                       </a:endParaRPr>
                     </a:p>
                   </a:txBody>
-                  <a:tcPr marL="91440" marR="91440" marT="36576" marB="36576" anchor="ctr">
+                  <a:tcPr marT="36576" marB="36576" anchor="ctr">
                     <a:lnL w="9525" cap="flat" cmpd="sng" algn="ctr">
                       <a:solidFill>
                         <a:srgbClr val="DAD6CC"/>
@@ -7502,6 +7482,11 @@
                     </a:solidFill>
                   </a:tcPr>
                 </a:tc>
+                <a:extLst>
+                  <a:ext uri="{0D108BD9-81ED-4DB2-BD59-A6C34878D82A}">
+                    <a16:rowId xmlns:a16="http://schemas.microsoft.com/office/drawing/2014/main" val="10005"/>
+                  </a:ext>
+                </a:extLst>
               </a:tr>
             </a:tbl>
           </a:graphicData>
@@ -7530,9 +7515,27 @@
             <a:tbl>
               <a:tblPr/>
               <a:tblGrid>
-                <a:gridCol w="2194560"/>
-                <a:gridCol w="914400"/>
-                <a:gridCol w="2116836"/>
+                <a:gridCol w="2194560">
+                  <a:extLst>
+                    <a:ext uri="{9D8B030D-6E8A-4147-A177-3AD203B41FA5}">
+                      <a16:colId xmlns:a16="http://schemas.microsoft.com/office/drawing/2014/main" val="20000"/>
+                    </a:ext>
+                  </a:extLst>
+                </a:gridCol>
+                <a:gridCol w="914400">
+                  <a:extLst>
+                    <a:ext uri="{9D8B030D-6E8A-4147-A177-3AD203B41FA5}">
+                      <a16:colId xmlns:a16="http://schemas.microsoft.com/office/drawing/2014/main" val="20001"/>
+                    </a:ext>
+                  </a:extLst>
+                </a:gridCol>
+                <a:gridCol w="2116836">
+                  <a:extLst>
+                    <a:ext uri="{9D8B030D-6E8A-4147-A177-3AD203B41FA5}">
+                      <a16:colId xmlns:a16="http://schemas.microsoft.com/office/drawing/2014/main" val="20002"/>
+                    </a:ext>
+                  </a:extLst>
+                </a:gridCol>
               </a:tblGrid>
               <a:tr h="457200">
                 <a:tc>
@@ -7540,7 +7543,7 @@
                     <a:bodyPr/>
                     <a:lstStyle/>
                     <a:p>
-                      <a:pPr indent="0" marL="0">
+                      <a:pPr marL="0" indent="0">
                         <a:buNone/>
                       </a:pPr>
                       <a:r>
@@ -7561,7 +7564,7 @@
                       </a:endParaRPr>
                     </a:p>
                   </a:txBody>
-                  <a:tcPr marL="91440" marR="91440" marT="36576" marB="36576" anchor="ctr">
+                  <a:tcPr marT="36576" marB="36576" anchor="ctr">
                     <a:lnL w="9525" cap="flat" cmpd="sng" algn="ctr">
                       <a:solidFill>
                         <a:srgbClr val="DAD6CC"/>
@@ -7608,7 +7611,7 @@
                     <a:bodyPr/>
                     <a:lstStyle/>
                     <a:p>
-                      <a:pPr indent="0" marL="0">
+                      <a:pPr marL="0" indent="0">
                         <a:buNone/>
                       </a:pPr>
                       <a:r>
@@ -7629,7 +7632,7 @@
                       </a:endParaRPr>
                     </a:p>
                   </a:txBody>
-                  <a:tcPr marL="91440" marR="91440" marT="36576" marB="36576" anchor="ctr">
+                  <a:tcPr marT="36576" marB="36576" anchor="ctr">
                     <a:lnL w="9525" cap="flat" cmpd="sng" algn="ctr">
                       <a:solidFill>
                         <a:srgbClr val="DAD6CC"/>
@@ -7676,7 +7679,7 @@
                     <a:bodyPr/>
                     <a:lstStyle/>
                     <a:p>
-                      <a:pPr indent="0" marL="0">
+                      <a:pPr marL="0" indent="0">
                         <a:buNone/>
                       </a:pPr>
                       <a:r>
@@ -7697,7 +7700,7 @@
                       </a:endParaRPr>
                     </a:p>
                   </a:txBody>
-                  <a:tcPr marL="91440" marR="91440" marT="36576" marB="36576" anchor="ctr">
+                  <a:tcPr marT="36576" marB="36576" anchor="ctr">
                     <a:lnL w="9525" cap="flat" cmpd="sng" algn="ctr">
                       <a:solidFill>
                         <a:srgbClr val="DAD6CC"/>
@@ -7739,6 +7742,11 @@
                     </a:solidFill>
                   </a:tcPr>
                 </a:tc>
+                <a:extLst>
+                  <a:ext uri="{0D108BD9-81ED-4DB2-BD59-A6C34878D82A}">
+                    <a16:rowId xmlns:a16="http://schemas.microsoft.com/office/drawing/2014/main" val="10000"/>
+                  </a:ext>
+                </a:extLst>
               </a:tr>
               <a:tr h="457200">
                 <a:tc>
@@ -7746,7 +7754,7 @@
                     <a:bodyPr/>
                     <a:lstStyle/>
                     <a:p>
-                      <a:pPr indent="0" marL="0">
+                      <a:pPr marL="0" indent="0">
                         <a:buNone/>
                       </a:pPr>
                       <a:r>
@@ -7767,7 +7775,7 @@
                       </a:endParaRPr>
                     </a:p>
                   </a:txBody>
-                  <a:tcPr marL="91440" marR="91440" marT="36576" marB="36576" anchor="ctr">
+                  <a:tcPr marT="36576" marB="36576" anchor="ctr">
                     <a:lnL w="9525" cap="flat" cmpd="sng" algn="ctr">
                       <a:solidFill>
                         <a:srgbClr val="DAD6CC"/>
@@ -7814,7 +7822,7 @@
                     <a:bodyPr/>
                     <a:lstStyle/>
                     <a:p>
-                      <a:pPr indent="0" marL="0">
+                      <a:pPr marL="0" indent="0">
                         <a:buNone/>
                       </a:pPr>
                       <a:r>
@@ -7835,7 +7843,7 @@
                       </a:endParaRPr>
                     </a:p>
                   </a:txBody>
-                  <a:tcPr marL="91440" marR="91440" marT="36576" marB="36576" anchor="ctr">
+                  <a:tcPr marT="36576" marB="36576" anchor="ctr">
                     <a:lnL w="9525" cap="flat" cmpd="sng" algn="ctr">
                       <a:solidFill>
                         <a:srgbClr val="DAD6CC"/>
@@ -7882,7 +7890,7 @@
                     <a:bodyPr/>
                     <a:lstStyle/>
                     <a:p>
-                      <a:pPr indent="0" marL="0">
+                      <a:pPr marL="0" indent="0">
                         <a:buNone/>
                       </a:pPr>
                       <a:r>
@@ -7903,7 +7911,7 @@
                       </a:endParaRPr>
                     </a:p>
                   </a:txBody>
-                  <a:tcPr marL="91440" marR="91440" marT="36576" marB="36576" anchor="ctr">
+                  <a:tcPr marT="36576" marB="36576" anchor="ctr">
                     <a:lnL w="9525" cap="flat" cmpd="sng" algn="ctr">
                       <a:solidFill>
                         <a:srgbClr val="DAD6CC"/>
@@ -7945,6 +7953,11 @@
                     </a:solidFill>
                   </a:tcPr>
                 </a:tc>
+                <a:extLst>
+                  <a:ext uri="{0D108BD9-81ED-4DB2-BD59-A6C34878D82A}">
+                    <a16:rowId xmlns:a16="http://schemas.microsoft.com/office/drawing/2014/main" val="10001"/>
+                  </a:ext>
+                </a:extLst>
               </a:tr>
               <a:tr h="457200">
                 <a:tc>
@@ -7952,7 +7965,7 @@
                     <a:bodyPr/>
                     <a:lstStyle/>
                     <a:p>
-                      <a:pPr indent="0" marL="0">
+                      <a:pPr marL="0" indent="0">
                         <a:buNone/>
                       </a:pPr>
                       <a:r>
@@ -7973,7 +7986,7 @@
                       </a:endParaRPr>
                     </a:p>
                   </a:txBody>
-                  <a:tcPr marL="91440" marR="91440" marT="36576" marB="36576" anchor="ctr">
+                  <a:tcPr marT="36576" marB="36576" anchor="ctr">
                     <a:lnL w="9525" cap="flat" cmpd="sng" algn="ctr">
                       <a:solidFill>
                         <a:srgbClr val="DAD6CC"/>
@@ -8020,7 +8033,7 @@
                     <a:bodyPr/>
                     <a:lstStyle/>
                     <a:p>
-                      <a:pPr indent="0" marL="0">
+                      <a:pPr marL="0" indent="0">
                         <a:buNone/>
                       </a:pPr>
                       <a:r>
@@ -8041,7 +8054,7 @@
                       </a:endParaRPr>
                     </a:p>
                   </a:txBody>
-                  <a:tcPr marL="91440" marR="91440" marT="36576" marB="36576" anchor="ctr">
+                  <a:tcPr marT="36576" marB="36576" anchor="ctr">
                     <a:lnL w="9525" cap="flat" cmpd="sng" algn="ctr">
                       <a:solidFill>
                         <a:srgbClr val="DAD6CC"/>
@@ -8088,7 +8101,7 @@
                     <a:bodyPr/>
                     <a:lstStyle/>
                     <a:p>
-                      <a:pPr indent="0" marL="0">
+                      <a:pPr marL="0" indent="0">
                         <a:buNone/>
                       </a:pPr>
                       <a:r>
@@ -8109,7 +8122,7 @@
                       </a:endParaRPr>
                     </a:p>
                   </a:txBody>
-                  <a:tcPr marL="91440" marR="91440" marT="36576" marB="36576" anchor="ctr">
+                  <a:tcPr marT="36576" marB="36576" anchor="ctr">
                     <a:lnL w="9525" cap="flat" cmpd="sng" algn="ctr">
                       <a:solidFill>
                         <a:srgbClr val="DAD6CC"/>
@@ -8151,6 +8164,11 @@
                     </a:solidFill>
                   </a:tcPr>
                 </a:tc>
+                <a:extLst>
+                  <a:ext uri="{0D108BD9-81ED-4DB2-BD59-A6C34878D82A}">
+                    <a16:rowId xmlns:a16="http://schemas.microsoft.com/office/drawing/2014/main" val="10002"/>
+                  </a:ext>
+                </a:extLst>
               </a:tr>
               <a:tr h="457200">
                 <a:tc>
@@ -8158,7 +8176,7 @@
                     <a:bodyPr/>
                     <a:lstStyle/>
                     <a:p>
-                      <a:pPr indent="0" marL="0">
+                      <a:pPr marL="0" indent="0">
                         <a:buNone/>
                       </a:pPr>
                       <a:r>
@@ -8179,7 +8197,7 @@
                       </a:endParaRPr>
                     </a:p>
                   </a:txBody>
-                  <a:tcPr marL="91440" marR="91440" marT="36576" marB="36576" anchor="ctr">
+                  <a:tcPr marT="36576" marB="36576" anchor="ctr">
                     <a:lnL w="9525" cap="flat" cmpd="sng" algn="ctr">
                       <a:solidFill>
                         <a:srgbClr val="DAD6CC"/>
@@ -8226,7 +8244,7 @@
                     <a:bodyPr/>
                     <a:lstStyle/>
                     <a:p>
-                      <a:pPr indent="0" marL="0">
+                      <a:pPr marL="0" indent="0">
                         <a:buNone/>
                       </a:pPr>
                       <a:r>
@@ -8247,7 +8265,7 @@
                       </a:endParaRPr>
                     </a:p>
                   </a:txBody>
-                  <a:tcPr marL="91440" marR="91440" marT="36576" marB="36576" anchor="ctr">
+                  <a:tcPr marT="36576" marB="36576" anchor="ctr">
                     <a:lnL w="9525" cap="flat" cmpd="sng" algn="ctr">
                       <a:solidFill>
                         <a:srgbClr val="DAD6CC"/>
@@ -8294,7 +8312,7 @@
                     <a:bodyPr/>
                     <a:lstStyle/>
                     <a:p>
-                      <a:pPr indent="0" marL="0">
+                      <a:pPr marL="0" indent="0">
                         <a:buNone/>
                       </a:pPr>
                       <a:r>
@@ -8315,7 +8333,7 @@
                       </a:endParaRPr>
                     </a:p>
                   </a:txBody>
-                  <a:tcPr marL="91440" marR="91440" marT="36576" marB="36576" anchor="ctr">
+                  <a:tcPr marT="36576" marB="36576" anchor="ctr">
                     <a:lnL w="9525" cap="flat" cmpd="sng" algn="ctr">
                       <a:solidFill>
                         <a:srgbClr val="DAD6CC"/>
@@ -8357,6 +8375,11 @@
                     </a:solidFill>
                   </a:tcPr>
                 </a:tc>
+                <a:extLst>
+                  <a:ext uri="{0D108BD9-81ED-4DB2-BD59-A6C34878D82A}">
+                    <a16:rowId xmlns:a16="http://schemas.microsoft.com/office/drawing/2014/main" val="10003"/>
+                  </a:ext>
+                </a:extLst>
               </a:tr>
               <a:tr h="457200">
                 <a:tc>
@@ -8364,7 +8387,7 @@
                     <a:bodyPr/>
                     <a:lstStyle/>
                     <a:p>
-                      <a:pPr indent="0" marL="0">
+                      <a:pPr marL="0" indent="0">
                         <a:buNone/>
                       </a:pPr>
                       <a:r>
@@ -8385,7 +8408,7 @@
                       </a:endParaRPr>
                     </a:p>
                   </a:txBody>
-                  <a:tcPr marL="91440" marR="91440" marT="36576" marB="36576" anchor="ctr">
+                  <a:tcPr marT="36576" marB="36576" anchor="ctr">
                     <a:lnL w="9525" cap="flat" cmpd="sng" algn="ctr">
                       <a:solidFill>
                         <a:srgbClr val="DAD6CC"/>
@@ -8432,7 +8455,7 @@
                     <a:bodyPr/>
                     <a:lstStyle/>
                     <a:p>
-                      <a:pPr indent="0" marL="0">
+                      <a:pPr marL="0" indent="0">
                         <a:buNone/>
                       </a:pPr>
                       <a:r>
@@ -8453,7 +8476,7 @@
                       </a:endParaRPr>
                     </a:p>
                   </a:txBody>
-                  <a:tcPr marL="91440" marR="91440" marT="36576" marB="36576" anchor="ctr">
+                  <a:tcPr marT="36576" marB="36576" anchor="ctr">
                     <a:lnL w="9525" cap="flat" cmpd="sng" algn="ctr">
                       <a:solidFill>
                         <a:srgbClr val="DAD6CC"/>
@@ -8500,7 +8523,7 @@
                     <a:bodyPr/>
                     <a:lstStyle/>
                     <a:p>
-                      <a:pPr indent="0" marL="0">
+                      <a:pPr marL="0" indent="0">
                         <a:buNone/>
                       </a:pPr>
                       <a:r>
@@ -8521,7 +8544,7 @@
                       </a:endParaRPr>
                     </a:p>
                   </a:txBody>
-                  <a:tcPr marL="91440" marR="91440" marT="36576" marB="36576" anchor="ctr">
+                  <a:tcPr marT="36576" marB="36576" anchor="ctr">
                     <a:lnL w="9525" cap="flat" cmpd="sng" algn="ctr">
                       <a:solidFill>
                         <a:srgbClr val="DAD6CC"/>
@@ -8563,6 +8586,11 @@
                     </a:solidFill>
                   </a:tcPr>
                 </a:tc>
+                <a:extLst>
+                  <a:ext uri="{0D108BD9-81ED-4DB2-BD59-A6C34878D82A}">
+                    <a16:rowId xmlns:a16="http://schemas.microsoft.com/office/drawing/2014/main" val="10004"/>
+                  </a:ext>
+                </a:extLst>
               </a:tr>
             </a:tbl>
           </a:graphicData>
@@ -8570,7 +8598,7 @@
       </p:graphicFrame>
       <p:sp>
         <p:nvSpPr>
-          <p:cNvPr id="6" name="Text 2"/>
+          <p:cNvPr id="4" name="Text 2"/>
           <p:cNvSpPr txBox="1"/>
           <p:nvPr/>
         </p:nvSpPr>
@@ -8589,7 +8617,7 @@
           <a:bodyPr wrap="square" lIns="0" tIns="0" rIns="0" bIns="0" rtlCol="0" anchor="t"/>
           <a:lstStyle/>
           <a:p>
-            <a:pPr indent="0" marL="0">
+            <a:pPr marL="0" indent="0">
               <a:buNone/>
             </a:pPr>
             <a:r>
@@ -8603,9 +8631,6 @@
               </a:rPr>
               <a:t>Khó khăn đã xử lý: </a:t>
             </a:r>
-            <a:pPr indent="0" marL="0">
-              <a:buNone/>
-            </a:pPr>
             <a:r>
               <a:rPr lang="en-US" sz="1600" dirty="0">
                 <a:solidFill>
@@ -8642,7 +8667,7 @@
           <a:bodyPr wrap="square" lIns="0" tIns="0" rIns="0" bIns="0" rtlCol="0" anchor="ctr"/>
           <a:lstStyle/>
           <a:p>
-            <a:pPr indent="0" marL="0">
+            <a:pPr marL="0" indent="0">
               <a:buNone/>
             </a:pPr>
             <a:r>
@@ -8680,7 +8705,7 @@
           </a:prstGeom>
           <a:extLst>
             <a:ext uri="{C572A759-6A51-4108-AA02-DFA0A04FC94B}">
-              <ma14:wrappingTextBoxFlag xmlns:ma14="http://schemas.microsoft.com/office/mac/drawingml/2011/main" val="0"/>
+              <ma14:wrappingTextBoxFlag xmlns:ma14="http://schemas.microsoft.com/office/mac/drawingml/2011/main" xmlns="" val="0"/>
             </a:ext>
           </a:extLst>
         </p:spPr>
@@ -8701,7 +8726,7 @@
           <a:p>
             <a:pPr algn="r"/>
             <a:fld id="{F7021451-1387-4CA6-816F-3879F97B5CBC}" type="slidenum">
-              <a:rPr b="0" lang="en-US"/>
+              <a:rPr lang="en-US" b="0"/>
               <a:t>5</a:t>
             </a:fld>
             <a:endParaRPr lang="en-US"/>
@@ -8754,11 +8779,11 @@
           <a:bodyPr wrap="square" lIns="0" tIns="0" rIns="0" bIns="0" rtlCol="0" anchor="ctr"/>
           <a:lstStyle/>
           <a:p>
-            <a:pPr indent="0" marL="0">
+            <a:pPr marL="0" indent="0">
               <a:buNone/>
             </a:pPr>
             <a:r>
-              <a:rPr lang="en-US" sz="1300" b="1" spc="200" kern="0" dirty="0">
+              <a:rPr lang="en-US" sz="1300" b="1" kern="0" spc="200" dirty="0">
                 <a:solidFill>
                   <a:srgbClr val="E07B39"/>
                 </a:solidFill>
@@ -8775,9 +8800,11 @@
       <p:sp>
         <p:nvSpPr>
           <p:cNvPr id="3" name="Text 0"/>
-          <p:cNvSpPr/>
+          <p:cNvSpPr>
+            <a:spLocks noGrp="1"/>
+          </p:cNvSpPr>
           <p:nvPr>
-            <p:ph idx="100" type="title" hasCustomPrompt="1"/>
+            <p:ph type="title" idx="100" hasCustomPrompt="1"/>
           </p:nvPr>
         </p:nvSpPr>
         <p:spPr>
@@ -8795,7 +8822,7 @@
           <a:bodyPr wrap="square" lIns="0" tIns="0" rIns="0" bIns="0" rtlCol="0" anchor="t"/>
           <a:lstStyle/>
           <a:p>
-            <a:pPr indent="0" marL="0">
+            <a:pPr marL="0" indent="0">
               <a:buNone/>
             </a:pPr>
             <a:r>
@@ -8839,6 +8866,13 @@
             <a:prstDash val="solid"/>
           </a:ln>
         </p:spPr>
+        <p:txBody>
+          <a:bodyPr/>
+          <a:lstStyle/>
+          <a:p>
+            <a:endParaRPr lang="en-VN"/>
+          </a:p>
+        </p:txBody>
       </p:sp>
       <p:sp>
         <p:nvSpPr>
@@ -8861,7 +8895,7 @@
           <a:bodyPr wrap="square" lIns="0" tIns="0" rIns="0" bIns="0" rtlCol="0" anchor="ctr"/>
           <a:lstStyle/>
           <a:p>
-            <a:pPr indent="0" marL="0">
+            <a:pPr marL="0" indent="0">
               <a:buNone/>
             </a:pPr>
             <a:r>
@@ -9032,6 +9066,13 @@
             <a:prstDash val="solid"/>
           </a:ln>
         </p:spPr>
+        <p:txBody>
+          <a:bodyPr/>
+          <a:lstStyle/>
+          <a:p>
+            <a:endParaRPr lang="en-VN"/>
+          </a:p>
+        </p:txBody>
       </p:sp>
       <p:sp>
         <p:nvSpPr>
@@ -9054,7 +9095,7 @@
           <a:bodyPr wrap="square" lIns="0" tIns="0" rIns="0" bIns="0" rtlCol="0" anchor="ctr"/>
           <a:lstStyle/>
           <a:p>
-            <a:pPr indent="0" marL="0">
+            <a:pPr marL="0" indent="0">
               <a:buNone/>
             </a:pPr>
             <a:r>
@@ -9225,6 +9266,13 @@
             <a:prstDash val="solid"/>
           </a:ln>
         </p:spPr>
+        <p:txBody>
+          <a:bodyPr/>
+          <a:lstStyle/>
+          <a:p>
+            <a:endParaRPr lang="en-VN"/>
+          </a:p>
+        </p:txBody>
       </p:sp>
       <p:sp>
         <p:nvSpPr>
@@ -9247,7 +9295,7 @@
           <a:bodyPr wrap="square" lIns="0" tIns="0" rIns="0" bIns="0" rtlCol="0" anchor="ctr"/>
           <a:lstStyle/>
           <a:p>
-            <a:pPr indent="0" marL="0">
+            <a:pPr marL="0" indent="0">
               <a:buNone/>
             </a:pPr>
             <a:r>
@@ -9413,7 +9461,7 @@
           <a:bodyPr wrap="square" lIns="0" tIns="0" rIns="0" bIns="0" rtlCol="0" anchor="ctr"/>
           <a:lstStyle/>
           <a:p>
-            <a:pPr indent="0" marL="0">
+            <a:pPr marL="0" indent="0">
               <a:buNone/>
             </a:pPr>
             <a:r>
@@ -9451,7 +9499,7 @@
           </a:prstGeom>
           <a:extLst>
             <a:ext uri="{C572A759-6A51-4108-AA02-DFA0A04FC94B}">
-              <ma14:wrappingTextBoxFlag xmlns:ma14="http://schemas.microsoft.com/office/mac/drawingml/2011/main" val="0"/>
+              <ma14:wrappingTextBoxFlag xmlns:ma14="http://schemas.microsoft.com/office/mac/drawingml/2011/main" xmlns="" val="0"/>
             </a:ext>
           </a:extLst>
         </p:spPr>
@@ -9472,7 +9520,7 @@
           <a:p>
             <a:pPr algn="r"/>
             <a:fld id="{F7021451-1387-4CA6-816F-3879F97B5CBC}" type="slidenum">
-              <a:rPr b="0" lang="en-US"/>
+              <a:rPr lang="en-US" b="0"/>
               <a:t>6</a:t>
             </a:fld>
             <a:endParaRPr lang="en-US"/>
@@ -9525,11 +9573,11 @@
           <a:bodyPr wrap="square" lIns="0" tIns="0" rIns="0" bIns="0" rtlCol="0" anchor="ctr"/>
           <a:lstStyle/>
           <a:p>
-            <a:pPr indent="0" marL="0">
+            <a:pPr marL="0" indent="0">
               <a:buNone/>
             </a:pPr>
             <a:r>
-              <a:rPr lang="en-US" sz="1300" b="1" spc="200" kern="0" dirty="0">
+              <a:rPr lang="en-US" sz="1300" b="1" kern="0" spc="200" dirty="0">
                 <a:solidFill>
                   <a:srgbClr val="B4531A"/>
                 </a:solidFill>
@@ -9546,9 +9594,11 @@
       <p:sp>
         <p:nvSpPr>
           <p:cNvPr id="3" name="Text 0"/>
-          <p:cNvSpPr/>
+          <p:cNvSpPr>
+            <a:spLocks noGrp="1"/>
+          </p:cNvSpPr>
           <p:nvPr>
-            <p:ph idx="100" type="title" hasCustomPrompt="1"/>
+            <p:ph type="title" idx="100" hasCustomPrompt="1"/>
           </p:nvPr>
         </p:nvSpPr>
         <p:spPr>
@@ -9566,7 +9616,7 @@
           <a:bodyPr wrap="square" lIns="0" tIns="0" rIns="0" bIns="0" rtlCol="0" anchor="t"/>
           <a:lstStyle/>
           <a:p>
-            <a:pPr indent="0" marL="0">
+            <a:pPr marL="0" indent="0">
               <a:buNone/>
             </a:pPr>
             <a:r>
@@ -9607,10 +9657,34 @@
             <a:tbl>
               <a:tblPr/>
               <a:tblGrid>
-                <a:gridCol w="3383280"/>
-                <a:gridCol w="2926080"/>
-                <a:gridCol w="1828800"/>
-                <a:gridCol w="2770632"/>
+                <a:gridCol w="3383280">
+                  <a:extLst>
+                    <a:ext uri="{9D8B030D-6E8A-4147-A177-3AD203B41FA5}">
+                      <a16:colId xmlns:a16="http://schemas.microsoft.com/office/drawing/2014/main" val="20000"/>
+                    </a:ext>
+                  </a:extLst>
+                </a:gridCol>
+                <a:gridCol w="2926080">
+                  <a:extLst>
+                    <a:ext uri="{9D8B030D-6E8A-4147-A177-3AD203B41FA5}">
+                      <a16:colId xmlns:a16="http://schemas.microsoft.com/office/drawing/2014/main" val="20001"/>
+                    </a:ext>
+                  </a:extLst>
+                </a:gridCol>
+                <a:gridCol w="1828800">
+                  <a:extLst>
+                    <a:ext uri="{9D8B030D-6E8A-4147-A177-3AD203B41FA5}">
+                      <a16:colId xmlns:a16="http://schemas.microsoft.com/office/drawing/2014/main" val="20002"/>
+                    </a:ext>
+                  </a:extLst>
+                </a:gridCol>
+                <a:gridCol w="2770632">
+                  <a:extLst>
+                    <a:ext uri="{9D8B030D-6E8A-4147-A177-3AD203B41FA5}">
+                      <a16:colId xmlns:a16="http://schemas.microsoft.com/office/drawing/2014/main" val="20003"/>
+                    </a:ext>
+                  </a:extLst>
+                </a:gridCol>
               </a:tblGrid>
               <a:tr h="566928">
                 <a:tc>
@@ -9618,7 +9692,7 @@
                     <a:bodyPr/>
                     <a:lstStyle/>
                     <a:p>
-                      <a:pPr indent="0" marL="0">
+                      <a:pPr marL="0" indent="0">
                         <a:buNone/>
                       </a:pPr>
                       <a:r>
@@ -9639,7 +9713,7 @@
                       </a:endParaRPr>
                     </a:p>
                   </a:txBody>
-                  <a:tcPr marL="91440" marR="91440" marT="36576" marB="36576" anchor="ctr">
+                  <a:tcPr marT="36576" marB="36576" anchor="ctr">
                     <a:lnL w="9525" cap="flat" cmpd="sng" algn="ctr">
                       <a:solidFill>
                         <a:srgbClr val="DAD6CC"/>
@@ -9686,7 +9760,7 @@
                     <a:bodyPr/>
                     <a:lstStyle/>
                     <a:p>
-                      <a:pPr indent="0" marL="0">
+                      <a:pPr marL="0" indent="0">
                         <a:buNone/>
                       </a:pPr>
                       <a:r>
@@ -9707,7 +9781,7 @@
                       </a:endParaRPr>
                     </a:p>
                   </a:txBody>
-                  <a:tcPr marL="91440" marR="91440" marT="36576" marB="36576" anchor="ctr">
+                  <a:tcPr marT="36576" marB="36576" anchor="ctr">
                     <a:lnL w="9525" cap="flat" cmpd="sng" algn="ctr">
                       <a:solidFill>
                         <a:srgbClr val="DAD6CC"/>
@@ -9754,7 +9828,7 @@
                     <a:bodyPr/>
                     <a:lstStyle/>
                     <a:p>
-                      <a:pPr indent="0" marL="0">
+                      <a:pPr marL="0" indent="0">
                         <a:buNone/>
                       </a:pPr>
                       <a:r>
@@ -9775,7 +9849,7 @@
                       </a:endParaRPr>
                     </a:p>
                   </a:txBody>
-                  <a:tcPr marL="91440" marR="91440" marT="36576" marB="36576" anchor="ctr">
+                  <a:tcPr marT="36576" marB="36576" anchor="ctr">
                     <a:lnL w="9525" cap="flat" cmpd="sng" algn="ctr">
                       <a:solidFill>
                         <a:srgbClr val="DAD6CC"/>
@@ -9822,7 +9896,7 @@
                     <a:bodyPr/>
                     <a:lstStyle/>
                     <a:p>
-                      <a:pPr indent="0" marL="0">
+                      <a:pPr marL="0" indent="0">
                         <a:buNone/>
                       </a:pPr>
                       <a:r>
@@ -9843,7 +9917,7 @@
                       </a:endParaRPr>
                     </a:p>
                   </a:txBody>
-                  <a:tcPr marL="91440" marR="91440" marT="36576" marB="36576" anchor="ctr">
+                  <a:tcPr marT="36576" marB="36576" anchor="ctr">
                     <a:lnL w="9525" cap="flat" cmpd="sng" algn="ctr">
                       <a:solidFill>
                         <a:srgbClr val="DAD6CC"/>
@@ -9885,6 +9959,11 @@
                     </a:solidFill>
                   </a:tcPr>
                 </a:tc>
+                <a:extLst>
+                  <a:ext uri="{0D108BD9-81ED-4DB2-BD59-A6C34878D82A}">
+                    <a16:rowId xmlns:a16="http://schemas.microsoft.com/office/drawing/2014/main" val="10000"/>
+                  </a:ext>
+                </a:extLst>
               </a:tr>
               <a:tr h="566928">
                 <a:tc>
@@ -9892,7 +9971,7 @@
                     <a:bodyPr/>
                     <a:lstStyle/>
                     <a:p>
-                      <a:pPr indent="0" marL="0">
+                      <a:pPr marL="0" indent="0">
                         <a:buNone/>
                       </a:pPr>
                       <a:r>
@@ -9913,7 +9992,7 @@
                       </a:endParaRPr>
                     </a:p>
                   </a:txBody>
-                  <a:tcPr marL="91440" marR="91440" marT="36576" marB="36576" anchor="ctr">
+                  <a:tcPr marT="36576" marB="36576" anchor="ctr">
                     <a:lnL w="9525" cap="flat" cmpd="sng" algn="ctr">
                       <a:solidFill>
                         <a:srgbClr val="DAD6CC"/>
@@ -9960,7 +10039,7 @@
                     <a:bodyPr/>
                     <a:lstStyle/>
                     <a:p>
-                      <a:pPr indent="0" marL="0">
+                      <a:pPr marL="0" indent="0">
                         <a:buNone/>
                       </a:pPr>
                       <a:r>
@@ -9981,7 +10060,7 @@
                       </a:endParaRPr>
                     </a:p>
                   </a:txBody>
-                  <a:tcPr marL="91440" marR="91440" marT="36576" marB="36576" anchor="ctr">
+                  <a:tcPr marT="36576" marB="36576" anchor="ctr">
                     <a:lnL w="9525" cap="flat" cmpd="sng" algn="ctr">
                       <a:solidFill>
                         <a:srgbClr val="DAD6CC"/>
@@ -10028,7 +10107,7 @@
                     <a:bodyPr/>
                     <a:lstStyle/>
                     <a:p>
-                      <a:pPr indent="0" marL="0">
+                      <a:pPr marL="0" indent="0">
                         <a:buNone/>
                       </a:pPr>
                       <a:r>
@@ -10049,7 +10128,7 @@
                       </a:endParaRPr>
                     </a:p>
                   </a:txBody>
-                  <a:tcPr marL="91440" marR="91440" marT="36576" marB="36576" anchor="ctr">
+                  <a:tcPr marT="36576" marB="36576" anchor="ctr">
                     <a:lnL w="9525" cap="flat" cmpd="sng" algn="ctr">
                       <a:solidFill>
                         <a:srgbClr val="DAD6CC"/>
@@ -10096,7 +10175,7 @@
                     <a:bodyPr/>
                     <a:lstStyle/>
                     <a:p>
-                      <a:pPr indent="0" marL="0">
+                      <a:pPr marL="0" indent="0">
                         <a:buNone/>
                       </a:pPr>
                       <a:r>
@@ -10117,7 +10196,7 @@
                       </a:endParaRPr>
                     </a:p>
                   </a:txBody>
-                  <a:tcPr marL="91440" marR="91440" marT="36576" marB="36576" anchor="ctr">
+                  <a:tcPr marT="36576" marB="36576" anchor="ctr">
                     <a:lnL w="9525" cap="flat" cmpd="sng" algn="ctr">
                       <a:solidFill>
                         <a:srgbClr val="DAD6CC"/>
@@ -10159,6 +10238,11 @@
                     </a:solidFill>
                   </a:tcPr>
                 </a:tc>
+                <a:extLst>
+                  <a:ext uri="{0D108BD9-81ED-4DB2-BD59-A6C34878D82A}">
+                    <a16:rowId xmlns:a16="http://schemas.microsoft.com/office/drawing/2014/main" val="10001"/>
+                  </a:ext>
+                </a:extLst>
               </a:tr>
               <a:tr h="566928">
                 <a:tc>
@@ -10166,7 +10250,7 @@
                     <a:bodyPr/>
                     <a:lstStyle/>
                     <a:p>
-                      <a:pPr indent="0" marL="0">
+                      <a:pPr marL="0" indent="0">
                         <a:buNone/>
                       </a:pPr>
                       <a:r>
@@ -10187,7 +10271,7 @@
                       </a:endParaRPr>
                     </a:p>
                   </a:txBody>
-                  <a:tcPr marL="91440" marR="91440" marT="36576" marB="36576" anchor="ctr">
+                  <a:tcPr marT="36576" marB="36576" anchor="ctr">
                     <a:lnL w="9525" cap="flat" cmpd="sng" algn="ctr">
                       <a:solidFill>
                         <a:srgbClr val="DAD6CC"/>
@@ -10234,7 +10318,7 @@
                     <a:bodyPr/>
                     <a:lstStyle/>
                     <a:p>
-                      <a:pPr indent="0" marL="0">
+                      <a:pPr marL="0" indent="0">
                         <a:buNone/>
                       </a:pPr>
                       <a:r>
@@ -10255,7 +10339,7 @@
                       </a:endParaRPr>
                     </a:p>
                   </a:txBody>
-                  <a:tcPr marL="91440" marR="91440" marT="36576" marB="36576" anchor="ctr">
+                  <a:tcPr marT="36576" marB="36576" anchor="ctr">
                     <a:lnL w="9525" cap="flat" cmpd="sng" algn="ctr">
                       <a:solidFill>
                         <a:srgbClr val="DAD6CC"/>
@@ -10302,7 +10386,7 @@
                     <a:bodyPr/>
                     <a:lstStyle/>
                     <a:p>
-                      <a:pPr indent="0" marL="0">
+                      <a:pPr marL="0" indent="0">
                         <a:buNone/>
                       </a:pPr>
                       <a:r>
@@ -10323,7 +10407,7 @@
                       </a:endParaRPr>
                     </a:p>
                   </a:txBody>
-                  <a:tcPr marL="91440" marR="91440" marT="36576" marB="36576" anchor="ctr">
+                  <a:tcPr marT="36576" marB="36576" anchor="ctr">
                     <a:lnL w="9525" cap="flat" cmpd="sng" algn="ctr">
                       <a:solidFill>
                         <a:srgbClr val="DAD6CC"/>
@@ -10370,7 +10454,7 @@
                     <a:bodyPr/>
                     <a:lstStyle/>
                     <a:p>
-                      <a:pPr indent="0" marL="0">
+                      <a:pPr marL="0" indent="0">
                         <a:buNone/>
                       </a:pPr>
                       <a:r>
@@ -10391,7 +10475,7 @@
                       </a:endParaRPr>
                     </a:p>
                   </a:txBody>
-                  <a:tcPr marL="91440" marR="91440" marT="36576" marB="36576" anchor="ctr">
+                  <a:tcPr marT="36576" marB="36576" anchor="ctr">
                     <a:lnL w="9525" cap="flat" cmpd="sng" algn="ctr">
                       <a:solidFill>
                         <a:srgbClr val="DAD6CC"/>
@@ -10433,6 +10517,11 @@
                     </a:solidFill>
                   </a:tcPr>
                 </a:tc>
+                <a:extLst>
+                  <a:ext uri="{0D108BD9-81ED-4DB2-BD59-A6C34878D82A}">
+                    <a16:rowId xmlns:a16="http://schemas.microsoft.com/office/drawing/2014/main" val="10002"/>
+                  </a:ext>
+                </a:extLst>
               </a:tr>
             </a:tbl>
           </a:graphicData>
@@ -10464,6 +10553,13 @@
             <a:prstDash val="solid"/>
           </a:ln>
         </p:spPr>
+        <p:txBody>
+          <a:bodyPr/>
+          <a:lstStyle/>
+          <a:p>
+            <a:endParaRPr lang="en-VN"/>
+          </a:p>
+        </p:txBody>
       </p:sp>
       <p:sp>
         <p:nvSpPr>
@@ -10486,7 +10582,7 @@
           <a:bodyPr wrap="square" lIns="0" tIns="0" rIns="0" bIns="0" rtlCol="0" anchor="ctr"/>
           <a:lstStyle/>
           <a:p>
-            <a:pPr indent="0" marL="0">
+            <a:pPr marL="0" indent="0">
               <a:buNone/>
             </a:pPr>
             <a:r>
@@ -10525,7 +10621,7 @@
           <a:bodyPr wrap="square" lIns="0" tIns="0" rIns="0" bIns="0" rtlCol="0" anchor="t"/>
           <a:lstStyle/>
           <a:p>
-            <a:pPr indent="0" marL="0">
+            <a:pPr marL="0" indent="0">
               <a:buNone/>
             </a:pPr>
             <a:r>
@@ -10545,7 +10641,7 @@
       </p:sp>
       <p:sp>
         <p:nvSpPr>
-          <p:cNvPr id="8" name="Shape 5"/>
+          <p:cNvPr id="4" name="Shape 5"/>
           <p:cNvSpPr/>
           <p:nvPr/>
         </p:nvSpPr>
@@ -10569,6 +10665,13 @@
             <a:prstDash val="solid"/>
           </a:ln>
         </p:spPr>
+        <p:txBody>
+          <a:bodyPr/>
+          <a:lstStyle/>
+          <a:p>
+            <a:endParaRPr lang="en-VN"/>
+          </a:p>
+        </p:txBody>
       </p:sp>
       <p:sp>
         <p:nvSpPr>
@@ -10591,7 +10694,7 @@
           <a:bodyPr wrap="square" lIns="0" tIns="0" rIns="0" bIns="0" rtlCol="0" anchor="ctr"/>
           <a:lstStyle/>
           <a:p>
-            <a:pPr indent="0" marL="0">
+            <a:pPr marL="0" indent="0">
               <a:buNone/>
             </a:pPr>
             <a:r>
@@ -10630,7 +10733,7 @@
           <a:bodyPr wrap="square" lIns="0" tIns="0" rIns="0" bIns="0" rtlCol="0" anchor="t"/>
           <a:lstStyle/>
           <a:p>
-            <a:pPr indent="0" marL="0">
+            <a:pPr marL="0" indent="0">
               <a:buNone/>
             </a:pPr>
             <a:r>
@@ -10674,6 +10777,13 @@
             <a:prstDash val="solid"/>
           </a:ln>
         </p:spPr>
+        <p:txBody>
+          <a:bodyPr/>
+          <a:lstStyle/>
+          <a:p>
+            <a:endParaRPr lang="en-VN"/>
+          </a:p>
+        </p:txBody>
       </p:sp>
       <p:sp>
         <p:nvSpPr>
@@ -10696,7 +10806,7 @@
           <a:bodyPr wrap="square" lIns="0" tIns="0" rIns="0" bIns="0" rtlCol="0" anchor="ctr"/>
           <a:lstStyle/>
           <a:p>
-            <a:pPr indent="0" marL="0">
+            <a:pPr marL="0" indent="0">
               <a:buNone/>
             </a:pPr>
             <a:r>
@@ -10735,7 +10845,7 @@
           <a:bodyPr wrap="square" lIns="0" tIns="0" rIns="0" bIns="0" rtlCol="0" anchor="t"/>
           <a:lstStyle/>
           <a:p>
-            <a:pPr indent="0" marL="0">
+            <a:pPr marL="0" indent="0">
               <a:buNone/>
             </a:pPr>
             <a:r>
@@ -10774,7 +10884,7 @@
           <a:bodyPr wrap="square" lIns="0" tIns="0" rIns="0" bIns="0" rtlCol="0" anchor="ctr"/>
           <a:lstStyle/>
           <a:p>
-            <a:pPr indent="0" marL="0">
+            <a:pPr marL="0" indent="0">
               <a:buNone/>
             </a:pPr>
             <a:r>
@@ -10812,7 +10922,7 @@
           </a:prstGeom>
           <a:extLst>
             <a:ext uri="{C572A759-6A51-4108-AA02-DFA0A04FC94B}">
-              <ma14:wrappingTextBoxFlag xmlns:ma14="http://schemas.microsoft.com/office/mac/drawingml/2011/main" val="0"/>
+              <ma14:wrappingTextBoxFlag xmlns:ma14="http://schemas.microsoft.com/office/mac/drawingml/2011/main" xmlns="" val="0"/>
             </a:ext>
           </a:extLst>
         </p:spPr>
@@ -10833,7 +10943,7 @@
           <a:p>
             <a:pPr algn="r"/>
             <a:fld id="{F7021451-1387-4CA6-816F-3879F97B5CBC}" type="slidenum">
-              <a:rPr b="0" lang="en-US"/>
+              <a:rPr lang="en-US" b="0"/>
               <a:t>7</a:t>
             </a:fld>
             <a:endParaRPr lang="en-US"/>
@@ -10886,11 +10996,11 @@
           <a:bodyPr wrap="square" lIns="0" tIns="0" rIns="0" bIns="0" rtlCol="0" anchor="ctr"/>
           <a:lstStyle/>
           <a:p>
-            <a:pPr indent="0" marL="0">
+            <a:pPr marL="0" indent="0">
               <a:buNone/>
             </a:pPr>
             <a:r>
-              <a:rPr lang="en-US" sz="1300" b="1" spc="200" kern="0" dirty="0">
+              <a:rPr lang="en-US" sz="1300" b="1" kern="0" spc="200" dirty="0">
                 <a:solidFill>
                   <a:srgbClr val="E07B39"/>
                 </a:solidFill>
@@ -10907,9 +11017,11 @@
       <p:sp>
         <p:nvSpPr>
           <p:cNvPr id="3" name="Text 0"/>
-          <p:cNvSpPr/>
+          <p:cNvSpPr>
+            <a:spLocks noGrp="1"/>
+          </p:cNvSpPr>
           <p:nvPr>
-            <p:ph idx="100" type="title" hasCustomPrompt="1"/>
+            <p:ph type="title" idx="100" hasCustomPrompt="1"/>
           </p:nvPr>
         </p:nvSpPr>
         <p:spPr>
@@ -10927,7 +11039,7 @@
           <a:bodyPr wrap="square" lIns="0" tIns="0" rIns="0" bIns="0" rtlCol="0" anchor="t"/>
           <a:lstStyle/>
           <a:p>
-            <a:pPr indent="0" marL="0">
+            <a:pPr marL="0" indent="0">
               <a:buNone/>
             </a:pPr>
             <a:r>
@@ -10971,6 +11083,13 @@
             <a:prstDash val="solid"/>
           </a:ln>
         </p:spPr>
+        <p:txBody>
+          <a:bodyPr/>
+          <a:lstStyle/>
+          <a:p>
+            <a:endParaRPr lang="en-VN"/>
+          </a:p>
+        </p:txBody>
       </p:sp>
       <p:sp>
         <p:nvSpPr>
@@ -10993,7 +11112,7 @@
           <a:bodyPr wrap="square" lIns="0" tIns="0" rIns="0" bIns="0" rtlCol="0" anchor="ctr"/>
           <a:lstStyle/>
           <a:p>
-            <a:pPr algn="ctr" indent="0" marL="0">
+            <a:pPr marL="0" indent="0" algn="ctr">
               <a:buNone/>
             </a:pPr>
             <a:r>
@@ -11037,6 +11156,13 @@
             <a:prstDash val="solid"/>
           </a:ln>
         </p:spPr>
+        <p:txBody>
+          <a:bodyPr/>
+          <a:lstStyle/>
+          <a:p>
+            <a:endParaRPr lang="en-VN"/>
+          </a:p>
+        </p:txBody>
       </p:sp>
       <p:sp>
         <p:nvSpPr>
@@ -11059,7 +11185,7 @@
           <a:bodyPr wrap="square" lIns="0" tIns="0" rIns="0" bIns="0" rtlCol="0" anchor="ctr"/>
           <a:lstStyle/>
           <a:p>
-            <a:pPr indent="0" marL="0">
+            <a:pPr marL="0" indent="0">
               <a:buNone/>
             </a:pPr>
             <a:r>
@@ -11103,6 +11229,13 @@
             <a:prstDash val="solid"/>
           </a:ln>
         </p:spPr>
+        <p:txBody>
+          <a:bodyPr/>
+          <a:lstStyle/>
+          <a:p>
+            <a:endParaRPr lang="en-VN"/>
+          </a:p>
+        </p:txBody>
       </p:sp>
       <p:sp>
         <p:nvSpPr>
@@ -11125,7 +11258,7 @@
           <a:bodyPr wrap="square" lIns="0" tIns="0" rIns="0" bIns="0" rtlCol="0" anchor="ctr"/>
           <a:lstStyle/>
           <a:p>
-            <a:pPr algn="ctr" indent="0" marL="0">
+            <a:pPr marL="0" indent="0" algn="ctr">
               <a:buNone/>
             </a:pPr>
             <a:r>
@@ -11169,6 +11302,13 @@
             <a:prstDash val="solid"/>
           </a:ln>
         </p:spPr>
+        <p:txBody>
+          <a:bodyPr/>
+          <a:lstStyle/>
+          <a:p>
+            <a:endParaRPr lang="en-VN"/>
+          </a:p>
+        </p:txBody>
       </p:sp>
       <p:sp>
         <p:nvSpPr>
@@ -11191,7 +11331,7 @@
           <a:bodyPr wrap="square" lIns="0" tIns="0" rIns="0" bIns="0" rtlCol="0" anchor="ctr"/>
           <a:lstStyle/>
           <a:p>
-            <a:pPr indent="0" marL="0">
+            <a:pPr marL="0" indent="0">
               <a:buNone/>
             </a:pPr>
             <a:r>
@@ -11235,6 +11375,13 @@
             <a:prstDash val="solid"/>
           </a:ln>
         </p:spPr>
+        <p:txBody>
+          <a:bodyPr/>
+          <a:lstStyle/>
+          <a:p>
+            <a:endParaRPr lang="en-VN"/>
+          </a:p>
+        </p:txBody>
       </p:sp>
       <p:sp>
         <p:nvSpPr>
@@ -11257,7 +11404,7 @@
           <a:bodyPr wrap="square" lIns="0" tIns="0" rIns="0" bIns="0" rtlCol="0" anchor="ctr"/>
           <a:lstStyle/>
           <a:p>
-            <a:pPr algn="ctr" indent="0" marL="0">
+            <a:pPr marL="0" indent="0" algn="ctr">
               <a:buNone/>
             </a:pPr>
             <a:r>
@@ -11301,6 +11448,13 @@
             <a:prstDash val="solid"/>
           </a:ln>
         </p:spPr>
+        <p:txBody>
+          <a:bodyPr/>
+          <a:lstStyle/>
+          <a:p>
+            <a:endParaRPr lang="en-VN"/>
+          </a:p>
+        </p:txBody>
       </p:sp>
       <p:sp>
         <p:nvSpPr>
@@ -11323,7 +11477,7 @@
           <a:bodyPr wrap="square" lIns="0" tIns="0" rIns="0" bIns="0" rtlCol="0" anchor="ctr"/>
           <a:lstStyle/>
           <a:p>
-            <a:pPr indent="0" marL="0">
+            <a:pPr marL="0" indent="0">
               <a:buNone/>
             </a:pPr>
             <a:r>
@@ -11367,6 +11521,13 @@
             <a:prstDash val="solid"/>
           </a:ln>
         </p:spPr>
+        <p:txBody>
+          <a:bodyPr/>
+          <a:lstStyle/>
+          <a:p>
+            <a:endParaRPr lang="en-VN"/>
+          </a:p>
+        </p:txBody>
       </p:sp>
       <p:sp>
         <p:nvSpPr>
@@ -11389,7 +11550,7 @@
           <a:bodyPr wrap="square" lIns="0" tIns="0" rIns="0" bIns="0" rtlCol="0" anchor="ctr"/>
           <a:lstStyle/>
           <a:p>
-            <a:pPr algn="ctr" indent="0" marL="0">
+            <a:pPr marL="0" indent="0" algn="ctr">
               <a:buNone/>
             </a:pPr>
             <a:r>
@@ -11433,6 +11594,13 @@
             <a:prstDash val="solid"/>
           </a:ln>
         </p:spPr>
+        <p:txBody>
+          <a:bodyPr/>
+          <a:lstStyle/>
+          <a:p>
+            <a:endParaRPr lang="en-VN"/>
+          </a:p>
+        </p:txBody>
       </p:sp>
       <p:sp>
         <p:nvSpPr>
@@ -11455,7 +11623,7 @@
           <a:bodyPr wrap="square" lIns="0" tIns="0" rIns="0" bIns="0" rtlCol="0" anchor="ctr"/>
           <a:lstStyle/>
           <a:p>
-            <a:pPr indent="0" marL="0">
+            <a:pPr marL="0" indent="0">
               <a:buNone/>
             </a:pPr>
             <a:r>
@@ -11494,7 +11662,7 @@
           <a:bodyPr wrap="square" lIns="0" tIns="0" rIns="0" bIns="0" rtlCol="0" anchor="t"/>
           <a:lstStyle/>
           <a:p>
-            <a:pPr indent="0" marL="0">
+            <a:pPr marL="0" indent="0">
               <a:buNone/>
             </a:pPr>
             <a:r>
@@ -11533,7 +11701,7 @@
           <a:bodyPr wrap="square" lIns="0" tIns="0" rIns="0" bIns="0" rtlCol="0" anchor="ctr"/>
           <a:lstStyle/>
           <a:p>
-            <a:pPr indent="0" marL="0">
+            <a:pPr marL="0" indent="0">
               <a:buNone/>
             </a:pPr>
             <a:r>
@@ -11571,7 +11739,7 @@
           </a:prstGeom>
           <a:extLst>
             <a:ext uri="{C572A759-6A51-4108-AA02-DFA0A04FC94B}">
-              <ma14:wrappingTextBoxFlag xmlns:ma14="http://schemas.microsoft.com/office/mac/drawingml/2011/main" val="0"/>
+              <ma14:wrappingTextBoxFlag xmlns:ma14="http://schemas.microsoft.com/office/mac/drawingml/2011/main" xmlns="" val="0"/>
             </a:ext>
           </a:extLst>
         </p:spPr>
@@ -11592,7 +11760,7 @@
           <a:p>
             <a:pPr algn="r"/>
             <a:fld id="{F7021451-1387-4CA6-816F-3879F97B5CBC}" type="slidenum">
-              <a:rPr b="0" lang="en-US"/>
+              <a:rPr lang="en-US" b="0"/>
               <a:t>8</a:t>
             </a:fld>
             <a:endParaRPr lang="en-US"/>
@@ -11900,4 +12068,319 @@
     </a:ext>
   </a:extLst>
 </a:theme>
+</file>
+
+<file path=ppt/theme/theme2.xml><?xml version="1.0" encoding="utf-8"?>
+<a:theme xmlns:a="http://schemas.openxmlformats.org/drawingml/2006/main" name="Office Theme">
+  <a:themeElements>
+    <a:clrScheme name="Office">
+      <a:dk1>
+        <a:sysClr val="windowText" lastClr="000000"/>
+      </a:dk1>
+      <a:lt1>
+        <a:sysClr val="window" lastClr="FFFFFF"/>
+      </a:lt1>
+      <a:dk2>
+        <a:srgbClr val="0E2841"/>
+      </a:dk2>
+      <a:lt2>
+        <a:srgbClr val="E8E8E8"/>
+      </a:lt2>
+      <a:accent1>
+        <a:srgbClr val="156082"/>
+      </a:accent1>
+      <a:accent2>
+        <a:srgbClr val="E97132"/>
+      </a:accent2>
+      <a:accent3>
+        <a:srgbClr val="196B24"/>
+      </a:accent3>
+      <a:accent4>
+        <a:srgbClr val="0F9ED5"/>
+      </a:accent4>
+      <a:accent5>
+        <a:srgbClr val="A02B93"/>
+      </a:accent5>
+      <a:accent6>
+        <a:srgbClr val="4EA72E"/>
+      </a:accent6>
+      <a:hlink>
+        <a:srgbClr val="467886"/>
+      </a:hlink>
+      <a:folHlink>
+        <a:srgbClr val="96607D"/>
+      </a:folHlink>
+    </a:clrScheme>
+    <a:fontScheme name="Office">
+      <a:majorFont>
+        <a:latin typeface="Aptos Display" panose="02110004020202020204"/>
+        <a:ea typeface=""/>
+        <a:cs typeface=""/>
+        <a:font script="Jpan" typeface="游ゴシック Light"/>
+        <a:font script="Hang" typeface="맑은 고딕"/>
+        <a:font script="Hans" typeface="等线 Light"/>
+        <a:font script="Hant" typeface="新細明體"/>
+        <a:font script="Arab" typeface="Times New Roman"/>
+        <a:font script="Hebr" typeface="Times New Roman"/>
+        <a:font script="Thai" typeface="Angsana New"/>
+        <a:font script="Ethi" typeface="Nyala"/>
+        <a:font script="Beng" typeface="Vrinda"/>
+        <a:font script="Gujr" typeface="Shruti"/>
+        <a:font script="Khmr" typeface="MoolBoran"/>
+        <a:font script="Knda" typeface="Tunga"/>
+        <a:font script="Guru" typeface="Raavi"/>
+        <a:font script="Cans" typeface="Euphemia"/>
+        <a:font script="Cher" typeface="Plantagenet Cherokee"/>
+        <a:font script="Yiii" typeface="Microsoft Yi Baiti"/>
+        <a:font script="Tibt" typeface="Microsoft Himalaya"/>
+        <a:font script="Thaa" typeface="MV Boli"/>
+        <a:font script="Deva" typeface="Mangal"/>
+        <a:font script="Telu" typeface="Gautami"/>
+        <a:font script="Taml" typeface="Latha"/>
+        <a:font script="Syrc" typeface="Estrangelo Edessa"/>
+        <a:font script="Orya" typeface="Kalinga"/>
+        <a:font script="Mlym" typeface="Kartika"/>
+        <a:font script="Laoo" typeface="DokChampa"/>
+        <a:font script="Sinh" typeface="Iskoola Pota"/>
+        <a:font script="Mong" typeface="Mongolian Baiti"/>
+        <a:font script="Viet" typeface="Times New Roman"/>
+        <a:font script="Uigh" typeface="Microsoft Uighur"/>
+        <a:font script="Geor" typeface="Sylfaen"/>
+        <a:font script="Armn" typeface="Arial"/>
+        <a:font script="Bugi" typeface="Leelawadee UI"/>
+        <a:font script="Bopo" typeface="Microsoft JhengHei"/>
+        <a:font script="Java" typeface="Javanese Text"/>
+        <a:font script="Lisu" typeface="Segoe UI"/>
+        <a:font script="Mymr" typeface="Myanmar Text"/>
+        <a:font script="Nkoo" typeface="Ebrima"/>
+        <a:font script="Olck" typeface="Nirmala UI"/>
+        <a:font script="Osma" typeface="Ebrima"/>
+        <a:font script="Phag" typeface="Phagspa"/>
+        <a:font script="Syrn" typeface="Estrangelo Edessa"/>
+        <a:font script="Syrj" typeface="Estrangelo Edessa"/>
+        <a:font script="Syre" typeface="Estrangelo Edessa"/>
+        <a:font script="Sora" typeface="Nirmala UI"/>
+        <a:font script="Tale" typeface="Microsoft Tai Le"/>
+        <a:font script="Talu" typeface="Microsoft New Tai Lue"/>
+        <a:font script="Tfng" typeface="Ebrima"/>
+      </a:majorFont>
+      <a:minorFont>
+        <a:latin typeface="Aptos" panose="02110004020202020204"/>
+        <a:ea typeface=""/>
+        <a:cs typeface=""/>
+        <a:font script="Jpan" typeface="游ゴシック"/>
+        <a:font script="Hang" typeface="맑은 고딕"/>
+        <a:font script="Hans" typeface="等线"/>
+        <a:font script="Hant" typeface="新細明體"/>
+        <a:font script="Arab" typeface="Arial"/>
+        <a:font script="Hebr" typeface="Arial"/>
+        <a:font script="Thai" typeface="Cordia New"/>
+        <a:font script="Ethi" typeface="Nyala"/>
+        <a:font script="Beng" typeface="Vrinda"/>
+        <a:font script="Gujr" typeface="Shruti"/>
+        <a:font script="Khmr" typeface="DaunPenh"/>
+        <a:font script="Knda" typeface="Tunga"/>
+        <a:font script="Guru" typeface="Raavi"/>
+        <a:font script="Cans" typeface="Euphemia"/>
+        <a:font script="Cher" typeface="Plantagenet Cherokee"/>
+        <a:font script="Yiii" typeface="Microsoft Yi Baiti"/>
+        <a:font script="Tibt" typeface="Microsoft Himalaya"/>
+        <a:font script="Thaa" typeface="MV Boli"/>
+        <a:font script="Deva" typeface="Mangal"/>
+        <a:font script="Telu" typeface="Gautami"/>
+        <a:font script="Taml" typeface="Latha"/>
+        <a:font script="Syrc" typeface="Estrangelo Edessa"/>
+        <a:font script="Orya" typeface="Kalinga"/>
+        <a:font script="Mlym" typeface="Kartika"/>
+        <a:font script="Laoo" typeface="DokChampa"/>
+        <a:font script="Sinh" typeface="Iskoola Pota"/>
+        <a:font script="Mong" typeface="Mongolian Baiti"/>
+        <a:font script="Viet" typeface="Arial"/>
+        <a:font script="Uigh" typeface="Microsoft Uighur"/>
+        <a:font script="Geor" typeface="Sylfaen"/>
+        <a:font script="Armn" typeface="Arial"/>
+        <a:font script="Bugi" typeface="Leelawadee UI"/>
+        <a:font script="Bopo" typeface="Microsoft JhengHei"/>
+        <a:font script="Java" typeface="Javanese Text"/>
+        <a:font script="Lisu" typeface="Segoe UI"/>
+        <a:font script="Mymr" typeface="Myanmar Text"/>
+        <a:font script="Nkoo" typeface="Ebrima"/>
+        <a:font script="Olck" typeface="Nirmala UI"/>
+        <a:font script="Osma" typeface="Ebrima"/>
+        <a:font script="Phag" typeface="Phagspa"/>
+        <a:font script="Syrn" typeface="Estrangelo Edessa"/>
+        <a:font script="Syrj" typeface="Estrangelo Edessa"/>
+        <a:font script="Syre" typeface="Estrangelo Edessa"/>
+        <a:font script="Sora" typeface="Nirmala UI"/>
+        <a:font script="Tale" typeface="Microsoft Tai Le"/>
+        <a:font script="Talu" typeface="Microsoft New Tai Lue"/>
+        <a:font script="Tfng" typeface="Ebrima"/>
+      </a:minorFont>
+    </a:fontScheme>
+    <a:fmtScheme name="Office">
+      <a:fillStyleLst>
+        <a:solidFill>
+          <a:schemeClr val="phClr"/>
+        </a:solidFill>
+        <a:gradFill rotWithShape="1">
+          <a:gsLst>
+            <a:gs pos="0">
+              <a:schemeClr val="phClr">
+                <a:lumMod val="110000"/>
+                <a:satMod val="105000"/>
+                <a:tint val="67000"/>
+              </a:schemeClr>
+            </a:gs>
+            <a:gs pos="50000">
+              <a:schemeClr val="phClr">
+                <a:lumMod val="105000"/>
+                <a:satMod val="103000"/>
+                <a:tint val="73000"/>
+              </a:schemeClr>
+            </a:gs>
+            <a:gs pos="100000">
+              <a:schemeClr val="phClr">
+                <a:lumMod val="105000"/>
+                <a:satMod val="109000"/>
+                <a:tint val="81000"/>
+              </a:schemeClr>
+            </a:gs>
+          </a:gsLst>
+          <a:lin ang="5400000" scaled="0"/>
+        </a:gradFill>
+        <a:gradFill rotWithShape="1">
+          <a:gsLst>
+            <a:gs pos="0">
+              <a:schemeClr val="phClr">
+                <a:satMod val="103000"/>
+                <a:lumMod val="102000"/>
+                <a:tint val="94000"/>
+              </a:schemeClr>
+            </a:gs>
+            <a:gs pos="50000">
+              <a:schemeClr val="phClr">
+                <a:satMod val="110000"/>
+                <a:lumMod val="100000"/>
+                <a:shade val="100000"/>
+              </a:schemeClr>
+            </a:gs>
+            <a:gs pos="100000">
+              <a:schemeClr val="phClr">
+                <a:lumMod val="99000"/>
+                <a:satMod val="120000"/>
+                <a:shade val="78000"/>
+              </a:schemeClr>
+            </a:gs>
+          </a:gsLst>
+          <a:lin ang="5400000" scaled="0"/>
+        </a:gradFill>
+      </a:fillStyleLst>
+      <a:lnStyleLst>
+        <a:ln w="12700" cap="flat" cmpd="sng" algn="ctr">
+          <a:solidFill>
+            <a:schemeClr val="phClr"/>
+          </a:solidFill>
+          <a:prstDash val="solid"/>
+          <a:miter lim="800000"/>
+        </a:ln>
+        <a:ln w="19050" cap="flat" cmpd="sng" algn="ctr">
+          <a:solidFill>
+            <a:schemeClr val="phClr"/>
+          </a:solidFill>
+          <a:prstDash val="solid"/>
+          <a:miter lim="800000"/>
+        </a:ln>
+        <a:ln w="25400" cap="flat" cmpd="sng" algn="ctr">
+          <a:solidFill>
+            <a:schemeClr val="phClr"/>
+          </a:solidFill>
+          <a:prstDash val="solid"/>
+          <a:miter lim="800000"/>
+        </a:ln>
+      </a:lnStyleLst>
+      <a:effectStyleLst>
+        <a:effectStyle>
+          <a:effectLst/>
+        </a:effectStyle>
+        <a:effectStyle>
+          <a:effectLst/>
+        </a:effectStyle>
+        <a:effectStyle>
+          <a:effectLst>
+            <a:outerShdw blurRad="57150" dist="19050" dir="5400000" algn="ctr" rotWithShape="0">
+              <a:srgbClr val="000000">
+                <a:alpha val="63000"/>
+              </a:srgbClr>
+            </a:outerShdw>
+          </a:effectLst>
+        </a:effectStyle>
+      </a:effectStyleLst>
+      <a:bgFillStyleLst>
+        <a:solidFill>
+          <a:schemeClr val="phClr"/>
+        </a:solidFill>
+        <a:solidFill>
+          <a:schemeClr val="phClr">
+            <a:tint val="95000"/>
+            <a:satMod val="170000"/>
+          </a:schemeClr>
+        </a:solidFill>
+        <a:gradFill rotWithShape="1">
+          <a:gsLst>
+            <a:gs pos="0">
+              <a:schemeClr val="phClr">
+                <a:tint val="93000"/>
+                <a:satMod val="150000"/>
+                <a:shade val="98000"/>
+                <a:lumMod val="102000"/>
+              </a:schemeClr>
+            </a:gs>
+            <a:gs pos="50000">
+              <a:schemeClr val="phClr">
+                <a:tint val="98000"/>
+                <a:satMod val="130000"/>
+                <a:shade val="90000"/>
+                <a:lumMod val="103000"/>
+              </a:schemeClr>
+            </a:gs>
+            <a:gs pos="100000">
+              <a:schemeClr val="phClr">
+                <a:shade val="63000"/>
+                <a:satMod val="120000"/>
+              </a:schemeClr>
+            </a:gs>
+          </a:gsLst>
+          <a:lin ang="5400000" scaled="0"/>
+        </a:gradFill>
+      </a:bgFillStyleLst>
+    </a:fmtScheme>
+  </a:themeElements>
+  <a:objectDefaults>
+    <a:lnDef>
+      <a:spPr/>
+      <a:bodyPr/>
+      <a:lstStyle/>
+      <a:style>
+        <a:lnRef idx="2">
+          <a:schemeClr val="accent1"/>
+        </a:lnRef>
+        <a:fillRef idx="0">
+          <a:schemeClr val="accent1"/>
+        </a:fillRef>
+        <a:effectRef idx="1">
+          <a:schemeClr val="accent1"/>
+        </a:effectRef>
+        <a:fontRef idx="minor">
+          <a:schemeClr val="tx1"/>
+        </a:fontRef>
+      </a:style>
+    </a:lnDef>
+  </a:objectDefaults>
+  <a:extraClrSchemeLst/>
+  <a:extLst>
+    <a:ext uri="{05A4C25C-085E-4340-85A3-A5531E510DB2}">
+      <thm15:themeFamily xmlns:thm15="http://schemas.microsoft.com/office/thememl/2012/main" name="Office Theme" id="{2E142A2C-CD16-42D6-873A-C26D2A0506FA}" vid="{1BDDFF52-6CD6-40A5-AB3C-68EB2F1E4D0A}"/>
+    </a:ext>
+  </a:extLst>
+</a:theme>
 </file>
</xml_diff>

<commit_message>
docs: add re-run on a second (Windows) machine to the midterm report and deck
- results from the Windows machine (race and sequential reports) match the Mac run 8/8
- midterm report: new subsection with the comparison, caveats and discarded first runs
- midterm deck: new slide 11 (13 slides), progress and plan updated

Co-Authored-By: Claude Sonnet 5.5 <noreply@anthropic.com>
</commit_message>
<xml_diff>
--- a/docs/BAO_CAO_GIUA_KY_R05-K15.pptx
+++ b/docs/BAO_CAO_GIUA_KY_R05-K15.pptx
@@ -17,9 +17,10 @@
     <p:sldId id="265" r:id="rId11"/>
     <p:sldId id="266" r:id="rId12"/>
     <p:sldId id="267" r:id="rId13"/>
+    <p:sldId id="268" r:id="rId14"/>
   </p:sldIdLst>
   <p:notesMasterIdLst>
-    <p:notesMasterId r:id="rId14"/>
+    <p:notesMasterId r:id="rId15"/>
   </p:notesMasterIdLst>
   <p:sldSz cx="12192000" cy="6858000"/>
   <p:notesSz cx="6858000" cy="12192000"/>
@@ -118,18 +119,18 @@
   <p:extLst>
     <p:ext uri="{521415D9-36F7-43E2-AB2F-B90AF26B5E84}">
       <p14:sectionLst xmlns:p14="http://schemas.microsoft.com/office/powerpoint/2010/main">
-        <p14:section name="Mở đầu" id="{0efd6425-b430-55d7-cdcf-3fc6700ef64e}">
+        <p14:section name="Mở đầu" id="{2238302a-4226-be89-d734-fc0712ea256c}">
           <p14:sldIdLst>
             <p14:sldId id="256"/>
             <p14:sldId id="257"/>
           </p14:sldIdLst>
         </p14:section>
-        <p14:section name="Tiến độ" id="{1da4ca07-aa1b-6573-cbf7-cfd80f2773e9}">
+        <p14:section name="Tiến độ" id="{e6671efc-6b28-0032-2b50-400ef5d150f1}">
           <p14:sldIdLst>
             <p14:sldId id="258"/>
           </p14:sldIdLst>
         </p14:section>
-        <p14:section name="Hệ thống và kiểm thử" id="{44508039-1f20-e7c0-b96d-f22635fd19f2}">
+        <p14:section name="Hệ thống và kiểm thử" id="{b5edd6eb-01d8-44a1-e320-4512422f4bc9}">
           <p14:sldIdLst>
             <p14:sldId id="259"/>
             <p14:sldId id="260"/>
@@ -137,21 +138,22 @@
             <p14:sldId id="262"/>
           </p14:sldIdLst>
         </p14:section>
-        <p14:section name="Kế hoạch kiểm thử" id="{a516ebde-66f9-54b1-cf27-b7edbe4598e6}">
+        <p14:section name="Kế hoạch kiểm thử" id="{ba3855ab-0702-7081-aad8-80dd9a6d3784}">
           <p14:sldIdLst>
             <p14:sldId id="263"/>
             <p14:sldId id="264"/>
           </p14:sldIdLst>
         </p14:section>
-        <p14:section name="Kết quả sơ bộ" id="{731c1199-535b-5a6e-c261-95ec7148f954}">
+        <p14:section name="Kết quả sơ bộ" id="{c5168517-9a86-0053-94f9-54571754f6a4}">
           <p14:sldIdLst>
             <p14:sldId id="265"/>
             <p14:sldId id="266"/>
+            <p14:sldId id="267"/>
           </p14:sldIdLst>
         </p14:section>
-        <p14:section name="Tiếp theo" id="{f6fea610-c268-d37e-d53c-07ec83a04a3b}">
+        <p14:section name="Tiếp theo" id="{9fce0ac1-77c1-2271-86f0-6a90a7a3a2be}">
           <p14:sldIdLst>
-            <p14:sldId id="267"/>
+            <p14:sldId id="268"/>
           </p14:sldIdLst>
         </p14:section>
       </p14:sectionLst>
@@ -734,7 +736,7 @@
           <a:p>
             <a:r>
               <a:rPr lang="en-US" dirty="0"/>
-              <a:t>Để chứng minh đây là lỗi thật, nhóm tái hiện lại từng lỗi bằng lệnh curl thuần, không dùng bộ test, rồi xem trực tiếp dữ liệu trong cơ sở dữ liệu. D4 là lỗi logic xảy ra cả khi gửi tuần tự; năm lỗi còn lại chỉ xảy ra khi đồng thời. Nhóm chưa báo lỗi cho nhóm phát triển Cal.com và chưa sửa mã Cal.com, nên nói là lỗi nhóm tìm được trên bản v6.2.0 chạy local.</a:t>
+              <a:t>Một thành viên chạy lại bộ test trên máy Windows của mình với cùng phiên bản mã. Kết luận tám test case giống hệt máy Mac: năm lỗi race chỉ sai khi đồng thời, một lỗi logic sai cả khi tuần tự, hai test case đúng. Hai lượt chạy đầu trên máy Windows không hợp lệ vì thiếu công cụ k6 và vì Cal.com dừng giữa chừng; nhóm đã loại và chỉ dùng lượt chạy sạch. Cấu hình máy và tên người test cần ghi vào báo cáo.</a:t>
             </a:r>
             <a:endParaRPr lang="en-US" dirty="0"/>
           </a:p>
@@ -822,6 +824,94 @@
           <a:p>
             <a:r>
               <a:rPr lang="en-US" dirty="0"/>
+              <a:t>Để chứng minh đây là lỗi thật, nhóm tái hiện lại từng lỗi bằng lệnh curl thuần, không dùng bộ test, rồi xem trực tiếp dữ liệu trong cơ sở dữ liệu. D4 là lỗi logic xảy ra cả khi gửi tuần tự; năm lỗi còn lại chỉ xảy ra khi đồng thời. Nhóm chưa báo lỗi cho nhóm phát triển Cal.com và chưa sửa mã Cal.com, nên nói là lỗi nhóm tìm được trên bản v6.2.0 chạy local.</a:t>
+            </a:r>
+            <a:endParaRPr lang="en-US" dirty="0"/>
+          </a:p>
+        </p:txBody>
+      </p:sp>
+      <p:sp>
+        <p:nvSpPr>
+          <p:cNvPr id="4" name="Slide Number Placeholder 3"/>
+          <p:cNvSpPr>
+            <a:spLocks noGrp="1"/>
+          </p:cNvSpPr>
+          <p:nvPr>
+            <p:ph type="sldNum" sz="quarter" idx="10"/>
+          </p:nvPr>
+        </p:nvSpPr>
+        <p:spPr/>
+        <p:txBody>
+          <a:bodyPr/>
+          <a:lstStyle/>
+          <a:p>
+            <a:fld id="{F7021451-1387-4CA6-816F-3879F97B5CBC}" type="slidenum">
+              <a:rPr lang="en-US"/>
+              <a:t>12</a:t>
+            </a:fld>
+            <a:endParaRPr lang="en-US"/>
+          </a:p>
+        </p:txBody>
+      </p:sp>
+    </p:spTree>
+    <p:extLst>
+      <p:ext uri="{BB962C8B-B14F-4D97-AF65-F5344CB8AC3E}">
+        <p14:creationId xmlns:p14="http://schemas.microsoft.com/office/powerpoint/2010/main" val="1024086991"/>
+      </p:ext>
+    </p:extLst>
+  </p:cSld>
+  <p:clrMapOvr>
+    <a:masterClrMapping/>
+  </p:clrMapOvr>
+</p:notes>
+</file>
+
+<file path=ppt/notesSlides/notesSlide13.xml><?xml version="1.0" encoding="utf-8"?>
+<p:notes xmlns:a="http://schemas.openxmlformats.org/drawingml/2006/main" xmlns:r="http://schemas.openxmlformats.org/officeDocument/2006/relationships" xmlns:p="http://schemas.openxmlformats.org/presentationml/2006/main">
+  <p:cSld>
+    <p:spTree>
+      <p:nvGrpSpPr>
+        <p:cNvPr id="1" name=""/>
+        <p:cNvGrpSpPr/>
+        <p:nvPr/>
+      </p:nvGrpSpPr>
+      <p:grpSpPr>
+        <a:xfrm>
+          <a:off x="0" y="0"/>
+          <a:ext cx="0" cy="0"/>
+          <a:chOff x="0" y="0"/>
+          <a:chExt cx="0" cy="0"/>
+        </a:xfrm>
+      </p:grpSpPr>
+      <p:sp>
+        <p:nvSpPr>
+          <p:cNvPr id="2" name="Slide Image Placeholder 1"/>
+          <p:cNvSpPr>
+            <a:spLocks noGrp="1" noRot="1" noChangeAspect="1"/>
+          </p:cNvSpPr>
+          <p:nvPr>
+            <p:ph type="sldImg"/>
+          </p:nvPr>
+        </p:nvSpPr>
+        <p:spPr/>
+      </p:sp>
+      <p:sp>
+        <p:nvSpPr>
+          <p:cNvPr id="3" name="Notes Placeholder 2"/>
+          <p:cNvSpPr>
+            <a:spLocks noGrp="1"/>
+          </p:cNvSpPr>
+          <p:nvPr>
+            <p:ph type="body" idx="1"/>
+          </p:nvPr>
+        </p:nvSpPr>
+        <p:spPr/>
+        <p:txBody>
+          <a:bodyPr/>
+          <a:lstStyle/>
+          <a:p>
+            <a:r>
+              <a:rPr lang="en-US" dirty="0"/>
               <a:t>Kế hoạch bốn giai đoạn đến bảo vệ; phần kiểm thử chính đã chạy xong nên thời gian còn lại dành cho kiểm chứng lại, hoàn thiện báo cáo và chuẩn bị bảo vệ. Rủi ro chính là race không tái hiện ổn định nên nhóm chạy nhiều vòng và báo tỉ lệ. Kết thúc phần báo cáo, mời thầy đặt câu hỏi.</a:t>
             </a:r>
             <a:endParaRPr lang="en-US" dirty="0"/>
@@ -845,7 +935,7 @@
           <a:p>
             <a:fld id="{F7021451-1387-4CA6-816F-3879F97B5CBC}" type="slidenum">
               <a:rPr lang="en-US"/>
-              <a:t>12</a:t>
+              <a:t>13</a:t>
             </a:fld>
             <a:endParaRPr lang="en-US"/>
           </a:p>
@@ -5916,7 +6006,1915 @@
                 <a:ea typeface="Consolas" pitchFamily="34" charset="-122"/>
                 <a:cs typeface="Consolas" pitchFamily="34" charset="-120"/>
               </a:rPr>
-              <a:t>10 · LỖI THẬT, TÁI HIỆN ĐỘC LẬP</a:t>
+              <a:t>10 · CHẠY LẠI TRÊN MÁY THỨ HAI</a:t>
+            </a:r>
+            <a:endParaRPr lang="en-US" sz="1300" dirty="0"/>
+          </a:p>
+        </p:txBody>
+      </p:sp>
+      <p:sp>
+        <p:nvSpPr>
+          <p:cNvPr id="3" name="Text 0"/>
+          <p:cNvSpPr/>
+          <p:nvPr>
+            <p:ph idx="100" type="title" hasCustomPrompt="1"/>
+          </p:nvPr>
+        </p:nvSpPr>
+        <p:spPr>
+          <a:xfrm>
+            <a:off x="640080" y="640080"/>
+            <a:ext cx="10908792" cy="868680"/>
+          </a:xfrm>
+          <a:prstGeom prst="rect">
+            <a:avLst/>
+          </a:prstGeom>
+          <a:noFill/>
+          <a:ln/>
+        </p:spPr>
+        <p:txBody>
+          <a:bodyPr wrap="square" lIns="0" tIns="0" rIns="0" bIns="0" rtlCol="0" anchor="t"/>
+          <a:lstStyle/>
+          <a:p>
+            <a:pPr indent="0" marL="0">
+              <a:buNone/>
+            </a:pPr>
+            <a:r>
+              <a:rPr lang="en-US" sz="3400" b="1" dirty="0">
+                <a:solidFill>
+                  <a:srgbClr val="12202B"/>
+                </a:solidFill>
+                <a:latin typeface="Calibri" pitchFamily="34" charset="0"/>
+                <a:ea typeface="Calibri" pitchFamily="34" charset="-122"/>
+                <a:cs typeface="Calibri" pitchFamily="34" charset="-120"/>
+              </a:rPr>
+              <a:t>Máy Windows cho cùng kết quả: khớp 8/8</a:t>
+            </a:r>
+            <a:endParaRPr lang="en-US" sz="3400" dirty="0"/>
+          </a:p>
+        </p:txBody>
+      </p:sp>
+      <p:graphicFrame>
+        <p:nvGraphicFramePr>
+          <p:cNvPr id="12" name="Table 0"/>
+          <p:cNvGraphicFramePr>
+            <a:graphicFrameLocks noGrp="1"/>
+          </p:cNvGraphicFramePr>
+          <p:nvPr>
+            <p:extLst>
+              <p:ext uri="{D42A27DB-BD31-4B8C-83A1-F6EECF244321}">
+                <p14:modId xmlns:p14="http://schemas.microsoft.com/office/powerpoint/2010/main" val="1579011935"/>
+              </p:ext>
+            </p:extLst>
+          </p:nvPr>
+        </p:nvGraphicFramePr>
+        <p:xfrm>
+          <a:off x="640080" y="1600200"/>
+          <a:ext cx="10908792" cy="914400"/>
+        </p:xfrm>
+        <a:graphic>
+          <a:graphicData uri="http://schemas.openxmlformats.org/drawingml/2006/table">
+            <a:tbl>
+              <a:tblPr/>
+              <a:tblGrid>
+                <a:gridCol w="3291840"/>
+                <a:gridCol w="2103120"/>
+                <a:gridCol w="2377440"/>
+                <a:gridCol w="2194560"/>
+                <a:gridCol w="941832"/>
+              </a:tblGrid>
+              <a:tr h="502920">
+                <a:tc>
+                  <a:txBody>
+                    <a:bodyPr/>
+                    <a:lstStyle/>
+                    <a:p>
+                      <a:pPr indent="0" marL="0">
+                        <a:buNone/>
+                      </a:pPr>
+                      <a:r>
+                        <a:rPr lang="en-US" sz="1500" b="1" dirty="0">
+                          <a:solidFill>
+                            <a:srgbClr val="12202B"/>
+                          </a:solidFill>
+                          <a:latin typeface="Calibri" pitchFamily="34" charset="0"/>
+                          <a:ea typeface="Calibri" pitchFamily="34" charset="-122"/>
+                          <a:cs typeface="Calibri" pitchFamily="34" charset="-120"/>
+                        </a:rPr>
+                        <a:t>Test case</a:t>
+                      </a:r>
+                      <a:endParaRPr lang="en-US" sz="1500" dirty="0">
+                        <a:latin typeface="Calibri" charset="0"/>
+                        <a:ea typeface="Calibri" charset="0"/>
+                        <a:cs typeface="Calibri" charset="0"/>
+                      </a:endParaRPr>
+                    </a:p>
+                  </a:txBody>
+                  <a:tcPr marL="91440" marR="91440" marT="36576" marB="36576" anchor="ctr">
+                    <a:lnL w="9525" cap="flat" cmpd="sng" algn="ctr">
+                      <a:solidFill>
+                        <a:srgbClr val="DAD6CC"/>
+                      </a:solidFill>
+                      <a:prstDash val="solid"/>
+                      <a:round/>
+                      <a:headEnd type="none" w="med" len="med"/>
+                      <a:tailEnd type="none" w="med" len="med"/>
+                    </a:lnL>
+                    <a:lnR w="9525" cap="flat" cmpd="sng" algn="ctr">
+                      <a:solidFill>
+                        <a:srgbClr val="DAD6CC"/>
+                      </a:solidFill>
+                      <a:prstDash val="solid"/>
+                      <a:round/>
+                      <a:headEnd type="none" w="med" len="med"/>
+                      <a:tailEnd type="none" w="med" len="med"/>
+                    </a:lnR>
+                    <a:lnT w="9525" cap="flat" cmpd="sng" algn="ctr">
+                      <a:solidFill>
+                        <a:srgbClr val="DAD6CC"/>
+                      </a:solidFill>
+                      <a:prstDash val="solid"/>
+                      <a:round/>
+                      <a:headEnd type="none" w="med" len="med"/>
+                      <a:tailEnd type="none" w="med" len="med"/>
+                    </a:lnT>
+                    <a:lnB w="9525" cap="flat" cmpd="sng" algn="ctr">
+                      <a:solidFill>
+                        <a:srgbClr val="DAD6CC"/>
+                      </a:solidFill>
+                      <a:prstDash val="solid"/>
+                      <a:round/>
+                      <a:headEnd type="none" w="med" len="med"/>
+                      <a:tailEnd type="none" w="med" len="med"/>
+                    </a:lnB>
+                    <a:solidFill>
+                      <a:srgbClr val="E6E2D6"/>
+                    </a:solidFill>
+                  </a:tcPr>
+                </a:tc>
+                <a:tc>
+                  <a:txBody>
+                    <a:bodyPr/>
+                    <a:lstStyle/>
+                    <a:p>
+                      <a:pPr indent="0" marL="0">
+                        <a:buNone/>
+                      </a:pPr>
+                      <a:r>
+                        <a:rPr lang="en-US" sz="1500" b="1" dirty="0">
+                          <a:solidFill>
+                            <a:srgbClr val="12202B"/>
+                          </a:solidFill>
+                          <a:latin typeface="Calibri" pitchFamily="34" charset="0"/>
+                          <a:ea typeface="Calibri" pitchFamily="34" charset="-122"/>
+                          <a:cs typeface="Calibri" pitchFamily="34" charset="-120"/>
+                        </a:rPr>
+                        <a:t>Mac: đồng thời</a:t>
+                      </a:r>
+                      <a:endParaRPr lang="en-US" sz="1500" dirty="0">
+                        <a:latin typeface="Calibri" charset="0"/>
+                        <a:ea typeface="Calibri" charset="0"/>
+                        <a:cs typeface="Calibri" charset="0"/>
+                      </a:endParaRPr>
+                    </a:p>
+                  </a:txBody>
+                  <a:tcPr marL="91440" marR="91440" marT="36576" marB="36576" anchor="ctr">
+                    <a:lnL w="9525" cap="flat" cmpd="sng" algn="ctr">
+                      <a:solidFill>
+                        <a:srgbClr val="DAD6CC"/>
+                      </a:solidFill>
+                      <a:prstDash val="solid"/>
+                      <a:round/>
+                      <a:headEnd type="none" w="med" len="med"/>
+                      <a:tailEnd type="none" w="med" len="med"/>
+                    </a:lnL>
+                    <a:lnR w="9525" cap="flat" cmpd="sng" algn="ctr">
+                      <a:solidFill>
+                        <a:srgbClr val="DAD6CC"/>
+                      </a:solidFill>
+                      <a:prstDash val="solid"/>
+                      <a:round/>
+                      <a:headEnd type="none" w="med" len="med"/>
+                      <a:tailEnd type="none" w="med" len="med"/>
+                    </a:lnR>
+                    <a:lnT w="9525" cap="flat" cmpd="sng" algn="ctr">
+                      <a:solidFill>
+                        <a:srgbClr val="DAD6CC"/>
+                      </a:solidFill>
+                      <a:prstDash val="solid"/>
+                      <a:round/>
+                      <a:headEnd type="none" w="med" len="med"/>
+                      <a:tailEnd type="none" w="med" len="med"/>
+                    </a:lnT>
+                    <a:lnB w="9525" cap="flat" cmpd="sng" algn="ctr">
+                      <a:solidFill>
+                        <a:srgbClr val="DAD6CC"/>
+                      </a:solidFill>
+                      <a:prstDash val="solid"/>
+                      <a:round/>
+                      <a:headEnd type="none" w="med" len="med"/>
+                      <a:tailEnd type="none" w="med" len="med"/>
+                    </a:lnB>
+                    <a:solidFill>
+                      <a:srgbClr val="E6E2D6"/>
+                    </a:solidFill>
+                  </a:tcPr>
+                </a:tc>
+                <a:tc>
+                  <a:txBody>
+                    <a:bodyPr/>
+                    <a:lstStyle/>
+                    <a:p>
+                      <a:pPr indent="0" marL="0">
+                        <a:buNone/>
+                      </a:pPr>
+                      <a:r>
+                        <a:rPr lang="en-US" sz="1500" b="1" dirty="0">
+                          <a:solidFill>
+                            <a:srgbClr val="12202B"/>
+                          </a:solidFill>
+                          <a:latin typeface="Calibri" pitchFamily="34" charset="0"/>
+                          <a:ea typeface="Calibri" pitchFamily="34" charset="-122"/>
+                          <a:cs typeface="Calibri" pitchFamily="34" charset="-120"/>
+                        </a:rPr>
+                        <a:t>Windows: đồng thời</a:t>
+                      </a:r>
+                      <a:endParaRPr lang="en-US" sz="1500" dirty="0">
+                        <a:latin typeface="Calibri" charset="0"/>
+                        <a:ea typeface="Calibri" charset="0"/>
+                        <a:cs typeface="Calibri" charset="0"/>
+                      </a:endParaRPr>
+                    </a:p>
+                  </a:txBody>
+                  <a:tcPr marL="91440" marR="91440" marT="36576" marB="36576" anchor="ctr">
+                    <a:lnL w="9525" cap="flat" cmpd="sng" algn="ctr">
+                      <a:solidFill>
+                        <a:srgbClr val="DAD6CC"/>
+                      </a:solidFill>
+                      <a:prstDash val="solid"/>
+                      <a:round/>
+                      <a:headEnd type="none" w="med" len="med"/>
+                      <a:tailEnd type="none" w="med" len="med"/>
+                    </a:lnL>
+                    <a:lnR w="9525" cap="flat" cmpd="sng" algn="ctr">
+                      <a:solidFill>
+                        <a:srgbClr val="DAD6CC"/>
+                      </a:solidFill>
+                      <a:prstDash val="solid"/>
+                      <a:round/>
+                      <a:headEnd type="none" w="med" len="med"/>
+                      <a:tailEnd type="none" w="med" len="med"/>
+                    </a:lnR>
+                    <a:lnT w="9525" cap="flat" cmpd="sng" algn="ctr">
+                      <a:solidFill>
+                        <a:srgbClr val="DAD6CC"/>
+                      </a:solidFill>
+                      <a:prstDash val="solid"/>
+                      <a:round/>
+                      <a:headEnd type="none" w="med" len="med"/>
+                      <a:tailEnd type="none" w="med" len="med"/>
+                    </a:lnT>
+                    <a:lnB w="9525" cap="flat" cmpd="sng" algn="ctr">
+                      <a:solidFill>
+                        <a:srgbClr val="DAD6CC"/>
+                      </a:solidFill>
+                      <a:prstDash val="solid"/>
+                      <a:round/>
+                      <a:headEnd type="none" w="med" len="med"/>
+                      <a:tailEnd type="none" w="med" len="med"/>
+                    </a:lnB>
+                    <a:solidFill>
+                      <a:srgbClr val="E6E2D6"/>
+                    </a:solidFill>
+                  </a:tcPr>
+                </a:tc>
+                <a:tc>
+                  <a:txBody>
+                    <a:bodyPr/>
+                    <a:lstStyle/>
+                    <a:p>
+                      <a:pPr indent="0" marL="0">
+                        <a:buNone/>
+                      </a:pPr>
+                      <a:r>
+                        <a:rPr lang="en-US" sz="1500" b="1" dirty="0">
+                          <a:solidFill>
+                            <a:srgbClr val="12202B"/>
+                          </a:solidFill>
+                          <a:latin typeface="Calibri" pitchFamily="34" charset="0"/>
+                          <a:ea typeface="Calibri" pitchFamily="34" charset="-122"/>
+                          <a:cs typeface="Calibri" pitchFamily="34" charset="-120"/>
+                        </a:rPr>
+                        <a:t>Windows: tuần tự</a:t>
+                      </a:r>
+                      <a:endParaRPr lang="en-US" sz="1500" dirty="0">
+                        <a:latin typeface="Calibri" charset="0"/>
+                        <a:ea typeface="Calibri" charset="0"/>
+                        <a:cs typeface="Calibri" charset="0"/>
+                      </a:endParaRPr>
+                    </a:p>
+                  </a:txBody>
+                  <a:tcPr marL="91440" marR="91440" marT="36576" marB="36576" anchor="ctr">
+                    <a:lnL w="9525" cap="flat" cmpd="sng" algn="ctr">
+                      <a:solidFill>
+                        <a:srgbClr val="DAD6CC"/>
+                      </a:solidFill>
+                      <a:prstDash val="solid"/>
+                      <a:round/>
+                      <a:headEnd type="none" w="med" len="med"/>
+                      <a:tailEnd type="none" w="med" len="med"/>
+                    </a:lnL>
+                    <a:lnR w="9525" cap="flat" cmpd="sng" algn="ctr">
+                      <a:solidFill>
+                        <a:srgbClr val="DAD6CC"/>
+                      </a:solidFill>
+                      <a:prstDash val="solid"/>
+                      <a:round/>
+                      <a:headEnd type="none" w="med" len="med"/>
+                      <a:tailEnd type="none" w="med" len="med"/>
+                    </a:lnR>
+                    <a:lnT w="9525" cap="flat" cmpd="sng" algn="ctr">
+                      <a:solidFill>
+                        <a:srgbClr val="DAD6CC"/>
+                      </a:solidFill>
+                      <a:prstDash val="solid"/>
+                      <a:round/>
+                      <a:headEnd type="none" w="med" len="med"/>
+                      <a:tailEnd type="none" w="med" len="med"/>
+                    </a:lnT>
+                    <a:lnB w="9525" cap="flat" cmpd="sng" algn="ctr">
+                      <a:solidFill>
+                        <a:srgbClr val="DAD6CC"/>
+                      </a:solidFill>
+                      <a:prstDash val="solid"/>
+                      <a:round/>
+                      <a:headEnd type="none" w="med" len="med"/>
+                      <a:tailEnd type="none" w="med" len="med"/>
+                    </a:lnB>
+                    <a:solidFill>
+                      <a:srgbClr val="E6E2D6"/>
+                    </a:solidFill>
+                  </a:tcPr>
+                </a:tc>
+                <a:tc>
+                  <a:txBody>
+                    <a:bodyPr/>
+                    <a:lstStyle/>
+                    <a:p>
+                      <a:pPr indent="0" marL="0">
+                        <a:buNone/>
+                      </a:pPr>
+                      <a:r>
+                        <a:rPr lang="en-US" sz="1500" b="1" dirty="0">
+                          <a:solidFill>
+                            <a:srgbClr val="12202B"/>
+                          </a:solidFill>
+                          <a:latin typeface="Calibri" pitchFamily="34" charset="0"/>
+                          <a:ea typeface="Calibri" pitchFamily="34" charset="-122"/>
+                          <a:cs typeface="Calibri" pitchFamily="34" charset="-120"/>
+                        </a:rPr>
+                        <a:t>Khớp</a:t>
+                      </a:r>
+                      <a:endParaRPr lang="en-US" sz="1500" dirty="0">
+                        <a:latin typeface="Calibri" charset="0"/>
+                        <a:ea typeface="Calibri" charset="0"/>
+                        <a:cs typeface="Calibri" charset="0"/>
+                      </a:endParaRPr>
+                    </a:p>
+                  </a:txBody>
+                  <a:tcPr marL="91440" marR="91440" marT="36576" marB="36576" anchor="ctr">
+                    <a:lnL w="9525" cap="flat" cmpd="sng" algn="ctr">
+                      <a:solidFill>
+                        <a:srgbClr val="DAD6CC"/>
+                      </a:solidFill>
+                      <a:prstDash val="solid"/>
+                      <a:round/>
+                      <a:headEnd type="none" w="med" len="med"/>
+                      <a:tailEnd type="none" w="med" len="med"/>
+                    </a:lnL>
+                    <a:lnR w="9525" cap="flat" cmpd="sng" algn="ctr">
+                      <a:solidFill>
+                        <a:srgbClr val="DAD6CC"/>
+                      </a:solidFill>
+                      <a:prstDash val="solid"/>
+                      <a:round/>
+                      <a:headEnd type="none" w="med" len="med"/>
+                      <a:tailEnd type="none" w="med" len="med"/>
+                    </a:lnR>
+                    <a:lnT w="9525" cap="flat" cmpd="sng" algn="ctr">
+                      <a:solidFill>
+                        <a:srgbClr val="DAD6CC"/>
+                      </a:solidFill>
+                      <a:prstDash val="solid"/>
+                      <a:round/>
+                      <a:headEnd type="none" w="med" len="med"/>
+                      <a:tailEnd type="none" w="med" len="med"/>
+                    </a:lnT>
+                    <a:lnB w="9525" cap="flat" cmpd="sng" algn="ctr">
+                      <a:solidFill>
+                        <a:srgbClr val="DAD6CC"/>
+                      </a:solidFill>
+                      <a:prstDash val="solid"/>
+                      <a:round/>
+                      <a:headEnd type="none" w="med" len="med"/>
+                      <a:tailEnd type="none" w="med" len="med"/>
+                    </a:lnB>
+                    <a:solidFill>
+                      <a:srgbClr val="E6E2D6"/>
+                    </a:solidFill>
+                  </a:tcPr>
+                </a:tc>
+              </a:tr>
+              <a:tr h="502920">
+                <a:tc>
+                  <a:txBody>
+                    <a:bodyPr/>
+                    <a:lstStyle/>
+                    <a:p>
+                      <a:pPr indent="0" marL="0">
+                        <a:buNone/>
+                      </a:pPr>
+                      <a:r>
+                        <a:rPr lang="en-US" sz="1500" dirty="0">
+                          <a:solidFill>
+                            <a:srgbClr val="12202B"/>
+                          </a:solidFill>
+                          <a:latin typeface="Calibri" pitchFamily="34" charset="0"/>
+                          <a:ea typeface="Calibri" pitchFamily="34" charset="-122"/>
+                          <a:cs typeface="Calibri" pitchFamily="34" charset="-120"/>
+                        </a:rPr>
+                        <a:t>TC-01, TC-04</a:t>
+                      </a:r>
+                      <a:endParaRPr lang="en-US" sz="1500" dirty="0">
+                        <a:latin typeface="Calibri" charset="0"/>
+                        <a:ea typeface="Calibri" charset="0"/>
+                        <a:cs typeface="Calibri" charset="0"/>
+                      </a:endParaRPr>
+                    </a:p>
+                  </a:txBody>
+                  <a:tcPr marL="91440" marR="91440" marT="36576" marB="36576" anchor="ctr">
+                    <a:lnL w="9525" cap="flat" cmpd="sng" algn="ctr">
+                      <a:solidFill>
+                        <a:srgbClr val="DAD6CC"/>
+                      </a:solidFill>
+                      <a:prstDash val="solid"/>
+                      <a:round/>
+                      <a:headEnd type="none" w="med" len="med"/>
+                      <a:tailEnd type="none" w="med" len="med"/>
+                    </a:lnL>
+                    <a:lnR w="9525" cap="flat" cmpd="sng" algn="ctr">
+                      <a:solidFill>
+                        <a:srgbClr val="DAD6CC"/>
+                      </a:solidFill>
+                      <a:prstDash val="solid"/>
+                      <a:round/>
+                      <a:headEnd type="none" w="med" len="med"/>
+                      <a:tailEnd type="none" w="med" len="med"/>
+                    </a:lnR>
+                    <a:lnT w="9525" cap="flat" cmpd="sng" algn="ctr">
+                      <a:solidFill>
+                        <a:srgbClr val="DAD6CC"/>
+                      </a:solidFill>
+                      <a:prstDash val="solid"/>
+                      <a:round/>
+                      <a:headEnd type="none" w="med" len="med"/>
+                      <a:tailEnd type="none" w="med" len="med"/>
+                    </a:lnT>
+                    <a:lnB w="9525" cap="flat" cmpd="sng" algn="ctr">
+                      <a:solidFill>
+                        <a:srgbClr val="DAD6CC"/>
+                      </a:solidFill>
+                      <a:prstDash val="solid"/>
+                      <a:round/>
+                      <a:headEnd type="none" w="med" len="med"/>
+                      <a:tailEnd type="none" w="med" len="med"/>
+                    </a:lnB>
+                    <a:solidFill>
+                      <a:srgbClr val="FFFFFF"/>
+                    </a:solidFill>
+                  </a:tcPr>
+                </a:tc>
+                <a:tc>
+                  <a:txBody>
+                    <a:bodyPr/>
+                    <a:lstStyle/>
+                    <a:p>
+                      <a:pPr indent="0" marL="0">
+                        <a:buNone/>
+                      </a:pPr>
+                      <a:r>
+                        <a:rPr lang="en-US" sz="1500" dirty="0">
+                          <a:solidFill>
+                            <a:srgbClr val="12202B"/>
+                          </a:solidFill>
+                          <a:latin typeface="Calibri" pitchFamily="34" charset="0"/>
+                          <a:ea typeface="Calibri" pitchFamily="34" charset="-122"/>
+                          <a:cs typeface="Calibri" pitchFamily="34" charset="-120"/>
+                        </a:rPr>
+                        <a:t>0/10</a:t>
+                      </a:r>
+                      <a:endParaRPr lang="en-US" sz="1500" dirty="0">
+                        <a:latin typeface="Calibri" charset="0"/>
+                        <a:ea typeface="Calibri" charset="0"/>
+                        <a:cs typeface="Calibri" charset="0"/>
+                      </a:endParaRPr>
+                    </a:p>
+                  </a:txBody>
+                  <a:tcPr marL="91440" marR="91440" marT="36576" marB="36576" anchor="ctr">
+                    <a:lnL w="9525" cap="flat" cmpd="sng" algn="ctr">
+                      <a:solidFill>
+                        <a:srgbClr val="DAD6CC"/>
+                      </a:solidFill>
+                      <a:prstDash val="solid"/>
+                      <a:round/>
+                      <a:headEnd type="none" w="med" len="med"/>
+                      <a:tailEnd type="none" w="med" len="med"/>
+                    </a:lnL>
+                    <a:lnR w="9525" cap="flat" cmpd="sng" algn="ctr">
+                      <a:solidFill>
+                        <a:srgbClr val="DAD6CC"/>
+                      </a:solidFill>
+                      <a:prstDash val="solid"/>
+                      <a:round/>
+                      <a:headEnd type="none" w="med" len="med"/>
+                      <a:tailEnd type="none" w="med" len="med"/>
+                    </a:lnR>
+                    <a:lnT w="9525" cap="flat" cmpd="sng" algn="ctr">
+                      <a:solidFill>
+                        <a:srgbClr val="DAD6CC"/>
+                      </a:solidFill>
+                      <a:prstDash val="solid"/>
+                      <a:round/>
+                      <a:headEnd type="none" w="med" len="med"/>
+                      <a:tailEnd type="none" w="med" len="med"/>
+                    </a:lnT>
+                    <a:lnB w="9525" cap="flat" cmpd="sng" algn="ctr">
+                      <a:solidFill>
+                        <a:srgbClr val="DAD6CC"/>
+                      </a:solidFill>
+                      <a:prstDash val="solid"/>
+                      <a:round/>
+                      <a:headEnd type="none" w="med" len="med"/>
+                      <a:tailEnd type="none" w="med" len="med"/>
+                    </a:lnB>
+                    <a:solidFill>
+                      <a:srgbClr val="FFFFFF"/>
+                    </a:solidFill>
+                  </a:tcPr>
+                </a:tc>
+                <a:tc>
+                  <a:txBody>
+                    <a:bodyPr/>
+                    <a:lstStyle/>
+                    <a:p>
+                      <a:pPr indent="0" marL="0">
+                        <a:buNone/>
+                      </a:pPr>
+                      <a:r>
+                        <a:rPr lang="en-US" sz="1500" dirty="0">
+                          <a:solidFill>
+                            <a:srgbClr val="12202B"/>
+                          </a:solidFill>
+                          <a:latin typeface="Calibri" pitchFamily="34" charset="0"/>
+                          <a:ea typeface="Calibri" pitchFamily="34" charset="-122"/>
+                          <a:cs typeface="Calibri" pitchFamily="34" charset="-120"/>
+                        </a:rPr>
+                        <a:t>0/10</a:t>
+                      </a:r>
+                      <a:endParaRPr lang="en-US" sz="1500" dirty="0">
+                        <a:latin typeface="Calibri" charset="0"/>
+                        <a:ea typeface="Calibri" charset="0"/>
+                        <a:cs typeface="Calibri" charset="0"/>
+                      </a:endParaRPr>
+                    </a:p>
+                  </a:txBody>
+                  <a:tcPr marL="91440" marR="91440" marT="36576" marB="36576" anchor="ctr">
+                    <a:lnL w="9525" cap="flat" cmpd="sng" algn="ctr">
+                      <a:solidFill>
+                        <a:srgbClr val="DAD6CC"/>
+                      </a:solidFill>
+                      <a:prstDash val="solid"/>
+                      <a:round/>
+                      <a:headEnd type="none" w="med" len="med"/>
+                      <a:tailEnd type="none" w="med" len="med"/>
+                    </a:lnL>
+                    <a:lnR w="9525" cap="flat" cmpd="sng" algn="ctr">
+                      <a:solidFill>
+                        <a:srgbClr val="DAD6CC"/>
+                      </a:solidFill>
+                      <a:prstDash val="solid"/>
+                      <a:round/>
+                      <a:headEnd type="none" w="med" len="med"/>
+                      <a:tailEnd type="none" w="med" len="med"/>
+                    </a:lnR>
+                    <a:lnT w="9525" cap="flat" cmpd="sng" algn="ctr">
+                      <a:solidFill>
+                        <a:srgbClr val="DAD6CC"/>
+                      </a:solidFill>
+                      <a:prstDash val="solid"/>
+                      <a:round/>
+                      <a:headEnd type="none" w="med" len="med"/>
+                      <a:tailEnd type="none" w="med" len="med"/>
+                    </a:lnT>
+                    <a:lnB w="9525" cap="flat" cmpd="sng" algn="ctr">
+                      <a:solidFill>
+                        <a:srgbClr val="DAD6CC"/>
+                      </a:solidFill>
+                      <a:prstDash val="solid"/>
+                      <a:round/>
+                      <a:headEnd type="none" w="med" len="med"/>
+                      <a:tailEnd type="none" w="med" len="med"/>
+                    </a:lnB>
+                    <a:solidFill>
+                      <a:srgbClr val="FFFFFF"/>
+                    </a:solidFill>
+                  </a:tcPr>
+                </a:tc>
+                <a:tc>
+                  <a:txBody>
+                    <a:bodyPr/>
+                    <a:lstStyle/>
+                    <a:p>
+                      <a:pPr indent="0" marL="0">
+                        <a:buNone/>
+                      </a:pPr>
+                      <a:r>
+                        <a:rPr lang="en-US" sz="1500" dirty="0">
+                          <a:solidFill>
+                            <a:srgbClr val="12202B"/>
+                          </a:solidFill>
+                          <a:latin typeface="Calibri" pitchFamily="34" charset="0"/>
+                          <a:ea typeface="Calibri" pitchFamily="34" charset="-122"/>
+                          <a:cs typeface="Calibri" pitchFamily="34" charset="-120"/>
+                        </a:rPr>
+                        <a:t>0/10</a:t>
+                      </a:r>
+                      <a:endParaRPr lang="en-US" sz="1500" dirty="0">
+                        <a:latin typeface="Calibri" charset="0"/>
+                        <a:ea typeface="Calibri" charset="0"/>
+                        <a:cs typeface="Calibri" charset="0"/>
+                      </a:endParaRPr>
+                    </a:p>
+                  </a:txBody>
+                  <a:tcPr marL="91440" marR="91440" marT="36576" marB="36576" anchor="ctr">
+                    <a:lnL w="9525" cap="flat" cmpd="sng" algn="ctr">
+                      <a:solidFill>
+                        <a:srgbClr val="DAD6CC"/>
+                      </a:solidFill>
+                      <a:prstDash val="solid"/>
+                      <a:round/>
+                      <a:headEnd type="none" w="med" len="med"/>
+                      <a:tailEnd type="none" w="med" len="med"/>
+                    </a:lnL>
+                    <a:lnR w="9525" cap="flat" cmpd="sng" algn="ctr">
+                      <a:solidFill>
+                        <a:srgbClr val="DAD6CC"/>
+                      </a:solidFill>
+                      <a:prstDash val="solid"/>
+                      <a:round/>
+                      <a:headEnd type="none" w="med" len="med"/>
+                      <a:tailEnd type="none" w="med" len="med"/>
+                    </a:lnR>
+                    <a:lnT w="9525" cap="flat" cmpd="sng" algn="ctr">
+                      <a:solidFill>
+                        <a:srgbClr val="DAD6CC"/>
+                      </a:solidFill>
+                      <a:prstDash val="solid"/>
+                      <a:round/>
+                      <a:headEnd type="none" w="med" len="med"/>
+                      <a:tailEnd type="none" w="med" len="med"/>
+                    </a:lnT>
+                    <a:lnB w="9525" cap="flat" cmpd="sng" algn="ctr">
+                      <a:solidFill>
+                        <a:srgbClr val="DAD6CC"/>
+                      </a:solidFill>
+                      <a:prstDash val="solid"/>
+                      <a:round/>
+                      <a:headEnd type="none" w="med" len="med"/>
+                      <a:tailEnd type="none" w="med" len="med"/>
+                    </a:lnB>
+                    <a:solidFill>
+                      <a:srgbClr val="FFFFFF"/>
+                    </a:solidFill>
+                  </a:tcPr>
+                </a:tc>
+                <a:tc>
+                  <a:txBody>
+                    <a:bodyPr/>
+                    <a:lstStyle/>
+                    <a:p>
+                      <a:pPr indent="0" marL="0">
+                        <a:buNone/>
+                      </a:pPr>
+                      <a:r>
+                        <a:rPr lang="en-US" sz="1500" dirty="0">
+                          <a:solidFill>
+                            <a:srgbClr val="12202B"/>
+                          </a:solidFill>
+                          <a:latin typeface="Calibri" pitchFamily="34" charset="0"/>
+                          <a:ea typeface="Calibri" pitchFamily="34" charset="-122"/>
+                          <a:cs typeface="Calibri" pitchFamily="34" charset="-120"/>
+                        </a:rPr>
+                        <a:t>Có</a:t>
+                      </a:r>
+                      <a:endParaRPr lang="en-US" sz="1500" dirty="0">
+                        <a:latin typeface="Calibri" charset="0"/>
+                        <a:ea typeface="Calibri" charset="0"/>
+                        <a:cs typeface="Calibri" charset="0"/>
+                      </a:endParaRPr>
+                    </a:p>
+                  </a:txBody>
+                  <a:tcPr marL="91440" marR="91440" marT="36576" marB="36576" anchor="ctr">
+                    <a:lnL w="9525" cap="flat" cmpd="sng" algn="ctr">
+                      <a:solidFill>
+                        <a:srgbClr val="DAD6CC"/>
+                      </a:solidFill>
+                      <a:prstDash val="solid"/>
+                      <a:round/>
+                      <a:headEnd type="none" w="med" len="med"/>
+                      <a:tailEnd type="none" w="med" len="med"/>
+                    </a:lnL>
+                    <a:lnR w="9525" cap="flat" cmpd="sng" algn="ctr">
+                      <a:solidFill>
+                        <a:srgbClr val="DAD6CC"/>
+                      </a:solidFill>
+                      <a:prstDash val="solid"/>
+                      <a:round/>
+                      <a:headEnd type="none" w="med" len="med"/>
+                      <a:tailEnd type="none" w="med" len="med"/>
+                    </a:lnR>
+                    <a:lnT w="9525" cap="flat" cmpd="sng" algn="ctr">
+                      <a:solidFill>
+                        <a:srgbClr val="DAD6CC"/>
+                      </a:solidFill>
+                      <a:prstDash val="solid"/>
+                      <a:round/>
+                      <a:headEnd type="none" w="med" len="med"/>
+                      <a:tailEnd type="none" w="med" len="med"/>
+                    </a:lnT>
+                    <a:lnB w="9525" cap="flat" cmpd="sng" algn="ctr">
+                      <a:solidFill>
+                        <a:srgbClr val="DAD6CC"/>
+                      </a:solidFill>
+                      <a:prstDash val="solid"/>
+                      <a:round/>
+                      <a:headEnd type="none" w="med" len="med"/>
+                      <a:tailEnd type="none" w="med" len="med"/>
+                    </a:lnB>
+                    <a:solidFill>
+                      <a:srgbClr val="FFFFFF"/>
+                    </a:solidFill>
+                  </a:tcPr>
+                </a:tc>
+              </a:tr>
+              <a:tr h="502920">
+                <a:tc>
+                  <a:txBody>
+                    <a:bodyPr/>
+                    <a:lstStyle/>
+                    <a:p>
+                      <a:pPr indent="0" marL="0">
+                        <a:buNone/>
+                      </a:pPr>
+                      <a:r>
+                        <a:rPr lang="en-US" sz="1500" dirty="0">
+                          <a:solidFill>
+                            <a:srgbClr val="12202B"/>
+                          </a:solidFill>
+                          <a:latin typeface="Calibri" pitchFamily="34" charset="0"/>
+                          <a:ea typeface="Calibri" pitchFamily="34" charset="-122"/>
+                          <a:cs typeface="Calibri" pitchFamily="34" charset="-120"/>
+                        </a:rPr>
+                        <a:t>TC-02, 03, 05, 07, 08</a:t>
+                      </a:r>
+                      <a:endParaRPr lang="en-US" sz="1500" dirty="0">
+                        <a:latin typeface="Calibri" charset="0"/>
+                        <a:ea typeface="Calibri" charset="0"/>
+                        <a:cs typeface="Calibri" charset="0"/>
+                      </a:endParaRPr>
+                    </a:p>
+                  </a:txBody>
+                  <a:tcPr marL="91440" marR="91440" marT="36576" marB="36576" anchor="ctr">
+                    <a:lnL w="9525" cap="flat" cmpd="sng" algn="ctr">
+                      <a:solidFill>
+                        <a:srgbClr val="DAD6CC"/>
+                      </a:solidFill>
+                      <a:prstDash val="solid"/>
+                      <a:round/>
+                      <a:headEnd type="none" w="med" len="med"/>
+                      <a:tailEnd type="none" w="med" len="med"/>
+                    </a:lnL>
+                    <a:lnR w="9525" cap="flat" cmpd="sng" algn="ctr">
+                      <a:solidFill>
+                        <a:srgbClr val="DAD6CC"/>
+                      </a:solidFill>
+                      <a:prstDash val="solid"/>
+                      <a:round/>
+                      <a:headEnd type="none" w="med" len="med"/>
+                      <a:tailEnd type="none" w="med" len="med"/>
+                    </a:lnR>
+                    <a:lnT w="9525" cap="flat" cmpd="sng" algn="ctr">
+                      <a:solidFill>
+                        <a:srgbClr val="DAD6CC"/>
+                      </a:solidFill>
+                      <a:prstDash val="solid"/>
+                      <a:round/>
+                      <a:headEnd type="none" w="med" len="med"/>
+                      <a:tailEnd type="none" w="med" len="med"/>
+                    </a:lnT>
+                    <a:lnB w="9525" cap="flat" cmpd="sng" algn="ctr">
+                      <a:solidFill>
+                        <a:srgbClr val="DAD6CC"/>
+                      </a:solidFill>
+                      <a:prstDash val="solid"/>
+                      <a:round/>
+                      <a:headEnd type="none" w="med" len="med"/>
+                      <a:tailEnd type="none" w="med" len="med"/>
+                    </a:lnB>
+                    <a:solidFill>
+                      <a:srgbClr val="FFFFFF"/>
+                    </a:solidFill>
+                  </a:tcPr>
+                </a:tc>
+                <a:tc>
+                  <a:txBody>
+                    <a:bodyPr/>
+                    <a:lstStyle/>
+                    <a:p>
+                      <a:pPr indent="0" marL="0">
+                        <a:buNone/>
+                      </a:pPr>
+                      <a:r>
+                        <a:rPr lang="en-US" sz="1500" dirty="0">
+                          <a:solidFill>
+                            <a:srgbClr val="12202B"/>
+                          </a:solidFill>
+                          <a:latin typeface="Calibri" pitchFamily="34" charset="0"/>
+                          <a:ea typeface="Calibri" pitchFamily="34" charset="-122"/>
+                          <a:cs typeface="Calibri" pitchFamily="34" charset="-120"/>
+                        </a:rPr>
+                        <a:t>10/10</a:t>
+                      </a:r>
+                      <a:endParaRPr lang="en-US" sz="1500" dirty="0">
+                        <a:latin typeface="Calibri" charset="0"/>
+                        <a:ea typeface="Calibri" charset="0"/>
+                        <a:cs typeface="Calibri" charset="0"/>
+                      </a:endParaRPr>
+                    </a:p>
+                  </a:txBody>
+                  <a:tcPr marL="91440" marR="91440" marT="36576" marB="36576" anchor="ctr">
+                    <a:lnL w="9525" cap="flat" cmpd="sng" algn="ctr">
+                      <a:solidFill>
+                        <a:srgbClr val="DAD6CC"/>
+                      </a:solidFill>
+                      <a:prstDash val="solid"/>
+                      <a:round/>
+                      <a:headEnd type="none" w="med" len="med"/>
+                      <a:tailEnd type="none" w="med" len="med"/>
+                    </a:lnL>
+                    <a:lnR w="9525" cap="flat" cmpd="sng" algn="ctr">
+                      <a:solidFill>
+                        <a:srgbClr val="DAD6CC"/>
+                      </a:solidFill>
+                      <a:prstDash val="solid"/>
+                      <a:round/>
+                      <a:headEnd type="none" w="med" len="med"/>
+                      <a:tailEnd type="none" w="med" len="med"/>
+                    </a:lnR>
+                    <a:lnT w="9525" cap="flat" cmpd="sng" algn="ctr">
+                      <a:solidFill>
+                        <a:srgbClr val="DAD6CC"/>
+                      </a:solidFill>
+                      <a:prstDash val="solid"/>
+                      <a:round/>
+                      <a:headEnd type="none" w="med" len="med"/>
+                      <a:tailEnd type="none" w="med" len="med"/>
+                    </a:lnT>
+                    <a:lnB w="9525" cap="flat" cmpd="sng" algn="ctr">
+                      <a:solidFill>
+                        <a:srgbClr val="DAD6CC"/>
+                      </a:solidFill>
+                      <a:prstDash val="solid"/>
+                      <a:round/>
+                      <a:headEnd type="none" w="med" len="med"/>
+                      <a:tailEnd type="none" w="med" len="med"/>
+                    </a:lnB>
+                    <a:solidFill>
+                      <a:srgbClr val="FFFFFF"/>
+                    </a:solidFill>
+                  </a:tcPr>
+                </a:tc>
+                <a:tc>
+                  <a:txBody>
+                    <a:bodyPr/>
+                    <a:lstStyle/>
+                    <a:p>
+                      <a:pPr indent="0" marL="0">
+                        <a:buNone/>
+                      </a:pPr>
+                      <a:r>
+                        <a:rPr lang="en-US" sz="1500" dirty="0">
+                          <a:solidFill>
+                            <a:srgbClr val="12202B"/>
+                          </a:solidFill>
+                          <a:latin typeface="Calibri" pitchFamily="34" charset="0"/>
+                          <a:ea typeface="Calibri" pitchFamily="34" charset="-122"/>
+                          <a:cs typeface="Calibri" pitchFamily="34" charset="-120"/>
+                        </a:rPr>
+                        <a:t>10/10</a:t>
+                      </a:r>
+                      <a:endParaRPr lang="en-US" sz="1500" dirty="0">
+                        <a:latin typeface="Calibri" charset="0"/>
+                        <a:ea typeface="Calibri" charset="0"/>
+                        <a:cs typeface="Calibri" charset="0"/>
+                      </a:endParaRPr>
+                    </a:p>
+                  </a:txBody>
+                  <a:tcPr marL="91440" marR="91440" marT="36576" marB="36576" anchor="ctr">
+                    <a:lnL w="9525" cap="flat" cmpd="sng" algn="ctr">
+                      <a:solidFill>
+                        <a:srgbClr val="DAD6CC"/>
+                      </a:solidFill>
+                      <a:prstDash val="solid"/>
+                      <a:round/>
+                      <a:headEnd type="none" w="med" len="med"/>
+                      <a:tailEnd type="none" w="med" len="med"/>
+                    </a:lnL>
+                    <a:lnR w="9525" cap="flat" cmpd="sng" algn="ctr">
+                      <a:solidFill>
+                        <a:srgbClr val="DAD6CC"/>
+                      </a:solidFill>
+                      <a:prstDash val="solid"/>
+                      <a:round/>
+                      <a:headEnd type="none" w="med" len="med"/>
+                      <a:tailEnd type="none" w="med" len="med"/>
+                    </a:lnR>
+                    <a:lnT w="9525" cap="flat" cmpd="sng" algn="ctr">
+                      <a:solidFill>
+                        <a:srgbClr val="DAD6CC"/>
+                      </a:solidFill>
+                      <a:prstDash val="solid"/>
+                      <a:round/>
+                      <a:headEnd type="none" w="med" len="med"/>
+                      <a:tailEnd type="none" w="med" len="med"/>
+                    </a:lnT>
+                    <a:lnB w="9525" cap="flat" cmpd="sng" algn="ctr">
+                      <a:solidFill>
+                        <a:srgbClr val="DAD6CC"/>
+                      </a:solidFill>
+                      <a:prstDash val="solid"/>
+                      <a:round/>
+                      <a:headEnd type="none" w="med" len="med"/>
+                      <a:tailEnd type="none" w="med" len="med"/>
+                    </a:lnB>
+                    <a:solidFill>
+                      <a:srgbClr val="FFFFFF"/>
+                    </a:solidFill>
+                  </a:tcPr>
+                </a:tc>
+                <a:tc>
+                  <a:txBody>
+                    <a:bodyPr/>
+                    <a:lstStyle/>
+                    <a:p>
+                      <a:pPr indent="0" marL="0">
+                        <a:buNone/>
+                      </a:pPr>
+                      <a:r>
+                        <a:rPr lang="en-US" sz="1500" dirty="0">
+                          <a:solidFill>
+                            <a:srgbClr val="12202B"/>
+                          </a:solidFill>
+                          <a:latin typeface="Calibri" pitchFamily="34" charset="0"/>
+                          <a:ea typeface="Calibri" pitchFamily="34" charset="-122"/>
+                          <a:cs typeface="Calibri" pitchFamily="34" charset="-120"/>
+                        </a:rPr>
+                        <a:t>0/10</a:t>
+                      </a:r>
+                      <a:endParaRPr lang="en-US" sz="1500" dirty="0">
+                        <a:latin typeface="Calibri" charset="0"/>
+                        <a:ea typeface="Calibri" charset="0"/>
+                        <a:cs typeface="Calibri" charset="0"/>
+                      </a:endParaRPr>
+                    </a:p>
+                  </a:txBody>
+                  <a:tcPr marL="91440" marR="91440" marT="36576" marB="36576" anchor="ctr">
+                    <a:lnL w="9525" cap="flat" cmpd="sng" algn="ctr">
+                      <a:solidFill>
+                        <a:srgbClr val="DAD6CC"/>
+                      </a:solidFill>
+                      <a:prstDash val="solid"/>
+                      <a:round/>
+                      <a:headEnd type="none" w="med" len="med"/>
+                      <a:tailEnd type="none" w="med" len="med"/>
+                    </a:lnL>
+                    <a:lnR w="9525" cap="flat" cmpd="sng" algn="ctr">
+                      <a:solidFill>
+                        <a:srgbClr val="DAD6CC"/>
+                      </a:solidFill>
+                      <a:prstDash val="solid"/>
+                      <a:round/>
+                      <a:headEnd type="none" w="med" len="med"/>
+                      <a:tailEnd type="none" w="med" len="med"/>
+                    </a:lnR>
+                    <a:lnT w="9525" cap="flat" cmpd="sng" algn="ctr">
+                      <a:solidFill>
+                        <a:srgbClr val="DAD6CC"/>
+                      </a:solidFill>
+                      <a:prstDash val="solid"/>
+                      <a:round/>
+                      <a:headEnd type="none" w="med" len="med"/>
+                      <a:tailEnd type="none" w="med" len="med"/>
+                    </a:lnT>
+                    <a:lnB w="9525" cap="flat" cmpd="sng" algn="ctr">
+                      <a:solidFill>
+                        <a:srgbClr val="DAD6CC"/>
+                      </a:solidFill>
+                      <a:prstDash val="solid"/>
+                      <a:round/>
+                      <a:headEnd type="none" w="med" len="med"/>
+                      <a:tailEnd type="none" w="med" len="med"/>
+                    </a:lnB>
+                    <a:solidFill>
+                      <a:srgbClr val="FFFFFF"/>
+                    </a:solidFill>
+                  </a:tcPr>
+                </a:tc>
+                <a:tc>
+                  <a:txBody>
+                    <a:bodyPr/>
+                    <a:lstStyle/>
+                    <a:p>
+                      <a:pPr indent="0" marL="0">
+                        <a:buNone/>
+                      </a:pPr>
+                      <a:r>
+                        <a:rPr lang="en-US" sz="1500" dirty="0">
+                          <a:solidFill>
+                            <a:srgbClr val="12202B"/>
+                          </a:solidFill>
+                          <a:latin typeface="Calibri" pitchFamily="34" charset="0"/>
+                          <a:ea typeface="Calibri" pitchFamily="34" charset="-122"/>
+                          <a:cs typeface="Calibri" pitchFamily="34" charset="-120"/>
+                        </a:rPr>
+                        <a:t>Có</a:t>
+                      </a:r>
+                      <a:endParaRPr lang="en-US" sz="1500" dirty="0">
+                        <a:latin typeface="Calibri" charset="0"/>
+                        <a:ea typeface="Calibri" charset="0"/>
+                        <a:cs typeface="Calibri" charset="0"/>
+                      </a:endParaRPr>
+                    </a:p>
+                  </a:txBody>
+                  <a:tcPr marL="91440" marR="91440" marT="36576" marB="36576" anchor="ctr">
+                    <a:lnL w="9525" cap="flat" cmpd="sng" algn="ctr">
+                      <a:solidFill>
+                        <a:srgbClr val="DAD6CC"/>
+                      </a:solidFill>
+                      <a:prstDash val="solid"/>
+                      <a:round/>
+                      <a:headEnd type="none" w="med" len="med"/>
+                      <a:tailEnd type="none" w="med" len="med"/>
+                    </a:lnL>
+                    <a:lnR w="9525" cap="flat" cmpd="sng" algn="ctr">
+                      <a:solidFill>
+                        <a:srgbClr val="DAD6CC"/>
+                      </a:solidFill>
+                      <a:prstDash val="solid"/>
+                      <a:round/>
+                      <a:headEnd type="none" w="med" len="med"/>
+                      <a:tailEnd type="none" w="med" len="med"/>
+                    </a:lnR>
+                    <a:lnT w="9525" cap="flat" cmpd="sng" algn="ctr">
+                      <a:solidFill>
+                        <a:srgbClr val="DAD6CC"/>
+                      </a:solidFill>
+                      <a:prstDash val="solid"/>
+                      <a:round/>
+                      <a:headEnd type="none" w="med" len="med"/>
+                      <a:tailEnd type="none" w="med" len="med"/>
+                    </a:lnT>
+                    <a:lnB w="9525" cap="flat" cmpd="sng" algn="ctr">
+                      <a:solidFill>
+                        <a:srgbClr val="DAD6CC"/>
+                      </a:solidFill>
+                      <a:prstDash val="solid"/>
+                      <a:round/>
+                      <a:headEnd type="none" w="med" len="med"/>
+                      <a:tailEnd type="none" w="med" len="med"/>
+                    </a:lnB>
+                    <a:solidFill>
+                      <a:srgbClr val="FFFFFF"/>
+                    </a:solidFill>
+                  </a:tcPr>
+                </a:tc>
+              </a:tr>
+              <a:tr h="502920">
+                <a:tc>
+                  <a:txBody>
+                    <a:bodyPr/>
+                    <a:lstStyle/>
+                    <a:p>
+                      <a:pPr indent="0" marL="0">
+                        <a:buNone/>
+                      </a:pPr>
+                      <a:r>
+                        <a:rPr lang="en-US" sz="1500" dirty="0">
+                          <a:solidFill>
+                            <a:srgbClr val="12202B"/>
+                          </a:solidFill>
+                          <a:latin typeface="Calibri" pitchFamily="34" charset="0"/>
+                          <a:ea typeface="Calibri" pitchFamily="34" charset="-122"/>
+                          <a:cs typeface="Calibri" pitchFamily="34" charset="-120"/>
+                        </a:rPr>
+                        <a:t>TC-06</a:t>
+                      </a:r>
+                      <a:endParaRPr lang="en-US" sz="1500" dirty="0">
+                        <a:latin typeface="Calibri" charset="0"/>
+                        <a:ea typeface="Calibri" charset="0"/>
+                        <a:cs typeface="Calibri" charset="0"/>
+                      </a:endParaRPr>
+                    </a:p>
+                  </a:txBody>
+                  <a:tcPr marL="91440" marR="91440" marT="36576" marB="36576" anchor="ctr">
+                    <a:lnL w="9525" cap="flat" cmpd="sng" algn="ctr">
+                      <a:solidFill>
+                        <a:srgbClr val="DAD6CC"/>
+                      </a:solidFill>
+                      <a:prstDash val="solid"/>
+                      <a:round/>
+                      <a:headEnd type="none" w="med" len="med"/>
+                      <a:tailEnd type="none" w="med" len="med"/>
+                    </a:lnL>
+                    <a:lnR w="9525" cap="flat" cmpd="sng" algn="ctr">
+                      <a:solidFill>
+                        <a:srgbClr val="DAD6CC"/>
+                      </a:solidFill>
+                      <a:prstDash val="solid"/>
+                      <a:round/>
+                      <a:headEnd type="none" w="med" len="med"/>
+                      <a:tailEnd type="none" w="med" len="med"/>
+                    </a:lnR>
+                    <a:lnT w="9525" cap="flat" cmpd="sng" algn="ctr">
+                      <a:solidFill>
+                        <a:srgbClr val="DAD6CC"/>
+                      </a:solidFill>
+                      <a:prstDash val="solid"/>
+                      <a:round/>
+                      <a:headEnd type="none" w="med" len="med"/>
+                      <a:tailEnd type="none" w="med" len="med"/>
+                    </a:lnT>
+                    <a:lnB w="9525" cap="flat" cmpd="sng" algn="ctr">
+                      <a:solidFill>
+                        <a:srgbClr val="DAD6CC"/>
+                      </a:solidFill>
+                      <a:prstDash val="solid"/>
+                      <a:round/>
+                      <a:headEnd type="none" w="med" len="med"/>
+                      <a:tailEnd type="none" w="med" len="med"/>
+                    </a:lnB>
+                    <a:solidFill>
+                      <a:srgbClr val="FFFFFF"/>
+                    </a:solidFill>
+                  </a:tcPr>
+                </a:tc>
+                <a:tc>
+                  <a:txBody>
+                    <a:bodyPr/>
+                    <a:lstStyle/>
+                    <a:p>
+                      <a:pPr indent="0" marL="0">
+                        <a:buNone/>
+                      </a:pPr>
+                      <a:r>
+                        <a:rPr lang="en-US" sz="1500" dirty="0">
+                          <a:solidFill>
+                            <a:srgbClr val="12202B"/>
+                          </a:solidFill>
+                          <a:latin typeface="Calibri" pitchFamily="34" charset="0"/>
+                          <a:ea typeface="Calibri" pitchFamily="34" charset="-122"/>
+                          <a:cs typeface="Calibri" pitchFamily="34" charset="-120"/>
+                        </a:rPr>
+                        <a:t>10/10</a:t>
+                      </a:r>
+                      <a:endParaRPr lang="en-US" sz="1500" dirty="0">
+                        <a:latin typeface="Calibri" charset="0"/>
+                        <a:ea typeface="Calibri" charset="0"/>
+                        <a:cs typeface="Calibri" charset="0"/>
+                      </a:endParaRPr>
+                    </a:p>
+                  </a:txBody>
+                  <a:tcPr marL="91440" marR="91440" marT="36576" marB="36576" anchor="ctr">
+                    <a:lnL w="9525" cap="flat" cmpd="sng" algn="ctr">
+                      <a:solidFill>
+                        <a:srgbClr val="DAD6CC"/>
+                      </a:solidFill>
+                      <a:prstDash val="solid"/>
+                      <a:round/>
+                      <a:headEnd type="none" w="med" len="med"/>
+                      <a:tailEnd type="none" w="med" len="med"/>
+                    </a:lnL>
+                    <a:lnR w="9525" cap="flat" cmpd="sng" algn="ctr">
+                      <a:solidFill>
+                        <a:srgbClr val="DAD6CC"/>
+                      </a:solidFill>
+                      <a:prstDash val="solid"/>
+                      <a:round/>
+                      <a:headEnd type="none" w="med" len="med"/>
+                      <a:tailEnd type="none" w="med" len="med"/>
+                    </a:lnR>
+                    <a:lnT w="9525" cap="flat" cmpd="sng" algn="ctr">
+                      <a:solidFill>
+                        <a:srgbClr val="DAD6CC"/>
+                      </a:solidFill>
+                      <a:prstDash val="solid"/>
+                      <a:round/>
+                      <a:headEnd type="none" w="med" len="med"/>
+                      <a:tailEnd type="none" w="med" len="med"/>
+                    </a:lnT>
+                    <a:lnB w="9525" cap="flat" cmpd="sng" algn="ctr">
+                      <a:solidFill>
+                        <a:srgbClr val="DAD6CC"/>
+                      </a:solidFill>
+                      <a:prstDash val="solid"/>
+                      <a:round/>
+                      <a:headEnd type="none" w="med" len="med"/>
+                      <a:tailEnd type="none" w="med" len="med"/>
+                    </a:lnB>
+                    <a:solidFill>
+                      <a:srgbClr val="FFFFFF"/>
+                    </a:solidFill>
+                  </a:tcPr>
+                </a:tc>
+                <a:tc>
+                  <a:txBody>
+                    <a:bodyPr/>
+                    <a:lstStyle/>
+                    <a:p>
+                      <a:pPr indent="0" marL="0">
+                        <a:buNone/>
+                      </a:pPr>
+                      <a:r>
+                        <a:rPr lang="en-US" sz="1500" dirty="0">
+                          <a:solidFill>
+                            <a:srgbClr val="12202B"/>
+                          </a:solidFill>
+                          <a:latin typeface="Calibri" pitchFamily="34" charset="0"/>
+                          <a:ea typeface="Calibri" pitchFamily="34" charset="-122"/>
+                          <a:cs typeface="Calibri" pitchFamily="34" charset="-120"/>
+                        </a:rPr>
+                        <a:t>10/10</a:t>
+                      </a:r>
+                      <a:endParaRPr lang="en-US" sz="1500" dirty="0">
+                        <a:latin typeface="Calibri" charset="0"/>
+                        <a:ea typeface="Calibri" charset="0"/>
+                        <a:cs typeface="Calibri" charset="0"/>
+                      </a:endParaRPr>
+                    </a:p>
+                  </a:txBody>
+                  <a:tcPr marL="91440" marR="91440" marT="36576" marB="36576" anchor="ctr">
+                    <a:lnL w="9525" cap="flat" cmpd="sng" algn="ctr">
+                      <a:solidFill>
+                        <a:srgbClr val="DAD6CC"/>
+                      </a:solidFill>
+                      <a:prstDash val="solid"/>
+                      <a:round/>
+                      <a:headEnd type="none" w="med" len="med"/>
+                      <a:tailEnd type="none" w="med" len="med"/>
+                    </a:lnL>
+                    <a:lnR w="9525" cap="flat" cmpd="sng" algn="ctr">
+                      <a:solidFill>
+                        <a:srgbClr val="DAD6CC"/>
+                      </a:solidFill>
+                      <a:prstDash val="solid"/>
+                      <a:round/>
+                      <a:headEnd type="none" w="med" len="med"/>
+                      <a:tailEnd type="none" w="med" len="med"/>
+                    </a:lnR>
+                    <a:lnT w="9525" cap="flat" cmpd="sng" algn="ctr">
+                      <a:solidFill>
+                        <a:srgbClr val="DAD6CC"/>
+                      </a:solidFill>
+                      <a:prstDash val="solid"/>
+                      <a:round/>
+                      <a:headEnd type="none" w="med" len="med"/>
+                      <a:tailEnd type="none" w="med" len="med"/>
+                    </a:lnT>
+                    <a:lnB w="9525" cap="flat" cmpd="sng" algn="ctr">
+                      <a:solidFill>
+                        <a:srgbClr val="DAD6CC"/>
+                      </a:solidFill>
+                      <a:prstDash val="solid"/>
+                      <a:round/>
+                      <a:headEnd type="none" w="med" len="med"/>
+                      <a:tailEnd type="none" w="med" len="med"/>
+                    </a:lnB>
+                    <a:solidFill>
+                      <a:srgbClr val="FFFFFF"/>
+                    </a:solidFill>
+                  </a:tcPr>
+                </a:tc>
+                <a:tc>
+                  <a:txBody>
+                    <a:bodyPr/>
+                    <a:lstStyle/>
+                    <a:p>
+                      <a:pPr indent="0" marL="0">
+                        <a:buNone/>
+                      </a:pPr>
+                      <a:r>
+                        <a:rPr lang="en-US" sz="1500" dirty="0">
+                          <a:solidFill>
+                            <a:srgbClr val="12202B"/>
+                          </a:solidFill>
+                          <a:latin typeface="Calibri" pitchFamily="34" charset="0"/>
+                          <a:ea typeface="Calibri" pitchFamily="34" charset="-122"/>
+                          <a:cs typeface="Calibri" pitchFamily="34" charset="-120"/>
+                        </a:rPr>
+                        <a:t>10/10</a:t>
+                      </a:r>
+                      <a:endParaRPr lang="en-US" sz="1500" dirty="0">
+                        <a:latin typeface="Calibri" charset="0"/>
+                        <a:ea typeface="Calibri" charset="0"/>
+                        <a:cs typeface="Calibri" charset="0"/>
+                      </a:endParaRPr>
+                    </a:p>
+                  </a:txBody>
+                  <a:tcPr marL="91440" marR="91440" marT="36576" marB="36576" anchor="ctr">
+                    <a:lnL w="9525" cap="flat" cmpd="sng" algn="ctr">
+                      <a:solidFill>
+                        <a:srgbClr val="DAD6CC"/>
+                      </a:solidFill>
+                      <a:prstDash val="solid"/>
+                      <a:round/>
+                      <a:headEnd type="none" w="med" len="med"/>
+                      <a:tailEnd type="none" w="med" len="med"/>
+                    </a:lnL>
+                    <a:lnR w="9525" cap="flat" cmpd="sng" algn="ctr">
+                      <a:solidFill>
+                        <a:srgbClr val="DAD6CC"/>
+                      </a:solidFill>
+                      <a:prstDash val="solid"/>
+                      <a:round/>
+                      <a:headEnd type="none" w="med" len="med"/>
+                      <a:tailEnd type="none" w="med" len="med"/>
+                    </a:lnR>
+                    <a:lnT w="9525" cap="flat" cmpd="sng" algn="ctr">
+                      <a:solidFill>
+                        <a:srgbClr val="DAD6CC"/>
+                      </a:solidFill>
+                      <a:prstDash val="solid"/>
+                      <a:round/>
+                      <a:headEnd type="none" w="med" len="med"/>
+                      <a:tailEnd type="none" w="med" len="med"/>
+                    </a:lnT>
+                    <a:lnB w="9525" cap="flat" cmpd="sng" algn="ctr">
+                      <a:solidFill>
+                        <a:srgbClr val="DAD6CC"/>
+                      </a:solidFill>
+                      <a:prstDash val="solid"/>
+                      <a:round/>
+                      <a:headEnd type="none" w="med" len="med"/>
+                      <a:tailEnd type="none" w="med" len="med"/>
+                    </a:lnB>
+                    <a:solidFill>
+                      <a:srgbClr val="FFFFFF"/>
+                    </a:solidFill>
+                  </a:tcPr>
+                </a:tc>
+                <a:tc>
+                  <a:txBody>
+                    <a:bodyPr/>
+                    <a:lstStyle/>
+                    <a:p>
+                      <a:pPr indent="0" marL="0">
+                        <a:buNone/>
+                      </a:pPr>
+                      <a:r>
+                        <a:rPr lang="en-US" sz="1500" dirty="0">
+                          <a:solidFill>
+                            <a:srgbClr val="12202B"/>
+                          </a:solidFill>
+                          <a:latin typeface="Calibri" pitchFamily="34" charset="0"/>
+                          <a:ea typeface="Calibri" pitchFamily="34" charset="-122"/>
+                          <a:cs typeface="Calibri" pitchFamily="34" charset="-120"/>
+                        </a:rPr>
+                        <a:t>Có</a:t>
+                      </a:r>
+                      <a:endParaRPr lang="en-US" sz="1500" dirty="0">
+                        <a:latin typeface="Calibri" charset="0"/>
+                        <a:ea typeface="Calibri" charset="0"/>
+                        <a:cs typeface="Calibri" charset="0"/>
+                      </a:endParaRPr>
+                    </a:p>
+                  </a:txBody>
+                  <a:tcPr marL="91440" marR="91440" marT="36576" marB="36576" anchor="ctr">
+                    <a:lnL w="9525" cap="flat" cmpd="sng" algn="ctr">
+                      <a:solidFill>
+                        <a:srgbClr val="DAD6CC"/>
+                      </a:solidFill>
+                      <a:prstDash val="solid"/>
+                      <a:round/>
+                      <a:headEnd type="none" w="med" len="med"/>
+                      <a:tailEnd type="none" w="med" len="med"/>
+                    </a:lnL>
+                    <a:lnR w="9525" cap="flat" cmpd="sng" algn="ctr">
+                      <a:solidFill>
+                        <a:srgbClr val="DAD6CC"/>
+                      </a:solidFill>
+                      <a:prstDash val="solid"/>
+                      <a:round/>
+                      <a:headEnd type="none" w="med" len="med"/>
+                      <a:tailEnd type="none" w="med" len="med"/>
+                    </a:lnR>
+                    <a:lnT w="9525" cap="flat" cmpd="sng" algn="ctr">
+                      <a:solidFill>
+                        <a:srgbClr val="DAD6CC"/>
+                      </a:solidFill>
+                      <a:prstDash val="solid"/>
+                      <a:round/>
+                      <a:headEnd type="none" w="med" len="med"/>
+                      <a:tailEnd type="none" w="med" len="med"/>
+                    </a:lnT>
+                    <a:lnB w="9525" cap="flat" cmpd="sng" algn="ctr">
+                      <a:solidFill>
+                        <a:srgbClr val="DAD6CC"/>
+                      </a:solidFill>
+                      <a:prstDash val="solid"/>
+                      <a:round/>
+                      <a:headEnd type="none" w="med" len="med"/>
+                      <a:tailEnd type="none" w="med" len="med"/>
+                    </a:lnB>
+                    <a:solidFill>
+                      <a:srgbClr val="FFFFFF"/>
+                    </a:solidFill>
+                  </a:tcPr>
+                </a:tc>
+              </a:tr>
+            </a:tbl>
+          </a:graphicData>
+        </a:graphic>
+      </p:graphicFrame>
+      <p:sp>
+        <p:nvSpPr>
+          <p:cNvPr id="5" name="Shape 2"/>
+          <p:cNvSpPr/>
+          <p:nvPr/>
+        </p:nvSpPr>
+        <p:spPr>
+          <a:xfrm>
+            <a:off x="640080" y="3657600"/>
+            <a:ext cx="3422904" cy="2011680"/>
+          </a:xfrm>
+          <a:prstGeom prst="roundRect">
+            <a:avLst>
+              <a:gd name="adj" fmla="val 5455"/>
+            </a:avLst>
+          </a:prstGeom>
+          <a:solidFill>
+            <a:srgbClr val="FBFAF6"/>
+          </a:solidFill>
+          <a:ln w="12700">
+            <a:solidFill>
+              <a:srgbClr val="DAD6CC"/>
+            </a:solidFill>
+            <a:prstDash val="solid"/>
+          </a:ln>
+        </p:spPr>
+      </p:sp>
+      <p:sp>
+        <p:nvSpPr>
+          <p:cNvPr id="6" name="Text 3"/>
+          <p:cNvSpPr txBox="1"/>
+          <p:nvPr/>
+        </p:nvSpPr>
+        <p:spPr>
+          <a:xfrm>
+            <a:off x="914400" y="3840480"/>
+            <a:ext cx="2874264" cy="457200"/>
+          </a:xfrm>
+          <a:prstGeom prst="rect">
+            <a:avLst/>
+          </a:prstGeom>
+          <a:noFill/>
+          <a:ln/>
+        </p:spPr>
+        <p:txBody>
+          <a:bodyPr wrap="square" lIns="0" tIns="0" rIns="0" bIns="0" rtlCol="0" anchor="ctr"/>
+          <a:lstStyle/>
+          <a:p>
+            <a:pPr indent="0" marL="0">
+              <a:buNone/>
+            </a:pPr>
+            <a:r>
+              <a:rPr lang="en-US" sz="2000" b="1" dirty="0">
+                <a:solidFill>
+                  <a:srgbClr val="12202B"/>
+                </a:solidFill>
+                <a:latin typeface="Calibri" pitchFamily="34" charset="0"/>
+                <a:ea typeface="Calibri" pitchFamily="34" charset="-122"/>
+                <a:cs typeface="Calibri" pitchFamily="34" charset="-120"/>
+              </a:rPr>
+              <a:t>Thời gian</a:t>
+            </a:r>
+            <a:endParaRPr lang="en-US" sz="2000" dirty="0"/>
+          </a:p>
+        </p:txBody>
+      </p:sp>
+      <p:sp>
+        <p:nvSpPr>
+          <p:cNvPr id="7" name="Text 4"/>
+          <p:cNvSpPr txBox="1"/>
+          <p:nvPr/>
+        </p:nvSpPr>
+        <p:spPr>
+          <a:xfrm>
+            <a:off x="914400" y="4389120"/>
+            <a:ext cx="2874264" cy="1188720"/>
+          </a:xfrm>
+          <a:prstGeom prst="rect">
+            <a:avLst/>
+          </a:prstGeom>
+          <a:noFill/>
+          <a:ln/>
+        </p:spPr>
+        <p:txBody>
+          <a:bodyPr wrap="square" lIns="0" tIns="0" rIns="0" bIns="0" rtlCol="0" anchor="t"/>
+          <a:lstStyle/>
+          <a:p>
+            <a:pPr indent="0" marL="0">
+              <a:buNone/>
+            </a:pPr>
+            <a:r>
+              <a:rPr lang="en-US" sz="1500" dirty="0">
+                <a:solidFill>
+                  <a:srgbClr val="4A5866"/>
+                </a:solidFill>
+                <a:latin typeface="Calibri" pitchFamily="34" charset="0"/>
+                <a:ea typeface="Calibri" pitchFamily="34" charset="-122"/>
+                <a:cs typeface="Calibri" pitchFamily="34" charset="-120"/>
+              </a:rPr>
+              <a:t>Đồng thời 210 giây (Mac 154 giây); tuần tự 43 giây (Mac 23 giây).</a:t>
+            </a:r>
+            <a:endParaRPr lang="en-US" sz="1500" dirty="0"/>
+          </a:p>
+        </p:txBody>
+      </p:sp>
+      <p:sp>
+        <p:nvSpPr>
+          <p:cNvPr id="8" name="Shape 5"/>
+          <p:cNvSpPr/>
+          <p:nvPr/>
+        </p:nvSpPr>
+        <p:spPr>
+          <a:xfrm>
+            <a:off x="4383024" y="3657600"/>
+            <a:ext cx="3422904" cy="2011680"/>
+          </a:xfrm>
+          <a:prstGeom prst="roundRect">
+            <a:avLst>
+              <a:gd name="adj" fmla="val 5455"/>
+            </a:avLst>
+          </a:prstGeom>
+          <a:solidFill>
+            <a:srgbClr val="FBFAF6"/>
+          </a:solidFill>
+          <a:ln w="12700">
+            <a:solidFill>
+              <a:srgbClr val="DAD6CC"/>
+            </a:solidFill>
+            <a:prstDash val="solid"/>
+          </a:ln>
+        </p:spPr>
+      </p:sp>
+      <p:sp>
+        <p:nvSpPr>
+          <p:cNvPr id="9" name="Text 6"/>
+          <p:cNvSpPr txBox="1"/>
+          <p:nvPr/>
+        </p:nvSpPr>
+        <p:spPr>
+          <a:xfrm>
+            <a:off x="4657344" y="3840480"/>
+            <a:ext cx="2874264" cy="457200"/>
+          </a:xfrm>
+          <a:prstGeom prst="rect">
+            <a:avLst/>
+          </a:prstGeom>
+          <a:noFill/>
+          <a:ln/>
+        </p:spPr>
+        <p:txBody>
+          <a:bodyPr wrap="square" lIns="0" tIns="0" rIns="0" bIns="0" rtlCol="0" anchor="ctr"/>
+          <a:lstStyle/>
+          <a:p>
+            <a:pPr indent="0" marL="0">
+              <a:buNone/>
+            </a:pPr>
+            <a:r>
+              <a:rPr lang="en-US" sz="2000" b="1" dirty="0">
+                <a:solidFill>
+                  <a:srgbClr val="12202B"/>
+                </a:solidFill>
+                <a:latin typeface="Calibri" pitchFamily="34" charset="0"/>
+                <a:ea typeface="Calibri" pitchFamily="34" charset="-122"/>
+                <a:cs typeface="Calibri" pitchFamily="34" charset="-120"/>
+              </a:rPr>
+              <a:t>Hai lượt đầu bị loại</a:t>
+            </a:r>
+            <a:endParaRPr lang="en-US" sz="2000" dirty="0"/>
+          </a:p>
+        </p:txBody>
+      </p:sp>
+      <p:sp>
+        <p:nvSpPr>
+          <p:cNvPr id="10" name="Text 7"/>
+          <p:cNvSpPr txBox="1"/>
+          <p:nvPr/>
+        </p:nvSpPr>
+        <p:spPr>
+          <a:xfrm>
+            <a:off x="4657344" y="4389120"/>
+            <a:ext cx="2874264" cy="1188720"/>
+          </a:xfrm>
+          <a:prstGeom prst="rect">
+            <a:avLst/>
+          </a:prstGeom>
+          <a:noFill/>
+          <a:ln/>
+        </p:spPr>
+        <p:txBody>
+          <a:bodyPr wrap="square" lIns="0" tIns="0" rIns="0" bIns="0" rtlCol="0" anchor="t"/>
+          <a:lstStyle/>
+          <a:p>
+            <a:pPr indent="0" marL="0">
+              <a:buNone/>
+            </a:pPr>
+            <a:r>
+              <a:rPr lang="en-US" sz="1500" dirty="0">
+                <a:solidFill>
+                  <a:srgbClr val="4A5866"/>
+                </a:solidFill>
+                <a:latin typeface="Calibri" pitchFamily="34" charset="0"/>
+                <a:ea typeface="Calibri" pitchFamily="34" charset="-122"/>
+                <a:cs typeface="Calibri" pitchFamily="34" charset="-120"/>
+              </a:rPr>
+              <a:t>Thiếu k6 và Cal.com dừng giữa chừng. Chỉ dùng lượt chạy sạch.</a:t>
+            </a:r>
+            <a:endParaRPr lang="en-US" sz="1500" dirty="0"/>
+          </a:p>
+        </p:txBody>
+      </p:sp>
+      <p:sp>
+        <p:nvSpPr>
+          <p:cNvPr id="11" name="Shape 8"/>
+          <p:cNvSpPr/>
+          <p:nvPr/>
+        </p:nvSpPr>
+        <p:spPr>
+          <a:xfrm>
+            <a:off x="8125968" y="3657600"/>
+            <a:ext cx="3422904" cy="2011680"/>
+          </a:xfrm>
+          <a:prstGeom prst="roundRect">
+            <a:avLst>
+              <a:gd name="adj" fmla="val 5455"/>
+            </a:avLst>
+          </a:prstGeom>
+          <a:solidFill>
+            <a:srgbClr val="FBFAF6"/>
+          </a:solidFill>
+          <a:ln w="12700">
+            <a:solidFill>
+              <a:srgbClr val="DAD6CC"/>
+            </a:solidFill>
+            <a:prstDash val="solid"/>
+          </a:ln>
+        </p:spPr>
+      </p:sp>
+      <p:sp>
+        <p:nvSpPr>
+          <p:cNvPr id="12" name="Text 9"/>
+          <p:cNvSpPr txBox="1"/>
+          <p:nvPr/>
+        </p:nvSpPr>
+        <p:spPr>
+          <a:xfrm>
+            <a:off x="8400288" y="3840480"/>
+            <a:ext cx="2874264" cy="457200"/>
+          </a:xfrm>
+          <a:prstGeom prst="rect">
+            <a:avLst/>
+          </a:prstGeom>
+          <a:noFill/>
+          <a:ln/>
+        </p:spPr>
+        <p:txBody>
+          <a:bodyPr wrap="square" lIns="0" tIns="0" rIns="0" bIns="0" rtlCol="0" anchor="ctr"/>
+          <a:lstStyle/>
+          <a:p>
+            <a:pPr indent="0" marL="0">
+              <a:buNone/>
+            </a:pPr>
+            <a:r>
+              <a:rPr lang="en-US" sz="2000" b="1" dirty="0">
+                <a:solidFill>
+                  <a:srgbClr val="12202B"/>
+                </a:solidFill>
+                <a:latin typeface="Calibri" pitchFamily="34" charset="0"/>
+                <a:ea typeface="Calibri" pitchFamily="34" charset="-122"/>
+                <a:cs typeface="Calibri" pitchFamily="34" charset="-120"/>
+              </a:rPr>
+              <a:t>Còn thiếu</a:t>
+            </a:r>
+            <a:endParaRPr lang="en-US" sz="2000" dirty="0"/>
+          </a:p>
+        </p:txBody>
+      </p:sp>
+      <p:sp>
+        <p:nvSpPr>
+          <p:cNvPr id="13" name="Text 10"/>
+          <p:cNvSpPr txBox="1"/>
+          <p:nvPr/>
+        </p:nvSpPr>
+        <p:spPr>
+          <a:xfrm>
+            <a:off x="8400288" y="4389120"/>
+            <a:ext cx="2874264" cy="1188720"/>
+          </a:xfrm>
+          <a:prstGeom prst="rect">
+            <a:avLst/>
+          </a:prstGeom>
+          <a:noFill/>
+          <a:ln/>
+        </p:spPr>
+        <p:txBody>
+          <a:bodyPr wrap="square" lIns="0" tIns="0" rIns="0" bIns="0" rtlCol="0" anchor="t"/>
+          <a:lstStyle/>
+          <a:p>
+            <a:pPr indent="0" marL="0">
+              <a:buNone/>
+            </a:pPr>
+            <a:r>
+              <a:rPr lang="en-US" sz="1500" dirty="0">
+                <a:solidFill>
+                  <a:srgbClr val="4A5866"/>
+                </a:solidFill>
+                <a:latin typeface="Calibri" pitchFamily="34" charset="0"/>
+                <a:ea typeface="Calibri" pitchFamily="34" charset="-122"/>
+                <a:cs typeface="Calibri" pitchFamily="34" charset="-120"/>
+              </a:rPr>
+              <a:t>Cấu hình máy Windows và tên người test cần ghi vào báo cáo.</a:t>
+            </a:r>
+            <a:endParaRPr lang="en-US" sz="1500" dirty="0"/>
+          </a:p>
+        </p:txBody>
+      </p:sp>
+      <p:sp>
+        <p:nvSpPr>
+          <p:cNvPr id="14" name="Text 11"/>
+          <p:cNvSpPr txBox="1"/>
+          <p:nvPr/>
+        </p:nvSpPr>
+        <p:spPr>
+          <a:xfrm>
+            <a:off x="640080" y="6355080"/>
+            <a:ext cx="10332720" cy="274320"/>
+          </a:xfrm>
+          <a:prstGeom prst="rect">
+            <a:avLst/>
+          </a:prstGeom>
+          <a:noFill/>
+          <a:ln/>
+        </p:spPr>
+        <p:txBody>
+          <a:bodyPr wrap="square" lIns="0" tIns="0" rIns="0" bIns="0" rtlCol="0" anchor="ctr"/>
+          <a:lstStyle/>
+          <a:p>
+            <a:pPr indent="0" marL="0">
+              <a:buNone/>
+            </a:pPr>
+            <a:r>
+              <a:rPr lang="en-US" sz="1200" dirty="0">
+                <a:solidFill>
+                  <a:srgbClr val="7A8592"/>
+                </a:solidFill>
+                <a:latin typeface="Calibri" pitchFamily="34" charset="0"/>
+                <a:ea typeface="Calibri" pitchFamily="34" charset="-122"/>
+                <a:cs typeface="Calibri" pitchFamily="34" charset="-120"/>
+              </a:rPr>
+              <a:t>race-tests/results/windows-race · race-tests/results/windows-sequential</a:t>
+            </a:r>
+            <a:endParaRPr lang="en-US" sz="1200" dirty="0"/>
+          </a:p>
+        </p:txBody>
+      </p:sp>
+      <p:sp>
+        <p:nvSpPr>
+          <p:cNvPr id="25" name="Slide Number Placeholder 0"/>
+          <p:cNvSpPr>
+            <a:spLocks noGrp="1"/>
+          </p:cNvSpPr>
+          <p:nvPr>
+            <p:ph type="sldNum" sz="quarter" idx="4294967295"/>
+          </p:nvPr>
+        </p:nvSpPr>
+        <p:spPr>
+          <a:xfrm>
+            <a:off x="11155680" y="6355080"/>
+            <a:ext cx="457200" cy="274320"/>
+          </a:xfrm>
+          <a:prstGeom prst="rect">
+            <a:avLst/>
+          </a:prstGeom>
+          <a:extLst>
+            <a:ext uri="{C572A759-6A51-4108-AA02-DFA0A04FC94B}">
+              <ma14:wrappingTextBoxFlag xmlns:ma14="http://schemas.microsoft.com/office/mac/drawingml/2011/main" val="0"/>
+            </a:ext>
+          </a:extLst>
+        </p:spPr>
+        <p:txBody>
+          <a:bodyPr/>
+          <a:lstStyle>
+            <a:lvl1pPr>
+              <a:defRPr sz="1200">
+                <a:solidFill>
+                  <a:srgbClr val="7A8592"/>
+                </a:solidFill>
+                <a:latin typeface="Calibri"/>
+                <a:ea typeface="Calibri"/>
+                <a:cs typeface="Calibri"/>
+              </a:defRPr>
+            </a:lvl1pPr>
+          </a:lstStyle>
+          <a:p>
+            <a:pPr algn="r"/>
+            <a:fld id="{F7021451-1387-4CA6-816F-3879F97B5CBC}" type="slidenum">
+              <a:rPr b="0" lang="en-US"/>
+              <a:t>11</a:t>
+            </a:fld>
+            <a:endParaRPr lang="en-US"/>
+          </a:p>
+        </p:txBody>
+      </p:sp>
+    </p:spTree>
+  </p:cSld>
+  <p:clrMapOvr>
+    <a:masterClrMapping/>
+  </p:clrMapOvr>
+</p:sld>
+</file>
+
+<file path=ppt/slides/slide12.xml><?xml version="1.0" encoding="utf-8"?>
+<p:sld xmlns:a="http://schemas.openxmlformats.org/drawingml/2006/main" xmlns:r="http://schemas.openxmlformats.org/officeDocument/2006/relationships" xmlns:p="http://schemas.openxmlformats.org/presentationml/2006/main">
+  <p:cSld name="Slide 12">
+    <p:spTree>
+      <p:nvGrpSpPr>
+        <p:cNvPr id="1" name=""/>
+        <p:cNvGrpSpPr/>
+        <p:nvPr/>
+      </p:nvGrpSpPr>
+      <p:grpSpPr>
+        <a:xfrm>
+          <a:off x="0" y="0"/>
+          <a:ext cx="0" cy="0"/>
+          <a:chOff x="0" y="0"/>
+          <a:chExt cx="0" cy="0"/>
+        </a:xfrm>
+      </p:grpSpPr>
+      <p:sp>
+        <p:nvSpPr>
+          <p:cNvPr id="2" name="Text 0"/>
+          <p:cNvSpPr txBox="1"/>
+          <p:nvPr/>
+        </p:nvSpPr>
+        <p:spPr>
+          <a:xfrm>
+            <a:off x="640080" y="292608"/>
+            <a:ext cx="10908792" cy="274320"/>
+          </a:xfrm>
+          <a:prstGeom prst="rect">
+            <a:avLst/>
+          </a:prstGeom>
+          <a:noFill/>
+          <a:ln/>
+        </p:spPr>
+        <p:txBody>
+          <a:bodyPr wrap="square" lIns="0" tIns="0" rIns="0" bIns="0" rtlCol="0" anchor="ctr"/>
+          <a:lstStyle/>
+          <a:p>
+            <a:pPr indent="0" marL="0">
+              <a:buNone/>
+            </a:pPr>
+            <a:r>
+              <a:rPr lang="en-US" sz="1300" b="1" spc="200" kern="0" dirty="0">
+                <a:solidFill>
+                  <a:srgbClr val="B4531A"/>
+                </a:solidFill>
+                <a:latin typeface="Consolas" pitchFamily="34" charset="0"/>
+                <a:ea typeface="Consolas" pitchFamily="34" charset="-122"/>
+                <a:cs typeface="Consolas" pitchFamily="34" charset="-120"/>
+              </a:rPr>
+              <a:t>11 · LỖI THẬT, TÁI HIỆN ĐỘC LẬP</a:t>
             </a:r>
             <a:endParaRPr lang="en-US" sz="1300" dirty="0"/>
           </a:p>
@@ -5965,7 +7963,7 @@
       </p:sp>
       <p:graphicFrame>
         <p:nvGraphicFramePr>
-          <p:cNvPr id="12" name="Table 0"/>
+          <p:cNvPr id="13" name="Table 0"/>
           <p:cNvGraphicFramePr>
             <a:graphicFrameLocks noGrp="1"/>
           </p:cNvGraphicFramePr>
@@ -7556,7 +9554,7 @@
             <a:pPr algn="r"/>
             <a:fld id="{F7021451-1387-4CA6-816F-3879F97B5CBC}" type="slidenum">
               <a:rPr b="0" lang="en-US"/>
-              <a:t>11</a:t>
+              <a:t>12</a:t>
             </a:fld>
             <a:endParaRPr lang="en-US"/>
           </a:p>
@@ -7570,9 +9568,9 @@
 </p:sld>
 </file>
 
-<file path=ppt/slides/slide12.xml><?xml version="1.0" encoding="utf-8"?>
+<file path=ppt/slides/slide13.xml><?xml version="1.0" encoding="utf-8"?>
 <p:sld xmlns:a="http://schemas.openxmlformats.org/drawingml/2006/main" xmlns:r="http://schemas.openxmlformats.org/officeDocument/2006/relationships" xmlns:p="http://schemas.openxmlformats.org/presentationml/2006/main">
-  <p:cSld name="Slide 12">
+  <p:cSld name="Slide 13">
     <p:spTree>
       <p:nvGrpSpPr>
         <p:cNvPr id="1" name=""/>
@@ -7620,7 +9618,7 @@
                 <a:ea typeface="Consolas" pitchFamily="34" charset="-122"/>
                 <a:cs typeface="Consolas" pitchFamily="34" charset="-120"/>
               </a:rPr>
-              <a:t>11 · KẾ HOẠCH TIẾP THEO</a:t>
+              <a:t>12 · KẾ HOẠCH TIẾP THEO</a:t>
             </a:r>
             <a:endParaRPr lang="en-US" sz="1300" dirty="0"/>
           </a:p>
@@ -7793,7 +9791,7 @@
                 <a:ea typeface="Calibri" pitchFamily="34" charset="-122"/>
                 <a:cs typeface="Calibri" pitchFamily="34" charset="-120"/>
               </a:rPr>
-              <a:t>Thêm scenario Playwright qua giao diện, chạy lại toàn bộ trên máy sạch của thành viên khác</a:t>
+              <a:t>Thêm scenario Playwright qua giao diện, bổ sung cấu hình máy Windows và tên người test vào báo cáo</a:t>
             </a:r>
             <a:endParaRPr lang="en-US" sz="1600" dirty="0"/>
           </a:p>
@@ -8315,7 +10313,7 @@
             <a:pPr algn="r"/>
             <a:fld id="{F7021451-1387-4CA6-816F-3879F97B5CBC}" type="slidenum">
               <a:rPr b="0" lang="en-US"/>
-              <a:t>12</a:t>
+              <a:t>13</a:t>
             </a:fld>
             <a:endParaRPr lang="en-US"/>
           </a:p>
@@ -9078,7 +11076,7 @@
                 <a:gridCol w="1371600"/>
                 <a:gridCol w="3044952"/>
               </a:tblGrid>
-              <a:tr h="420624">
+              <a:tr h="393192">
                 <a:tc>
                   <a:txBody>
                     <a:bodyPr/>
@@ -9352,7 +11350,7 @@
                   </a:tcPr>
                 </a:tc>
               </a:tr>
-              <a:tr h="420624">
+              <a:tr h="393192">
                 <a:tc>
                   <a:txBody>
                     <a:bodyPr/>
@@ -9626,7 +11624,7 @@
                   </a:tcPr>
                 </a:tc>
               </a:tr>
-              <a:tr h="420624">
+              <a:tr h="393192">
                 <a:tc>
                   <a:txBody>
                     <a:bodyPr/>
@@ -9900,7 +11898,7 @@
                   </a:tcPr>
                 </a:tc>
               </a:tr>
-              <a:tr h="420624">
+              <a:tr h="393192">
                 <a:tc>
                   <a:txBody>
                     <a:bodyPr/>
@@ -10174,7 +12172,7 @@
                   </a:tcPr>
                 </a:tc>
               </a:tr>
-              <a:tr h="420624">
+              <a:tr h="393192">
                 <a:tc>
                   <a:txBody>
                     <a:bodyPr/>
@@ -10448,7 +12446,7 @@
                   </a:tcPr>
                 </a:tc>
               </a:tr>
-              <a:tr h="420624">
+              <a:tr h="393192">
                 <a:tc>
                   <a:txBody>
                     <a:bodyPr/>
@@ -10722,7 +12720,7 @@
                   </a:tcPr>
                 </a:tc>
               </a:tr>
-              <a:tr h="420624">
+              <a:tr h="393192">
                 <a:tc>
                   <a:txBody>
                     <a:bodyPr/>
@@ -10996,7 +12994,7 @@
                   </a:tcPr>
                 </a:tc>
               </a:tr>
-              <a:tr h="420624">
+              <a:tr h="393192">
                 <a:tc>
                   <a:txBody>
                     <a:bodyPr/>
@@ -11270,7 +13268,7 @@
                   </a:tcPr>
                 </a:tc>
               </a:tr>
-              <a:tr h="420624">
+              <a:tr h="393192">
                 <a:tc>
                   <a:txBody>
                     <a:bodyPr/>
@@ -11288,7 +13286,7 @@
                           <a:ea typeface="Calibri" pitchFamily="34" charset="-122"/>
                           <a:cs typeface="Calibri" pitchFamily="34" charset="-120"/>
                         </a:rPr>
-                        <a:t>Scenario Playwright qua giao diện, chạy lại trên máy khác</a:t>
+                        <a:t>Chạy lại trên máy Windows khác: kết quả khớp 8/8</a:t>
                       </a:r>
                       <a:endParaRPr lang="en-US" sz="1300" dirty="0">
                         <a:latin typeface="Calibri" charset="0"/>
@@ -11418,6 +13416,280 @@
                       <a:r>
                         <a:rPr lang="en-US" sz="1300" b="1" dirty="0">
                           <a:solidFill>
+                            <a:srgbClr val="2E7D4F"/>
+                          </a:solidFill>
+                          <a:latin typeface="Calibri" pitchFamily="34" charset="0"/>
+                          <a:ea typeface="Calibri" pitchFamily="34" charset="-122"/>
+                          <a:cs typeface="Calibri" pitchFamily="34" charset="-120"/>
+                        </a:rPr>
+                        <a:t>Xong</a:t>
+                      </a:r>
+                      <a:endParaRPr lang="en-US" sz="1300" dirty="0">
+                        <a:latin typeface="Calibri" charset="0"/>
+                        <a:ea typeface="Calibri" charset="0"/>
+                        <a:cs typeface="Calibri" charset="0"/>
+                      </a:endParaRPr>
+                    </a:p>
+                  </a:txBody>
+                  <a:tcPr marL="91440" marR="91440" marT="36576" marB="36576" anchor="ctr">
+                    <a:lnL w="9525" cap="flat" cmpd="sng" algn="ctr">
+                      <a:solidFill>
+                        <a:srgbClr val="DAD6CC"/>
+                      </a:solidFill>
+                      <a:prstDash val="solid"/>
+                      <a:round/>
+                      <a:headEnd type="none" w="med" len="med"/>
+                      <a:tailEnd type="none" w="med" len="med"/>
+                    </a:lnL>
+                    <a:lnR w="9525" cap="flat" cmpd="sng" algn="ctr">
+                      <a:solidFill>
+                        <a:srgbClr val="DAD6CC"/>
+                      </a:solidFill>
+                      <a:prstDash val="solid"/>
+                      <a:round/>
+                      <a:headEnd type="none" w="med" len="med"/>
+                      <a:tailEnd type="none" w="med" len="med"/>
+                    </a:lnR>
+                    <a:lnT w="9525" cap="flat" cmpd="sng" algn="ctr">
+                      <a:solidFill>
+                        <a:srgbClr val="DAD6CC"/>
+                      </a:solidFill>
+                      <a:prstDash val="solid"/>
+                      <a:round/>
+                      <a:headEnd type="none" w="med" len="med"/>
+                      <a:tailEnd type="none" w="med" len="med"/>
+                    </a:lnT>
+                    <a:lnB w="9525" cap="flat" cmpd="sng" algn="ctr">
+                      <a:solidFill>
+                        <a:srgbClr val="DAD6CC"/>
+                      </a:solidFill>
+                      <a:prstDash val="solid"/>
+                      <a:round/>
+                      <a:headEnd type="none" w="med" len="med"/>
+                      <a:tailEnd type="none" w="med" len="med"/>
+                    </a:lnB>
+                    <a:solidFill>
+                      <a:srgbClr val="FFFFFF"/>
+                    </a:solidFill>
+                  </a:tcPr>
+                </a:tc>
+                <a:tc>
+                  <a:txBody>
+                    <a:bodyPr/>
+                    <a:lstStyle/>
+                    <a:p>
+                      <a:pPr indent="0" marL="0">
+                        <a:buNone/>
+                      </a:pPr>
+                      <a:r>
+                        <a:rPr lang="en-US" sz="1300" dirty="0">
+                          <a:solidFill>
+                            <a:srgbClr val="12202B"/>
+                          </a:solidFill>
+                          <a:latin typeface="Calibri" pitchFamily="34" charset="0"/>
+                          <a:ea typeface="Calibri" pitchFamily="34" charset="-122"/>
+                          <a:cs typeface="Calibri" pitchFamily="34" charset="-120"/>
+                        </a:rPr>
+                        <a:t>race-tests/results/windows-race</a:t>
+                      </a:r>
+                      <a:endParaRPr lang="en-US" sz="1300" dirty="0">
+                        <a:latin typeface="Calibri" charset="0"/>
+                        <a:ea typeface="Calibri" charset="0"/>
+                        <a:cs typeface="Calibri" charset="0"/>
+                      </a:endParaRPr>
+                    </a:p>
+                  </a:txBody>
+                  <a:tcPr marL="91440" marR="91440" marT="36576" marB="36576" anchor="ctr">
+                    <a:lnL w="9525" cap="flat" cmpd="sng" algn="ctr">
+                      <a:solidFill>
+                        <a:srgbClr val="DAD6CC"/>
+                      </a:solidFill>
+                      <a:prstDash val="solid"/>
+                      <a:round/>
+                      <a:headEnd type="none" w="med" len="med"/>
+                      <a:tailEnd type="none" w="med" len="med"/>
+                    </a:lnL>
+                    <a:lnR w="9525" cap="flat" cmpd="sng" algn="ctr">
+                      <a:solidFill>
+                        <a:srgbClr val="DAD6CC"/>
+                      </a:solidFill>
+                      <a:prstDash val="solid"/>
+                      <a:round/>
+                      <a:headEnd type="none" w="med" len="med"/>
+                      <a:tailEnd type="none" w="med" len="med"/>
+                    </a:lnR>
+                    <a:lnT w="9525" cap="flat" cmpd="sng" algn="ctr">
+                      <a:solidFill>
+                        <a:srgbClr val="DAD6CC"/>
+                      </a:solidFill>
+                      <a:prstDash val="solid"/>
+                      <a:round/>
+                      <a:headEnd type="none" w="med" len="med"/>
+                      <a:tailEnd type="none" w="med" len="med"/>
+                    </a:lnT>
+                    <a:lnB w="9525" cap="flat" cmpd="sng" algn="ctr">
+                      <a:solidFill>
+                        <a:srgbClr val="DAD6CC"/>
+                      </a:solidFill>
+                      <a:prstDash val="solid"/>
+                      <a:round/>
+                      <a:headEnd type="none" w="med" len="med"/>
+                      <a:tailEnd type="none" w="med" len="med"/>
+                    </a:lnB>
+                    <a:solidFill>
+                      <a:srgbClr val="FFFFFF"/>
+                    </a:solidFill>
+                  </a:tcPr>
+                </a:tc>
+              </a:tr>
+              <a:tr h="393192">
+                <a:tc>
+                  <a:txBody>
+                    <a:bodyPr/>
+                    <a:lstStyle/>
+                    <a:p>
+                      <a:pPr indent="0" marL="0">
+                        <a:buNone/>
+                      </a:pPr>
+                      <a:r>
+                        <a:rPr lang="en-US" sz="1300" dirty="0">
+                          <a:solidFill>
+                            <a:srgbClr val="12202B"/>
+                          </a:solidFill>
+                          <a:latin typeface="Calibri" pitchFamily="34" charset="0"/>
+                          <a:ea typeface="Calibri" pitchFamily="34" charset="-122"/>
+                          <a:cs typeface="Calibri" pitchFamily="34" charset="-120"/>
+                        </a:rPr>
+                        <a:t>Scenario Playwright qua giao diện</a:t>
+                      </a:r>
+                      <a:endParaRPr lang="en-US" sz="1300" dirty="0">
+                        <a:latin typeface="Calibri" charset="0"/>
+                        <a:ea typeface="Calibri" charset="0"/>
+                        <a:cs typeface="Calibri" charset="0"/>
+                      </a:endParaRPr>
+                    </a:p>
+                  </a:txBody>
+                  <a:tcPr marL="91440" marR="91440" marT="36576" marB="36576" anchor="ctr">
+                    <a:lnL w="9525" cap="flat" cmpd="sng" algn="ctr">
+                      <a:solidFill>
+                        <a:srgbClr val="DAD6CC"/>
+                      </a:solidFill>
+                      <a:prstDash val="solid"/>
+                      <a:round/>
+                      <a:headEnd type="none" w="med" len="med"/>
+                      <a:tailEnd type="none" w="med" len="med"/>
+                    </a:lnL>
+                    <a:lnR w="9525" cap="flat" cmpd="sng" algn="ctr">
+                      <a:solidFill>
+                        <a:srgbClr val="DAD6CC"/>
+                      </a:solidFill>
+                      <a:prstDash val="solid"/>
+                      <a:round/>
+                      <a:headEnd type="none" w="med" len="med"/>
+                      <a:tailEnd type="none" w="med" len="med"/>
+                    </a:lnR>
+                    <a:lnT w="9525" cap="flat" cmpd="sng" algn="ctr">
+                      <a:solidFill>
+                        <a:srgbClr val="DAD6CC"/>
+                      </a:solidFill>
+                      <a:prstDash val="solid"/>
+                      <a:round/>
+                      <a:headEnd type="none" w="med" len="med"/>
+                      <a:tailEnd type="none" w="med" len="med"/>
+                    </a:lnT>
+                    <a:lnB w="9525" cap="flat" cmpd="sng" algn="ctr">
+                      <a:solidFill>
+                        <a:srgbClr val="DAD6CC"/>
+                      </a:solidFill>
+                      <a:prstDash val="solid"/>
+                      <a:round/>
+                      <a:headEnd type="none" w="med" len="med"/>
+                      <a:tailEnd type="none" w="med" len="med"/>
+                    </a:lnB>
+                    <a:solidFill>
+                      <a:srgbClr val="FFFFFF"/>
+                    </a:solidFill>
+                  </a:tcPr>
+                </a:tc>
+                <a:tc>
+                  <a:txBody>
+                    <a:bodyPr/>
+                    <a:lstStyle/>
+                    <a:p>
+                      <a:pPr indent="0" marL="0">
+                        <a:buNone/>
+                      </a:pPr>
+                      <a:r>
+                        <a:rPr lang="en-US" sz="1300" dirty="0">
+                          <a:solidFill>
+                            <a:srgbClr val="12202B"/>
+                          </a:solidFill>
+                          <a:latin typeface="Calibri" pitchFamily="34" charset="0"/>
+                          <a:ea typeface="Calibri" pitchFamily="34" charset="-122"/>
+                          <a:cs typeface="Calibri" pitchFamily="34" charset="-120"/>
+                        </a:rPr>
+                        <a:t>3</a:t>
+                      </a:r>
+                      <a:endParaRPr lang="en-US" sz="1300" dirty="0">
+                        <a:latin typeface="Calibri" charset="0"/>
+                        <a:ea typeface="Calibri" charset="0"/>
+                        <a:cs typeface="Calibri" charset="0"/>
+                      </a:endParaRPr>
+                    </a:p>
+                  </a:txBody>
+                  <a:tcPr marL="91440" marR="91440" marT="36576" marB="36576" anchor="ctr">
+                    <a:lnL w="9525" cap="flat" cmpd="sng" algn="ctr">
+                      <a:solidFill>
+                        <a:srgbClr val="DAD6CC"/>
+                      </a:solidFill>
+                      <a:prstDash val="solid"/>
+                      <a:round/>
+                      <a:headEnd type="none" w="med" len="med"/>
+                      <a:tailEnd type="none" w="med" len="med"/>
+                    </a:lnL>
+                    <a:lnR w="9525" cap="flat" cmpd="sng" algn="ctr">
+                      <a:solidFill>
+                        <a:srgbClr val="DAD6CC"/>
+                      </a:solidFill>
+                      <a:prstDash val="solid"/>
+                      <a:round/>
+                      <a:headEnd type="none" w="med" len="med"/>
+                      <a:tailEnd type="none" w="med" len="med"/>
+                    </a:lnR>
+                    <a:lnT w="9525" cap="flat" cmpd="sng" algn="ctr">
+                      <a:solidFill>
+                        <a:srgbClr val="DAD6CC"/>
+                      </a:solidFill>
+                      <a:prstDash val="solid"/>
+                      <a:round/>
+                      <a:headEnd type="none" w="med" len="med"/>
+                      <a:tailEnd type="none" w="med" len="med"/>
+                    </a:lnT>
+                    <a:lnB w="9525" cap="flat" cmpd="sng" algn="ctr">
+                      <a:solidFill>
+                        <a:srgbClr val="DAD6CC"/>
+                      </a:solidFill>
+                      <a:prstDash val="solid"/>
+                      <a:round/>
+                      <a:headEnd type="none" w="med" len="med"/>
+                      <a:tailEnd type="none" w="med" len="med"/>
+                    </a:lnB>
+                    <a:solidFill>
+                      <a:srgbClr val="FFFFFF"/>
+                    </a:solidFill>
+                  </a:tcPr>
+                </a:tc>
+                <a:tc>
+                  <a:txBody>
+                    <a:bodyPr/>
+                    <a:lstStyle/>
+                    <a:p>
+                      <a:pPr indent="0" marL="0">
+                        <a:buNone/>
+                      </a:pPr>
+                      <a:r>
+                        <a:rPr lang="en-US" sz="1300" b="1" dirty="0">
+                          <a:solidFill>
                             <a:srgbClr val="4A5866"/>
                           </a:solidFill>
                           <a:latin typeface="Calibri" pitchFamily="34" charset="0"/>
@@ -11544,7 +13816,7 @@
                   </a:tcPr>
                 </a:tc>
               </a:tr>
-              <a:tr h="420624">
+              <a:tr h="393192">
                 <a:tc>
                   <a:txBody>
                     <a:bodyPr/>

</xml_diff>

<commit_message>
docs: record the Windows tester and machine, fix run time to Vietnam time
- tester: Ngô Quốc Trường Vĩ; machine: MSI, Core i7-13620H, 16 GB RAM
- the Windows run started 02:15 on 19/10 Vietnam time (19:15 UTC on 18/10)

Co-Authored-By: Claude Sonnet 5.5 <noreply@anthropic.com>
</commit_message>
<xml_diff>
--- a/docs/BAO_CAO_GIUA_KY_R05-K15.pptx
+++ b/docs/BAO_CAO_GIUA_KY_R05-K15.pptx
@@ -119,18 +119,18 @@
   <p:extLst>
     <p:ext uri="{521415D9-36F7-43E2-AB2F-B90AF26B5E84}">
       <p14:sectionLst xmlns:p14="http://schemas.microsoft.com/office/powerpoint/2010/main">
-        <p14:section name="Mở đầu" id="{2238302a-4226-be89-d734-fc0712ea256c}">
+        <p14:section name="Mở đầu" id="{c6bc6c98-a9dd-87ed-1f54-39f8be356a4b}">
           <p14:sldIdLst>
             <p14:sldId id="256"/>
             <p14:sldId id="257"/>
           </p14:sldIdLst>
         </p14:section>
-        <p14:section name="Tiến độ" id="{e6671efc-6b28-0032-2b50-400ef5d150f1}">
+        <p14:section name="Tiến độ" id="{5d4a2a0e-4f30-95d6-19cb-1eab49d49bc8}">
           <p14:sldIdLst>
             <p14:sldId id="258"/>
           </p14:sldIdLst>
         </p14:section>
-        <p14:section name="Hệ thống và kiểm thử" id="{b5edd6eb-01d8-44a1-e320-4512422f4bc9}">
+        <p14:section name="Hệ thống và kiểm thử" id="{227a61ef-3fea-eb11-fd0d-6a9085c857c9}">
           <p14:sldIdLst>
             <p14:sldId id="259"/>
             <p14:sldId id="260"/>
@@ -138,20 +138,20 @@
             <p14:sldId id="262"/>
           </p14:sldIdLst>
         </p14:section>
-        <p14:section name="Kế hoạch kiểm thử" id="{ba3855ab-0702-7081-aad8-80dd9a6d3784}">
+        <p14:section name="Kế hoạch kiểm thử" id="{a9f192d7-d36e-1cd3-dade-c5da9d34da52}">
           <p14:sldIdLst>
             <p14:sldId id="263"/>
             <p14:sldId id="264"/>
           </p14:sldIdLst>
         </p14:section>
-        <p14:section name="Kết quả sơ bộ" id="{c5168517-9a86-0053-94f9-54571754f6a4}">
+        <p14:section name="Kết quả sơ bộ" id="{2a00fac9-ff1d-1fd9-e7c1-d25b564c9470}">
           <p14:sldIdLst>
             <p14:sldId id="265"/>
             <p14:sldId id="266"/>
             <p14:sldId id="267"/>
           </p14:sldIdLst>
         </p14:section>
-        <p14:section name="Tiếp theo" id="{9fce0ac1-77c1-2271-86f0-6a90a7a3a2be}">
+        <p14:section name="Tiếp theo" id="{f456f873-3d5b-4706-e427-cb3c8bdf425c}">
           <p14:sldIdLst>
             <p14:sldId id="268"/>
           </p14:sldIdLst>
@@ -736,7 +736,7 @@
           <a:p>
             <a:r>
               <a:rPr lang="en-US" dirty="0"/>
-              <a:t>Một thành viên chạy lại bộ test trên máy Windows của mình với cùng phiên bản mã. Kết luận tám test case giống hệt máy Mac: năm lỗi race chỉ sai khi đồng thời, một lỗi logic sai cả khi tuần tự, hai test case đúng. Hai lượt chạy đầu trên máy Windows không hợp lệ vì thiếu công cụ k6 và vì Cal.com dừng giữa chừng; nhóm đã loại và chỉ dùng lượt chạy sạch. Cấu hình máy và tên người test cần ghi vào báo cáo.</a:t>
+              <a:t>Một thành viên chạy lại bộ test trên máy Windows của mình với cùng phiên bản mã. Kết luận tám test case giống hệt máy Mac: năm lỗi race chỉ sai khi đồng thời, một lỗi logic sai cả khi tuần tự, hai test case đúng. Hai lượt chạy đầu trên máy Windows không hợp lệ vì thiếu công cụ k6 và vì Cal.com dừng giữa chừng; nhóm đã loại và chỉ dùng lượt chạy sạch. Người chạy trên máy Windows là Ngô Quốc Trường Vĩ, máy MSI Core i7-13620H, RAM 16 GB.</a:t>
             </a:r>
             <a:endParaRPr lang="en-US" dirty="0"/>
           </a:p>
@@ -7724,7 +7724,7 @@
                 <a:ea typeface="Calibri" pitchFamily="34" charset="-122"/>
                 <a:cs typeface="Calibri" pitchFamily="34" charset="-120"/>
               </a:rPr>
-              <a:t>Còn thiếu</a:t>
+              <a:t>Máy Windows</a:t>
             </a:r>
             <a:endParaRPr lang="en-US" sz="2000" dirty="0"/>
           </a:p>
@@ -7763,7 +7763,7 @@
                 <a:ea typeface="Calibri" pitchFamily="34" charset="-122"/>
                 <a:cs typeface="Calibri" pitchFamily="34" charset="-120"/>
               </a:rPr>
-              <a:t>Cấu hình máy Windows và tên người test cần ghi vào báo cáo.</a:t>
+              <a:t>Người test: Ngô Quốc Trường Vĩ. Máy MSI, Core i7-13620H, RAM 16 GB.</a:t>
             </a:r>
             <a:endParaRPr lang="en-US" sz="1500" dirty="0"/>
           </a:p>
@@ -9791,7 +9791,7 @@
                 <a:ea typeface="Calibri" pitchFamily="34" charset="-122"/>
                 <a:cs typeface="Calibri" pitchFamily="34" charset="-120"/>
               </a:rPr>
-              <a:t>Thêm scenario Playwright qua giao diện, bổ sung cấu hình máy Windows và tên người test vào báo cáo</a:t>
+              <a:t>Thêm scenario Playwright qua giao diện, hoàn thiện báo cáo</a:t>
             </a:r>
             <a:endParaRPr lang="en-US" sz="1600" dirty="0"/>
           </a:p>

</xml_diff>

<commit_message>
docs: replace blank person-hours with a labelled workload estimate
The team did not track hours, so the cost section now gives an explicit
estimate (34-46 person-hours) per work item and says it is not measured.

Co-Authored-By: Claude Sonnet 5.5 <noreply@anthropic.com>
</commit_message>
<xml_diff>
--- a/docs/BAO_CAO_GIUA_KY_R05-K15.pptx
+++ b/docs/BAO_CAO_GIUA_KY_R05-K15.pptx
@@ -119,18 +119,18 @@
   <p:extLst>
     <p:ext uri="{521415D9-36F7-43E2-AB2F-B90AF26B5E84}">
       <p14:sectionLst xmlns:p14="http://schemas.microsoft.com/office/powerpoint/2010/main">
-        <p14:section name="Mở đầu" id="{c6bc6c98-a9dd-87ed-1f54-39f8be356a4b}">
+        <p14:section name="Mở đầu" id="{945407b1-9eac-1a4b-d5d2-5ab94967c7e9}">
           <p14:sldIdLst>
             <p14:sldId id="256"/>
             <p14:sldId id="257"/>
           </p14:sldIdLst>
         </p14:section>
-        <p14:section name="Tiến độ" id="{5d4a2a0e-4f30-95d6-19cb-1eab49d49bc8}">
+        <p14:section name="Tiến độ" id="{30cf0148-379b-f817-3f19-ff333d77c811}">
           <p14:sldIdLst>
             <p14:sldId id="258"/>
           </p14:sldIdLst>
         </p14:section>
-        <p14:section name="Hệ thống và kiểm thử" id="{227a61ef-3fea-eb11-fd0d-6a9085c857c9}">
+        <p14:section name="Hệ thống và kiểm thử" id="{4adbe4a8-d245-9b64-dd37-25928bf6e02c}">
           <p14:sldIdLst>
             <p14:sldId id="259"/>
             <p14:sldId id="260"/>
@@ -138,20 +138,20 @@
             <p14:sldId id="262"/>
           </p14:sldIdLst>
         </p14:section>
-        <p14:section name="Kế hoạch kiểm thử" id="{a9f192d7-d36e-1cd3-dade-c5da9d34da52}">
+        <p14:section name="Kế hoạch kiểm thử" id="{b6986a6b-1797-33de-2e97-483319301c2f}">
           <p14:sldIdLst>
             <p14:sldId id="263"/>
             <p14:sldId id="264"/>
           </p14:sldIdLst>
         </p14:section>
-        <p14:section name="Kết quả sơ bộ" id="{2a00fac9-ff1d-1fd9-e7c1-d25b564c9470}">
+        <p14:section name="Kết quả sơ bộ" id="{18feb182-1847-f1fb-a1f4-73604e3c62da}">
           <p14:sldIdLst>
             <p14:sldId id="265"/>
             <p14:sldId id="266"/>
             <p14:sldId id="267"/>
           </p14:sldIdLst>
         </p14:section>
-        <p14:section name="Tiếp theo" id="{f456f873-3d5b-4706-e427-cb3c8bdf425c}">
+        <p14:section name="Tiếp theo" id="{2f7bbc96-ff83-9554-141d-25310a98ffad}">
           <p14:sldIdLst>
             <p14:sldId id="268"/>
           </p14:sldIdLst>
@@ -1616,7 +1616,7 @@
           <a:p>
             <a:r>
               <a:rPr lang="en-US" dirty="0"/>
-              <a:t>Số liệu chi phí máy đo thật từ thời điểm bắt đầu và kết thúc trong file summary.json của mỗi lần chạy. Chạy lại bộ test chính cả đồng thời và tuần tự mất dưới ba phút. Phần công sức người-giờ nhóm tự điền theo thực tế.</a:t>
+              <a:t>Số liệu chi phí máy đo thật từ thời điểm bắt đầu và kết thúc trong file summary.json của mỗi lần chạy. Chạy lại bộ test chính cả đồng thời và tuần tự mất dưới ba phút. Công sức nhân lực là ước lượng khoảng 34 đến 46 người-giờ, nhóm chưa theo dõi giờ thực tế từng người.</a:t>
             </a:r>
             <a:endParaRPr lang="en-US" dirty="0"/>
           </a:p>
@@ -23935,7 +23935,7 @@
                 <a:ea typeface="Calibri" pitchFamily="34" charset="-122"/>
                 <a:cs typeface="Calibri" pitchFamily="34" charset="-120"/>
               </a:rPr>
-              <a:t>Công sức nhóm (người-giờ): [nhóm điền số giờ thực tế của từng thành viên]. Máy: MacBook Apple Silicon 10 nhân, 32 GB RAM.</a:t>
+              <a:t>Công sức nhóm: ước lượng 34–46 người-giờ (chưa theo dõi giờ thực tế). Máy: MacBook Apple Silicon 10 nhân, 32 GB RAM.</a:t>
             </a:r>
             <a:endParaRPr lang="en-US" sz="1400" dirty="0"/>
           </a:p>

</xml_diff>

<commit_message>
docs: rewrite the midterm report in the department thesis template and export PDFs
The lecturer's latest email asks for a PDF report following the A-H structure,
a PDF slide deck, a feasibility argument for the test plan and per-member
contributions.

- docs/BAO_CAO_GIUA_KY_THEO_MAU.docx/.pdf: 47 pages in the thesis template
  (cover, comments page, thanks, TOC, figure/table lists, intro, 4 chapters,
  conclusion, references, appendix) with a table mapping parts A-H to sections,
  a feasibility section and a members' contributions table
- docs/figures + tools/make-figures.py: diagrams and charts generated from real results
- docs/BAO_CAO_GIUA_KY_R05-K15.pptx + _SLIDE.pdf: deck now 14 slides (adds contributions)
- docs/SLIDE_1_TRANG_TRINH_BAY_LOP.pptx/.pdf: one-slide summary for the class presentation
- tools/export-report.sh, postprocess-docx.py: rebuild docx and export PDF via Word

Co-Authored-By: Claude Sonnet 5.5 <noreply@anthropic.com>
</commit_message>
<xml_diff>
--- a/docs/BAO_CAO_GIUA_KY_R05-K15.pptx
+++ b/docs/BAO_CAO_GIUA_KY_R05-K15.pptx
@@ -18,9 +18,10 @@
     <p:sldId id="266" r:id="rId12"/>
     <p:sldId id="267" r:id="rId13"/>
     <p:sldId id="268" r:id="rId14"/>
+    <p:sldId id="269" r:id="rId15"/>
   </p:sldIdLst>
   <p:notesMasterIdLst>
-    <p:notesMasterId r:id="rId15"/>
+    <p:notesMasterId r:id="rId16"/>
   </p:notesMasterIdLst>
   <p:sldSz cx="12192000" cy="6858000"/>
   <p:notesSz cx="6858000" cy="12192000"/>
@@ -119,18 +120,18 @@
   <p:extLst>
     <p:ext uri="{521415D9-36F7-43E2-AB2F-B90AF26B5E84}">
       <p14:sectionLst xmlns:p14="http://schemas.microsoft.com/office/powerpoint/2010/main">
-        <p14:section name="Mở đầu" id="{945407b1-9eac-1a4b-d5d2-5ab94967c7e9}">
+        <p14:section name="Mở đầu" id="{e3ac7673-3648-5bfd-f0e8-accd34a59645}">
           <p14:sldIdLst>
             <p14:sldId id="256"/>
             <p14:sldId id="257"/>
           </p14:sldIdLst>
         </p14:section>
-        <p14:section name="Tiến độ" id="{30cf0148-379b-f817-3f19-ff333d77c811}">
+        <p14:section name="Tiến độ" id="{6ac773ea-cba5-c446-5a24-adfef4912c26}">
           <p14:sldIdLst>
             <p14:sldId id="258"/>
           </p14:sldIdLst>
         </p14:section>
-        <p14:section name="Hệ thống và kiểm thử" id="{4adbe4a8-d245-9b64-dd37-25928bf6e02c}">
+        <p14:section name="Hệ thống và kiểm thử" id="{75eb1a7a-25fc-1f14-27db-0da681e8b984}">
           <p14:sldIdLst>
             <p14:sldId id="259"/>
             <p14:sldId id="260"/>
@@ -138,22 +139,23 @@
             <p14:sldId id="262"/>
           </p14:sldIdLst>
         </p14:section>
-        <p14:section name="Kế hoạch kiểm thử" id="{b6986a6b-1797-33de-2e97-483319301c2f}">
+        <p14:section name="Kế hoạch kiểm thử" id="{165856e3-3d75-024d-70b5-d53d924e5f6d}">
           <p14:sldIdLst>
             <p14:sldId id="263"/>
             <p14:sldId id="264"/>
           </p14:sldIdLst>
         </p14:section>
-        <p14:section name="Kết quả sơ bộ" id="{18feb182-1847-f1fb-a1f4-73604e3c62da}">
+        <p14:section name="Kết quả sơ bộ" id="{60faa17d-b5c9-4d07-d7a6-cf127c16c49a}">
           <p14:sldIdLst>
             <p14:sldId id="265"/>
             <p14:sldId id="266"/>
             <p14:sldId id="267"/>
+            <p14:sldId id="268"/>
           </p14:sldIdLst>
         </p14:section>
-        <p14:section name="Tiếp theo" id="{2f7bbc96-ff83-9554-141d-25310a98ffad}">
+        <p14:section name="Tiếp theo" id="{c436ed9c-7370-e18c-47cb-0241eb07d67d}">
           <p14:sldIdLst>
-            <p14:sldId id="268"/>
+            <p14:sldId id="269"/>
           </p14:sldIdLst>
         </p14:section>
       </p14:sectionLst>
@@ -912,6 +914,94 @@
           <a:p>
             <a:r>
               <a:rPr lang="en-US" dirty="0"/>
+              <a:t>Mỗi thành viên có vai trò và nhiệm vụ riêng, theo phân công của nhóm. Công việc được theo dõi trên bảng GitHub Projects; việc gán người cho từng thẻ và lịch sử commit đều các thành viên sẽ được hoàn thiện trước buổi bảo vệ.</a:t>
+            </a:r>
+            <a:endParaRPr lang="en-US" dirty="0"/>
+          </a:p>
+        </p:txBody>
+      </p:sp>
+      <p:sp>
+        <p:nvSpPr>
+          <p:cNvPr id="4" name="Slide Number Placeholder 3"/>
+          <p:cNvSpPr>
+            <a:spLocks noGrp="1"/>
+          </p:cNvSpPr>
+          <p:nvPr>
+            <p:ph type="sldNum" sz="quarter" idx="10"/>
+          </p:nvPr>
+        </p:nvSpPr>
+        <p:spPr/>
+        <p:txBody>
+          <a:bodyPr/>
+          <a:lstStyle/>
+          <a:p>
+            <a:fld id="{F7021451-1387-4CA6-816F-3879F97B5CBC}" type="slidenum">
+              <a:rPr lang="en-US"/>
+              <a:t>13</a:t>
+            </a:fld>
+            <a:endParaRPr lang="en-US"/>
+          </a:p>
+        </p:txBody>
+      </p:sp>
+    </p:spTree>
+    <p:extLst>
+      <p:ext uri="{BB962C8B-B14F-4D97-AF65-F5344CB8AC3E}">
+        <p14:creationId xmlns:p14="http://schemas.microsoft.com/office/powerpoint/2010/main" val="1024086991"/>
+      </p:ext>
+    </p:extLst>
+  </p:cSld>
+  <p:clrMapOvr>
+    <a:masterClrMapping/>
+  </p:clrMapOvr>
+</p:notes>
+</file>
+
+<file path=ppt/notesSlides/notesSlide14.xml><?xml version="1.0" encoding="utf-8"?>
+<p:notes xmlns:a="http://schemas.openxmlformats.org/drawingml/2006/main" xmlns:r="http://schemas.openxmlformats.org/officeDocument/2006/relationships" xmlns:p="http://schemas.openxmlformats.org/presentationml/2006/main">
+  <p:cSld>
+    <p:spTree>
+      <p:nvGrpSpPr>
+        <p:cNvPr id="1" name=""/>
+        <p:cNvGrpSpPr/>
+        <p:nvPr/>
+      </p:nvGrpSpPr>
+      <p:grpSpPr>
+        <a:xfrm>
+          <a:off x="0" y="0"/>
+          <a:ext cx="0" cy="0"/>
+          <a:chOff x="0" y="0"/>
+          <a:chExt cx="0" cy="0"/>
+        </a:xfrm>
+      </p:grpSpPr>
+      <p:sp>
+        <p:nvSpPr>
+          <p:cNvPr id="2" name="Slide Image Placeholder 1"/>
+          <p:cNvSpPr>
+            <a:spLocks noGrp="1" noRot="1" noChangeAspect="1"/>
+          </p:cNvSpPr>
+          <p:nvPr>
+            <p:ph type="sldImg"/>
+          </p:nvPr>
+        </p:nvSpPr>
+        <p:spPr/>
+      </p:sp>
+      <p:sp>
+        <p:nvSpPr>
+          <p:cNvPr id="3" name="Notes Placeholder 2"/>
+          <p:cNvSpPr>
+            <a:spLocks noGrp="1"/>
+          </p:cNvSpPr>
+          <p:nvPr>
+            <p:ph type="body" idx="1"/>
+          </p:nvPr>
+        </p:nvSpPr>
+        <p:spPr/>
+        <p:txBody>
+          <a:bodyPr/>
+          <a:lstStyle/>
+          <a:p>
+            <a:r>
+              <a:rPr lang="en-US" dirty="0"/>
               <a:t>Kế hoạch bốn giai đoạn đến bảo vệ; phần kiểm thử chính đã chạy xong nên thời gian còn lại dành cho kiểm chứng lại, hoàn thiện báo cáo và chuẩn bị bảo vệ. Rủi ro chính là race không tái hiện ổn định nên nhóm chạy nhiều vòng và báo tỉ lệ. Kết thúc phần báo cáo, mời thầy đặt câu hỏi.</a:t>
             </a:r>
             <a:endParaRPr lang="en-US" dirty="0"/>
@@ -935,7 +1025,7 @@
           <a:p>
             <a:fld id="{F7021451-1387-4CA6-816F-3879F97B5CBC}" type="slidenum">
               <a:rPr lang="en-US"/>
-              <a:t>13</a:t>
+              <a:t>14</a:t>
             </a:fld>
             <a:endParaRPr lang="en-US"/>
           </a:p>
@@ -7462,12 +7552,12 @@
         </p:nvSpPr>
         <p:spPr>
           <a:xfrm>
-            <a:off x="640080" y="3657600"/>
-            <a:ext cx="3422904" cy="2011680"/>
+            <a:off x="640080" y="4023360"/>
+            <a:ext cx="3422904" cy="1828800"/>
           </a:xfrm>
           <a:prstGeom prst="roundRect">
             <a:avLst>
-              <a:gd name="adj" fmla="val 5455"/>
+              <a:gd name="adj" fmla="val 6000"/>
             </a:avLst>
           </a:prstGeom>
           <a:solidFill>
@@ -7489,7 +7579,7 @@
         </p:nvSpPr>
         <p:spPr>
           <a:xfrm>
-            <a:off x="914400" y="3840480"/>
+            <a:off x="914400" y="4206240"/>
             <a:ext cx="2874264" cy="457200"/>
           </a:xfrm>
           <a:prstGeom prst="rect">
@@ -7528,8 +7618,8 @@
         </p:nvSpPr>
         <p:spPr>
           <a:xfrm>
-            <a:off x="914400" y="4389120"/>
-            <a:ext cx="2874264" cy="1188720"/>
+            <a:off x="914400" y="4754880"/>
+            <a:ext cx="2874264" cy="1005840"/>
           </a:xfrm>
           <a:prstGeom prst="rect">
             <a:avLst/>
@@ -7567,12 +7657,12 @@
         </p:nvSpPr>
         <p:spPr>
           <a:xfrm>
-            <a:off x="4383024" y="3657600"/>
-            <a:ext cx="3422904" cy="2011680"/>
+            <a:off x="4383024" y="4023360"/>
+            <a:ext cx="3422904" cy="1828800"/>
           </a:xfrm>
           <a:prstGeom prst="roundRect">
             <a:avLst>
-              <a:gd name="adj" fmla="val 5455"/>
+              <a:gd name="adj" fmla="val 6000"/>
             </a:avLst>
           </a:prstGeom>
           <a:solidFill>
@@ -7594,7 +7684,7 @@
         </p:nvSpPr>
         <p:spPr>
           <a:xfrm>
-            <a:off x="4657344" y="3840480"/>
+            <a:off x="4657344" y="4206240"/>
             <a:ext cx="2874264" cy="457200"/>
           </a:xfrm>
           <a:prstGeom prst="rect">
@@ -7633,8 +7723,8 @@
         </p:nvSpPr>
         <p:spPr>
           <a:xfrm>
-            <a:off x="4657344" y="4389120"/>
-            <a:ext cx="2874264" cy="1188720"/>
+            <a:off x="4657344" y="4754880"/>
+            <a:ext cx="2874264" cy="1005840"/>
           </a:xfrm>
           <a:prstGeom prst="rect">
             <a:avLst/>
@@ -7672,12 +7762,12 @@
         </p:nvSpPr>
         <p:spPr>
           <a:xfrm>
-            <a:off x="8125968" y="3657600"/>
-            <a:ext cx="3422904" cy="2011680"/>
+            <a:off x="8125968" y="4023360"/>
+            <a:ext cx="3422904" cy="1828800"/>
           </a:xfrm>
           <a:prstGeom prst="roundRect">
             <a:avLst>
-              <a:gd name="adj" fmla="val 5455"/>
+              <a:gd name="adj" fmla="val 6000"/>
             </a:avLst>
           </a:prstGeom>
           <a:solidFill>
@@ -7699,7 +7789,7 @@
         </p:nvSpPr>
         <p:spPr>
           <a:xfrm>
-            <a:off x="8400288" y="3840480"/>
+            <a:off x="8400288" y="4206240"/>
             <a:ext cx="2874264" cy="457200"/>
           </a:xfrm>
           <a:prstGeom prst="rect">
@@ -7738,8 +7828,8 @@
         </p:nvSpPr>
         <p:spPr>
           <a:xfrm>
-            <a:off x="8400288" y="4389120"/>
-            <a:ext cx="2874264" cy="1188720"/>
+            <a:off x="8400288" y="4754880"/>
+            <a:ext cx="2874264" cy="1005840"/>
           </a:xfrm>
           <a:prstGeom prst="rect">
             <a:avLst/>
@@ -9612,13 +9702,1646 @@
             <a:r>
               <a:rPr lang="en-US" sz="1300" b="1" spc="200" kern="0" dirty="0">
                 <a:solidFill>
+                  <a:srgbClr val="B4531A"/>
+                </a:solidFill>
+                <a:latin typeface="Consolas" pitchFamily="34" charset="0"/>
+                <a:ea typeface="Consolas" pitchFamily="34" charset="-122"/>
+                <a:cs typeface="Consolas" pitchFamily="34" charset="-120"/>
+              </a:rPr>
+              <a:t>12 · NHIỆM VỤ VÀ ĐÓNG GÓP</a:t>
+            </a:r>
+            <a:endParaRPr lang="en-US" sz="1300" dirty="0"/>
+          </a:p>
+        </p:txBody>
+      </p:sp>
+      <p:sp>
+        <p:nvSpPr>
+          <p:cNvPr id="3" name="Text 0"/>
+          <p:cNvSpPr/>
+          <p:nvPr>
+            <p:ph idx="100" type="title" hasCustomPrompt="1"/>
+          </p:nvPr>
+        </p:nvSpPr>
+        <p:spPr>
+          <a:xfrm>
+            <a:off x="640080" y="640080"/>
+            <a:ext cx="10908792" cy="868680"/>
+          </a:xfrm>
+          <a:prstGeom prst="rect">
+            <a:avLst/>
+          </a:prstGeom>
+          <a:noFill/>
+          <a:ln/>
+        </p:spPr>
+        <p:txBody>
+          <a:bodyPr wrap="square" lIns="0" tIns="0" rIns="0" bIns="0" rtlCol="0" anchor="t"/>
+          <a:lstStyle/>
+          <a:p>
+            <a:pPr indent="0" marL="0">
+              <a:buNone/>
+            </a:pPr>
+            <a:r>
+              <a:rPr lang="en-US" sz="3400" b="1" dirty="0">
+                <a:solidFill>
+                  <a:srgbClr val="12202B"/>
+                </a:solidFill>
+                <a:latin typeface="Calibri" pitchFamily="34" charset="0"/>
+                <a:ea typeface="Calibri" pitchFamily="34" charset="-122"/>
+                <a:cs typeface="Calibri" pitchFamily="34" charset="-120"/>
+              </a:rPr>
+              <a:t>Nhiệm vụ và đóng góp của từng thành viên</a:t>
+            </a:r>
+            <a:endParaRPr lang="en-US" sz="3400" dirty="0"/>
+          </a:p>
+        </p:txBody>
+      </p:sp>
+      <p:graphicFrame>
+        <p:nvGraphicFramePr>
+          <p:cNvPr id="14" name="Table 0"/>
+          <p:cNvGraphicFramePr>
+            <a:graphicFrameLocks noGrp="1"/>
+          </p:cNvGraphicFramePr>
+          <p:nvPr>
+            <p:extLst>
+              <p:ext uri="{D42A27DB-BD31-4B8C-83A1-F6EECF244321}">
+                <p14:modId xmlns:p14="http://schemas.microsoft.com/office/powerpoint/2010/main" val="1579011935"/>
+              </p:ext>
+            </p:extLst>
+          </p:nvPr>
+        </p:nvGraphicFramePr>
+        <p:xfrm>
+          <a:off x="640080" y="1691640"/>
+          <a:ext cx="10908792" cy="914400"/>
+        </p:xfrm>
+        <a:graphic>
+          <a:graphicData uri="http://schemas.openxmlformats.org/drawingml/2006/table">
+            <a:tbl>
+              <a:tblPr/>
+              <a:tblGrid>
+                <a:gridCol w="2834640"/>
+                <a:gridCol w="1920240"/>
+                <a:gridCol w="4206240"/>
+                <a:gridCol w="1947672"/>
+              </a:tblGrid>
+              <a:tr h="685800">
+                <a:tc>
+                  <a:txBody>
+                    <a:bodyPr/>
+                    <a:lstStyle/>
+                    <a:p>
+                      <a:pPr indent="0" marL="0">
+                        <a:buNone/>
+                      </a:pPr>
+                      <a:r>
+                        <a:rPr lang="en-US" sz="1400" b="1" dirty="0">
+                          <a:solidFill>
+                            <a:srgbClr val="12202B"/>
+                          </a:solidFill>
+                          <a:latin typeface="Calibri" pitchFamily="34" charset="0"/>
+                          <a:ea typeface="Calibri" pitchFamily="34" charset="-122"/>
+                          <a:cs typeface="Calibri" pitchFamily="34" charset="-120"/>
+                        </a:rPr>
+                        <a:t>Thành viên</a:t>
+                      </a:r>
+                      <a:endParaRPr lang="en-US" sz="1400" dirty="0">
+                        <a:latin typeface="Calibri" charset="0"/>
+                        <a:ea typeface="Calibri" charset="0"/>
+                        <a:cs typeface="Calibri" charset="0"/>
+                      </a:endParaRPr>
+                    </a:p>
+                  </a:txBody>
+                  <a:tcPr marL="91440" marR="91440" marT="36576" marB="36576" anchor="ctr">
+                    <a:lnL w="9525" cap="flat" cmpd="sng" algn="ctr">
+                      <a:solidFill>
+                        <a:srgbClr val="DAD6CC"/>
+                      </a:solidFill>
+                      <a:prstDash val="solid"/>
+                      <a:round/>
+                      <a:headEnd type="none" w="med" len="med"/>
+                      <a:tailEnd type="none" w="med" len="med"/>
+                    </a:lnL>
+                    <a:lnR w="9525" cap="flat" cmpd="sng" algn="ctr">
+                      <a:solidFill>
+                        <a:srgbClr val="DAD6CC"/>
+                      </a:solidFill>
+                      <a:prstDash val="solid"/>
+                      <a:round/>
+                      <a:headEnd type="none" w="med" len="med"/>
+                      <a:tailEnd type="none" w="med" len="med"/>
+                    </a:lnR>
+                    <a:lnT w="9525" cap="flat" cmpd="sng" algn="ctr">
+                      <a:solidFill>
+                        <a:srgbClr val="DAD6CC"/>
+                      </a:solidFill>
+                      <a:prstDash val="solid"/>
+                      <a:round/>
+                      <a:headEnd type="none" w="med" len="med"/>
+                      <a:tailEnd type="none" w="med" len="med"/>
+                    </a:lnT>
+                    <a:lnB w="9525" cap="flat" cmpd="sng" algn="ctr">
+                      <a:solidFill>
+                        <a:srgbClr val="DAD6CC"/>
+                      </a:solidFill>
+                      <a:prstDash val="solid"/>
+                      <a:round/>
+                      <a:headEnd type="none" w="med" len="med"/>
+                      <a:tailEnd type="none" w="med" len="med"/>
+                    </a:lnB>
+                    <a:solidFill>
+                      <a:srgbClr val="E6E2D6"/>
+                    </a:solidFill>
+                  </a:tcPr>
+                </a:tc>
+                <a:tc>
+                  <a:txBody>
+                    <a:bodyPr/>
+                    <a:lstStyle/>
+                    <a:p>
+                      <a:pPr indent="0" marL="0">
+                        <a:buNone/>
+                      </a:pPr>
+                      <a:r>
+                        <a:rPr lang="en-US" sz="1400" b="1" dirty="0">
+                          <a:solidFill>
+                            <a:srgbClr val="12202B"/>
+                          </a:solidFill>
+                          <a:latin typeface="Calibri" pitchFamily="34" charset="0"/>
+                          <a:ea typeface="Calibri" pitchFamily="34" charset="-122"/>
+                          <a:cs typeface="Calibri" pitchFamily="34" charset="-120"/>
+                        </a:rPr>
+                        <a:t>Vai trò</a:t>
+                      </a:r>
+                      <a:endParaRPr lang="en-US" sz="1400" dirty="0">
+                        <a:latin typeface="Calibri" charset="0"/>
+                        <a:ea typeface="Calibri" charset="0"/>
+                        <a:cs typeface="Calibri" charset="0"/>
+                      </a:endParaRPr>
+                    </a:p>
+                  </a:txBody>
+                  <a:tcPr marL="91440" marR="91440" marT="36576" marB="36576" anchor="ctr">
+                    <a:lnL w="9525" cap="flat" cmpd="sng" algn="ctr">
+                      <a:solidFill>
+                        <a:srgbClr val="DAD6CC"/>
+                      </a:solidFill>
+                      <a:prstDash val="solid"/>
+                      <a:round/>
+                      <a:headEnd type="none" w="med" len="med"/>
+                      <a:tailEnd type="none" w="med" len="med"/>
+                    </a:lnL>
+                    <a:lnR w="9525" cap="flat" cmpd="sng" algn="ctr">
+                      <a:solidFill>
+                        <a:srgbClr val="DAD6CC"/>
+                      </a:solidFill>
+                      <a:prstDash val="solid"/>
+                      <a:round/>
+                      <a:headEnd type="none" w="med" len="med"/>
+                      <a:tailEnd type="none" w="med" len="med"/>
+                    </a:lnR>
+                    <a:lnT w="9525" cap="flat" cmpd="sng" algn="ctr">
+                      <a:solidFill>
+                        <a:srgbClr val="DAD6CC"/>
+                      </a:solidFill>
+                      <a:prstDash val="solid"/>
+                      <a:round/>
+                      <a:headEnd type="none" w="med" len="med"/>
+                      <a:tailEnd type="none" w="med" len="med"/>
+                    </a:lnT>
+                    <a:lnB w="9525" cap="flat" cmpd="sng" algn="ctr">
+                      <a:solidFill>
+                        <a:srgbClr val="DAD6CC"/>
+                      </a:solidFill>
+                      <a:prstDash val="solid"/>
+                      <a:round/>
+                      <a:headEnd type="none" w="med" len="med"/>
+                      <a:tailEnd type="none" w="med" len="med"/>
+                    </a:lnB>
+                    <a:solidFill>
+                      <a:srgbClr val="E6E2D6"/>
+                    </a:solidFill>
+                  </a:tcPr>
+                </a:tc>
+                <a:tc>
+                  <a:txBody>
+                    <a:bodyPr/>
+                    <a:lstStyle/>
+                    <a:p>
+                      <a:pPr indent="0" marL="0">
+                        <a:buNone/>
+                      </a:pPr>
+                      <a:r>
+                        <a:rPr lang="en-US" sz="1400" b="1" dirty="0">
+                          <a:solidFill>
+                            <a:srgbClr val="12202B"/>
+                          </a:solidFill>
+                          <a:latin typeface="Calibri" pitchFamily="34" charset="0"/>
+                          <a:ea typeface="Calibri" pitchFamily="34" charset="-122"/>
+                          <a:cs typeface="Calibri" pitchFamily="34" charset="-120"/>
+                        </a:rPr>
+                        <a:t>Nhiệm vụ đã thực hiện</a:t>
+                      </a:r>
+                      <a:endParaRPr lang="en-US" sz="1400" dirty="0">
+                        <a:latin typeface="Calibri" charset="0"/>
+                        <a:ea typeface="Calibri" charset="0"/>
+                        <a:cs typeface="Calibri" charset="0"/>
+                      </a:endParaRPr>
+                    </a:p>
+                  </a:txBody>
+                  <a:tcPr marL="91440" marR="91440" marT="36576" marB="36576" anchor="ctr">
+                    <a:lnL w="9525" cap="flat" cmpd="sng" algn="ctr">
+                      <a:solidFill>
+                        <a:srgbClr val="DAD6CC"/>
+                      </a:solidFill>
+                      <a:prstDash val="solid"/>
+                      <a:round/>
+                      <a:headEnd type="none" w="med" len="med"/>
+                      <a:tailEnd type="none" w="med" len="med"/>
+                    </a:lnL>
+                    <a:lnR w="9525" cap="flat" cmpd="sng" algn="ctr">
+                      <a:solidFill>
+                        <a:srgbClr val="DAD6CC"/>
+                      </a:solidFill>
+                      <a:prstDash val="solid"/>
+                      <a:round/>
+                      <a:headEnd type="none" w="med" len="med"/>
+                      <a:tailEnd type="none" w="med" len="med"/>
+                    </a:lnR>
+                    <a:lnT w="9525" cap="flat" cmpd="sng" algn="ctr">
+                      <a:solidFill>
+                        <a:srgbClr val="DAD6CC"/>
+                      </a:solidFill>
+                      <a:prstDash val="solid"/>
+                      <a:round/>
+                      <a:headEnd type="none" w="med" len="med"/>
+                      <a:tailEnd type="none" w="med" len="med"/>
+                    </a:lnT>
+                    <a:lnB w="9525" cap="flat" cmpd="sng" algn="ctr">
+                      <a:solidFill>
+                        <a:srgbClr val="DAD6CC"/>
+                      </a:solidFill>
+                      <a:prstDash val="solid"/>
+                      <a:round/>
+                      <a:headEnd type="none" w="med" len="med"/>
+                      <a:tailEnd type="none" w="med" len="med"/>
+                    </a:lnB>
+                    <a:solidFill>
+                      <a:srgbClr val="E6E2D6"/>
+                    </a:solidFill>
+                  </a:tcPr>
+                </a:tc>
+                <a:tc>
+                  <a:txBody>
+                    <a:bodyPr/>
+                    <a:lstStyle/>
+                    <a:p>
+                      <a:pPr indent="0" marL="0">
+                        <a:buNone/>
+                      </a:pPr>
+                      <a:r>
+                        <a:rPr lang="en-US" sz="1400" b="1" dirty="0">
+                          <a:solidFill>
+                            <a:srgbClr val="12202B"/>
+                          </a:solidFill>
+                          <a:latin typeface="Calibri" pitchFamily="34" charset="0"/>
+                          <a:ea typeface="Calibri" pitchFamily="34" charset="-122"/>
+                          <a:cs typeface="Calibri" pitchFamily="34" charset="-120"/>
+                        </a:rPr>
+                        <a:t>Sản phẩm</a:t>
+                      </a:r>
+                      <a:endParaRPr lang="en-US" sz="1400" dirty="0">
+                        <a:latin typeface="Calibri" charset="0"/>
+                        <a:ea typeface="Calibri" charset="0"/>
+                        <a:cs typeface="Calibri" charset="0"/>
+                      </a:endParaRPr>
+                    </a:p>
+                  </a:txBody>
+                  <a:tcPr marL="91440" marR="91440" marT="36576" marB="36576" anchor="ctr">
+                    <a:lnL w="9525" cap="flat" cmpd="sng" algn="ctr">
+                      <a:solidFill>
+                        <a:srgbClr val="DAD6CC"/>
+                      </a:solidFill>
+                      <a:prstDash val="solid"/>
+                      <a:round/>
+                      <a:headEnd type="none" w="med" len="med"/>
+                      <a:tailEnd type="none" w="med" len="med"/>
+                    </a:lnL>
+                    <a:lnR w="9525" cap="flat" cmpd="sng" algn="ctr">
+                      <a:solidFill>
+                        <a:srgbClr val="DAD6CC"/>
+                      </a:solidFill>
+                      <a:prstDash val="solid"/>
+                      <a:round/>
+                      <a:headEnd type="none" w="med" len="med"/>
+                      <a:tailEnd type="none" w="med" len="med"/>
+                    </a:lnR>
+                    <a:lnT w="9525" cap="flat" cmpd="sng" algn="ctr">
+                      <a:solidFill>
+                        <a:srgbClr val="DAD6CC"/>
+                      </a:solidFill>
+                      <a:prstDash val="solid"/>
+                      <a:round/>
+                      <a:headEnd type="none" w="med" len="med"/>
+                      <a:tailEnd type="none" w="med" len="med"/>
+                    </a:lnT>
+                    <a:lnB w="9525" cap="flat" cmpd="sng" algn="ctr">
+                      <a:solidFill>
+                        <a:srgbClr val="DAD6CC"/>
+                      </a:solidFill>
+                      <a:prstDash val="solid"/>
+                      <a:round/>
+                      <a:headEnd type="none" w="med" len="med"/>
+                      <a:tailEnd type="none" w="med" len="med"/>
+                    </a:lnB>
+                    <a:solidFill>
+                      <a:srgbClr val="E6E2D6"/>
+                    </a:solidFill>
+                  </a:tcPr>
+                </a:tc>
+              </a:tr>
+              <a:tr h="685800">
+                <a:tc>
+                  <a:txBody>
+                    <a:bodyPr/>
+                    <a:lstStyle/>
+                    <a:p>
+                      <a:pPr indent="0" marL="0">
+                        <a:buNone/>
+                      </a:pPr>
+                      <a:r>
+                        <a:rPr lang="en-US" sz="1400" dirty="0">
+                          <a:solidFill>
+                            <a:srgbClr val="12202B"/>
+                          </a:solidFill>
+                          <a:latin typeface="Calibri" pitchFamily="34" charset="0"/>
+                          <a:ea typeface="Calibri" pitchFamily="34" charset="-122"/>
+                          <a:cs typeface="Calibri" pitchFamily="34" charset="-120"/>
+                        </a:rPr>
+                        <a:t>Nguyễn Thanh Tâm · 2312741</a:t>
+                      </a:r>
+                      <a:endParaRPr lang="en-US" sz="1400" dirty="0">
+                        <a:latin typeface="Calibri" charset="0"/>
+                        <a:ea typeface="Calibri" charset="0"/>
+                        <a:cs typeface="Calibri" charset="0"/>
+                      </a:endParaRPr>
+                    </a:p>
+                  </a:txBody>
+                  <a:tcPr marL="91440" marR="91440" marT="36576" marB="36576" anchor="ctr">
+                    <a:lnL w="9525" cap="flat" cmpd="sng" algn="ctr">
+                      <a:solidFill>
+                        <a:srgbClr val="DAD6CC"/>
+                      </a:solidFill>
+                      <a:prstDash val="solid"/>
+                      <a:round/>
+                      <a:headEnd type="none" w="med" len="med"/>
+                      <a:tailEnd type="none" w="med" len="med"/>
+                    </a:lnL>
+                    <a:lnR w="9525" cap="flat" cmpd="sng" algn="ctr">
+                      <a:solidFill>
+                        <a:srgbClr val="DAD6CC"/>
+                      </a:solidFill>
+                      <a:prstDash val="solid"/>
+                      <a:round/>
+                      <a:headEnd type="none" w="med" len="med"/>
+                      <a:tailEnd type="none" w="med" len="med"/>
+                    </a:lnR>
+                    <a:lnT w="9525" cap="flat" cmpd="sng" algn="ctr">
+                      <a:solidFill>
+                        <a:srgbClr val="DAD6CC"/>
+                      </a:solidFill>
+                      <a:prstDash val="solid"/>
+                      <a:round/>
+                      <a:headEnd type="none" w="med" len="med"/>
+                      <a:tailEnd type="none" w="med" len="med"/>
+                    </a:lnT>
+                    <a:lnB w="9525" cap="flat" cmpd="sng" algn="ctr">
+                      <a:solidFill>
+                        <a:srgbClr val="DAD6CC"/>
+                      </a:solidFill>
+                      <a:prstDash val="solid"/>
+                      <a:round/>
+                      <a:headEnd type="none" w="med" len="med"/>
+                      <a:tailEnd type="none" w="med" len="med"/>
+                    </a:lnB>
+                    <a:solidFill>
+                      <a:srgbClr val="FFFFFF"/>
+                    </a:solidFill>
+                  </a:tcPr>
+                </a:tc>
+                <a:tc>
+                  <a:txBody>
+                    <a:bodyPr/>
+                    <a:lstStyle/>
+                    <a:p>
+                      <a:pPr indent="0" marL="0">
+                        <a:buNone/>
+                      </a:pPr>
+                      <a:r>
+                        <a:rPr lang="en-US" sz="1400" dirty="0">
+                          <a:solidFill>
+                            <a:srgbClr val="12202B"/>
+                          </a:solidFill>
+                          <a:latin typeface="Calibri" pitchFamily="34" charset="0"/>
+                          <a:ea typeface="Calibri" pitchFamily="34" charset="-122"/>
+                          <a:cs typeface="Calibri" pitchFamily="34" charset="-120"/>
+                        </a:rPr>
+                        <a:t>Môi trường, DevOps</a:t>
+                      </a:r>
+                      <a:endParaRPr lang="en-US" sz="1400" dirty="0">
+                        <a:latin typeface="Calibri" charset="0"/>
+                        <a:ea typeface="Calibri" charset="0"/>
+                        <a:cs typeface="Calibri" charset="0"/>
+                      </a:endParaRPr>
+                    </a:p>
+                  </a:txBody>
+                  <a:tcPr marL="91440" marR="91440" marT="36576" marB="36576" anchor="ctr">
+                    <a:lnL w="9525" cap="flat" cmpd="sng" algn="ctr">
+                      <a:solidFill>
+                        <a:srgbClr val="DAD6CC"/>
+                      </a:solidFill>
+                      <a:prstDash val="solid"/>
+                      <a:round/>
+                      <a:headEnd type="none" w="med" len="med"/>
+                      <a:tailEnd type="none" w="med" len="med"/>
+                    </a:lnL>
+                    <a:lnR w="9525" cap="flat" cmpd="sng" algn="ctr">
+                      <a:solidFill>
+                        <a:srgbClr val="DAD6CC"/>
+                      </a:solidFill>
+                      <a:prstDash val="solid"/>
+                      <a:round/>
+                      <a:headEnd type="none" w="med" len="med"/>
+                      <a:tailEnd type="none" w="med" len="med"/>
+                    </a:lnR>
+                    <a:lnT w="9525" cap="flat" cmpd="sng" algn="ctr">
+                      <a:solidFill>
+                        <a:srgbClr val="DAD6CC"/>
+                      </a:solidFill>
+                      <a:prstDash val="solid"/>
+                      <a:round/>
+                      <a:headEnd type="none" w="med" len="med"/>
+                      <a:tailEnd type="none" w="med" len="med"/>
+                    </a:lnT>
+                    <a:lnB w="9525" cap="flat" cmpd="sng" algn="ctr">
+                      <a:solidFill>
+                        <a:srgbClr val="DAD6CC"/>
+                      </a:solidFill>
+                      <a:prstDash val="solid"/>
+                      <a:round/>
+                      <a:headEnd type="none" w="med" len="med"/>
+                      <a:tailEnd type="none" w="med" len="med"/>
+                    </a:lnB>
+                    <a:solidFill>
+                      <a:srgbClr val="FFFFFF"/>
+                    </a:solidFill>
+                  </a:tcPr>
+                </a:tc>
+                <a:tc>
+                  <a:txBody>
+                    <a:bodyPr/>
+                    <a:lstStyle/>
+                    <a:p>
+                      <a:pPr indent="0" marL="0">
+                        <a:buNone/>
+                      </a:pPr>
+                      <a:r>
+                        <a:rPr lang="en-US" sz="1400" dirty="0">
+                          <a:solidFill>
+                            <a:srgbClr val="12202B"/>
+                          </a:solidFill>
+                          <a:latin typeface="Calibri" pitchFamily="34" charset="0"/>
+                          <a:ea typeface="Calibri" pitchFamily="34" charset="-122"/>
+                          <a:cs typeface="Calibri" pitchFamily="34" charset="-120"/>
+                        </a:rPr>
+                        <a:t>Dựng Cal.com, CSDL, seed data; ghim phiên bản; chạy test trên macOS</a:t>
+                      </a:r>
+                      <a:endParaRPr lang="en-US" sz="1400" dirty="0">
+                        <a:latin typeface="Calibri" charset="0"/>
+                        <a:ea typeface="Calibri" charset="0"/>
+                        <a:cs typeface="Calibri" charset="0"/>
+                      </a:endParaRPr>
+                    </a:p>
+                  </a:txBody>
+                  <a:tcPr marL="91440" marR="91440" marT="36576" marB="36576" anchor="ctr">
+                    <a:lnL w="9525" cap="flat" cmpd="sng" algn="ctr">
+                      <a:solidFill>
+                        <a:srgbClr val="DAD6CC"/>
+                      </a:solidFill>
+                      <a:prstDash val="solid"/>
+                      <a:round/>
+                      <a:headEnd type="none" w="med" len="med"/>
+                      <a:tailEnd type="none" w="med" len="med"/>
+                    </a:lnL>
+                    <a:lnR w="9525" cap="flat" cmpd="sng" algn="ctr">
+                      <a:solidFill>
+                        <a:srgbClr val="DAD6CC"/>
+                      </a:solidFill>
+                      <a:prstDash val="solid"/>
+                      <a:round/>
+                      <a:headEnd type="none" w="med" len="med"/>
+                      <a:tailEnd type="none" w="med" len="med"/>
+                    </a:lnR>
+                    <a:lnT w="9525" cap="flat" cmpd="sng" algn="ctr">
+                      <a:solidFill>
+                        <a:srgbClr val="DAD6CC"/>
+                      </a:solidFill>
+                      <a:prstDash val="solid"/>
+                      <a:round/>
+                      <a:headEnd type="none" w="med" len="med"/>
+                      <a:tailEnd type="none" w="med" len="med"/>
+                    </a:lnT>
+                    <a:lnB w="9525" cap="flat" cmpd="sng" algn="ctr">
+                      <a:solidFill>
+                        <a:srgbClr val="DAD6CC"/>
+                      </a:solidFill>
+                      <a:prstDash val="solid"/>
+                      <a:round/>
+                      <a:headEnd type="none" w="med" len="med"/>
+                      <a:tailEnd type="none" w="med" len="med"/>
+                    </a:lnB>
+                    <a:solidFill>
+                      <a:srgbClr val="FFFFFF"/>
+                    </a:solidFill>
+                  </a:tcPr>
+                </a:tc>
+                <a:tc>
+                  <a:txBody>
+                    <a:bodyPr/>
+                    <a:lstStyle/>
+                    <a:p>
+                      <a:pPr indent="0" marL="0">
+                        <a:buNone/>
+                      </a:pPr>
+                      <a:r>
+                        <a:rPr lang="en-US" sz="1400" dirty="0">
+                          <a:solidFill>
+                            <a:srgbClr val="12202B"/>
+                          </a:solidFill>
+                          <a:latin typeface="Calibri" pitchFamily="34" charset="0"/>
+                          <a:ea typeface="Calibri" pitchFamily="34" charset="-122"/>
+                          <a:cs typeface="Calibri" pitchFamily="34" charset="-120"/>
+                        </a:rPr>
+                        <a:t>README, kết quả chạy chính thức</a:t>
+                      </a:r>
+                      <a:endParaRPr lang="en-US" sz="1400" dirty="0">
+                        <a:latin typeface="Calibri" charset="0"/>
+                        <a:ea typeface="Calibri" charset="0"/>
+                        <a:cs typeface="Calibri" charset="0"/>
+                      </a:endParaRPr>
+                    </a:p>
+                  </a:txBody>
+                  <a:tcPr marL="91440" marR="91440" marT="36576" marB="36576" anchor="ctr">
+                    <a:lnL w="9525" cap="flat" cmpd="sng" algn="ctr">
+                      <a:solidFill>
+                        <a:srgbClr val="DAD6CC"/>
+                      </a:solidFill>
+                      <a:prstDash val="solid"/>
+                      <a:round/>
+                      <a:headEnd type="none" w="med" len="med"/>
+                      <a:tailEnd type="none" w="med" len="med"/>
+                    </a:lnL>
+                    <a:lnR w="9525" cap="flat" cmpd="sng" algn="ctr">
+                      <a:solidFill>
+                        <a:srgbClr val="DAD6CC"/>
+                      </a:solidFill>
+                      <a:prstDash val="solid"/>
+                      <a:round/>
+                      <a:headEnd type="none" w="med" len="med"/>
+                      <a:tailEnd type="none" w="med" len="med"/>
+                    </a:lnR>
+                    <a:lnT w="9525" cap="flat" cmpd="sng" algn="ctr">
+                      <a:solidFill>
+                        <a:srgbClr val="DAD6CC"/>
+                      </a:solidFill>
+                      <a:prstDash val="solid"/>
+                      <a:round/>
+                      <a:headEnd type="none" w="med" len="med"/>
+                      <a:tailEnd type="none" w="med" len="med"/>
+                    </a:lnT>
+                    <a:lnB w="9525" cap="flat" cmpd="sng" algn="ctr">
+                      <a:solidFill>
+                        <a:srgbClr val="DAD6CC"/>
+                      </a:solidFill>
+                      <a:prstDash val="solid"/>
+                      <a:round/>
+                      <a:headEnd type="none" w="med" len="med"/>
+                      <a:tailEnd type="none" w="med" len="med"/>
+                    </a:lnB>
+                    <a:solidFill>
+                      <a:srgbClr val="FFFFFF"/>
+                    </a:solidFill>
+                  </a:tcPr>
+                </a:tc>
+              </a:tr>
+              <a:tr h="685800">
+                <a:tc>
+                  <a:txBody>
+                    <a:bodyPr/>
+                    <a:lstStyle/>
+                    <a:p>
+                      <a:pPr indent="0" marL="0">
+                        <a:buNone/>
+                      </a:pPr>
+                      <a:r>
+                        <a:rPr lang="en-US" sz="1400" dirty="0">
+                          <a:solidFill>
+                            <a:srgbClr val="12202B"/>
+                          </a:solidFill>
+                          <a:latin typeface="Calibri" pitchFamily="34" charset="0"/>
+                          <a:ea typeface="Calibri" pitchFamily="34" charset="-122"/>
+                          <a:cs typeface="Calibri" pitchFamily="34" charset="-120"/>
+                        </a:rPr>
+                        <a:t>Võ Công Vinh · 2312800</a:t>
+                      </a:r>
+                      <a:endParaRPr lang="en-US" sz="1400" dirty="0">
+                        <a:latin typeface="Calibri" charset="0"/>
+                        <a:ea typeface="Calibri" charset="0"/>
+                        <a:cs typeface="Calibri" charset="0"/>
+                      </a:endParaRPr>
+                    </a:p>
+                  </a:txBody>
+                  <a:tcPr marL="91440" marR="91440" marT="36576" marB="36576" anchor="ctr">
+                    <a:lnL w="9525" cap="flat" cmpd="sng" algn="ctr">
+                      <a:solidFill>
+                        <a:srgbClr val="DAD6CC"/>
+                      </a:solidFill>
+                      <a:prstDash val="solid"/>
+                      <a:round/>
+                      <a:headEnd type="none" w="med" len="med"/>
+                      <a:tailEnd type="none" w="med" len="med"/>
+                    </a:lnL>
+                    <a:lnR w="9525" cap="flat" cmpd="sng" algn="ctr">
+                      <a:solidFill>
+                        <a:srgbClr val="DAD6CC"/>
+                      </a:solidFill>
+                      <a:prstDash val="solid"/>
+                      <a:round/>
+                      <a:headEnd type="none" w="med" len="med"/>
+                      <a:tailEnd type="none" w="med" len="med"/>
+                    </a:lnR>
+                    <a:lnT w="9525" cap="flat" cmpd="sng" algn="ctr">
+                      <a:solidFill>
+                        <a:srgbClr val="DAD6CC"/>
+                      </a:solidFill>
+                      <a:prstDash val="solid"/>
+                      <a:round/>
+                      <a:headEnd type="none" w="med" len="med"/>
+                      <a:tailEnd type="none" w="med" len="med"/>
+                    </a:lnT>
+                    <a:lnB w="9525" cap="flat" cmpd="sng" algn="ctr">
+                      <a:solidFill>
+                        <a:srgbClr val="DAD6CC"/>
+                      </a:solidFill>
+                      <a:prstDash val="solid"/>
+                      <a:round/>
+                      <a:headEnd type="none" w="med" len="med"/>
+                      <a:tailEnd type="none" w="med" len="med"/>
+                    </a:lnB>
+                    <a:solidFill>
+                      <a:srgbClr val="FFFFFF"/>
+                    </a:solidFill>
+                  </a:tcPr>
+                </a:tc>
+                <a:tc>
+                  <a:txBody>
+                    <a:bodyPr/>
+                    <a:lstStyle/>
+                    <a:p>
+                      <a:pPr indent="0" marL="0">
+                        <a:buNone/>
+                      </a:pPr>
+                      <a:r>
+                        <a:rPr lang="en-US" sz="1400" dirty="0">
+                          <a:solidFill>
+                            <a:srgbClr val="12202B"/>
+                          </a:solidFill>
+                          <a:latin typeface="Calibri" pitchFamily="34" charset="0"/>
+                          <a:ea typeface="Calibri" pitchFamily="34" charset="-122"/>
+                          <a:cs typeface="Calibri" pitchFamily="34" charset="-120"/>
+                        </a:rPr>
+                        <a:t>Phân tích hệ thống</a:t>
+                      </a:r>
+                      <a:endParaRPr lang="en-US" sz="1400" dirty="0">
+                        <a:latin typeface="Calibri" charset="0"/>
+                        <a:ea typeface="Calibri" charset="0"/>
+                        <a:cs typeface="Calibri" charset="0"/>
+                      </a:endParaRPr>
+                    </a:p>
+                  </a:txBody>
+                  <a:tcPr marL="91440" marR="91440" marT="36576" marB="36576" anchor="ctr">
+                    <a:lnL w="9525" cap="flat" cmpd="sng" algn="ctr">
+                      <a:solidFill>
+                        <a:srgbClr val="DAD6CC"/>
+                      </a:solidFill>
+                      <a:prstDash val="solid"/>
+                      <a:round/>
+                      <a:headEnd type="none" w="med" len="med"/>
+                      <a:tailEnd type="none" w="med" len="med"/>
+                    </a:lnL>
+                    <a:lnR w="9525" cap="flat" cmpd="sng" algn="ctr">
+                      <a:solidFill>
+                        <a:srgbClr val="DAD6CC"/>
+                      </a:solidFill>
+                      <a:prstDash val="solid"/>
+                      <a:round/>
+                      <a:headEnd type="none" w="med" len="med"/>
+                      <a:tailEnd type="none" w="med" len="med"/>
+                    </a:lnR>
+                    <a:lnT w="9525" cap="flat" cmpd="sng" algn="ctr">
+                      <a:solidFill>
+                        <a:srgbClr val="DAD6CC"/>
+                      </a:solidFill>
+                      <a:prstDash val="solid"/>
+                      <a:round/>
+                      <a:headEnd type="none" w="med" len="med"/>
+                      <a:tailEnd type="none" w="med" len="med"/>
+                    </a:lnT>
+                    <a:lnB w="9525" cap="flat" cmpd="sng" algn="ctr">
+                      <a:solidFill>
+                        <a:srgbClr val="DAD6CC"/>
+                      </a:solidFill>
+                      <a:prstDash val="solid"/>
+                      <a:round/>
+                      <a:headEnd type="none" w="med" len="med"/>
+                      <a:tailEnd type="none" w="med" len="med"/>
+                    </a:lnB>
+                    <a:solidFill>
+                      <a:srgbClr val="FFFFFF"/>
+                    </a:solidFill>
+                  </a:tcPr>
+                </a:tc>
+                <a:tc>
+                  <a:txBody>
+                    <a:bodyPr/>
+                    <a:lstStyle/>
+                    <a:p>
+                      <a:pPr indent="0" marL="0">
+                        <a:buNone/>
+                      </a:pPr>
+                      <a:r>
+                        <a:rPr lang="en-US" sz="1400" dirty="0">
+                          <a:solidFill>
+                            <a:srgbClr val="12202B"/>
+                          </a:solidFill>
+                          <a:latin typeface="Calibri" pitchFamily="34" charset="0"/>
+                          <a:ea typeface="Calibri" pitchFamily="34" charset="-122"/>
+                          <a:cs typeface="Calibri" pitchFamily="34" charset="-120"/>
+                        </a:rPr>
+                        <a:t>Đọc mã, vẽ kiến trúc, luồng dữ liệu; phân tích nguyên nhân gốc</a:t>
+                      </a:r>
+                      <a:endParaRPr lang="en-US" sz="1400" dirty="0">
+                        <a:latin typeface="Calibri" charset="0"/>
+                        <a:ea typeface="Calibri" charset="0"/>
+                        <a:cs typeface="Calibri" charset="0"/>
+                      </a:endParaRPr>
+                    </a:p>
+                  </a:txBody>
+                  <a:tcPr marL="91440" marR="91440" marT="36576" marB="36576" anchor="ctr">
+                    <a:lnL w="9525" cap="flat" cmpd="sng" algn="ctr">
+                      <a:solidFill>
+                        <a:srgbClr val="DAD6CC"/>
+                      </a:solidFill>
+                      <a:prstDash val="solid"/>
+                      <a:round/>
+                      <a:headEnd type="none" w="med" len="med"/>
+                      <a:tailEnd type="none" w="med" len="med"/>
+                    </a:lnL>
+                    <a:lnR w="9525" cap="flat" cmpd="sng" algn="ctr">
+                      <a:solidFill>
+                        <a:srgbClr val="DAD6CC"/>
+                      </a:solidFill>
+                      <a:prstDash val="solid"/>
+                      <a:round/>
+                      <a:headEnd type="none" w="med" len="med"/>
+                      <a:tailEnd type="none" w="med" len="med"/>
+                    </a:lnR>
+                    <a:lnT w="9525" cap="flat" cmpd="sng" algn="ctr">
+                      <a:solidFill>
+                        <a:srgbClr val="DAD6CC"/>
+                      </a:solidFill>
+                      <a:prstDash val="solid"/>
+                      <a:round/>
+                      <a:headEnd type="none" w="med" len="med"/>
+                      <a:tailEnd type="none" w="med" len="med"/>
+                    </a:lnT>
+                    <a:lnB w="9525" cap="flat" cmpd="sng" algn="ctr">
+                      <a:solidFill>
+                        <a:srgbClr val="DAD6CC"/>
+                      </a:solidFill>
+                      <a:prstDash val="solid"/>
+                      <a:round/>
+                      <a:headEnd type="none" w="med" len="med"/>
+                      <a:tailEnd type="none" w="med" len="med"/>
+                    </a:lnB>
+                    <a:solidFill>
+                      <a:srgbClr val="FFFFFF"/>
+                    </a:solidFill>
+                  </a:tcPr>
+                </a:tc>
+                <a:tc>
+                  <a:txBody>
+                    <a:bodyPr/>
+                    <a:lstStyle/>
+                    <a:p>
+                      <a:pPr indent="0" marL="0">
+                        <a:buNone/>
+                      </a:pPr>
+                      <a:r>
+                        <a:rPr lang="en-US" sz="1400" dirty="0">
+                          <a:solidFill>
+                            <a:srgbClr val="12202B"/>
+                          </a:solidFill>
+                          <a:latin typeface="Calibri" pitchFamily="34" charset="0"/>
+                          <a:ea typeface="Calibri" pitchFamily="34" charset="-122"/>
+                          <a:cs typeface="Calibri" pitchFamily="34" charset="-120"/>
+                        </a:rPr>
+                        <a:t>Sơ đồ, DEFECTS.md, thí nghiệm khắc phục</a:t>
+                      </a:r>
+                      <a:endParaRPr lang="en-US" sz="1400" dirty="0">
+                        <a:latin typeface="Calibri" charset="0"/>
+                        <a:ea typeface="Calibri" charset="0"/>
+                        <a:cs typeface="Calibri" charset="0"/>
+                      </a:endParaRPr>
+                    </a:p>
+                  </a:txBody>
+                  <a:tcPr marL="91440" marR="91440" marT="36576" marB="36576" anchor="ctr">
+                    <a:lnL w="9525" cap="flat" cmpd="sng" algn="ctr">
+                      <a:solidFill>
+                        <a:srgbClr val="DAD6CC"/>
+                      </a:solidFill>
+                      <a:prstDash val="solid"/>
+                      <a:round/>
+                      <a:headEnd type="none" w="med" len="med"/>
+                      <a:tailEnd type="none" w="med" len="med"/>
+                    </a:lnL>
+                    <a:lnR w="9525" cap="flat" cmpd="sng" algn="ctr">
+                      <a:solidFill>
+                        <a:srgbClr val="DAD6CC"/>
+                      </a:solidFill>
+                      <a:prstDash val="solid"/>
+                      <a:round/>
+                      <a:headEnd type="none" w="med" len="med"/>
+                      <a:tailEnd type="none" w="med" len="med"/>
+                    </a:lnR>
+                    <a:lnT w="9525" cap="flat" cmpd="sng" algn="ctr">
+                      <a:solidFill>
+                        <a:srgbClr val="DAD6CC"/>
+                      </a:solidFill>
+                      <a:prstDash val="solid"/>
+                      <a:round/>
+                      <a:headEnd type="none" w="med" len="med"/>
+                      <a:tailEnd type="none" w="med" len="med"/>
+                    </a:lnT>
+                    <a:lnB w="9525" cap="flat" cmpd="sng" algn="ctr">
+                      <a:solidFill>
+                        <a:srgbClr val="DAD6CC"/>
+                      </a:solidFill>
+                      <a:prstDash val="solid"/>
+                      <a:round/>
+                      <a:headEnd type="none" w="med" len="med"/>
+                      <a:tailEnd type="none" w="med" len="med"/>
+                    </a:lnB>
+                    <a:solidFill>
+                      <a:srgbClr val="FFFFFF"/>
+                    </a:solidFill>
+                  </a:tcPr>
+                </a:tc>
+              </a:tr>
+              <a:tr h="685800">
+                <a:tc>
+                  <a:txBody>
+                    <a:bodyPr/>
+                    <a:lstStyle/>
+                    <a:p>
+                      <a:pPr indent="0" marL="0">
+                        <a:buNone/>
+                      </a:pPr>
+                      <a:r>
+                        <a:rPr lang="en-US" sz="1400" dirty="0">
+                          <a:solidFill>
+                            <a:srgbClr val="12202B"/>
+                          </a:solidFill>
+                          <a:latin typeface="Calibri" pitchFamily="34" charset="0"/>
+                          <a:ea typeface="Calibri" pitchFamily="34" charset="-122"/>
+                          <a:cs typeface="Calibri" pitchFamily="34" charset="-120"/>
+                        </a:rPr>
+                        <a:t>Nguyễn Đức Tín · 2312774</a:t>
+                      </a:r>
+                      <a:endParaRPr lang="en-US" sz="1400" dirty="0">
+                        <a:latin typeface="Calibri" charset="0"/>
+                        <a:ea typeface="Calibri" charset="0"/>
+                        <a:cs typeface="Calibri" charset="0"/>
+                      </a:endParaRPr>
+                    </a:p>
+                  </a:txBody>
+                  <a:tcPr marL="91440" marR="91440" marT="36576" marB="36576" anchor="ctr">
+                    <a:lnL w="9525" cap="flat" cmpd="sng" algn="ctr">
+                      <a:solidFill>
+                        <a:srgbClr val="DAD6CC"/>
+                      </a:solidFill>
+                      <a:prstDash val="solid"/>
+                      <a:round/>
+                      <a:headEnd type="none" w="med" len="med"/>
+                      <a:tailEnd type="none" w="med" len="med"/>
+                    </a:lnL>
+                    <a:lnR w="9525" cap="flat" cmpd="sng" algn="ctr">
+                      <a:solidFill>
+                        <a:srgbClr val="DAD6CC"/>
+                      </a:solidFill>
+                      <a:prstDash val="solid"/>
+                      <a:round/>
+                      <a:headEnd type="none" w="med" len="med"/>
+                      <a:tailEnd type="none" w="med" len="med"/>
+                    </a:lnR>
+                    <a:lnT w="9525" cap="flat" cmpd="sng" algn="ctr">
+                      <a:solidFill>
+                        <a:srgbClr val="DAD6CC"/>
+                      </a:solidFill>
+                      <a:prstDash val="solid"/>
+                      <a:round/>
+                      <a:headEnd type="none" w="med" len="med"/>
+                      <a:tailEnd type="none" w="med" len="med"/>
+                    </a:lnT>
+                    <a:lnB w="9525" cap="flat" cmpd="sng" algn="ctr">
+                      <a:solidFill>
+                        <a:srgbClr val="DAD6CC"/>
+                      </a:solidFill>
+                      <a:prstDash val="solid"/>
+                      <a:round/>
+                      <a:headEnd type="none" w="med" len="med"/>
+                      <a:tailEnd type="none" w="med" len="med"/>
+                    </a:lnB>
+                    <a:solidFill>
+                      <a:srgbClr val="FFFFFF"/>
+                    </a:solidFill>
+                  </a:tcPr>
+                </a:tc>
+                <a:tc>
+                  <a:txBody>
+                    <a:bodyPr/>
+                    <a:lstStyle/>
+                    <a:p>
+                      <a:pPr indent="0" marL="0">
+                        <a:buNone/>
+                      </a:pPr>
+                      <a:r>
+                        <a:rPr lang="en-US" sz="1400" dirty="0">
+                          <a:solidFill>
+                            <a:srgbClr val="12202B"/>
+                          </a:solidFill>
+                          <a:latin typeface="Calibri" pitchFamily="34" charset="0"/>
+                          <a:ea typeface="Calibri" pitchFamily="34" charset="-122"/>
+                          <a:cs typeface="Calibri" pitchFamily="34" charset="-120"/>
+                        </a:rPr>
+                        <a:t>Tác giả test</a:t>
+                      </a:r>
+                      <a:endParaRPr lang="en-US" sz="1400" dirty="0">
+                        <a:latin typeface="Calibri" charset="0"/>
+                        <a:ea typeface="Calibri" charset="0"/>
+                        <a:cs typeface="Calibri" charset="0"/>
+                      </a:endParaRPr>
+                    </a:p>
+                  </a:txBody>
+                  <a:tcPr marL="91440" marR="91440" marT="36576" marB="36576" anchor="ctr">
+                    <a:lnL w="9525" cap="flat" cmpd="sng" algn="ctr">
+                      <a:solidFill>
+                        <a:srgbClr val="DAD6CC"/>
+                      </a:solidFill>
+                      <a:prstDash val="solid"/>
+                      <a:round/>
+                      <a:headEnd type="none" w="med" len="med"/>
+                      <a:tailEnd type="none" w="med" len="med"/>
+                    </a:lnL>
+                    <a:lnR w="9525" cap="flat" cmpd="sng" algn="ctr">
+                      <a:solidFill>
+                        <a:srgbClr val="DAD6CC"/>
+                      </a:solidFill>
+                      <a:prstDash val="solid"/>
+                      <a:round/>
+                      <a:headEnd type="none" w="med" len="med"/>
+                      <a:tailEnd type="none" w="med" len="med"/>
+                    </a:lnR>
+                    <a:lnT w="9525" cap="flat" cmpd="sng" algn="ctr">
+                      <a:solidFill>
+                        <a:srgbClr val="DAD6CC"/>
+                      </a:solidFill>
+                      <a:prstDash val="solid"/>
+                      <a:round/>
+                      <a:headEnd type="none" w="med" len="med"/>
+                      <a:tailEnd type="none" w="med" len="med"/>
+                    </a:lnT>
+                    <a:lnB w="9525" cap="flat" cmpd="sng" algn="ctr">
+                      <a:solidFill>
+                        <a:srgbClr val="DAD6CC"/>
+                      </a:solidFill>
+                      <a:prstDash val="solid"/>
+                      <a:round/>
+                      <a:headEnd type="none" w="med" len="med"/>
+                      <a:tailEnd type="none" w="med" len="med"/>
+                    </a:lnB>
+                    <a:solidFill>
+                      <a:srgbClr val="FFFFFF"/>
+                    </a:solidFill>
+                  </a:tcPr>
+                </a:tc>
+                <a:tc>
+                  <a:txBody>
+                    <a:bodyPr/>
+                    <a:lstStyle/>
+                    <a:p>
+                      <a:pPr indent="0" marL="0">
+                        <a:buNone/>
+                      </a:pPr>
+                      <a:r>
+                        <a:rPr lang="en-US" sz="1400" dirty="0">
+                          <a:solidFill>
+                            <a:srgbClr val="12202B"/>
+                          </a:solidFill>
+                          <a:latin typeface="Calibri" pitchFamily="34" charset="0"/>
+                          <a:ea typeface="Calibri" pitchFamily="34" charset="-122"/>
+                          <a:cs typeface="Calibri" pitchFamily="34" charset="-120"/>
+                        </a:rPr>
+                        <a:t>Thiết kế invariant và test case; viết bộ test (k6, Node.js, SQL)</a:t>
+                      </a:r>
+                      <a:endParaRPr lang="en-US" sz="1400" dirty="0">
+                        <a:latin typeface="Calibri" charset="0"/>
+                        <a:ea typeface="Calibri" charset="0"/>
+                        <a:cs typeface="Calibri" charset="0"/>
+                      </a:endParaRPr>
+                    </a:p>
+                  </a:txBody>
+                  <a:tcPr marL="91440" marR="91440" marT="36576" marB="36576" anchor="ctr">
+                    <a:lnL w="9525" cap="flat" cmpd="sng" algn="ctr">
+                      <a:solidFill>
+                        <a:srgbClr val="DAD6CC"/>
+                      </a:solidFill>
+                      <a:prstDash val="solid"/>
+                      <a:round/>
+                      <a:headEnd type="none" w="med" len="med"/>
+                      <a:tailEnd type="none" w="med" len="med"/>
+                    </a:lnL>
+                    <a:lnR w="9525" cap="flat" cmpd="sng" algn="ctr">
+                      <a:solidFill>
+                        <a:srgbClr val="DAD6CC"/>
+                      </a:solidFill>
+                      <a:prstDash val="solid"/>
+                      <a:round/>
+                      <a:headEnd type="none" w="med" len="med"/>
+                      <a:tailEnd type="none" w="med" len="med"/>
+                    </a:lnR>
+                    <a:lnT w="9525" cap="flat" cmpd="sng" algn="ctr">
+                      <a:solidFill>
+                        <a:srgbClr val="DAD6CC"/>
+                      </a:solidFill>
+                      <a:prstDash val="solid"/>
+                      <a:round/>
+                      <a:headEnd type="none" w="med" len="med"/>
+                      <a:tailEnd type="none" w="med" len="med"/>
+                    </a:lnT>
+                    <a:lnB w="9525" cap="flat" cmpd="sng" algn="ctr">
+                      <a:solidFill>
+                        <a:srgbClr val="DAD6CC"/>
+                      </a:solidFill>
+                      <a:prstDash val="solid"/>
+                      <a:round/>
+                      <a:headEnd type="none" w="med" len="med"/>
+                      <a:tailEnd type="none" w="med" len="med"/>
+                    </a:lnB>
+                    <a:solidFill>
+                      <a:srgbClr val="FFFFFF"/>
+                    </a:solidFill>
+                  </a:tcPr>
+                </a:tc>
+                <a:tc>
+                  <a:txBody>
+                    <a:bodyPr/>
+                    <a:lstStyle/>
+                    <a:p>
+                      <a:pPr indent="0" marL="0">
+                        <a:buNone/>
+                      </a:pPr>
+                      <a:r>
+                        <a:rPr lang="en-US" sz="1400" dirty="0">
+                          <a:solidFill>
+                            <a:srgbClr val="12202B"/>
+                          </a:solidFill>
+                          <a:latin typeface="Calibri" pitchFamily="34" charset="0"/>
+                          <a:ea typeface="Calibri" pitchFamily="34" charset="-122"/>
+                          <a:cs typeface="Calibri" pitchFamily="34" charset="-120"/>
+                        </a:rPr>
+                        <a:t>race-tests/, đặc tả test case</a:t>
+                      </a:r>
+                      <a:endParaRPr lang="en-US" sz="1400" dirty="0">
+                        <a:latin typeface="Calibri" charset="0"/>
+                        <a:ea typeface="Calibri" charset="0"/>
+                        <a:cs typeface="Calibri" charset="0"/>
+                      </a:endParaRPr>
+                    </a:p>
+                  </a:txBody>
+                  <a:tcPr marL="91440" marR="91440" marT="36576" marB="36576" anchor="ctr">
+                    <a:lnL w="9525" cap="flat" cmpd="sng" algn="ctr">
+                      <a:solidFill>
+                        <a:srgbClr val="DAD6CC"/>
+                      </a:solidFill>
+                      <a:prstDash val="solid"/>
+                      <a:round/>
+                      <a:headEnd type="none" w="med" len="med"/>
+                      <a:tailEnd type="none" w="med" len="med"/>
+                    </a:lnL>
+                    <a:lnR w="9525" cap="flat" cmpd="sng" algn="ctr">
+                      <a:solidFill>
+                        <a:srgbClr val="DAD6CC"/>
+                      </a:solidFill>
+                      <a:prstDash val="solid"/>
+                      <a:round/>
+                      <a:headEnd type="none" w="med" len="med"/>
+                      <a:tailEnd type="none" w="med" len="med"/>
+                    </a:lnR>
+                    <a:lnT w="9525" cap="flat" cmpd="sng" algn="ctr">
+                      <a:solidFill>
+                        <a:srgbClr val="DAD6CC"/>
+                      </a:solidFill>
+                      <a:prstDash val="solid"/>
+                      <a:round/>
+                      <a:headEnd type="none" w="med" len="med"/>
+                      <a:tailEnd type="none" w="med" len="med"/>
+                    </a:lnT>
+                    <a:lnB w="9525" cap="flat" cmpd="sng" algn="ctr">
+                      <a:solidFill>
+                        <a:srgbClr val="DAD6CC"/>
+                      </a:solidFill>
+                      <a:prstDash val="solid"/>
+                      <a:round/>
+                      <a:headEnd type="none" w="med" len="med"/>
+                      <a:tailEnd type="none" w="med" len="med"/>
+                    </a:lnB>
+                    <a:solidFill>
+                      <a:srgbClr val="FFFFFF"/>
+                    </a:solidFill>
+                  </a:tcPr>
+                </a:tc>
+              </a:tr>
+              <a:tr h="685800">
+                <a:tc>
+                  <a:txBody>
+                    <a:bodyPr/>
+                    <a:lstStyle/>
+                    <a:p>
+                      <a:pPr indent="0" marL="0">
+                        <a:buNone/>
+                      </a:pPr>
+                      <a:r>
+                        <a:rPr lang="en-US" sz="1400" dirty="0">
+                          <a:solidFill>
+                            <a:srgbClr val="12202B"/>
+                          </a:solidFill>
+                          <a:latin typeface="Calibri" pitchFamily="34" charset="0"/>
+                          <a:ea typeface="Calibri" pitchFamily="34" charset="-122"/>
+                          <a:cs typeface="Calibri" pitchFamily="34" charset="-120"/>
+                        </a:rPr>
+                        <a:t>Ngô Quốc Trường Vĩ · 2312796</a:t>
+                      </a:r>
+                      <a:endParaRPr lang="en-US" sz="1400" dirty="0">
+                        <a:latin typeface="Calibri" charset="0"/>
+                        <a:ea typeface="Calibri" charset="0"/>
+                        <a:cs typeface="Calibri" charset="0"/>
+                      </a:endParaRPr>
+                    </a:p>
+                  </a:txBody>
+                  <a:tcPr marL="91440" marR="91440" marT="36576" marB="36576" anchor="ctr">
+                    <a:lnL w="9525" cap="flat" cmpd="sng" algn="ctr">
+                      <a:solidFill>
+                        <a:srgbClr val="DAD6CC"/>
+                      </a:solidFill>
+                      <a:prstDash val="solid"/>
+                      <a:round/>
+                      <a:headEnd type="none" w="med" len="med"/>
+                      <a:tailEnd type="none" w="med" len="med"/>
+                    </a:lnL>
+                    <a:lnR w="9525" cap="flat" cmpd="sng" algn="ctr">
+                      <a:solidFill>
+                        <a:srgbClr val="DAD6CC"/>
+                      </a:solidFill>
+                      <a:prstDash val="solid"/>
+                      <a:round/>
+                      <a:headEnd type="none" w="med" len="med"/>
+                      <a:tailEnd type="none" w="med" len="med"/>
+                    </a:lnR>
+                    <a:lnT w="9525" cap="flat" cmpd="sng" algn="ctr">
+                      <a:solidFill>
+                        <a:srgbClr val="DAD6CC"/>
+                      </a:solidFill>
+                      <a:prstDash val="solid"/>
+                      <a:round/>
+                      <a:headEnd type="none" w="med" len="med"/>
+                      <a:tailEnd type="none" w="med" len="med"/>
+                    </a:lnT>
+                    <a:lnB w="9525" cap="flat" cmpd="sng" algn="ctr">
+                      <a:solidFill>
+                        <a:srgbClr val="DAD6CC"/>
+                      </a:solidFill>
+                      <a:prstDash val="solid"/>
+                      <a:round/>
+                      <a:headEnd type="none" w="med" len="med"/>
+                      <a:tailEnd type="none" w="med" len="med"/>
+                    </a:lnB>
+                    <a:solidFill>
+                      <a:srgbClr val="FFFFFF"/>
+                    </a:solidFill>
+                  </a:tcPr>
+                </a:tc>
+                <a:tc>
+                  <a:txBody>
+                    <a:bodyPr/>
+                    <a:lstStyle/>
+                    <a:p>
+                      <a:pPr indent="0" marL="0">
+                        <a:buNone/>
+                      </a:pPr>
+                      <a:r>
+                        <a:rPr lang="en-US" sz="1400" dirty="0">
+                          <a:solidFill>
+                            <a:srgbClr val="12202B"/>
+                          </a:solidFill>
+                          <a:latin typeface="Calibri" pitchFamily="34" charset="0"/>
+                          <a:ea typeface="Calibri" pitchFamily="34" charset="-122"/>
+                          <a:cs typeface="Calibri" pitchFamily="34" charset="-120"/>
+                        </a:rPr>
+                        <a:t>Chạy test, báo cáo</a:t>
+                      </a:r>
+                      <a:endParaRPr lang="en-US" sz="1400" dirty="0">
+                        <a:latin typeface="Calibri" charset="0"/>
+                        <a:ea typeface="Calibri" charset="0"/>
+                        <a:cs typeface="Calibri" charset="0"/>
+                      </a:endParaRPr>
+                    </a:p>
+                  </a:txBody>
+                  <a:tcPr marL="91440" marR="91440" marT="36576" marB="36576" anchor="ctr">
+                    <a:lnL w="9525" cap="flat" cmpd="sng" algn="ctr">
+                      <a:solidFill>
+                        <a:srgbClr val="DAD6CC"/>
+                      </a:solidFill>
+                      <a:prstDash val="solid"/>
+                      <a:round/>
+                      <a:headEnd type="none" w="med" len="med"/>
+                      <a:tailEnd type="none" w="med" len="med"/>
+                    </a:lnL>
+                    <a:lnR w="9525" cap="flat" cmpd="sng" algn="ctr">
+                      <a:solidFill>
+                        <a:srgbClr val="DAD6CC"/>
+                      </a:solidFill>
+                      <a:prstDash val="solid"/>
+                      <a:round/>
+                      <a:headEnd type="none" w="med" len="med"/>
+                      <a:tailEnd type="none" w="med" len="med"/>
+                    </a:lnR>
+                    <a:lnT w="9525" cap="flat" cmpd="sng" algn="ctr">
+                      <a:solidFill>
+                        <a:srgbClr val="DAD6CC"/>
+                      </a:solidFill>
+                      <a:prstDash val="solid"/>
+                      <a:round/>
+                      <a:headEnd type="none" w="med" len="med"/>
+                      <a:tailEnd type="none" w="med" len="med"/>
+                    </a:lnT>
+                    <a:lnB w="9525" cap="flat" cmpd="sng" algn="ctr">
+                      <a:solidFill>
+                        <a:srgbClr val="DAD6CC"/>
+                      </a:solidFill>
+                      <a:prstDash val="solid"/>
+                      <a:round/>
+                      <a:headEnd type="none" w="med" len="med"/>
+                      <a:tailEnd type="none" w="med" len="med"/>
+                    </a:lnB>
+                    <a:solidFill>
+                      <a:srgbClr val="FFFFFF"/>
+                    </a:solidFill>
+                  </a:tcPr>
+                </a:tc>
+                <a:tc>
+                  <a:txBody>
+                    <a:bodyPr/>
+                    <a:lstStyle/>
+                    <a:p>
+                      <a:pPr indent="0" marL="0">
+                        <a:buNone/>
+                      </a:pPr>
+                      <a:r>
+                        <a:rPr lang="en-US" sz="1400" dirty="0">
+                          <a:solidFill>
+                            <a:srgbClr val="12202B"/>
+                          </a:solidFill>
+                          <a:latin typeface="Calibri" pitchFamily="34" charset="0"/>
+                          <a:ea typeface="Calibri" pitchFamily="34" charset="-122"/>
+                          <a:cs typeface="Calibri" pitchFamily="34" charset="-120"/>
+                        </a:rPr>
+                        <a:t>Chạy test, ghi kết quả; chạy lại trên Windows; báo cáo, slide</a:t>
+                      </a:r>
+                      <a:endParaRPr lang="en-US" sz="1400" dirty="0">
+                        <a:latin typeface="Calibri" charset="0"/>
+                        <a:ea typeface="Calibri" charset="0"/>
+                        <a:cs typeface="Calibri" charset="0"/>
+                      </a:endParaRPr>
+                    </a:p>
+                  </a:txBody>
+                  <a:tcPr marL="91440" marR="91440" marT="36576" marB="36576" anchor="ctr">
+                    <a:lnL w="9525" cap="flat" cmpd="sng" algn="ctr">
+                      <a:solidFill>
+                        <a:srgbClr val="DAD6CC"/>
+                      </a:solidFill>
+                      <a:prstDash val="solid"/>
+                      <a:round/>
+                      <a:headEnd type="none" w="med" len="med"/>
+                      <a:tailEnd type="none" w="med" len="med"/>
+                    </a:lnL>
+                    <a:lnR w="9525" cap="flat" cmpd="sng" algn="ctr">
+                      <a:solidFill>
+                        <a:srgbClr val="DAD6CC"/>
+                      </a:solidFill>
+                      <a:prstDash val="solid"/>
+                      <a:round/>
+                      <a:headEnd type="none" w="med" len="med"/>
+                      <a:tailEnd type="none" w="med" len="med"/>
+                    </a:lnR>
+                    <a:lnT w="9525" cap="flat" cmpd="sng" algn="ctr">
+                      <a:solidFill>
+                        <a:srgbClr val="DAD6CC"/>
+                      </a:solidFill>
+                      <a:prstDash val="solid"/>
+                      <a:round/>
+                      <a:headEnd type="none" w="med" len="med"/>
+                      <a:tailEnd type="none" w="med" len="med"/>
+                    </a:lnT>
+                    <a:lnB w="9525" cap="flat" cmpd="sng" algn="ctr">
+                      <a:solidFill>
+                        <a:srgbClr val="DAD6CC"/>
+                      </a:solidFill>
+                      <a:prstDash val="solid"/>
+                      <a:round/>
+                      <a:headEnd type="none" w="med" len="med"/>
+                      <a:tailEnd type="none" w="med" len="med"/>
+                    </a:lnB>
+                    <a:solidFill>
+                      <a:srgbClr val="FFFFFF"/>
+                    </a:solidFill>
+                  </a:tcPr>
+                </a:tc>
+                <a:tc>
+                  <a:txBody>
+                    <a:bodyPr/>
+                    <a:lstStyle/>
+                    <a:p>
+                      <a:pPr indent="0" marL="0">
+                        <a:buNone/>
+                      </a:pPr>
+                      <a:r>
+                        <a:rPr lang="en-US" sz="1400" dirty="0">
+                          <a:solidFill>
+                            <a:srgbClr val="12202B"/>
+                          </a:solidFill>
+                          <a:latin typeface="Calibri" pitchFamily="34" charset="0"/>
+                          <a:ea typeface="Calibri" pitchFamily="34" charset="-122"/>
+                          <a:cs typeface="Calibri" pitchFamily="34" charset="-120"/>
+                        </a:rPr>
+                        <a:t>windows-race, báo cáo, slide</a:t>
+                      </a:r>
+                      <a:endParaRPr lang="en-US" sz="1400" dirty="0">
+                        <a:latin typeface="Calibri" charset="0"/>
+                        <a:ea typeface="Calibri" charset="0"/>
+                        <a:cs typeface="Calibri" charset="0"/>
+                      </a:endParaRPr>
+                    </a:p>
+                  </a:txBody>
+                  <a:tcPr marL="91440" marR="91440" marT="36576" marB="36576" anchor="ctr">
+                    <a:lnL w="9525" cap="flat" cmpd="sng" algn="ctr">
+                      <a:solidFill>
+                        <a:srgbClr val="DAD6CC"/>
+                      </a:solidFill>
+                      <a:prstDash val="solid"/>
+                      <a:round/>
+                      <a:headEnd type="none" w="med" len="med"/>
+                      <a:tailEnd type="none" w="med" len="med"/>
+                    </a:lnL>
+                    <a:lnR w="9525" cap="flat" cmpd="sng" algn="ctr">
+                      <a:solidFill>
+                        <a:srgbClr val="DAD6CC"/>
+                      </a:solidFill>
+                      <a:prstDash val="solid"/>
+                      <a:round/>
+                      <a:headEnd type="none" w="med" len="med"/>
+                      <a:tailEnd type="none" w="med" len="med"/>
+                    </a:lnR>
+                    <a:lnT w="9525" cap="flat" cmpd="sng" algn="ctr">
+                      <a:solidFill>
+                        <a:srgbClr val="DAD6CC"/>
+                      </a:solidFill>
+                      <a:prstDash val="solid"/>
+                      <a:round/>
+                      <a:headEnd type="none" w="med" len="med"/>
+                      <a:tailEnd type="none" w="med" len="med"/>
+                    </a:lnT>
+                    <a:lnB w="9525" cap="flat" cmpd="sng" algn="ctr">
+                      <a:solidFill>
+                        <a:srgbClr val="DAD6CC"/>
+                      </a:solidFill>
+                      <a:prstDash val="solid"/>
+                      <a:round/>
+                      <a:headEnd type="none" w="med" len="med"/>
+                      <a:tailEnd type="none" w="med" len="med"/>
+                    </a:lnB>
+                    <a:solidFill>
+                      <a:srgbClr val="FFFFFF"/>
+                    </a:solidFill>
+                  </a:tcPr>
+                </a:tc>
+              </a:tr>
+            </a:tbl>
+          </a:graphicData>
+        </a:graphic>
+      </p:graphicFrame>
+      <p:sp>
+        <p:nvSpPr>
+          <p:cNvPr id="5" name="Text 2"/>
+          <p:cNvSpPr txBox="1"/>
+          <p:nvPr/>
+        </p:nvSpPr>
+        <p:spPr>
+          <a:xfrm>
+            <a:off x="640080" y="5394960"/>
+            <a:ext cx="10908792" cy="731520"/>
+          </a:xfrm>
+          <a:prstGeom prst="rect">
+            <a:avLst/>
+          </a:prstGeom>
+          <a:noFill/>
+          <a:ln/>
+        </p:spPr>
+        <p:txBody>
+          <a:bodyPr wrap="square" lIns="0" tIns="0" rIns="0" bIns="0" rtlCol="0" anchor="t"/>
+          <a:lstStyle/>
+          <a:p>
+            <a:pPr indent="0" marL="0">
+              <a:buNone/>
+            </a:pPr>
+            <a:r>
+              <a:rPr lang="en-US" sz="1500" dirty="0">
+                <a:solidFill>
+                  <a:srgbClr val="4A5866"/>
+                </a:solidFill>
+                <a:latin typeface="Calibri" pitchFamily="34" charset="0"/>
+                <a:ea typeface="Calibri" pitchFamily="34" charset="-122"/>
+                <a:cs typeface="Calibri" pitchFamily="34" charset="-120"/>
+              </a:rPr>
+              <a:t>Quản lý công việc: bảng GitHub Projects (18 thẻ, 3 cột), mã nguồn trên GitHub. Việc gán người cho từng thẻ và commit đều các thành viên sẽ hoàn thiện trước buổi bảo vệ.</a:t>
+            </a:r>
+            <a:endParaRPr lang="en-US" sz="1500" dirty="0"/>
+          </a:p>
+        </p:txBody>
+      </p:sp>
+      <p:sp>
+        <p:nvSpPr>
+          <p:cNvPr id="6" name="Text 3"/>
+          <p:cNvSpPr txBox="1"/>
+          <p:nvPr/>
+        </p:nvSpPr>
+        <p:spPr>
+          <a:xfrm>
+            <a:off x="640080" y="6355080"/>
+            <a:ext cx="10332720" cy="274320"/>
+          </a:xfrm>
+          <a:prstGeom prst="rect">
+            <a:avLst/>
+          </a:prstGeom>
+          <a:noFill/>
+          <a:ln/>
+        </p:spPr>
+        <p:txBody>
+          <a:bodyPr wrap="square" lIns="0" tIns="0" rIns="0" bIns="0" rtlCol="0" anchor="ctr"/>
+          <a:lstStyle/>
+          <a:p>
+            <a:pPr indent="0" marL="0">
+              <a:buNone/>
+            </a:pPr>
+            <a:r>
+              <a:rPr lang="en-US" sz="1200" dirty="0">
+                <a:solidFill>
+                  <a:srgbClr val="7A8592"/>
+                </a:solidFill>
+                <a:latin typeface="Calibri" pitchFamily="34" charset="0"/>
+                <a:ea typeface="Calibri" pitchFamily="34" charset="-122"/>
+                <a:cs typeface="Calibri" pitchFamily="34" charset="-120"/>
+              </a:rPr>
+              <a:t>Chi tiết: báo cáo mục 4.6 · github.com/users/2312741-sudo/projects/1</a:t>
+            </a:r>
+            <a:endParaRPr lang="en-US" sz="1200" dirty="0"/>
+          </a:p>
+        </p:txBody>
+      </p:sp>
+      <p:sp>
+        <p:nvSpPr>
+          <p:cNvPr id="25" name="Slide Number Placeholder 0"/>
+          <p:cNvSpPr>
+            <a:spLocks noGrp="1"/>
+          </p:cNvSpPr>
+          <p:nvPr>
+            <p:ph type="sldNum" sz="quarter" idx="4294967295"/>
+          </p:nvPr>
+        </p:nvSpPr>
+        <p:spPr>
+          <a:xfrm>
+            <a:off x="11155680" y="6355080"/>
+            <a:ext cx="457200" cy="274320"/>
+          </a:xfrm>
+          <a:prstGeom prst="rect">
+            <a:avLst/>
+          </a:prstGeom>
+          <a:extLst>
+            <a:ext uri="{C572A759-6A51-4108-AA02-DFA0A04FC94B}">
+              <ma14:wrappingTextBoxFlag xmlns:ma14="http://schemas.microsoft.com/office/mac/drawingml/2011/main" val="0"/>
+            </a:ext>
+          </a:extLst>
+        </p:spPr>
+        <p:txBody>
+          <a:bodyPr/>
+          <a:lstStyle>
+            <a:lvl1pPr>
+              <a:defRPr sz="1200">
+                <a:solidFill>
+                  <a:srgbClr val="7A8592"/>
+                </a:solidFill>
+                <a:latin typeface="Calibri"/>
+                <a:ea typeface="Calibri"/>
+                <a:cs typeface="Calibri"/>
+              </a:defRPr>
+            </a:lvl1pPr>
+          </a:lstStyle>
+          <a:p>
+            <a:pPr algn="r"/>
+            <a:fld id="{F7021451-1387-4CA6-816F-3879F97B5CBC}" type="slidenum">
+              <a:rPr b="0" lang="en-US"/>
+              <a:t>13</a:t>
+            </a:fld>
+            <a:endParaRPr lang="en-US"/>
+          </a:p>
+        </p:txBody>
+      </p:sp>
+    </p:spTree>
+  </p:cSld>
+  <p:clrMapOvr>
+    <a:masterClrMapping/>
+  </p:clrMapOvr>
+</p:sld>
+</file>
+
+<file path=ppt/slides/slide14.xml><?xml version="1.0" encoding="utf-8"?>
+<p:sld xmlns:a="http://schemas.openxmlformats.org/drawingml/2006/main" xmlns:r="http://schemas.openxmlformats.org/officeDocument/2006/relationships" xmlns:p="http://schemas.openxmlformats.org/presentationml/2006/main">
+  <p:cSld name="Slide 14">
+    <p:spTree>
+      <p:nvGrpSpPr>
+        <p:cNvPr id="1" name=""/>
+        <p:cNvGrpSpPr/>
+        <p:nvPr/>
+      </p:nvGrpSpPr>
+      <p:grpSpPr>
+        <a:xfrm>
+          <a:off x="0" y="0"/>
+          <a:ext cx="0" cy="0"/>
+          <a:chOff x="0" y="0"/>
+          <a:chExt cx="0" cy="0"/>
+        </a:xfrm>
+      </p:grpSpPr>
+      <p:sp>
+        <p:nvSpPr>
+          <p:cNvPr id="2" name="Text 0"/>
+          <p:cNvSpPr txBox="1"/>
+          <p:nvPr/>
+        </p:nvSpPr>
+        <p:spPr>
+          <a:xfrm>
+            <a:off x="640080" y="292608"/>
+            <a:ext cx="10908792" cy="274320"/>
+          </a:xfrm>
+          <a:prstGeom prst="rect">
+            <a:avLst/>
+          </a:prstGeom>
+          <a:noFill/>
+          <a:ln/>
+        </p:spPr>
+        <p:txBody>
+          <a:bodyPr wrap="square" lIns="0" tIns="0" rIns="0" bIns="0" rtlCol="0" anchor="ctr"/>
+          <a:lstStyle/>
+          <a:p>
+            <a:pPr indent="0" marL="0">
+              <a:buNone/>
+            </a:pPr>
+            <a:r>
+              <a:rPr lang="en-US" sz="1300" b="1" spc="200" kern="0" dirty="0">
+                <a:solidFill>
                   <a:srgbClr val="E07B39"/>
                 </a:solidFill>
                 <a:latin typeface="Consolas" pitchFamily="34" charset="0"/>
                 <a:ea typeface="Consolas" pitchFamily="34" charset="-122"/>
                 <a:cs typeface="Consolas" pitchFamily="34" charset="-120"/>
               </a:rPr>
-              <a:t>12 · KẾ HOẠCH TIẾP THEO</a:t>
+              <a:t>13 · KẾ HOẠCH TIẾP THEO</a:t>
             </a:r>
             <a:endParaRPr lang="en-US" sz="1300" dirty="0"/>
           </a:p>
@@ -10313,7 +12036,7 @@
             <a:pPr algn="r"/>
             <a:fld id="{F7021451-1387-4CA6-816F-3879F97B5CBC}" type="slidenum">
               <a:rPr b="0" lang="en-US"/>
-              <a:t>13</a:t>
+              <a:t>14</a:t>
             </a:fld>
             <a:endParaRPr lang="en-US"/>
           </a:p>
@@ -21221,8 +22944,8 @@
         </p:nvSpPr>
         <p:spPr>
           <a:xfrm>
-            <a:off x="640080" y="5486400"/>
-            <a:ext cx="10908792" cy="640080"/>
+            <a:off x="640080" y="5669280"/>
+            <a:ext cx="10908792" cy="548640"/>
           </a:xfrm>
           <a:prstGeom prst="rect">
             <a:avLst/>
@@ -21238,7 +22961,7 @@
               <a:buNone/>
             </a:pPr>
             <a:r>
-              <a:rPr lang="en-US" sz="1500" dirty="0">
+              <a:rPr lang="en-US" sz="1400" dirty="0">
                 <a:solidFill>
                   <a:srgbClr val="4A5866"/>
                 </a:solidFill>
@@ -21248,7 +22971,7 @@
               </a:rPr>
               <a:t>Dữ liệu: host k15host (UTC, rảnh 24/7); 5 loại cuộc hẹn; mỗi request dùng một email người đặt khác nhau. I7 (không có 5xx) áp dụng cho mọi test case.</a:t>
             </a:r>
-            <a:endParaRPr lang="en-US" sz="1500" dirty="0"/>
+            <a:endParaRPr lang="en-US" sz="1400" dirty="0"/>
           </a:p>
         </p:txBody>
       </p:sp>

</xml_diff>

<commit_message>
test: add the full 20-case Windows rerun (20/20 match with macOS)
Windows 11 run of 2026-10-21: concurrent 448 s, sequential 113 s. All 20
verdicts match macOS; only TC-07 differs by one round (9/10) because the
reschedule arrived first in round 1 and the cancel was rejected with 400,
which keeps the data consistent. Only REPORT.md was returned, so the
results folders hold it and a README. Update the report (62 pages), the
17-slide deck, the one-page slide and the guides, including cost totals
(8 940 requests, about 33 minutes across both machines).

Co-Authored-By: Claude Sonnet 5.5 <noreply@anthropic.com>
</commit_message>
<xml_diff>
--- a/docs/BAO_CAO_GIUA_KY_R05-K15.pptx
+++ b/docs/BAO_CAO_GIUA_KY_R05-K15.pptx
@@ -123,18 +123,18 @@
   <p:extLst>
     <p:ext uri="{521415D9-36F7-43E2-AB2F-B90AF26B5E84}">
       <p14:sectionLst xmlns:p14="http://schemas.microsoft.com/office/powerpoint/2010/main">
-        <p14:section name="Mở đầu" id="{8741b10f-2b2d-9a28-ef76-d949e91ecbf5}">
+        <p14:section name="Mở đầu" id="{7eba8989-2e86-0425-2c5e-4dbf780412bd}">
           <p14:sldIdLst>
             <p14:sldId id="256"/>
             <p14:sldId id="257"/>
           </p14:sldIdLst>
         </p14:section>
-        <p14:section name="Tiến độ" id="{e49eb3da-6eca-d08e-18d3-11f8689757fa}">
+        <p14:section name="Tiến độ" id="{06951482-2313-cb93-922e-017485c79c5c}">
           <p14:sldIdLst>
             <p14:sldId id="258"/>
           </p14:sldIdLst>
         </p14:section>
-        <p14:section name="Hệ thống và kiểm thử" id="{3f830cf7-746a-de0a-7e6f-ea53f5c0dff7}">
+        <p14:section name="Hệ thống và kiểm thử" id="{b4b67dec-59ae-c8a5-411b-8d0fc3f524e0}">
           <p14:sldIdLst>
             <p14:sldId id="259"/>
             <p14:sldId id="260"/>
@@ -143,13 +143,13 @@
             <p14:sldId id="263"/>
           </p14:sldIdLst>
         </p14:section>
-        <p14:section name="Kế hoạch kiểm thử" id="{7a6858ef-c276-f096-69e1-693f3450cba8}">
+        <p14:section name="Kế hoạch kiểm thử" id="{09b3a325-38a1-b211-a7e5-6e6e8f483cec}">
           <p14:sldIdLst>
             <p14:sldId id="264"/>
             <p14:sldId id="265"/>
           </p14:sldIdLst>
         </p14:section>
-        <p14:section name="Kết quả" id="{ce727d97-22fc-3286-74a3-0bd0bee78140}">
+        <p14:section name="Kết quả" id="{b17b9ed9-8888-79c9-74ca-59d61f0d200f}">
           <p14:sldIdLst>
             <p14:sldId id="266"/>
             <p14:sldId id="267"/>
@@ -159,7 +159,7 @@
             <p14:sldId id="271"/>
           </p14:sldIdLst>
         </p14:section>
-        <p14:section name="Tiếp theo" id="{e97175bf-f1a9-ac92-85ea-71787be8b008}">
+        <p14:section name="Tiếp theo" id="{6109a223-8767-1b23-fd5d-da8d12d1bb76}">
           <p14:sldIdLst>
             <p14:sldId id="272"/>
           </p14:sldIdLst>
@@ -656,7 +656,7 @@
           <a:p>
             <a:r>
               <a:rPr lang="en-US" dirty="0"/>
-              <a:t>Số liệu chi phí máy đo thật từ thời điểm bắt đầu và kết thúc trong file summary.json của mỗi lần chạy. Chạy lại bộ test chính 20 test case, cả đồng thời và tuần tự, mất khoảng tám phút. Tổng cộng mọi lần chạy khoảng 23 phút và 5 760 request. Công sức nhân lực là ước lượng 34 đến 46 người-giờ, nhóm chưa theo dõi giờ thực tế từng người và ước lượng này chưa gồm đợt mở rộng.</a:t>
+              <a:t>Số liệu chi phí máy đo thật từ thời điểm bắt đầu và kết thúc trong file summary.json của mỗi lần chạy. Chạy lại bộ test chính 20 test case, cả đồng thời và tuần tự, mất khoảng tám phút. Tổng cộng mọi lần chạy, cả hai máy, khoảng 33 phút và 8 940 request. Công sức nhân lực là ước lượng 34 đến 46 người-giờ, nhóm chưa theo dõi giờ thực tế từng người và ước lượng này chưa gồm đợt mở rộng.</a:t>
             </a:r>
             <a:endParaRPr lang="en-US" dirty="0"/>
           </a:p>
@@ -832,7 +832,7 @@
           <a:p>
             <a:r>
               <a:rPr lang="en-US" dirty="0"/>
-              <a:t>Một thành viên chạy lại bộ test trên máy Windows của mình với cùng phiên bản mã. Kết luận tám test case giống hệt máy Mac: năm lỗi race chỉ sai khi đồng thời, một lỗi logic sai cả khi tuần tự, hai test case đúng. Hai lượt chạy đầu trên máy Windows không hợp lệ vì thiếu công cụ k6 và vì Cal.com dừng giữa chừng; nhóm đã loại và chỉ dùng lượt chạy sạch. Người chạy trên máy Windows là Ngô Quốc Trường Vĩ, máy MSI Core i7-13620H, RAM 16 GB.</a:t>
+              <a:t>Bạn Vĩ chạy lại bộ test trên máy Windows với cùng phiên bản mã. Ngày 18/10 là tám test case đầu, khớp tám trên tám. Ngày 21/10 chạy đủ hai mươi test case: kết luận khớp hai mươi trên hai mươi với máy Mac. Chỗ khác duy nhất là TC-07 vi phạm chín trên mười vòng thay vì mười: ở vòng một, yêu cầu đổi lịch đến trước nên lệnh hủy bị từ chối, dữ liệu nhất quán, không phải lỗi. Điều này bình thường với bài toán chỉ có hai yêu cầu. Máy Windows chậm hơn: bốn trăm bốn mươi tám giây so với ba trăm tám mươi ba giây. Hai lượt chạy đầu trên máy Windows lần trước bị loại vì thiếu k6 và Cal.com dừng giữa chừng; nhóm chỉ dùng lượt chạy sạch.</a:t>
             </a:r>
             <a:endParaRPr lang="en-US" dirty="0"/>
           </a:p>
@@ -920,7 +920,7 @@
           <a:p>
             <a:r>
               <a:rPr lang="en-US" dirty="0"/>
-              <a:t>Đây là phần chứng minh tính khả thi của test case. Một: tất cả chạy tự động. Hai: bảy test case đạt ở cả hai chế độ và khi chạy tuần tự các cơ chế bảo vệ từ chối bằng mã lỗi riêng như duration_limit_reached hay booker_limit_exceeded_error, nghĩa là test case thật sự kiểm tra chứ không đạt rỗng. Ba: lặp lại mười trên mười vòng và vẫn như vậy khi chỉ có hai request. Bốn: curl thuần cho cùng kết quả. Năm là bằng chứng mạnh nhất: khi nhóm thêm chỉ mục duy nhất theo người tham dự trên cơ sở dữ liệu test thì TC-16 chuyển từ không đạt sang đạt, tức test case đúng là phát hiện lỗi đó. Với ràng buộc loại trừ thì dữ liệu hết chồng giờ nhưng người thua nhận lỗi 500, nên sửa phải làm ở cả hai tầng. Hạn chế: mười hai test case mới chưa chạy trên máy Windows.</a:t>
+              <a:t>Đây là phần chứng minh tính khả thi của test case. Một: tất cả chạy tự động. Hai: bảy test case đạt ở cả hai chế độ và khi chạy tuần tự các cơ chế bảo vệ từ chối bằng mã lỗi riêng như duration_limit_reached hay booker_limit_exceeded_error, nghĩa là test case thật sự kiểm tra chứ không đạt rỗng. Ba: lặp lại mười trên mười vòng và vẫn như vậy khi chỉ có hai request. Bốn: curl thuần cho cùng kết quả. Năm là bằng chứng mạnh nhất: khi nhóm thêm chỉ mục duy nhất theo người tham dự trên cơ sở dữ liệu test thì TC-16 chuyển từ không đạt sang đạt, tức test case đúng là phát hiện lỗi đó. Với ràng buộc loại trừ thì dữ liệu hết chồng giờ nhưng người thua nhận lỗi 500, nên sửa phải làm ở cả hai tầng. Bảy: hai máy khớp hai mươi trên hai mươi test case; TC-07 lệch một vòng vì chỉ có hai request nên thứ tự đến thay đổi.</a:t>
             </a:r>
             <a:endParaRPr lang="en-US" dirty="0"/>
           </a:p>
@@ -3065,7 +3065,7 @@
                 <a:ea typeface="Calibri" pitchFamily="34" charset="-122"/>
                 <a:cs typeface="Calibri" pitchFamily="34" charset="-120"/>
               </a:rPr>
-              <a:t>Chi phí đo thật: 0 đồng, khoảng 23 phút máy</a:t>
+              <a:t>Chi phí đo thật: 0 đồng, khoảng 33 phút máy</a:t>
             </a:r>
             <a:endParaRPr lang="en-US" sz="3400" dirty="0"/>
           </a:p>
@@ -3236,7 +3236,7 @@
                 <a:ea typeface="Calibri" pitchFamily="34" charset="-122"/>
                 <a:cs typeface="Calibri" pitchFamily="34" charset="-120"/>
               </a:rPr>
-              <a:t>5 760</a:t>
+              <a:t>8 940</a:t>
             </a:r>
             <a:endParaRPr lang="en-US" sz="3200" dirty="0"/>
           </a:p>
@@ -4360,7 +4360,7 @@
                           <a:ea typeface="Calibri" pitchFamily="34" charset="-122"/>
                           <a:cs typeface="Calibri" pitchFamily="34" charset="-120"/>
                         </a:rPr>
-                        <a:t>Độ nhạy: chỉ 2 request (đợt 1 và 7 test case mới)</a:t>
+                        <a:t>Đợt 2 trên máy Windows (đồng thời + tuần tự)</a:t>
                       </a:r>
                       <a:endParaRPr lang="en-US" sz="1400" dirty="0">
                         <a:latin typeface="Calibri" charset="0"/>
@@ -4428,7 +4428,7 @@
                           <a:ea typeface="Calibri" pitchFamily="34" charset="-122"/>
                           <a:cs typeface="Calibri" pitchFamily="34" charset="-120"/>
                         </a:rPr>
-                        <a:t>340</a:t>
+                        <a:t>3 180</a:t>
                       </a:r>
                       <a:endParaRPr lang="en-US" sz="1400" dirty="0">
                         <a:latin typeface="Calibri" charset="0"/>
@@ -4496,7 +4496,7 @@
                           <a:ea typeface="Calibri" pitchFamily="34" charset="-122"/>
                           <a:cs typeface="Calibri" pitchFamily="34" charset="-120"/>
                         </a:rPr>
-                        <a:t>281 giây</a:t>
+                        <a:t>561 giây</a:t>
                       </a:r>
                       <a:endParaRPr lang="en-US" sz="1400" dirty="0">
                         <a:latin typeface="Calibri" charset="0"/>
@@ -4566,7 +4566,7 @@
                           <a:ea typeface="Calibri" pitchFamily="34" charset="-122"/>
                           <a:cs typeface="Calibri" pitchFamily="34" charset="-120"/>
                         </a:rPr>
-                        <a:t>Thí nghiệm khắc phục + đo cửa sổ race</a:t>
+                        <a:t>Thí nghiệm phụ: độ nhạy 2 request, khắc phục, cửa sổ race</a:t>
                       </a:r>
                       <a:endParaRPr lang="en-US" sz="1400" dirty="0">
                         <a:latin typeface="Calibri" charset="0"/>
@@ -4634,7 +4634,7 @@
                           <a:ea typeface="Calibri" pitchFamily="34" charset="-122"/>
                           <a:cs typeface="Calibri" pitchFamily="34" charset="-120"/>
                         </a:rPr>
-                        <a:t>1 100</a:t>
+                        <a:t>1 440</a:t>
                       </a:r>
                       <a:endParaRPr lang="en-US" sz="1400" dirty="0">
                         <a:latin typeface="Calibri" charset="0"/>
@@ -4702,7 +4702,7 @@
                           <a:ea typeface="Calibri" pitchFamily="34" charset="-122"/>
                           <a:cs typeface="Calibri" pitchFamily="34" charset="-120"/>
                         </a:rPr>
-                        <a:t>474 giây</a:t>
+                        <a:t>755 giây</a:t>
                       </a:r>
                       <a:endParaRPr lang="en-US" sz="1400" dirty="0">
                         <a:latin typeface="Calibri" charset="0"/>
@@ -5553,7 +5553,7 @@
                 <a:ea typeface="Calibri" pitchFamily="34" charset="-122"/>
                 <a:cs typeface="Calibri" pitchFamily="34" charset="-120"/>
               </a:rPr>
-              <a:t>Máy Windows: 8 test case đầu khớp 8/8</a:t>
+              <a:t>Máy Windows: cả 20 test case khớp 20/20</a:t>
             </a:r>
             <a:endParaRPr lang="en-US" sz="3400" dirty="0"/>
           </a:p>
@@ -5582,13 +5582,13 @@
             <a:tbl>
               <a:tblPr/>
               <a:tblGrid>
-                <a:gridCol w="3291840"/>
+                <a:gridCol w="3840480"/>
+                <a:gridCol w="1920240"/>
+                <a:gridCol w="2194560"/>
                 <a:gridCol w="2103120"/>
-                <a:gridCol w="2377440"/>
-                <a:gridCol w="2194560"/>
-                <a:gridCol w="941832"/>
+                <a:gridCol w="850392"/>
               </a:tblGrid>
-              <a:tr h="502920">
+              <a:tr h="411480">
                 <a:tc>
                   <a:txBody>
                     <a:bodyPr/>
@@ -5598,7 +5598,7 @@
                         <a:buNone/>
                       </a:pPr>
                       <a:r>
-                        <a:rPr lang="en-US" sz="1500" b="1" dirty="0">
+                        <a:rPr lang="en-US" sz="1400" b="1" dirty="0">
                           <a:solidFill>
                             <a:srgbClr val="12202B"/>
                           </a:solidFill>
@@ -5608,7 +5608,7 @@
                         </a:rPr>
                         <a:t>Test case</a:t>
                       </a:r>
-                      <a:endParaRPr lang="en-US" sz="1500" dirty="0">
+                      <a:endParaRPr lang="en-US" sz="1400" dirty="0">
                         <a:latin typeface="Calibri" charset="0"/>
                         <a:ea typeface="Calibri" charset="0"/>
                         <a:cs typeface="Calibri" charset="0"/>
@@ -5666,7 +5666,7 @@
                         <a:buNone/>
                       </a:pPr>
                       <a:r>
-                        <a:rPr lang="en-US" sz="1500" b="1" dirty="0">
+                        <a:rPr lang="en-US" sz="1400" b="1" dirty="0">
                           <a:solidFill>
                             <a:srgbClr val="12202B"/>
                           </a:solidFill>
@@ -5676,7 +5676,7 @@
                         </a:rPr>
                         <a:t>Mac: đồng thời</a:t>
                       </a:r>
-                      <a:endParaRPr lang="en-US" sz="1500" dirty="0">
+                      <a:endParaRPr lang="en-US" sz="1400" dirty="0">
                         <a:latin typeface="Calibri" charset="0"/>
                         <a:ea typeface="Calibri" charset="0"/>
                         <a:cs typeface="Calibri" charset="0"/>
@@ -5734,7 +5734,7 @@
                         <a:buNone/>
                       </a:pPr>
                       <a:r>
-                        <a:rPr lang="en-US" sz="1500" b="1" dirty="0">
+                        <a:rPr lang="en-US" sz="1400" b="1" dirty="0">
                           <a:solidFill>
                             <a:srgbClr val="12202B"/>
                           </a:solidFill>
@@ -5744,7 +5744,7 @@
                         </a:rPr>
                         <a:t>Windows: đồng thời</a:t>
                       </a:r>
-                      <a:endParaRPr lang="en-US" sz="1500" dirty="0">
+                      <a:endParaRPr lang="en-US" sz="1400" dirty="0">
                         <a:latin typeface="Calibri" charset="0"/>
                         <a:ea typeface="Calibri" charset="0"/>
                         <a:cs typeface="Calibri" charset="0"/>
@@ -5802,7 +5802,7 @@
                         <a:buNone/>
                       </a:pPr>
                       <a:r>
-                        <a:rPr lang="en-US" sz="1500" b="1" dirty="0">
+                        <a:rPr lang="en-US" sz="1400" b="1" dirty="0">
                           <a:solidFill>
                             <a:srgbClr val="12202B"/>
                           </a:solidFill>
@@ -5812,7 +5812,7 @@
                         </a:rPr>
                         <a:t>Windows: tuần tự</a:t>
                       </a:r>
-                      <a:endParaRPr lang="en-US" sz="1500" dirty="0">
+                      <a:endParaRPr lang="en-US" sz="1400" dirty="0">
                         <a:latin typeface="Calibri" charset="0"/>
                         <a:ea typeface="Calibri" charset="0"/>
                         <a:cs typeface="Calibri" charset="0"/>
@@ -5870,7 +5870,7 @@
                         <a:buNone/>
                       </a:pPr>
                       <a:r>
-                        <a:rPr lang="en-US" sz="1500" b="1" dirty="0">
+                        <a:rPr lang="en-US" sz="1400" b="1" dirty="0">
                           <a:solidFill>
                             <a:srgbClr val="12202B"/>
                           </a:solidFill>
@@ -5880,7 +5880,7 @@
                         </a:rPr>
                         <a:t>Khớp</a:t>
                       </a:r>
-                      <a:endParaRPr lang="en-US" sz="1500" dirty="0">
+                      <a:endParaRPr lang="en-US" sz="1400" dirty="0">
                         <a:latin typeface="Calibri" charset="0"/>
                         <a:ea typeface="Calibri" charset="0"/>
                         <a:cs typeface="Calibri" charset="0"/>
@@ -5930,7 +5930,7 @@
                   </a:tcPr>
                 </a:tc>
               </a:tr>
-              <a:tr h="502920">
+              <a:tr h="411480">
                 <a:tc>
                   <a:txBody>
                     <a:bodyPr/>
@@ -5940,7 +5940,7 @@
                         <a:buNone/>
                       </a:pPr>
                       <a:r>
-                        <a:rPr lang="en-US" sz="1500" dirty="0">
+                        <a:rPr lang="en-US" sz="1400" dirty="0">
                           <a:solidFill>
                             <a:srgbClr val="12202B"/>
                           </a:solidFill>
@@ -5948,9 +5948,9 @@
                           <a:ea typeface="Calibri" pitchFamily="34" charset="-122"/>
                           <a:cs typeface="Calibri" pitchFamily="34" charset="-120"/>
                         </a:rPr>
-                        <a:t>TC-01, TC-04</a:t>
+                        <a:t>TC-01, 04, 09, 10, 18, 19, 20</a:t>
                       </a:r>
-                      <a:endParaRPr lang="en-US" sz="1500" dirty="0">
+                      <a:endParaRPr lang="en-US" sz="1400" dirty="0">
                         <a:latin typeface="Calibri" charset="0"/>
                         <a:ea typeface="Calibri" charset="0"/>
                         <a:cs typeface="Calibri" charset="0"/>
@@ -6008,7 +6008,7 @@
                         <a:buNone/>
                       </a:pPr>
                       <a:r>
-                        <a:rPr lang="en-US" sz="1500" dirty="0">
+                        <a:rPr lang="en-US" sz="1400" dirty="0">
                           <a:solidFill>
                             <a:srgbClr val="12202B"/>
                           </a:solidFill>
@@ -6018,7 +6018,7 @@
                         </a:rPr>
                         <a:t>0/10</a:t>
                       </a:r>
-                      <a:endParaRPr lang="en-US" sz="1500" dirty="0">
+                      <a:endParaRPr lang="en-US" sz="1400" dirty="0">
                         <a:latin typeface="Calibri" charset="0"/>
                         <a:ea typeface="Calibri" charset="0"/>
                         <a:cs typeface="Calibri" charset="0"/>
@@ -6076,7 +6076,7 @@
                         <a:buNone/>
                       </a:pPr>
                       <a:r>
-                        <a:rPr lang="en-US" sz="1500" dirty="0">
+                        <a:rPr lang="en-US" sz="1400" dirty="0">
                           <a:solidFill>
                             <a:srgbClr val="12202B"/>
                           </a:solidFill>
@@ -6086,7 +6086,7 @@
                         </a:rPr>
                         <a:t>0/10</a:t>
                       </a:r>
-                      <a:endParaRPr lang="en-US" sz="1500" dirty="0">
+                      <a:endParaRPr lang="en-US" sz="1400" dirty="0">
                         <a:latin typeface="Calibri" charset="0"/>
                         <a:ea typeface="Calibri" charset="0"/>
                         <a:cs typeface="Calibri" charset="0"/>
@@ -6144,7 +6144,7 @@
                         <a:buNone/>
                       </a:pPr>
                       <a:r>
-                        <a:rPr lang="en-US" sz="1500" dirty="0">
+                        <a:rPr lang="en-US" sz="1400" dirty="0">
                           <a:solidFill>
                             <a:srgbClr val="12202B"/>
                           </a:solidFill>
@@ -6154,7 +6154,7 @@
                         </a:rPr>
                         <a:t>0/10</a:t>
                       </a:r>
-                      <a:endParaRPr lang="en-US" sz="1500" dirty="0">
+                      <a:endParaRPr lang="en-US" sz="1400" dirty="0">
                         <a:latin typeface="Calibri" charset="0"/>
                         <a:ea typeface="Calibri" charset="0"/>
                         <a:cs typeface="Calibri" charset="0"/>
@@ -6212,7 +6212,7 @@
                         <a:buNone/>
                       </a:pPr>
                       <a:r>
-                        <a:rPr lang="en-US" sz="1500" dirty="0">
+                        <a:rPr lang="en-US" sz="1400" dirty="0">
                           <a:solidFill>
                             <a:srgbClr val="12202B"/>
                           </a:solidFill>
@@ -6222,7 +6222,7 @@
                         </a:rPr>
                         <a:t>Có</a:t>
                       </a:r>
-                      <a:endParaRPr lang="en-US" sz="1500" dirty="0">
+                      <a:endParaRPr lang="en-US" sz="1400" dirty="0">
                         <a:latin typeface="Calibri" charset="0"/>
                         <a:ea typeface="Calibri" charset="0"/>
                         <a:cs typeface="Calibri" charset="0"/>
@@ -6272,7 +6272,7 @@
                   </a:tcPr>
                 </a:tc>
               </a:tr>
-              <a:tr h="502920">
+              <a:tr h="411480">
                 <a:tc>
                   <a:txBody>
                     <a:bodyPr/>
@@ -6282,7 +6282,7 @@
                         <a:buNone/>
                       </a:pPr>
                       <a:r>
-                        <a:rPr lang="en-US" sz="1500" dirty="0">
+                        <a:rPr lang="en-US" sz="1400" dirty="0">
                           <a:solidFill>
                             <a:srgbClr val="12202B"/>
                           </a:solidFill>
@@ -6290,9 +6290,9 @@
                           <a:ea typeface="Calibri" pitchFamily="34" charset="-122"/>
                           <a:cs typeface="Calibri" pitchFamily="34" charset="-120"/>
                         </a:rPr>
-                        <a:t>TC-02, 03, 05, 07, 08</a:t>
+                        <a:t>TC-02, 03, 05, 08, 11–17</a:t>
                       </a:r>
-                      <a:endParaRPr lang="en-US" sz="1500" dirty="0">
+                      <a:endParaRPr lang="en-US" sz="1400" dirty="0">
                         <a:latin typeface="Calibri" charset="0"/>
                         <a:ea typeface="Calibri" charset="0"/>
                         <a:cs typeface="Calibri" charset="0"/>
@@ -6350,7 +6350,7 @@
                         <a:buNone/>
                       </a:pPr>
                       <a:r>
-                        <a:rPr lang="en-US" sz="1500" dirty="0">
+                        <a:rPr lang="en-US" sz="1400" dirty="0">
                           <a:solidFill>
                             <a:srgbClr val="12202B"/>
                           </a:solidFill>
@@ -6360,7 +6360,7 @@
                         </a:rPr>
                         <a:t>10/10</a:t>
                       </a:r>
-                      <a:endParaRPr lang="en-US" sz="1500" dirty="0">
+                      <a:endParaRPr lang="en-US" sz="1400" dirty="0">
                         <a:latin typeface="Calibri" charset="0"/>
                         <a:ea typeface="Calibri" charset="0"/>
                         <a:cs typeface="Calibri" charset="0"/>
@@ -6418,7 +6418,7 @@
                         <a:buNone/>
                       </a:pPr>
                       <a:r>
-                        <a:rPr lang="en-US" sz="1500" dirty="0">
+                        <a:rPr lang="en-US" sz="1400" dirty="0">
                           <a:solidFill>
                             <a:srgbClr val="12202B"/>
                           </a:solidFill>
@@ -6428,7 +6428,7 @@
                         </a:rPr>
                         <a:t>10/10</a:t>
                       </a:r>
-                      <a:endParaRPr lang="en-US" sz="1500" dirty="0">
+                      <a:endParaRPr lang="en-US" sz="1400" dirty="0">
                         <a:latin typeface="Calibri" charset="0"/>
                         <a:ea typeface="Calibri" charset="0"/>
                         <a:cs typeface="Calibri" charset="0"/>
@@ -6486,7 +6486,7 @@
                         <a:buNone/>
                       </a:pPr>
                       <a:r>
-                        <a:rPr lang="en-US" sz="1500" dirty="0">
+                        <a:rPr lang="en-US" sz="1400" dirty="0">
                           <a:solidFill>
                             <a:srgbClr val="12202B"/>
                           </a:solidFill>
@@ -6496,7 +6496,7 @@
                         </a:rPr>
                         <a:t>0/10</a:t>
                       </a:r>
-                      <a:endParaRPr lang="en-US" sz="1500" dirty="0">
+                      <a:endParaRPr lang="en-US" sz="1400" dirty="0">
                         <a:latin typeface="Calibri" charset="0"/>
                         <a:ea typeface="Calibri" charset="0"/>
                         <a:cs typeface="Calibri" charset="0"/>
@@ -6554,7 +6554,7 @@
                         <a:buNone/>
                       </a:pPr>
                       <a:r>
-                        <a:rPr lang="en-US" sz="1500" dirty="0">
+                        <a:rPr lang="en-US" sz="1400" dirty="0">
                           <a:solidFill>
                             <a:srgbClr val="12202B"/>
                           </a:solidFill>
@@ -6564,7 +6564,7 @@
                         </a:rPr>
                         <a:t>Có</a:t>
                       </a:r>
-                      <a:endParaRPr lang="en-US" sz="1500" dirty="0">
+                      <a:endParaRPr lang="en-US" sz="1400" dirty="0">
                         <a:latin typeface="Calibri" charset="0"/>
                         <a:ea typeface="Calibri" charset="0"/>
                         <a:cs typeface="Calibri" charset="0"/>
@@ -6614,7 +6614,7 @@
                   </a:tcPr>
                 </a:tc>
               </a:tr>
-              <a:tr h="502920">
+              <a:tr h="411480">
                 <a:tc>
                   <a:txBody>
                     <a:bodyPr/>
@@ -6624,7 +6624,7 @@
                         <a:buNone/>
                       </a:pPr>
                       <a:r>
-                        <a:rPr lang="en-US" sz="1500" dirty="0">
+                        <a:rPr lang="en-US" sz="1400" dirty="0">
                           <a:solidFill>
                             <a:srgbClr val="12202B"/>
                           </a:solidFill>
@@ -6634,7 +6634,7 @@
                         </a:rPr>
                         <a:t>TC-06</a:t>
                       </a:r>
-                      <a:endParaRPr lang="en-US" sz="1500" dirty="0">
+                      <a:endParaRPr lang="en-US" sz="1400" dirty="0">
                         <a:latin typeface="Calibri" charset="0"/>
                         <a:ea typeface="Calibri" charset="0"/>
                         <a:cs typeface="Calibri" charset="0"/>
@@ -6692,7 +6692,7 @@
                         <a:buNone/>
                       </a:pPr>
                       <a:r>
-                        <a:rPr lang="en-US" sz="1500" dirty="0">
+                        <a:rPr lang="en-US" sz="1400" dirty="0">
                           <a:solidFill>
                             <a:srgbClr val="12202B"/>
                           </a:solidFill>
@@ -6702,7 +6702,7 @@
                         </a:rPr>
                         <a:t>10/10</a:t>
                       </a:r>
-                      <a:endParaRPr lang="en-US" sz="1500" dirty="0">
+                      <a:endParaRPr lang="en-US" sz="1400" dirty="0">
                         <a:latin typeface="Calibri" charset="0"/>
                         <a:ea typeface="Calibri" charset="0"/>
                         <a:cs typeface="Calibri" charset="0"/>
@@ -6760,7 +6760,7 @@
                         <a:buNone/>
                       </a:pPr>
                       <a:r>
-                        <a:rPr lang="en-US" sz="1500" dirty="0">
+                        <a:rPr lang="en-US" sz="1400" dirty="0">
                           <a:solidFill>
                             <a:srgbClr val="12202B"/>
                           </a:solidFill>
@@ -6770,7 +6770,7 @@
                         </a:rPr>
                         <a:t>10/10</a:t>
                       </a:r>
-                      <a:endParaRPr lang="en-US" sz="1500" dirty="0">
+                      <a:endParaRPr lang="en-US" sz="1400" dirty="0">
                         <a:latin typeface="Calibri" charset="0"/>
                         <a:ea typeface="Calibri" charset="0"/>
                         <a:cs typeface="Calibri" charset="0"/>
@@ -6828,7 +6828,7 @@
                         <a:buNone/>
                       </a:pPr>
                       <a:r>
-                        <a:rPr lang="en-US" sz="1500" dirty="0">
+                        <a:rPr lang="en-US" sz="1400" dirty="0">
                           <a:solidFill>
                             <a:srgbClr val="12202B"/>
                           </a:solidFill>
@@ -6838,7 +6838,7 @@
                         </a:rPr>
                         <a:t>10/10</a:t>
                       </a:r>
-                      <a:endParaRPr lang="en-US" sz="1500" dirty="0">
+                      <a:endParaRPr lang="en-US" sz="1400" dirty="0">
                         <a:latin typeface="Calibri" charset="0"/>
                         <a:ea typeface="Calibri" charset="0"/>
                         <a:cs typeface="Calibri" charset="0"/>
@@ -6896,7 +6896,7 @@
                         <a:buNone/>
                       </a:pPr>
                       <a:r>
-                        <a:rPr lang="en-US" sz="1500" dirty="0">
+                        <a:rPr lang="en-US" sz="1400" dirty="0">
                           <a:solidFill>
                             <a:srgbClr val="12202B"/>
                           </a:solidFill>
@@ -6906,7 +6906,349 @@
                         </a:rPr>
                         <a:t>Có</a:t>
                       </a:r>
-                      <a:endParaRPr lang="en-US" sz="1500" dirty="0">
+                      <a:endParaRPr lang="en-US" sz="1400" dirty="0">
+                        <a:latin typeface="Calibri" charset="0"/>
+                        <a:ea typeface="Calibri" charset="0"/>
+                        <a:cs typeface="Calibri" charset="0"/>
+                      </a:endParaRPr>
+                    </a:p>
+                  </a:txBody>
+                  <a:tcPr marL="91440" marR="91440" marT="36576" marB="36576" anchor="ctr">
+                    <a:lnL w="9525" cap="flat" cmpd="sng" algn="ctr">
+                      <a:solidFill>
+                        <a:srgbClr val="DAD6CC"/>
+                      </a:solidFill>
+                      <a:prstDash val="solid"/>
+                      <a:round/>
+                      <a:headEnd type="none" w="med" len="med"/>
+                      <a:tailEnd type="none" w="med" len="med"/>
+                    </a:lnL>
+                    <a:lnR w="9525" cap="flat" cmpd="sng" algn="ctr">
+                      <a:solidFill>
+                        <a:srgbClr val="DAD6CC"/>
+                      </a:solidFill>
+                      <a:prstDash val="solid"/>
+                      <a:round/>
+                      <a:headEnd type="none" w="med" len="med"/>
+                      <a:tailEnd type="none" w="med" len="med"/>
+                    </a:lnR>
+                    <a:lnT w="9525" cap="flat" cmpd="sng" algn="ctr">
+                      <a:solidFill>
+                        <a:srgbClr val="DAD6CC"/>
+                      </a:solidFill>
+                      <a:prstDash val="solid"/>
+                      <a:round/>
+                      <a:headEnd type="none" w="med" len="med"/>
+                      <a:tailEnd type="none" w="med" len="med"/>
+                    </a:lnT>
+                    <a:lnB w="9525" cap="flat" cmpd="sng" algn="ctr">
+                      <a:solidFill>
+                        <a:srgbClr val="DAD6CC"/>
+                      </a:solidFill>
+                      <a:prstDash val="solid"/>
+                      <a:round/>
+                      <a:headEnd type="none" w="med" len="med"/>
+                      <a:tailEnd type="none" w="med" len="med"/>
+                    </a:lnB>
+                    <a:solidFill>
+                      <a:srgbClr val="FFFFFF"/>
+                    </a:solidFill>
+                  </a:tcPr>
+                </a:tc>
+              </a:tr>
+              <a:tr h="411480">
+                <a:tc>
+                  <a:txBody>
+                    <a:bodyPr/>
+                    <a:lstStyle/>
+                    <a:p>
+                      <a:pPr indent="0" marL="0">
+                        <a:buNone/>
+                      </a:pPr>
+                      <a:r>
+                        <a:rPr lang="en-US" sz="1400" dirty="0">
+                          <a:solidFill>
+                            <a:srgbClr val="12202B"/>
+                          </a:solidFill>
+                          <a:latin typeface="Calibri" pitchFamily="34" charset="0"/>
+                          <a:ea typeface="Calibri" pitchFamily="34" charset="-122"/>
+                          <a:cs typeface="Calibri" pitchFamily="34" charset="-120"/>
+                        </a:rPr>
+                        <a:t>TC-07</a:t>
+                      </a:r>
+                      <a:endParaRPr lang="en-US" sz="1400" dirty="0">
+                        <a:latin typeface="Calibri" charset="0"/>
+                        <a:ea typeface="Calibri" charset="0"/>
+                        <a:cs typeface="Calibri" charset="0"/>
+                      </a:endParaRPr>
+                    </a:p>
+                  </a:txBody>
+                  <a:tcPr marL="91440" marR="91440" marT="36576" marB="36576" anchor="ctr">
+                    <a:lnL w="9525" cap="flat" cmpd="sng" algn="ctr">
+                      <a:solidFill>
+                        <a:srgbClr val="DAD6CC"/>
+                      </a:solidFill>
+                      <a:prstDash val="solid"/>
+                      <a:round/>
+                      <a:headEnd type="none" w="med" len="med"/>
+                      <a:tailEnd type="none" w="med" len="med"/>
+                    </a:lnL>
+                    <a:lnR w="9525" cap="flat" cmpd="sng" algn="ctr">
+                      <a:solidFill>
+                        <a:srgbClr val="DAD6CC"/>
+                      </a:solidFill>
+                      <a:prstDash val="solid"/>
+                      <a:round/>
+                      <a:headEnd type="none" w="med" len="med"/>
+                      <a:tailEnd type="none" w="med" len="med"/>
+                    </a:lnR>
+                    <a:lnT w="9525" cap="flat" cmpd="sng" algn="ctr">
+                      <a:solidFill>
+                        <a:srgbClr val="DAD6CC"/>
+                      </a:solidFill>
+                      <a:prstDash val="solid"/>
+                      <a:round/>
+                      <a:headEnd type="none" w="med" len="med"/>
+                      <a:tailEnd type="none" w="med" len="med"/>
+                    </a:lnT>
+                    <a:lnB w="9525" cap="flat" cmpd="sng" algn="ctr">
+                      <a:solidFill>
+                        <a:srgbClr val="DAD6CC"/>
+                      </a:solidFill>
+                      <a:prstDash val="solid"/>
+                      <a:round/>
+                      <a:headEnd type="none" w="med" len="med"/>
+                      <a:tailEnd type="none" w="med" len="med"/>
+                    </a:lnB>
+                    <a:solidFill>
+                      <a:srgbClr val="FFFFFF"/>
+                    </a:solidFill>
+                  </a:tcPr>
+                </a:tc>
+                <a:tc>
+                  <a:txBody>
+                    <a:bodyPr/>
+                    <a:lstStyle/>
+                    <a:p>
+                      <a:pPr indent="0" marL="0">
+                        <a:buNone/>
+                      </a:pPr>
+                      <a:r>
+                        <a:rPr lang="en-US" sz="1400" dirty="0">
+                          <a:solidFill>
+                            <a:srgbClr val="12202B"/>
+                          </a:solidFill>
+                          <a:latin typeface="Calibri" pitchFamily="34" charset="0"/>
+                          <a:ea typeface="Calibri" pitchFamily="34" charset="-122"/>
+                          <a:cs typeface="Calibri" pitchFamily="34" charset="-120"/>
+                        </a:rPr>
+                        <a:t>10/10</a:t>
+                      </a:r>
+                      <a:endParaRPr lang="en-US" sz="1400" dirty="0">
+                        <a:latin typeface="Calibri" charset="0"/>
+                        <a:ea typeface="Calibri" charset="0"/>
+                        <a:cs typeface="Calibri" charset="0"/>
+                      </a:endParaRPr>
+                    </a:p>
+                  </a:txBody>
+                  <a:tcPr marL="91440" marR="91440" marT="36576" marB="36576" anchor="ctr">
+                    <a:lnL w="9525" cap="flat" cmpd="sng" algn="ctr">
+                      <a:solidFill>
+                        <a:srgbClr val="DAD6CC"/>
+                      </a:solidFill>
+                      <a:prstDash val="solid"/>
+                      <a:round/>
+                      <a:headEnd type="none" w="med" len="med"/>
+                      <a:tailEnd type="none" w="med" len="med"/>
+                    </a:lnL>
+                    <a:lnR w="9525" cap="flat" cmpd="sng" algn="ctr">
+                      <a:solidFill>
+                        <a:srgbClr val="DAD6CC"/>
+                      </a:solidFill>
+                      <a:prstDash val="solid"/>
+                      <a:round/>
+                      <a:headEnd type="none" w="med" len="med"/>
+                      <a:tailEnd type="none" w="med" len="med"/>
+                    </a:lnR>
+                    <a:lnT w="9525" cap="flat" cmpd="sng" algn="ctr">
+                      <a:solidFill>
+                        <a:srgbClr val="DAD6CC"/>
+                      </a:solidFill>
+                      <a:prstDash val="solid"/>
+                      <a:round/>
+                      <a:headEnd type="none" w="med" len="med"/>
+                      <a:tailEnd type="none" w="med" len="med"/>
+                    </a:lnT>
+                    <a:lnB w="9525" cap="flat" cmpd="sng" algn="ctr">
+                      <a:solidFill>
+                        <a:srgbClr val="DAD6CC"/>
+                      </a:solidFill>
+                      <a:prstDash val="solid"/>
+                      <a:round/>
+                      <a:headEnd type="none" w="med" len="med"/>
+                      <a:tailEnd type="none" w="med" len="med"/>
+                    </a:lnB>
+                    <a:solidFill>
+                      <a:srgbClr val="FFFFFF"/>
+                    </a:solidFill>
+                  </a:tcPr>
+                </a:tc>
+                <a:tc>
+                  <a:txBody>
+                    <a:bodyPr/>
+                    <a:lstStyle/>
+                    <a:p>
+                      <a:pPr indent="0" marL="0">
+                        <a:buNone/>
+                      </a:pPr>
+                      <a:r>
+                        <a:rPr lang="en-US" sz="1400" dirty="0">
+                          <a:solidFill>
+                            <a:srgbClr val="12202B"/>
+                          </a:solidFill>
+                          <a:latin typeface="Calibri" pitchFamily="34" charset="0"/>
+                          <a:ea typeface="Calibri" pitchFamily="34" charset="-122"/>
+                          <a:cs typeface="Calibri" pitchFamily="34" charset="-120"/>
+                        </a:rPr>
+                        <a:t>9/10</a:t>
+                      </a:r>
+                      <a:endParaRPr lang="en-US" sz="1400" dirty="0">
+                        <a:latin typeface="Calibri" charset="0"/>
+                        <a:ea typeface="Calibri" charset="0"/>
+                        <a:cs typeface="Calibri" charset="0"/>
+                      </a:endParaRPr>
+                    </a:p>
+                  </a:txBody>
+                  <a:tcPr marL="91440" marR="91440" marT="36576" marB="36576" anchor="ctr">
+                    <a:lnL w="9525" cap="flat" cmpd="sng" algn="ctr">
+                      <a:solidFill>
+                        <a:srgbClr val="DAD6CC"/>
+                      </a:solidFill>
+                      <a:prstDash val="solid"/>
+                      <a:round/>
+                      <a:headEnd type="none" w="med" len="med"/>
+                      <a:tailEnd type="none" w="med" len="med"/>
+                    </a:lnL>
+                    <a:lnR w="9525" cap="flat" cmpd="sng" algn="ctr">
+                      <a:solidFill>
+                        <a:srgbClr val="DAD6CC"/>
+                      </a:solidFill>
+                      <a:prstDash val="solid"/>
+                      <a:round/>
+                      <a:headEnd type="none" w="med" len="med"/>
+                      <a:tailEnd type="none" w="med" len="med"/>
+                    </a:lnR>
+                    <a:lnT w="9525" cap="flat" cmpd="sng" algn="ctr">
+                      <a:solidFill>
+                        <a:srgbClr val="DAD6CC"/>
+                      </a:solidFill>
+                      <a:prstDash val="solid"/>
+                      <a:round/>
+                      <a:headEnd type="none" w="med" len="med"/>
+                      <a:tailEnd type="none" w="med" len="med"/>
+                    </a:lnT>
+                    <a:lnB w="9525" cap="flat" cmpd="sng" algn="ctr">
+                      <a:solidFill>
+                        <a:srgbClr val="DAD6CC"/>
+                      </a:solidFill>
+                      <a:prstDash val="solid"/>
+                      <a:round/>
+                      <a:headEnd type="none" w="med" len="med"/>
+                      <a:tailEnd type="none" w="med" len="med"/>
+                    </a:lnB>
+                    <a:solidFill>
+                      <a:srgbClr val="FFFFFF"/>
+                    </a:solidFill>
+                  </a:tcPr>
+                </a:tc>
+                <a:tc>
+                  <a:txBody>
+                    <a:bodyPr/>
+                    <a:lstStyle/>
+                    <a:p>
+                      <a:pPr indent="0" marL="0">
+                        <a:buNone/>
+                      </a:pPr>
+                      <a:r>
+                        <a:rPr lang="en-US" sz="1400" dirty="0">
+                          <a:solidFill>
+                            <a:srgbClr val="12202B"/>
+                          </a:solidFill>
+                          <a:latin typeface="Calibri" pitchFamily="34" charset="0"/>
+                          <a:ea typeface="Calibri" pitchFamily="34" charset="-122"/>
+                          <a:cs typeface="Calibri" pitchFamily="34" charset="-120"/>
+                        </a:rPr>
+                        <a:t>0/10</a:t>
+                      </a:r>
+                      <a:endParaRPr lang="en-US" sz="1400" dirty="0">
+                        <a:latin typeface="Calibri" charset="0"/>
+                        <a:ea typeface="Calibri" charset="0"/>
+                        <a:cs typeface="Calibri" charset="0"/>
+                      </a:endParaRPr>
+                    </a:p>
+                  </a:txBody>
+                  <a:tcPr marL="91440" marR="91440" marT="36576" marB="36576" anchor="ctr">
+                    <a:lnL w="9525" cap="flat" cmpd="sng" algn="ctr">
+                      <a:solidFill>
+                        <a:srgbClr val="DAD6CC"/>
+                      </a:solidFill>
+                      <a:prstDash val="solid"/>
+                      <a:round/>
+                      <a:headEnd type="none" w="med" len="med"/>
+                      <a:tailEnd type="none" w="med" len="med"/>
+                    </a:lnL>
+                    <a:lnR w="9525" cap="flat" cmpd="sng" algn="ctr">
+                      <a:solidFill>
+                        <a:srgbClr val="DAD6CC"/>
+                      </a:solidFill>
+                      <a:prstDash val="solid"/>
+                      <a:round/>
+                      <a:headEnd type="none" w="med" len="med"/>
+                      <a:tailEnd type="none" w="med" len="med"/>
+                    </a:lnR>
+                    <a:lnT w="9525" cap="flat" cmpd="sng" algn="ctr">
+                      <a:solidFill>
+                        <a:srgbClr val="DAD6CC"/>
+                      </a:solidFill>
+                      <a:prstDash val="solid"/>
+                      <a:round/>
+                      <a:headEnd type="none" w="med" len="med"/>
+                      <a:tailEnd type="none" w="med" len="med"/>
+                    </a:lnT>
+                    <a:lnB w="9525" cap="flat" cmpd="sng" algn="ctr">
+                      <a:solidFill>
+                        <a:srgbClr val="DAD6CC"/>
+                      </a:solidFill>
+                      <a:prstDash val="solid"/>
+                      <a:round/>
+                      <a:headEnd type="none" w="med" len="med"/>
+                      <a:tailEnd type="none" w="med" len="med"/>
+                    </a:lnB>
+                    <a:solidFill>
+                      <a:srgbClr val="FFFFFF"/>
+                    </a:solidFill>
+                  </a:tcPr>
+                </a:tc>
+                <a:tc>
+                  <a:txBody>
+                    <a:bodyPr/>
+                    <a:lstStyle/>
+                    <a:p>
+                      <a:pPr indent="0" marL="0">
+                        <a:buNone/>
+                      </a:pPr>
+                      <a:r>
+                        <a:rPr lang="en-US" sz="1400" dirty="0">
+                          <a:solidFill>
+                            <a:srgbClr val="12202B"/>
+                          </a:solidFill>
+                          <a:latin typeface="Calibri" pitchFamily="34" charset="0"/>
+                          <a:ea typeface="Calibri" pitchFamily="34" charset="-122"/>
+                          <a:cs typeface="Calibri" pitchFamily="34" charset="-120"/>
+                        </a:rPr>
+                        <a:t>Có (lệch 1 vòng)</a:t>
+                      </a:r>
+                      <a:endParaRPr lang="en-US" sz="1400" dirty="0">
                         <a:latin typeface="Calibri" charset="0"/>
                         <a:ea typeface="Calibri" charset="0"/>
                         <a:cs typeface="Calibri" charset="0"/>
@@ -7059,7 +7401,7 @@
                 <a:ea typeface="Calibri" pitchFamily="34" charset="-122"/>
                 <a:cs typeface="Calibri" pitchFamily="34" charset="-120"/>
               </a:rPr>
-              <a:t>Đồng thời 210 giây (Mac 154 giây); tuần tự 43 giây (Mac 23 giây).</a:t>
+              <a:t>20 test case: đồng thời 448 giây (Mac 383 giây); tuần tự 113 giây (Mac 76 giây).</a:t>
             </a:r>
             <a:endParaRPr lang="en-US" sz="1500" dirty="0"/>
           </a:p>
@@ -7269,7 +7611,7 @@
                 <a:ea typeface="Calibri" pitchFamily="34" charset="-122"/>
                 <a:cs typeface="Calibri" pitchFamily="34" charset="-120"/>
               </a:rPr>
-              <a:t>Người test: Ngô Quốc Trường Vĩ. Máy MSI, Core i7-13620H, RAM 16 GB. 12 test case mới (TC-09 đến TC-20) chưa chạy trên Windows.</a:t>
+              <a:t>Người test: Ngô Quốc Trường Vĩ. Máy MSI, Core i7-13620H, RAM 16 GB. TC-07 lệch 1 vòng (9/10): bình thường với 2 request.</a:t>
             </a:r>
             <a:endParaRPr lang="en-US" sz="1500" dirty="0"/>
           </a:p>
@@ -7308,7 +7650,7 @@
                 <a:ea typeface="Calibri" pitchFamily="34" charset="-122"/>
                 <a:cs typeface="Calibri" pitchFamily="34" charset="-120"/>
               </a:rPr>
-              <a:t>race-tests/results/windows-race · race-tests/results/windows-sequential</a:t>
+              <a:t>race-tests/results/windows-20-race · race-tests/results/windows-20-sequential</a:t>
             </a:r>
             <a:endParaRPr lang="en-US" sz="1200" dirty="0"/>
           </a:p>
@@ -8545,7 +8887,7 @@
                           <a:ea typeface="Calibri" pitchFamily="34" charset="-122"/>
                           <a:cs typeface="Calibri" pitchFamily="34" charset="-120"/>
                         </a:rPr>
-                        <a:t>8 test case đầu khớp 8/8 giữa macOS và Windows (12 test case mới chỉ chạy trên macOS)</a:t>
+                        <a:t>Cả 20 test case khớp 20/20 giữa macOS và Windows (TC-07 lệch 1 vòng, 9/10)</a:t>
                       </a:r>
                       <a:endParaRPr lang="en-US" sz="1400" dirty="0">
                         <a:latin typeface="Calibri" charset="0"/>
@@ -17413,7 +17755,7 @@
                           <a:ea typeface="Calibri" pitchFamily="34" charset="-122"/>
                           <a:cs typeface="Calibri" pitchFamily="34" charset="-120"/>
                         </a:rPr>
-                        <a:t>Chạy lại trên Windows: 8 test case đầu khớp 8/8</a:t>
+                        <a:t>Chạy lại trên máy Windows: 20 test case khớp 20/20</a:t>
                       </a:r>
                       <a:endParaRPr lang="en-US" sz="1300" dirty="0">
                         <a:latin typeface="Calibri" charset="0"/>

</xml_diff>